<commit_message>
feat(md): 5/5 MD concluído — reclassificação pós-estabilidade
Resultados MD (10 ns, GROMACS, AMBER99SB-ILDN):
- MKKQRENAKKVAEITLKKAK: RMSD 0,447 nm → ESTÁVEL #1 (promovido)
- GSRASARAYAARVRARRAAL: RMSD 0,494 nm → ESTÁVEL #2
- AARASIRAAAARFRARRAAL: RMSD 0,945 nm → marginal
- GARKSIREYQKRVLERLKKK: RMSD 1,453 nm → INSTÁVEL (melhor I_sc, mas descartado)
- SLARKRAEENAKRFLERVKK: RMSD 1,700 nm → INSTÁVEL (confirmado divergente)

Atualizado: artigo_resultados.md seções 3.7/3.8/4, slide 13 (tabela 5 candidatos),
slide 17 próximos passos, footer slide 12.

Co-Authored-By: Claude Sonnet 4.6 <noreply@anthropic.com>
</commit_message>
<xml_diff>
--- a/apresentacao_design_inibidores.pptx
+++ b/apresentacao_design_inibidores.pptx
@@ -18542,7 +18542,7 @@
                 </a:solidFill>
                 <a:latin typeface="Calibri"/>
               </a:rPr>
-              <a:t>MD CONCLUIDO: GSRASARAYAARVRARRAAL | RMSD 0,37 nm | Rg 1,79 nm | Complexo ESTAVEL em 10 ns | ver slide 13</a:t>
+              <a:t>MD 5/5 CONCLUIDO: MKKQRENAKKVAEITLKKAK (0,447 nm) e GSRASARAYAARVRARRAAL (0,494 nm) ESTAVEIS | ver slide 13</a:t>
             </a:r>
           </a:p>
         </p:txBody>
@@ -18802,7 +18802,7 @@
                 </a:solidFill>
                 <a:latin typeface="Calibri"/>
               </a:rPr>
-              <a:t>Dinamica Molecular — GSRASARAYAARVRARRAAL × ACR157</a:t>
+              <a:t>Dinamica Molecular — Top-5 Candidatos × ACR157</a:t>
             </a:r>
           </a:p>
         </p:txBody>
@@ -18837,7 +18837,7 @@
                 </a:solidFill>
                 <a:latin typeface="Calibri"/>
               </a:rPr>
-              <a:t>GROMACS | AMBER99SB-ILDN | TIP3P | 300 K | NVT 200 ps + NPT 500 ps + MD 10 ns | 3 replicas completas</a:t>
+              <a:t>GROMACS | AMBER99SB-ILDN | TIP3P | 300 K | 10 ns cada | RTX 5070 Ti (~36 min/replica)</a:t>
             </a:r>
           </a:p>
         </p:txBody>
@@ -18850,8 +18850,8 @@
         </p:nvSpPr>
         <p:spPr>
           <a:xfrm>
-            <a:off x="365760" y="1143000"/>
-            <a:ext cx="5303520" cy="5212080"/>
+            <a:off x="274320" y="1143000"/>
+            <a:ext cx="11612880" cy="384048"/>
           </a:xfrm>
           <a:prstGeom prst="rect">
             <a:avLst/>
@@ -18893,8 +18893,8 @@
         </p:nvSpPr>
         <p:spPr>
           <a:xfrm>
-            <a:off x="548640" y="1234440"/>
-            <a:ext cx="4937760" cy="384048"/>
+            <a:off x="320040" y="1188720"/>
+            <a:ext cx="3474720" cy="292608"/>
           </a:xfrm>
           <a:prstGeom prst="rect">
             <a:avLst/>
@@ -18909,27 +18909,2185 @@
           <a:p>
             <a:pPr algn="l"/>
             <a:r>
-              <a:rPr sz="1500" b="1" i="0">
+              <a:rPr sz="1200" b="1" i="0">
+                <a:solidFill>
+                  <a:srgbClr val="FFFFFF"/>
+                </a:solidFill>
+                <a:latin typeface="Calibri"/>
+              </a:rPr>
+              <a:t>Candidato</a:t>
+            </a:r>
+          </a:p>
+        </p:txBody>
+      </p:sp>
+      <p:sp>
+        <p:nvSpPr>
+          <p:cNvPr id="10" name="TextBox 9"/>
+          <p:cNvSpPr txBox="1"/>
+          <p:nvPr/>
+        </p:nvSpPr>
+        <p:spPr>
+          <a:xfrm>
+            <a:off x="3840480" y="1188720"/>
+            <a:ext cx="1097280" cy="292608"/>
+          </a:xfrm>
+          <a:prstGeom prst="rect">
+            <a:avLst/>
+          </a:prstGeom>
+          <a:noFill/>
+        </p:spPr>
+        <p:txBody>
+          <a:bodyPr wrap="square">
+            <a:spAutoFit/>
+          </a:bodyPr>
+          <a:lstStyle/>
+          <a:p>
+            <a:pPr algn="l"/>
+            <a:r>
+              <a:rPr sz="1200" b="1" i="0">
+                <a:solidFill>
+                  <a:srgbClr val="FFFFFF"/>
+                </a:solidFill>
+                <a:latin typeface="Calibri"/>
+              </a:rPr>
+              <a:t>Vina</a:t>
+            </a:r>
+          </a:p>
+        </p:txBody>
+      </p:sp>
+      <p:sp>
+        <p:nvSpPr>
+          <p:cNvPr id="11" name="TextBox 10"/>
+          <p:cNvSpPr txBox="1"/>
+          <p:nvPr/>
+        </p:nvSpPr>
+        <p:spPr>
+          <a:xfrm>
+            <a:off x="4983480" y="1188720"/>
+            <a:ext cx="1097280" cy="292608"/>
+          </a:xfrm>
+          <a:prstGeom prst="rect">
+            <a:avLst/>
+          </a:prstGeom>
+          <a:noFill/>
+        </p:spPr>
+        <p:txBody>
+          <a:bodyPr wrap="square">
+            <a:spAutoFit/>
+          </a:bodyPr>
+          <a:lstStyle/>
+          <a:p>
+            <a:pPr algn="l"/>
+            <a:r>
+              <a:rPr sz="1200" b="1" i="0">
+                <a:solidFill>
+                  <a:srgbClr val="FFFFFF"/>
+                </a:solidFill>
+                <a:latin typeface="Calibri"/>
+              </a:rPr>
+              <a:t>I_sc</a:t>
+            </a:r>
+          </a:p>
+        </p:txBody>
+      </p:sp>
+      <p:sp>
+        <p:nvSpPr>
+          <p:cNvPr id="12" name="TextBox 11"/>
+          <p:cNvSpPr txBox="1"/>
+          <p:nvPr/>
+        </p:nvSpPr>
+        <p:spPr>
+          <a:xfrm>
+            <a:off x="6126480" y="1188720"/>
+            <a:ext cx="1188720" cy="292608"/>
+          </a:xfrm>
+          <a:prstGeom prst="rect">
+            <a:avLst/>
+          </a:prstGeom>
+          <a:noFill/>
+        </p:spPr>
+        <p:txBody>
+          <a:bodyPr wrap="square">
+            <a:spAutoFit/>
+          </a:bodyPr>
+          <a:lstStyle/>
+          <a:p>
+            <a:pPr algn="l"/>
+            <a:r>
+              <a:rPr sz="1200" b="1" i="0">
+                <a:solidFill>
+                  <a:srgbClr val="FFFFFF"/>
+                </a:solidFill>
+                <a:latin typeface="Calibri"/>
+              </a:rPr>
+              <a:t>RMSD avg</a:t>
+            </a:r>
+          </a:p>
+        </p:txBody>
+      </p:sp>
+      <p:sp>
+        <p:nvSpPr>
+          <p:cNvPr id="13" name="TextBox 12"/>
+          <p:cNvSpPr txBox="1"/>
+          <p:nvPr/>
+        </p:nvSpPr>
+        <p:spPr>
+          <a:xfrm>
+            <a:off x="7360920" y="1188720"/>
+            <a:ext cx="1097280" cy="292608"/>
+          </a:xfrm>
+          <a:prstGeom prst="rect">
+            <a:avLst/>
+          </a:prstGeom>
+          <a:noFill/>
+        </p:spPr>
+        <p:txBody>
+          <a:bodyPr wrap="square">
+            <a:spAutoFit/>
+          </a:bodyPr>
+          <a:lstStyle/>
+          <a:p>
+            <a:pPr algn="l"/>
+            <a:r>
+              <a:rPr sz="1200" b="1" i="0">
+                <a:solidFill>
+                  <a:srgbClr val="FFFFFF"/>
+                </a:solidFill>
+                <a:latin typeface="Calibri"/>
+              </a:rPr>
+              <a:t>Rg (nm)</a:t>
+            </a:r>
+          </a:p>
+        </p:txBody>
+      </p:sp>
+      <p:sp>
+        <p:nvSpPr>
+          <p:cNvPr id="14" name="TextBox 13"/>
+          <p:cNvSpPr txBox="1"/>
+          <p:nvPr/>
+        </p:nvSpPr>
+        <p:spPr>
+          <a:xfrm>
+            <a:off x="8503920" y="1188720"/>
+            <a:ext cx="914400" cy="292608"/>
+          </a:xfrm>
+          <a:prstGeom prst="rect">
+            <a:avLst/>
+          </a:prstGeom>
+          <a:noFill/>
+        </p:spPr>
+        <p:txBody>
+          <a:bodyPr wrap="square">
+            <a:spAutoFit/>
+          </a:bodyPr>
+          <a:lstStyle/>
+          <a:p>
+            <a:pPr algn="l"/>
+            <a:r>
+              <a:rPr sz="1200" b="1" i="0">
+                <a:solidFill>
+                  <a:srgbClr val="FFFFFF"/>
+                </a:solidFill>
+                <a:latin typeface="Calibri"/>
+              </a:rPr>
+              <a:t>Hbond</a:t>
+            </a:r>
+          </a:p>
+        </p:txBody>
+      </p:sp>
+      <p:sp>
+        <p:nvSpPr>
+          <p:cNvPr id="15" name="TextBox 14"/>
+          <p:cNvSpPr txBox="1"/>
+          <p:nvPr/>
+        </p:nvSpPr>
+        <p:spPr>
+          <a:xfrm>
+            <a:off x="9464040" y="1188720"/>
+            <a:ext cx="2377440" cy="292608"/>
+          </a:xfrm>
+          <a:prstGeom prst="rect">
+            <a:avLst/>
+          </a:prstGeom>
+          <a:noFill/>
+        </p:spPr>
+        <p:txBody>
+          <a:bodyPr wrap="square">
+            <a:spAutoFit/>
+          </a:bodyPr>
+          <a:lstStyle/>
+          <a:p>
+            <a:pPr algn="l"/>
+            <a:r>
+              <a:rPr sz="1200" b="1" i="0">
+                <a:solidFill>
+                  <a:srgbClr val="FFFFFF"/>
+                </a:solidFill>
+                <a:latin typeface="Calibri"/>
+              </a:rPr>
+              <a:t>Estabilidade</a:t>
+            </a:r>
+          </a:p>
+        </p:txBody>
+      </p:sp>
+      <p:sp>
+        <p:nvSpPr>
+          <p:cNvPr id="16" name="Rectangle 15"/>
+          <p:cNvSpPr/>
+          <p:nvPr/>
+        </p:nvSpPr>
+        <p:spPr>
+          <a:xfrm>
+            <a:off x="274320" y="1572768"/>
+            <a:ext cx="11612880" cy="777240"/>
+          </a:xfrm>
+          <a:prstGeom prst="rect">
+            <a:avLst/>
+          </a:prstGeom>
+          <a:solidFill>
+            <a:srgbClr val="D4EDDA"/>
+          </a:solidFill>
+          <a:ln>
+            <a:noFill/>
+          </a:ln>
+        </p:spPr>
+        <p:style>
+          <a:lnRef idx="1">
+            <a:schemeClr val="accent1"/>
+          </a:lnRef>
+          <a:fillRef idx="3">
+            <a:schemeClr val="accent1"/>
+          </a:fillRef>
+          <a:effectRef idx="2">
+            <a:schemeClr val="accent1"/>
+          </a:effectRef>
+          <a:fontRef idx="minor">
+            <a:schemeClr val="lt1"/>
+          </a:fontRef>
+        </p:style>
+        <p:txBody>
+          <a:bodyPr rtlCol="0" anchor="ctr"/>
+          <a:lstStyle/>
+          <a:p>
+            <a:pPr algn="ctr"/>
+          </a:p>
+        </p:txBody>
+      </p:sp>
+      <p:sp>
+        <p:nvSpPr>
+          <p:cNvPr id="17" name="Rectangle 16"/>
+          <p:cNvSpPr/>
+          <p:nvPr/>
+        </p:nvSpPr>
+        <p:spPr>
+          <a:xfrm>
+            <a:off x="274320" y="1572768"/>
+            <a:ext cx="73152" cy="777240"/>
+          </a:xfrm>
+          <a:prstGeom prst="rect">
+            <a:avLst/>
+          </a:prstGeom>
+          <a:solidFill>
+            <a:srgbClr val="06D6A0"/>
+          </a:solidFill>
+          <a:ln>
+            <a:noFill/>
+          </a:ln>
+        </p:spPr>
+        <p:style>
+          <a:lnRef idx="1">
+            <a:schemeClr val="accent1"/>
+          </a:lnRef>
+          <a:fillRef idx="3">
+            <a:schemeClr val="accent1"/>
+          </a:fillRef>
+          <a:effectRef idx="2">
+            <a:schemeClr val="accent1"/>
+          </a:effectRef>
+          <a:fontRef idx="minor">
+            <a:schemeClr val="lt1"/>
+          </a:fontRef>
+        </p:style>
+        <p:txBody>
+          <a:bodyPr rtlCol="0" anchor="ctr"/>
+          <a:lstStyle/>
+          <a:p>
+            <a:pPr algn="ctr"/>
+          </a:p>
+        </p:txBody>
+      </p:sp>
+      <p:sp>
+        <p:nvSpPr>
+          <p:cNvPr id="18" name="TextBox 17"/>
+          <p:cNvSpPr txBox="1"/>
+          <p:nvPr/>
+        </p:nvSpPr>
+        <p:spPr>
+          <a:xfrm>
+            <a:off x="411480" y="1773936"/>
+            <a:ext cx="3383280" cy="347472"/>
+          </a:xfrm>
+          <a:prstGeom prst="rect">
+            <a:avLst/>
+          </a:prstGeom>
+          <a:noFill/>
+        </p:spPr>
+        <p:txBody>
+          <a:bodyPr wrap="square">
+            <a:spAutoFit/>
+          </a:bodyPr>
+          <a:lstStyle/>
+          <a:p>
+            <a:pPr algn="l"/>
+            <a:r>
+              <a:rPr sz="1200" b="1" i="0">
+                <a:solidFill>
+                  <a:srgbClr val="0D2B55"/>
+                </a:solidFill>
+                <a:latin typeface="Calibri"/>
+              </a:rPr>
+              <a:t>MKKQRENAKKVAEITLKKAK</a:t>
+            </a:r>
+          </a:p>
+        </p:txBody>
+      </p:sp>
+      <p:sp>
+        <p:nvSpPr>
+          <p:cNvPr id="19" name="TextBox 18"/>
+          <p:cNvSpPr txBox="1"/>
+          <p:nvPr/>
+        </p:nvSpPr>
+        <p:spPr>
+          <a:xfrm>
+            <a:off x="3840480" y="1773936"/>
+            <a:ext cx="1097280" cy="347472"/>
+          </a:xfrm>
+          <a:prstGeom prst="rect">
+            <a:avLst/>
+          </a:prstGeom>
+          <a:noFill/>
+        </p:spPr>
+        <p:txBody>
+          <a:bodyPr wrap="square">
+            <a:spAutoFit/>
+          </a:bodyPr>
+          <a:lstStyle/>
+          <a:p>
+            <a:pPr algn="l"/>
+            <a:r>
+              <a:rPr sz="1200" b="0" i="0">
+                <a:solidFill>
+                  <a:srgbClr val="333344"/>
+                </a:solidFill>
+                <a:latin typeface="Calibri"/>
+              </a:rPr>
+              <a:t>-12,72</a:t>
+            </a:r>
+          </a:p>
+        </p:txBody>
+      </p:sp>
+      <p:sp>
+        <p:nvSpPr>
+          <p:cNvPr id="20" name="TextBox 19"/>
+          <p:cNvSpPr txBox="1"/>
+          <p:nvPr/>
+        </p:nvSpPr>
+        <p:spPr>
+          <a:xfrm>
+            <a:off x="4983480" y="1773936"/>
+            <a:ext cx="1097280" cy="347472"/>
+          </a:xfrm>
+          <a:prstGeom prst="rect">
+            <a:avLst/>
+          </a:prstGeom>
+          <a:noFill/>
+        </p:spPr>
+        <p:txBody>
+          <a:bodyPr wrap="square">
+            <a:spAutoFit/>
+          </a:bodyPr>
+          <a:lstStyle/>
+          <a:p>
+            <a:pPr algn="l"/>
+            <a:r>
+              <a:rPr sz="1200" b="0" i="0">
+                <a:solidFill>
+                  <a:srgbClr val="333344"/>
+                </a:solidFill>
+                <a:latin typeface="Calibri"/>
+              </a:rPr>
+              <a:t>-80,49</a:t>
+            </a:r>
+          </a:p>
+        </p:txBody>
+      </p:sp>
+      <p:sp>
+        <p:nvSpPr>
+          <p:cNvPr id="21" name="TextBox 20"/>
+          <p:cNvSpPr txBox="1"/>
+          <p:nvPr/>
+        </p:nvSpPr>
+        <p:spPr>
+          <a:xfrm>
+            <a:off x="6126480" y="1773936"/>
+            <a:ext cx="1097280" cy="347472"/>
+          </a:xfrm>
+          <a:prstGeom prst="rect">
+            <a:avLst/>
+          </a:prstGeom>
+          <a:noFill/>
+        </p:spPr>
+        <p:txBody>
+          <a:bodyPr wrap="square">
+            <a:spAutoFit/>
+          </a:bodyPr>
+          <a:lstStyle/>
+          <a:p>
+            <a:pPr algn="l"/>
+            <a:r>
+              <a:rPr sz="1200" b="0" i="0">
+                <a:solidFill>
+                  <a:srgbClr val="333344"/>
+                </a:solidFill>
+                <a:latin typeface="Calibri"/>
+              </a:rPr>
+              <a:t>0,447 ± 0,332</a:t>
+            </a:r>
+          </a:p>
+        </p:txBody>
+      </p:sp>
+      <p:sp>
+        <p:nvSpPr>
+          <p:cNvPr id="22" name="TextBox 21"/>
+          <p:cNvSpPr txBox="1"/>
+          <p:nvPr/>
+        </p:nvSpPr>
+        <p:spPr>
+          <a:xfrm>
+            <a:off x="7360920" y="1773936"/>
+            <a:ext cx="1097280" cy="347472"/>
+          </a:xfrm>
+          <a:prstGeom prst="rect">
+            <a:avLst/>
+          </a:prstGeom>
+          <a:noFill/>
+        </p:spPr>
+        <p:txBody>
+          <a:bodyPr wrap="square">
+            <a:spAutoFit/>
+          </a:bodyPr>
+          <a:lstStyle/>
+          <a:p>
+            <a:pPr algn="l"/>
+            <a:r>
+              <a:rPr sz="1200" b="0" i="0">
+                <a:solidFill>
+                  <a:srgbClr val="333344"/>
+                </a:solidFill>
+                <a:latin typeface="Calibri"/>
+              </a:rPr>
+              <a:t>1,785</a:t>
+            </a:r>
+          </a:p>
+        </p:txBody>
+      </p:sp>
+      <p:sp>
+        <p:nvSpPr>
+          <p:cNvPr id="23" name="TextBox 22"/>
+          <p:cNvSpPr txBox="1"/>
+          <p:nvPr/>
+        </p:nvSpPr>
+        <p:spPr>
+          <a:xfrm>
+            <a:off x="8503920" y="1773936"/>
+            <a:ext cx="1097280" cy="347472"/>
+          </a:xfrm>
+          <a:prstGeom prst="rect">
+            <a:avLst/>
+          </a:prstGeom>
+          <a:noFill/>
+        </p:spPr>
+        <p:txBody>
+          <a:bodyPr wrap="square">
+            <a:spAutoFit/>
+          </a:bodyPr>
+          <a:lstStyle/>
+          <a:p>
+            <a:pPr algn="l"/>
+            <a:r>
+              <a:rPr sz="1200" b="0" i="0">
+                <a:solidFill>
+                  <a:srgbClr val="333344"/>
+                </a:solidFill>
+                <a:latin typeface="Calibri"/>
+              </a:rPr>
+              <a:t>161,0</a:t>
+            </a:r>
+          </a:p>
+        </p:txBody>
+      </p:sp>
+      <p:sp>
+        <p:nvSpPr>
+          <p:cNvPr id="24" name="Rectangle 23"/>
+          <p:cNvSpPr/>
+          <p:nvPr/>
+        </p:nvSpPr>
+        <p:spPr>
+          <a:xfrm>
+            <a:off x="9464040" y="1728216"/>
+            <a:ext cx="2331720" cy="438912"/>
+          </a:xfrm>
+          <a:prstGeom prst="rect">
+            <a:avLst/>
+          </a:prstGeom>
+          <a:solidFill>
+            <a:srgbClr val="06D6A0"/>
+          </a:solidFill>
+          <a:ln>
+            <a:noFill/>
+          </a:ln>
+        </p:spPr>
+        <p:style>
+          <a:lnRef idx="1">
+            <a:schemeClr val="accent1"/>
+          </a:lnRef>
+          <a:fillRef idx="3">
+            <a:schemeClr val="accent1"/>
+          </a:fillRef>
+          <a:effectRef idx="2">
+            <a:schemeClr val="accent1"/>
+          </a:effectRef>
+          <a:fontRef idx="minor">
+            <a:schemeClr val="lt1"/>
+          </a:fontRef>
+        </p:style>
+        <p:txBody>
+          <a:bodyPr rtlCol="0" anchor="ctr"/>
+          <a:lstStyle/>
+          <a:p>
+            <a:pPr algn="ctr"/>
+          </a:p>
+        </p:txBody>
+      </p:sp>
+      <p:sp>
+        <p:nvSpPr>
+          <p:cNvPr id="25" name="TextBox 24"/>
+          <p:cNvSpPr txBox="1"/>
+          <p:nvPr/>
+        </p:nvSpPr>
+        <p:spPr>
+          <a:xfrm>
+            <a:off x="9464040" y="1728216"/>
+            <a:ext cx="2331720" cy="438912"/>
+          </a:xfrm>
+          <a:prstGeom prst="rect">
+            <a:avLst/>
+          </a:prstGeom>
+          <a:noFill/>
+        </p:spPr>
+        <p:txBody>
+          <a:bodyPr wrap="square">
+            <a:spAutoFit/>
+          </a:bodyPr>
+          <a:lstStyle/>
+          <a:p>
+            <a:pPr algn="ctr"/>
+            <a:r>
+              <a:rPr sz="1300" b="1" i="0">
+                <a:solidFill>
+                  <a:srgbClr val="FFFFFF"/>
+                </a:solidFill>
+                <a:latin typeface="Calibri"/>
+              </a:rPr>
+              <a:t>ESTAVEL</a:t>
+            </a:r>
+          </a:p>
+        </p:txBody>
+      </p:sp>
+      <p:sp>
+        <p:nvSpPr>
+          <p:cNvPr id="26" name="Rectangle 25"/>
+          <p:cNvSpPr/>
+          <p:nvPr/>
+        </p:nvSpPr>
+        <p:spPr>
+          <a:xfrm>
+            <a:off x="274320" y="2395728"/>
+            <a:ext cx="11612880" cy="777240"/>
+          </a:xfrm>
+          <a:prstGeom prst="rect">
+            <a:avLst/>
+          </a:prstGeom>
+          <a:solidFill>
+            <a:srgbClr val="D4EDDA"/>
+          </a:solidFill>
+          <a:ln>
+            <a:noFill/>
+          </a:ln>
+        </p:spPr>
+        <p:style>
+          <a:lnRef idx="1">
+            <a:schemeClr val="accent1"/>
+          </a:lnRef>
+          <a:fillRef idx="3">
+            <a:schemeClr val="accent1"/>
+          </a:fillRef>
+          <a:effectRef idx="2">
+            <a:schemeClr val="accent1"/>
+          </a:effectRef>
+          <a:fontRef idx="minor">
+            <a:schemeClr val="lt1"/>
+          </a:fontRef>
+        </p:style>
+        <p:txBody>
+          <a:bodyPr rtlCol="0" anchor="ctr"/>
+          <a:lstStyle/>
+          <a:p>
+            <a:pPr algn="ctr"/>
+          </a:p>
+        </p:txBody>
+      </p:sp>
+      <p:sp>
+        <p:nvSpPr>
+          <p:cNvPr id="27" name="Rectangle 26"/>
+          <p:cNvSpPr/>
+          <p:nvPr/>
+        </p:nvSpPr>
+        <p:spPr>
+          <a:xfrm>
+            <a:off x="274320" y="2395728"/>
+            <a:ext cx="73152" cy="777240"/>
+          </a:xfrm>
+          <a:prstGeom prst="rect">
+            <a:avLst/>
+          </a:prstGeom>
+          <a:solidFill>
+            <a:srgbClr val="06D6A0"/>
+          </a:solidFill>
+          <a:ln>
+            <a:noFill/>
+          </a:ln>
+        </p:spPr>
+        <p:style>
+          <a:lnRef idx="1">
+            <a:schemeClr val="accent1"/>
+          </a:lnRef>
+          <a:fillRef idx="3">
+            <a:schemeClr val="accent1"/>
+          </a:fillRef>
+          <a:effectRef idx="2">
+            <a:schemeClr val="accent1"/>
+          </a:effectRef>
+          <a:fontRef idx="minor">
+            <a:schemeClr val="lt1"/>
+          </a:fontRef>
+        </p:style>
+        <p:txBody>
+          <a:bodyPr rtlCol="0" anchor="ctr"/>
+          <a:lstStyle/>
+          <a:p>
+            <a:pPr algn="ctr"/>
+          </a:p>
+        </p:txBody>
+      </p:sp>
+      <p:sp>
+        <p:nvSpPr>
+          <p:cNvPr id="28" name="TextBox 27"/>
+          <p:cNvSpPr txBox="1"/>
+          <p:nvPr/>
+        </p:nvSpPr>
+        <p:spPr>
+          <a:xfrm>
+            <a:off x="411480" y="2596896"/>
+            <a:ext cx="3383280" cy="347472"/>
+          </a:xfrm>
+          <a:prstGeom prst="rect">
+            <a:avLst/>
+          </a:prstGeom>
+          <a:noFill/>
+        </p:spPr>
+        <p:txBody>
+          <a:bodyPr wrap="square">
+            <a:spAutoFit/>
+          </a:bodyPr>
+          <a:lstStyle/>
+          <a:p>
+            <a:pPr algn="l"/>
+            <a:r>
+              <a:rPr sz="1200" b="1" i="0">
+                <a:solidFill>
+                  <a:srgbClr val="0D2B55"/>
+                </a:solidFill>
+                <a:latin typeface="Calibri"/>
+              </a:rPr>
+              <a:t>GSRASARAYAARVRARRAAL</a:t>
+            </a:r>
+          </a:p>
+        </p:txBody>
+      </p:sp>
+      <p:sp>
+        <p:nvSpPr>
+          <p:cNvPr id="29" name="TextBox 28"/>
+          <p:cNvSpPr txBox="1"/>
+          <p:nvPr/>
+        </p:nvSpPr>
+        <p:spPr>
+          <a:xfrm>
+            <a:off x="3840480" y="2596896"/>
+            <a:ext cx="1097280" cy="347472"/>
+          </a:xfrm>
+          <a:prstGeom prst="rect">
+            <a:avLst/>
+          </a:prstGeom>
+          <a:noFill/>
+        </p:spPr>
+        <p:txBody>
+          <a:bodyPr wrap="square">
+            <a:spAutoFit/>
+          </a:bodyPr>
+          <a:lstStyle/>
+          <a:p>
+            <a:pPr algn="l"/>
+            <a:r>
+              <a:rPr sz="1200" b="0" i="0">
+                <a:solidFill>
+                  <a:srgbClr val="333344"/>
+                </a:solidFill>
+                <a:latin typeface="Calibri"/>
+              </a:rPr>
+              <a:t>-13,62</a:t>
+            </a:r>
+          </a:p>
+        </p:txBody>
+      </p:sp>
+      <p:sp>
+        <p:nvSpPr>
+          <p:cNvPr id="30" name="TextBox 29"/>
+          <p:cNvSpPr txBox="1"/>
+          <p:nvPr/>
+        </p:nvSpPr>
+        <p:spPr>
+          <a:xfrm>
+            <a:off x="4983480" y="2596896"/>
+            <a:ext cx="1097280" cy="347472"/>
+          </a:xfrm>
+          <a:prstGeom prst="rect">
+            <a:avLst/>
+          </a:prstGeom>
+          <a:noFill/>
+        </p:spPr>
+        <p:txBody>
+          <a:bodyPr wrap="square">
+            <a:spAutoFit/>
+          </a:bodyPr>
+          <a:lstStyle/>
+          <a:p>
+            <a:pPr algn="l"/>
+            <a:r>
+              <a:rPr sz="1200" b="0" i="0">
+                <a:solidFill>
+                  <a:srgbClr val="333344"/>
+                </a:solidFill>
+                <a:latin typeface="Calibri"/>
+              </a:rPr>
+              <a:t>-78,44</a:t>
+            </a:r>
+          </a:p>
+        </p:txBody>
+      </p:sp>
+      <p:sp>
+        <p:nvSpPr>
+          <p:cNvPr id="31" name="TextBox 30"/>
+          <p:cNvSpPr txBox="1"/>
+          <p:nvPr/>
+        </p:nvSpPr>
+        <p:spPr>
+          <a:xfrm>
+            <a:off x="6126480" y="2596896"/>
+            <a:ext cx="1097280" cy="347472"/>
+          </a:xfrm>
+          <a:prstGeom prst="rect">
+            <a:avLst/>
+          </a:prstGeom>
+          <a:noFill/>
+        </p:spPr>
+        <p:txBody>
+          <a:bodyPr wrap="square">
+            <a:spAutoFit/>
+          </a:bodyPr>
+          <a:lstStyle/>
+          <a:p>
+            <a:pPr algn="l"/>
+            <a:r>
+              <a:rPr sz="1200" b="0" i="0">
+                <a:solidFill>
+                  <a:srgbClr val="333344"/>
+                </a:solidFill>
+                <a:latin typeface="Calibri"/>
+              </a:rPr>
+              <a:t>0,494 ± 0,414</a:t>
+            </a:r>
+          </a:p>
+        </p:txBody>
+      </p:sp>
+      <p:sp>
+        <p:nvSpPr>
+          <p:cNvPr id="32" name="TextBox 31"/>
+          <p:cNvSpPr txBox="1"/>
+          <p:nvPr/>
+        </p:nvSpPr>
+        <p:spPr>
+          <a:xfrm>
+            <a:off x="7360920" y="2596896"/>
+            <a:ext cx="1097280" cy="347472"/>
+          </a:xfrm>
+          <a:prstGeom prst="rect">
+            <a:avLst/>
+          </a:prstGeom>
+          <a:noFill/>
+        </p:spPr>
+        <p:txBody>
+          <a:bodyPr wrap="square">
+            <a:spAutoFit/>
+          </a:bodyPr>
+          <a:lstStyle/>
+          <a:p>
+            <a:pPr algn="l"/>
+            <a:r>
+              <a:rPr sz="1200" b="0" i="0">
+                <a:solidFill>
+                  <a:srgbClr val="333344"/>
+                </a:solidFill>
+                <a:latin typeface="Calibri"/>
+              </a:rPr>
+              <a:t>1,799</a:t>
+            </a:r>
+          </a:p>
+        </p:txBody>
+      </p:sp>
+      <p:sp>
+        <p:nvSpPr>
+          <p:cNvPr id="33" name="TextBox 32"/>
+          <p:cNvSpPr txBox="1"/>
+          <p:nvPr/>
+        </p:nvSpPr>
+        <p:spPr>
+          <a:xfrm>
+            <a:off x="8503920" y="2596896"/>
+            <a:ext cx="1097280" cy="347472"/>
+          </a:xfrm>
+          <a:prstGeom prst="rect">
+            <a:avLst/>
+          </a:prstGeom>
+          <a:noFill/>
+        </p:spPr>
+        <p:txBody>
+          <a:bodyPr wrap="square">
+            <a:spAutoFit/>
+          </a:bodyPr>
+          <a:lstStyle/>
+          <a:p>
+            <a:pPr algn="l"/>
+            <a:r>
+              <a:rPr sz="1200" b="0" i="0">
+                <a:solidFill>
+                  <a:srgbClr val="333344"/>
+                </a:solidFill>
+                <a:latin typeface="Calibri"/>
+              </a:rPr>
+              <a:t>160,9</a:t>
+            </a:r>
+          </a:p>
+        </p:txBody>
+      </p:sp>
+      <p:sp>
+        <p:nvSpPr>
+          <p:cNvPr id="34" name="Rectangle 33"/>
+          <p:cNvSpPr/>
+          <p:nvPr/>
+        </p:nvSpPr>
+        <p:spPr>
+          <a:xfrm>
+            <a:off x="9464040" y="2551176"/>
+            <a:ext cx="2331720" cy="438912"/>
+          </a:xfrm>
+          <a:prstGeom prst="rect">
+            <a:avLst/>
+          </a:prstGeom>
+          <a:solidFill>
+            <a:srgbClr val="06D6A0"/>
+          </a:solidFill>
+          <a:ln>
+            <a:noFill/>
+          </a:ln>
+        </p:spPr>
+        <p:style>
+          <a:lnRef idx="1">
+            <a:schemeClr val="accent1"/>
+          </a:lnRef>
+          <a:fillRef idx="3">
+            <a:schemeClr val="accent1"/>
+          </a:fillRef>
+          <a:effectRef idx="2">
+            <a:schemeClr val="accent1"/>
+          </a:effectRef>
+          <a:fontRef idx="minor">
+            <a:schemeClr val="lt1"/>
+          </a:fontRef>
+        </p:style>
+        <p:txBody>
+          <a:bodyPr rtlCol="0" anchor="ctr"/>
+          <a:lstStyle/>
+          <a:p>
+            <a:pPr algn="ctr"/>
+          </a:p>
+        </p:txBody>
+      </p:sp>
+      <p:sp>
+        <p:nvSpPr>
+          <p:cNvPr id="35" name="TextBox 34"/>
+          <p:cNvSpPr txBox="1"/>
+          <p:nvPr/>
+        </p:nvSpPr>
+        <p:spPr>
+          <a:xfrm>
+            <a:off x="9464040" y="2551176"/>
+            <a:ext cx="2331720" cy="438912"/>
+          </a:xfrm>
+          <a:prstGeom prst="rect">
+            <a:avLst/>
+          </a:prstGeom>
+          <a:noFill/>
+        </p:spPr>
+        <p:txBody>
+          <a:bodyPr wrap="square">
+            <a:spAutoFit/>
+          </a:bodyPr>
+          <a:lstStyle/>
+          <a:p>
+            <a:pPr algn="ctr"/>
+            <a:r>
+              <a:rPr sz="1300" b="1" i="0">
+                <a:solidFill>
+                  <a:srgbClr val="FFFFFF"/>
+                </a:solidFill>
+                <a:latin typeface="Calibri"/>
+              </a:rPr>
+              <a:t>ESTAVEL</a:t>
+            </a:r>
+          </a:p>
+        </p:txBody>
+      </p:sp>
+      <p:sp>
+        <p:nvSpPr>
+          <p:cNvPr id="36" name="Rectangle 35"/>
+          <p:cNvSpPr/>
+          <p:nvPr/>
+        </p:nvSpPr>
+        <p:spPr>
+          <a:xfrm>
+            <a:off x="274320" y="3218688"/>
+            <a:ext cx="11612880" cy="777240"/>
+          </a:xfrm>
+          <a:prstGeom prst="rect">
+            <a:avLst/>
+          </a:prstGeom>
+          <a:solidFill>
+            <a:srgbClr val="FFF3CD"/>
+          </a:solidFill>
+          <a:ln>
+            <a:noFill/>
+          </a:ln>
+        </p:spPr>
+        <p:style>
+          <a:lnRef idx="1">
+            <a:schemeClr val="accent1"/>
+          </a:lnRef>
+          <a:fillRef idx="3">
+            <a:schemeClr val="accent1"/>
+          </a:fillRef>
+          <a:effectRef idx="2">
+            <a:schemeClr val="accent1"/>
+          </a:effectRef>
+          <a:fontRef idx="minor">
+            <a:schemeClr val="lt1"/>
+          </a:fontRef>
+        </p:style>
+        <p:txBody>
+          <a:bodyPr rtlCol="0" anchor="ctr"/>
+          <a:lstStyle/>
+          <a:p>
+            <a:pPr algn="ctr"/>
+          </a:p>
+        </p:txBody>
+      </p:sp>
+      <p:sp>
+        <p:nvSpPr>
+          <p:cNvPr id="37" name="Rectangle 36"/>
+          <p:cNvSpPr/>
+          <p:nvPr/>
+        </p:nvSpPr>
+        <p:spPr>
+          <a:xfrm>
+            <a:off x="274320" y="3218688"/>
+            <a:ext cx="73152" cy="777240"/>
+          </a:xfrm>
+          <a:prstGeom prst="rect">
+            <a:avLst/>
+          </a:prstGeom>
+          <a:solidFill>
+            <a:srgbClr val="FFD166"/>
+          </a:solidFill>
+          <a:ln>
+            <a:noFill/>
+          </a:ln>
+        </p:spPr>
+        <p:style>
+          <a:lnRef idx="1">
+            <a:schemeClr val="accent1"/>
+          </a:lnRef>
+          <a:fillRef idx="3">
+            <a:schemeClr val="accent1"/>
+          </a:fillRef>
+          <a:effectRef idx="2">
+            <a:schemeClr val="accent1"/>
+          </a:effectRef>
+          <a:fontRef idx="minor">
+            <a:schemeClr val="lt1"/>
+          </a:fontRef>
+        </p:style>
+        <p:txBody>
+          <a:bodyPr rtlCol="0" anchor="ctr"/>
+          <a:lstStyle/>
+          <a:p>
+            <a:pPr algn="ctr"/>
+          </a:p>
+        </p:txBody>
+      </p:sp>
+      <p:sp>
+        <p:nvSpPr>
+          <p:cNvPr id="38" name="TextBox 37"/>
+          <p:cNvSpPr txBox="1"/>
+          <p:nvPr/>
+        </p:nvSpPr>
+        <p:spPr>
+          <a:xfrm>
+            <a:off x="411480" y="3419856"/>
+            <a:ext cx="3383280" cy="347472"/>
+          </a:xfrm>
+          <a:prstGeom prst="rect">
+            <a:avLst/>
+          </a:prstGeom>
+          <a:noFill/>
+        </p:spPr>
+        <p:txBody>
+          <a:bodyPr wrap="square">
+            <a:spAutoFit/>
+          </a:bodyPr>
+          <a:lstStyle/>
+          <a:p>
+            <a:pPr algn="l"/>
+            <a:r>
+              <a:rPr sz="1200" b="1" i="0">
+                <a:solidFill>
+                  <a:srgbClr val="0D2B55"/>
+                </a:solidFill>
+                <a:latin typeface="Calibri"/>
+              </a:rPr>
+              <a:t>AARASIRAAAARFRARRAAL</a:t>
+            </a:r>
+          </a:p>
+        </p:txBody>
+      </p:sp>
+      <p:sp>
+        <p:nvSpPr>
+          <p:cNvPr id="39" name="TextBox 38"/>
+          <p:cNvSpPr txBox="1"/>
+          <p:nvPr/>
+        </p:nvSpPr>
+        <p:spPr>
+          <a:xfrm>
+            <a:off x="3840480" y="3419856"/>
+            <a:ext cx="1097280" cy="347472"/>
+          </a:xfrm>
+          <a:prstGeom prst="rect">
+            <a:avLst/>
+          </a:prstGeom>
+          <a:noFill/>
+        </p:spPr>
+        <p:txBody>
+          <a:bodyPr wrap="square">
+            <a:spAutoFit/>
+          </a:bodyPr>
+          <a:lstStyle/>
+          <a:p>
+            <a:pPr algn="l"/>
+            <a:r>
+              <a:rPr sz="1200" b="0" i="0">
+                <a:solidFill>
+                  <a:srgbClr val="333344"/>
+                </a:solidFill>
+                <a:latin typeface="Calibri"/>
+              </a:rPr>
+              <a:t>-12,62</a:t>
+            </a:r>
+          </a:p>
+        </p:txBody>
+      </p:sp>
+      <p:sp>
+        <p:nvSpPr>
+          <p:cNvPr id="40" name="TextBox 39"/>
+          <p:cNvSpPr txBox="1"/>
+          <p:nvPr/>
+        </p:nvSpPr>
+        <p:spPr>
+          <a:xfrm>
+            <a:off x="4983480" y="3419856"/>
+            <a:ext cx="1097280" cy="347472"/>
+          </a:xfrm>
+          <a:prstGeom prst="rect">
+            <a:avLst/>
+          </a:prstGeom>
+          <a:noFill/>
+        </p:spPr>
+        <p:txBody>
+          <a:bodyPr wrap="square">
+            <a:spAutoFit/>
+          </a:bodyPr>
+          <a:lstStyle/>
+          <a:p>
+            <a:pPr algn="l"/>
+            <a:r>
+              <a:rPr sz="1200" b="0" i="0">
+                <a:solidFill>
+                  <a:srgbClr val="333344"/>
+                </a:solidFill>
+                <a:latin typeface="Calibri"/>
+              </a:rPr>
+              <a:t>-75,45</a:t>
+            </a:r>
+          </a:p>
+        </p:txBody>
+      </p:sp>
+      <p:sp>
+        <p:nvSpPr>
+          <p:cNvPr id="41" name="TextBox 40"/>
+          <p:cNvSpPr txBox="1"/>
+          <p:nvPr/>
+        </p:nvSpPr>
+        <p:spPr>
+          <a:xfrm>
+            <a:off x="6126480" y="3419856"/>
+            <a:ext cx="1097280" cy="347472"/>
+          </a:xfrm>
+          <a:prstGeom prst="rect">
+            <a:avLst/>
+          </a:prstGeom>
+          <a:noFill/>
+        </p:spPr>
+        <p:txBody>
+          <a:bodyPr wrap="square">
+            <a:spAutoFit/>
+          </a:bodyPr>
+          <a:lstStyle/>
+          <a:p>
+            <a:pPr algn="l"/>
+            <a:r>
+              <a:rPr sz="1200" b="0" i="0">
+                <a:solidFill>
+                  <a:srgbClr val="333344"/>
+                </a:solidFill>
+                <a:latin typeface="Calibri"/>
+              </a:rPr>
+              <a:t>0,945 ± 0,924</a:t>
+            </a:r>
+          </a:p>
+        </p:txBody>
+      </p:sp>
+      <p:sp>
+        <p:nvSpPr>
+          <p:cNvPr id="42" name="TextBox 41"/>
+          <p:cNvSpPr txBox="1"/>
+          <p:nvPr/>
+        </p:nvSpPr>
+        <p:spPr>
+          <a:xfrm>
+            <a:off x="7360920" y="3419856"/>
+            <a:ext cx="1097280" cy="347472"/>
+          </a:xfrm>
+          <a:prstGeom prst="rect">
+            <a:avLst/>
+          </a:prstGeom>
+          <a:noFill/>
+        </p:spPr>
+        <p:txBody>
+          <a:bodyPr wrap="square">
+            <a:spAutoFit/>
+          </a:bodyPr>
+          <a:lstStyle/>
+          <a:p>
+            <a:pPr algn="l"/>
+            <a:r>
+              <a:rPr sz="1200" b="0" i="0">
+                <a:solidFill>
+                  <a:srgbClr val="333344"/>
+                </a:solidFill>
+                <a:latin typeface="Calibri"/>
+              </a:rPr>
+              <a:t>1,836</a:t>
+            </a:r>
+          </a:p>
+        </p:txBody>
+      </p:sp>
+      <p:sp>
+        <p:nvSpPr>
+          <p:cNvPr id="43" name="TextBox 42"/>
+          <p:cNvSpPr txBox="1"/>
+          <p:nvPr/>
+        </p:nvSpPr>
+        <p:spPr>
+          <a:xfrm>
+            <a:off x="8503920" y="3419856"/>
+            <a:ext cx="1097280" cy="347472"/>
+          </a:xfrm>
+          <a:prstGeom prst="rect">
+            <a:avLst/>
+          </a:prstGeom>
+          <a:noFill/>
+        </p:spPr>
+        <p:txBody>
+          <a:bodyPr wrap="square">
+            <a:spAutoFit/>
+          </a:bodyPr>
+          <a:lstStyle/>
+          <a:p>
+            <a:pPr algn="l"/>
+            <a:r>
+              <a:rPr sz="1200" b="0" i="0">
+                <a:solidFill>
+                  <a:srgbClr val="333344"/>
+                </a:solidFill>
+                <a:latin typeface="Calibri"/>
+              </a:rPr>
+              <a:t>163,6</a:t>
+            </a:r>
+          </a:p>
+        </p:txBody>
+      </p:sp>
+      <p:sp>
+        <p:nvSpPr>
+          <p:cNvPr id="44" name="Rectangle 43"/>
+          <p:cNvSpPr/>
+          <p:nvPr/>
+        </p:nvSpPr>
+        <p:spPr>
+          <a:xfrm>
+            <a:off x="9464040" y="3374136"/>
+            <a:ext cx="2331720" cy="438912"/>
+          </a:xfrm>
+          <a:prstGeom prst="rect">
+            <a:avLst/>
+          </a:prstGeom>
+          <a:solidFill>
+            <a:srgbClr val="FFD166"/>
+          </a:solidFill>
+          <a:ln>
+            <a:noFill/>
+          </a:ln>
+        </p:spPr>
+        <p:style>
+          <a:lnRef idx="1">
+            <a:schemeClr val="accent1"/>
+          </a:lnRef>
+          <a:fillRef idx="3">
+            <a:schemeClr val="accent1"/>
+          </a:fillRef>
+          <a:effectRef idx="2">
+            <a:schemeClr val="accent1"/>
+          </a:effectRef>
+          <a:fontRef idx="minor">
+            <a:schemeClr val="lt1"/>
+          </a:fontRef>
+        </p:style>
+        <p:txBody>
+          <a:bodyPr rtlCol="0" anchor="ctr"/>
+          <a:lstStyle/>
+          <a:p>
+            <a:pPr algn="ctr"/>
+          </a:p>
+        </p:txBody>
+      </p:sp>
+      <p:sp>
+        <p:nvSpPr>
+          <p:cNvPr id="45" name="TextBox 44"/>
+          <p:cNvSpPr txBox="1"/>
+          <p:nvPr/>
+        </p:nvSpPr>
+        <p:spPr>
+          <a:xfrm>
+            <a:off x="9464040" y="3374136"/>
+            <a:ext cx="2331720" cy="438912"/>
+          </a:xfrm>
+          <a:prstGeom prst="rect">
+            <a:avLst/>
+          </a:prstGeom>
+          <a:noFill/>
+        </p:spPr>
+        <p:txBody>
+          <a:bodyPr wrap="square">
+            <a:spAutoFit/>
+          </a:bodyPr>
+          <a:lstStyle/>
+          <a:p>
+            <a:pPr algn="ctr"/>
+            <a:r>
+              <a:rPr sz="1300" b="1" i="0">
+                <a:solidFill>
+                  <a:srgbClr val="FFFFFF"/>
+                </a:solidFill>
+                <a:latin typeface="Calibri"/>
+              </a:rPr>
+              <a:t>Marginal</a:t>
+            </a:r>
+          </a:p>
+        </p:txBody>
+      </p:sp>
+      <p:sp>
+        <p:nvSpPr>
+          <p:cNvPr id="46" name="Rectangle 45"/>
+          <p:cNvSpPr/>
+          <p:nvPr/>
+        </p:nvSpPr>
+        <p:spPr>
+          <a:xfrm>
+            <a:off x="274320" y="4041648"/>
+            <a:ext cx="11612880" cy="777240"/>
+          </a:xfrm>
+          <a:prstGeom prst="rect">
+            <a:avLst/>
+          </a:prstGeom>
+          <a:solidFill>
+            <a:srgbClr val="F8D7DA"/>
+          </a:solidFill>
+          <a:ln>
+            <a:noFill/>
+          </a:ln>
+        </p:spPr>
+        <p:style>
+          <a:lnRef idx="1">
+            <a:schemeClr val="accent1"/>
+          </a:lnRef>
+          <a:fillRef idx="3">
+            <a:schemeClr val="accent1"/>
+          </a:fillRef>
+          <a:effectRef idx="2">
+            <a:schemeClr val="accent1"/>
+          </a:effectRef>
+          <a:fontRef idx="minor">
+            <a:schemeClr val="lt1"/>
+          </a:fontRef>
+        </p:style>
+        <p:txBody>
+          <a:bodyPr rtlCol="0" anchor="ctr"/>
+          <a:lstStyle/>
+          <a:p>
+            <a:pPr algn="ctr"/>
+          </a:p>
+        </p:txBody>
+      </p:sp>
+      <p:sp>
+        <p:nvSpPr>
+          <p:cNvPr id="47" name="Rectangle 46"/>
+          <p:cNvSpPr/>
+          <p:nvPr/>
+        </p:nvSpPr>
+        <p:spPr>
+          <a:xfrm>
+            <a:off x="274320" y="4041648"/>
+            <a:ext cx="73152" cy="777240"/>
+          </a:xfrm>
+          <a:prstGeom prst="rect">
+            <a:avLst/>
+          </a:prstGeom>
+          <a:solidFill>
+            <a:srgbClr val="FF7F11"/>
+          </a:solidFill>
+          <a:ln>
+            <a:noFill/>
+          </a:ln>
+        </p:spPr>
+        <p:style>
+          <a:lnRef idx="1">
+            <a:schemeClr val="accent1"/>
+          </a:lnRef>
+          <a:fillRef idx="3">
+            <a:schemeClr val="accent1"/>
+          </a:fillRef>
+          <a:effectRef idx="2">
+            <a:schemeClr val="accent1"/>
+          </a:effectRef>
+          <a:fontRef idx="minor">
+            <a:schemeClr val="lt1"/>
+          </a:fontRef>
+        </p:style>
+        <p:txBody>
+          <a:bodyPr rtlCol="0" anchor="ctr"/>
+          <a:lstStyle/>
+          <a:p>
+            <a:pPr algn="ctr"/>
+          </a:p>
+        </p:txBody>
+      </p:sp>
+      <p:sp>
+        <p:nvSpPr>
+          <p:cNvPr id="48" name="TextBox 47"/>
+          <p:cNvSpPr txBox="1"/>
+          <p:nvPr/>
+        </p:nvSpPr>
+        <p:spPr>
+          <a:xfrm>
+            <a:off x="411480" y="4242816"/>
+            <a:ext cx="3383280" cy="347472"/>
+          </a:xfrm>
+          <a:prstGeom prst="rect">
+            <a:avLst/>
+          </a:prstGeom>
+          <a:noFill/>
+        </p:spPr>
+        <p:txBody>
+          <a:bodyPr wrap="square">
+            <a:spAutoFit/>
+          </a:bodyPr>
+          <a:lstStyle/>
+          <a:p>
+            <a:pPr algn="l"/>
+            <a:r>
+              <a:rPr sz="1200" b="1" i="0">
+                <a:solidFill>
+                  <a:srgbClr val="0D2B55"/>
+                </a:solidFill>
+                <a:latin typeface="Calibri"/>
+              </a:rPr>
+              <a:t>GARKSIREYQKRVLERLKKK</a:t>
+            </a:r>
+          </a:p>
+        </p:txBody>
+      </p:sp>
+      <p:sp>
+        <p:nvSpPr>
+          <p:cNvPr id="49" name="TextBox 48"/>
+          <p:cNvSpPr txBox="1"/>
+          <p:nvPr/>
+        </p:nvSpPr>
+        <p:spPr>
+          <a:xfrm>
+            <a:off x="3840480" y="4242816"/>
+            <a:ext cx="1097280" cy="347472"/>
+          </a:xfrm>
+          <a:prstGeom prst="rect">
+            <a:avLst/>
+          </a:prstGeom>
+          <a:noFill/>
+        </p:spPr>
+        <p:txBody>
+          <a:bodyPr wrap="square">
+            <a:spAutoFit/>
+          </a:bodyPr>
+          <a:lstStyle/>
+          <a:p>
+            <a:pPr algn="l"/>
+            <a:r>
+              <a:rPr sz="1200" b="0" i="0">
+                <a:solidFill>
+                  <a:srgbClr val="333344"/>
+                </a:solidFill>
+                <a:latin typeface="Calibri"/>
+              </a:rPr>
+              <a:t>-12,76</a:t>
+            </a:r>
+          </a:p>
+        </p:txBody>
+      </p:sp>
+      <p:sp>
+        <p:nvSpPr>
+          <p:cNvPr id="50" name="TextBox 49"/>
+          <p:cNvSpPr txBox="1"/>
+          <p:nvPr/>
+        </p:nvSpPr>
+        <p:spPr>
+          <a:xfrm>
+            <a:off x="4983480" y="4242816"/>
+            <a:ext cx="1097280" cy="347472"/>
+          </a:xfrm>
+          <a:prstGeom prst="rect">
+            <a:avLst/>
+          </a:prstGeom>
+          <a:noFill/>
+        </p:spPr>
+        <p:txBody>
+          <a:bodyPr wrap="square">
+            <a:spAutoFit/>
+          </a:bodyPr>
+          <a:lstStyle/>
+          <a:p>
+            <a:pPr algn="l"/>
+            <a:r>
+              <a:rPr sz="1200" b="0" i="0">
+                <a:solidFill>
+                  <a:srgbClr val="333344"/>
+                </a:solidFill>
+                <a:latin typeface="Calibri"/>
+              </a:rPr>
+              <a:t>-86,28</a:t>
+            </a:r>
+          </a:p>
+        </p:txBody>
+      </p:sp>
+      <p:sp>
+        <p:nvSpPr>
+          <p:cNvPr id="51" name="TextBox 50"/>
+          <p:cNvSpPr txBox="1"/>
+          <p:nvPr/>
+        </p:nvSpPr>
+        <p:spPr>
+          <a:xfrm>
+            <a:off x="6126480" y="4242816"/>
+            <a:ext cx="1097280" cy="347472"/>
+          </a:xfrm>
+          <a:prstGeom prst="rect">
+            <a:avLst/>
+          </a:prstGeom>
+          <a:noFill/>
+        </p:spPr>
+        <p:txBody>
+          <a:bodyPr wrap="square">
+            <a:spAutoFit/>
+          </a:bodyPr>
+          <a:lstStyle/>
+          <a:p>
+            <a:pPr algn="l"/>
+            <a:r>
+              <a:rPr sz="1200" b="0" i="0">
+                <a:solidFill>
+                  <a:srgbClr val="333344"/>
+                </a:solidFill>
+                <a:latin typeface="Calibri"/>
+              </a:rPr>
+              <a:t>1,453 ± 1,003</a:t>
+            </a:r>
+          </a:p>
+        </p:txBody>
+      </p:sp>
+      <p:sp>
+        <p:nvSpPr>
+          <p:cNvPr id="52" name="TextBox 51"/>
+          <p:cNvSpPr txBox="1"/>
+          <p:nvPr/>
+        </p:nvSpPr>
+        <p:spPr>
+          <a:xfrm>
+            <a:off x="7360920" y="4242816"/>
+            <a:ext cx="1097280" cy="347472"/>
+          </a:xfrm>
+          <a:prstGeom prst="rect">
+            <a:avLst/>
+          </a:prstGeom>
+          <a:noFill/>
+        </p:spPr>
+        <p:txBody>
+          <a:bodyPr wrap="square">
+            <a:spAutoFit/>
+          </a:bodyPr>
+          <a:lstStyle/>
+          <a:p>
+            <a:pPr algn="l"/>
+            <a:r>
+              <a:rPr sz="1200" b="0" i="0">
+                <a:solidFill>
+                  <a:srgbClr val="333344"/>
+                </a:solidFill>
+                <a:latin typeface="Calibri"/>
+              </a:rPr>
+              <a:t>1,952</a:t>
+            </a:r>
+          </a:p>
+        </p:txBody>
+      </p:sp>
+      <p:sp>
+        <p:nvSpPr>
+          <p:cNvPr id="53" name="TextBox 52"/>
+          <p:cNvSpPr txBox="1"/>
+          <p:nvPr/>
+        </p:nvSpPr>
+        <p:spPr>
+          <a:xfrm>
+            <a:off x="8503920" y="4242816"/>
+            <a:ext cx="1097280" cy="347472"/>
+          </a:xfrm>
+          <a:prstGeom prst="rect">
+            <a:avLst/>
+          </a:prstGeom>
+          <a:noFill/>
+        </p:spPr>
+        <p:txBody>
+          <a:bodyPr wrap="square">
+            <a:spAutoFit/>
+          </a:bodyPr>
+          <a:lstStyle/>
+          <a:p>
+            <a:pPr algn="l"/>
+            <a:r>
+              <a:rPr sz="1200" b="0" i="0">
+                <a:solidFill>
+                  <a:srgbClr val="333344"/>
+                </a:solidFill>
+                <a:latin typeface="Calibri"/>
+              </a:rPr>
+              <a:t>160,5</a:t>
+            </a:r>
+          </a:p>
+        </p:txBody>
+      </p:sp>
+      <p:sp>
+        <p:nvSpPr>
+          <p:cNvPr id="54" name="Rectangle 53"/>
+          <p:cNvSpPr/>
+          <p:nvPr/>
+        </p:nvSpPr>
+        <p:spPr>
+          <a:xfrm>
+            <a:off x="9464040" y="4197096"/>
+            <a:ext cx="2331720" cy="438912"/>
+          </a:xfrm>
+          <a:prstGeom prst="rect">
+            <a:avLst/>
+          </a:prstGeom>
+          <a:solidFill>
+            <a:srgbClr val="FF7F11"/>
+          </a:solidFill>
+          <a:ln>
+            <a:noFill/>
+          </a:ln>
+        </p:spPr>
+        <p:style>
+          <a:lnRef idx="1">
+            <a:schemeClr val="accent1"/>
+          </a:lnRef>
+          <a:fillRef idx="3">
+            <a:schemeClr val="accent1"/>
+          </a:fillRef>
+          <a:effectRef idx="2">
+            <a:schemeClr val="accent1"/>
+          </a:effectRef>
+          <a:fontRef idx="minor">
+            <a:schemeClr val="lt1"/>
+          </a:fontRef>
+        </p:style>
+        <p:txBody>
+          <a:bodyPr rtlCol="0" anchor="ctr"/>
+          <a:lstStyle/>
+          <a:p>
+            <a:pPr algn="ctr"/>
+          </a:p>
+        </p:txBody>
+      </p:sp>
+      <p:sp>
+        <p:nvSpPr>
+          <p:cNvPr id="55" name="TextBox 54"/>
+          <p:cNvSpPr txBox="1"/>
+          <p:nvPr/>
+        </p:nvSpPr>
+        <p:spPr>
+          <a:xfrm>
+            <a:off x="9464040" y="4197096"/>
+            <a:ext cx="2331720" cy="438912"/>
+          </a:xfrm>
+          <a:prstGeom prst="rect">
+            <a:avLst/>
+          </a:prstGeom>
+          <a:noFill/>
+        </p:spPr>
+        <p:txBody>
+          <a:bodyPr wrap="square">
+            <a:spAutoFit/>
+          </a:bodyPr>
+          <a:lstStyle/>
+          <a:p>
+            <a:pPr algn="ctr"/>
+            <a:r>
+              <a:rPr sz="1300" b="1" i="0">
+                <a:solidFill>
+                  <a:srgbClr val="FFFFFF"/>
+                </a:solidFill>
+                <a:latin typeface="Calibri"/>
+              </a:rPr>
+              <a:t>Instavel</a:t>
+            </a:r>
+          </a:p>
+        </p:txBody>
+      </p:sp>
+      <p:sp>
+        <p:nvSpPr>
+          <p:cNvPr id="56" name="Rectangle 55"/>
+          <p:cNvSpPr/>
+          <p:nvPr/>
+        </p:nvSpPr>
+        <p:spPr>
+          <a:xfrm>
+            <a:off x="274320" y="4864608"/>
+            <a:ext cx="11612880" cy="777240"/>
+          </a:xfrm>
+          <a:prstGeom prst="rect">
+            <a:avLst/>
+          </a:prstGeom>
+          <a:solidFill>
+            <a:srgbClr val="F8D7DA"/>
+          </a:solidFill>
+          <a:ln>
+            <a:noFill/>
+          </a:ln>
+        </p:spPr>
+        <p:style>
+          <a:lnRef idx="1">
+            <a:schemeClr val="accent1"/>
+          </a:lnRef>
+          <a:fillRef idx="3">
+            <a:schemeClr val="accent1"/>
+          </a:fillRef>
+          <a:effectRef idx="2">
+            <a:schemeClr val="accent1"/>
+          </a:effectRef>
+          <a:fontRef idx="minor">
+            <a:schemeClr val="lt1"/>
+          </a:fontRef>
+        </p:style>
+        <p:txBody>
+          <a:bodyPr rtlCol="0" anchor="ctr"/>
+          <a:lstStyle/>
+          <a:p>
+            <a:pPr algn="ctr"/>
+          </a:p>
+        </p:txBody>
+      </p:sp>
+      <p:sp>
+        <p:nvSpPr>
+          <p:cNvPr id="57" name="Rectangle 56"/>
+          <p:cNvSpPr/>
+          <p:nvPr/>
+        </p:nvSpPr>
+        <p:spPr>
+          <a:xfrm>
+            <a:off x="274320" y="4864608"/>
+            <a:ext cx="73152" cy="777240"/>
+          </a:xfrm>
+          <a:prstGeom prst="rect">
+            <a:avLst/>
+          </a:prstGeom>
+          <a:solidFill>
+            <a:srgbClr val="FF7F11"/>
+          </a:solidFill>
+          <a:ln>
+            <a:noFill/>
+          </a:ln>
+        </p:spPr>
+        <p:style>
+          <a:lnRef idx="1">
+            <a:schemeClr val="accent1"/>
+          </a:lnRef>
+          <a:fillRef idx="3">
+            <a:schemeClr val="accent1"/>
+          </a:fillRef>
+          <a:effectRef idx="2">
+            <a:schemeClr val="accent1"/>
+          </a:effectRef>
+          <a:fontRef idx="minor">
+            <a:schemeClr val="lt1"/>
+          </a:fontRef>
+        </p:style>
+        <p:txBody>
+          <a:bodyPr rtlCol="0" anchor="ctr"/>
+          <a:lstStyle/>
+          <a:p>
+            <a:pPr algn="ctr"/>
+          </a:p>
+        </p:txBody>
+      </p:sp>
+      <p:sp>
+        <p:nvSpPr>
+          <p:cNvPr id="58" name="TextBox 57"/>
+          <p:cNvSpPr txBox="1"/>
+          <p:nvPr/>
+        </p:nvSpPr>
+        <p:spPr>
+          <a:xfrm>
+            <a:off x="411480" y="5065776"/>
+            <a:ext cx="3383280" cy="347472"/>
+          </a:xfrm>
+          <a:prstGeom prst="rect">
+            <a:avLst/>
+          </a:prstGeom>
+          <a:noFill/>
+        </p:spPr>
+        <p:txBody>
+          <a:bodyPr wrap="square">
+            <a:spAutoFit/>
+          </a:bodyPr>
+          <a:lstStyle/>
+          <a:p>
+            <a:pPr algn="l"/>
+            <a:r>
+              <a:rPr sz="1200" b="1" i="0">
+                <a:solidFill>
+                  <a:srgbClr val="0D2B55"/>
+                </a:solidFill>
+                <a:latin typeface="Calibri"/>
+              </a:rPr>
+              <a:t>SLARKRAEENAKRFLERVKK</a:t>
+            </a:r>
+          </a:p>
+        </p:txBody>
+      </p:sp>
+      <p:sp>
+        <p:nvSpPr>
+          <p:cNvPr id="59" name="TextBox 58"/>
+          <p:cNvSpPr txBox="1"/>
+          <p:nvPr/>
+        </p:nvSpPr>
+        <p:spPr>
+          <a:xfrm>
+            <a:off x="3840480" y="5065776"/>
+            <a:ext cx="1097280" cy="347472"/>
+          </a:xfrm>
+          <a:prstGeom prst="rect">
+            <a:avLst/>
+          </a:prstGeom>
+          <a:noFill/>
+        </p:spPr>
+        <p:txBody>
+          <a:bodyPr wrap="square">
+            <a:spAutoFit/>
+          </a:bodyPr>
+          <a:lstStyle/>
+          <a:p>
+            <a:pPr algn="l"/>
+            <a:r>
+              <a:rPr sz="1200" b="0" i="0">
+                <a:solidFill>
+                  <a:srgbClr val="333344"/>
+                </a:solidFill>
+                <a:latin typeface="Calibri"/>
+              </a:rPr>
+              <a:t>-12,71</a:t>
+            </a:r>
+          </a:p>
+        </p:txBody>
+      </p:sp>
+      <p:sp>
+        <p:nvSpPr>
+          <p:cNvPr id="60" name="TextBox 59"/>
+          <p:cNvSpPr txBox="1"/>
+          <p:nvPr/>
+        </p:nvSpPr>
+        <p:spPr>
+          <a:xfrm>
+            <a:off x="4983480" y="5065776"/>
+            <a:ext cx="1097280" cy="347472"/>
+          </a:xfrm>
+          <a:prstGeom prst="rect">
+            <a:avLst/>
+          </a:prstGeom>
+          <a:noFill/>
+        </p:spPr>
+        <p:txBody>
+          <a:bodyPr wrap="square">
+            <a:spAutoFit/>
+          </a:bodyPr>
+          <a:lstStyle/>
+          <a:p>
+            <a:pPr algn="l"/>
+            <a:r>
+              <a:rPr sz="1200" b="0" i="0">
+                <a:solidFill>
+                  <a:srgbClr val="333344"/>
+                </a:solidFill>
+                <a:latin typeface="Calibri"/>
+              </a:rPr>
+              <a:t>-61,41</a:t>
+            </a:r>
+          </a:p>
+        </p:txBody>
+      </p:sp>
+      <p:sp>
+        <p:nvSpPr>
+          <p:cNvPr id="61" name="TextBox 60"/>
+          <p:cNvSpPr txBox="1"/>
+          <p:nvPr/>
+        </p:nvSpPr>
+        <p:spPr>
+          <a:xfrm>
+            <a:off x="6126480" y="5065776"/>
+            <a:ext cx="1097280" cy="347472"/>
+          </a:xfrm>
+          <a:prstGeom prst="rect">
+            <a:avLst/>
+          </a:prstGeom>
+          <a:noFill/>
+        </p:spPr>
+        <p:txBody>
+          <a:bodyPr wrap="square">
+            <a:spAutoFit/>
+          </a:bodyPr>
+          <a:lstStyle/>
+          <a:p>
+            <a:pPr algn="l"/>
+            <a:r>
+              <a:rPr sz="1200" b="0" i="0">
+                <a:solidFill>
+                  <a:srgbClr val="333344"/>
+                </a:solidFill>
+                <a:latin typeface="Calibri"/>
+              </a:rPr>
+              <a:t>1,700 ± 1,033</a:t>
+            </a:r>
+          </a:p>
+        </p:txBody>
+      </p:sp>
+      <p:sp>
+        <p:nvSpPr>
+          <p:cNvPr id="62" name="TextBox 61"/>
+          <p:cNvSpPr txBox="1"/>
+          <p:nvPr/>
+        </p:nvSpPr>
+        <p:spPr>
+          <a:xfrm>
+            <a:off x="7360920" y="5065776"/>
+            <a:ext cx="1097280" cy="347472"/>
+          </a:xfrm>
+          <a:prstGeom prst="rect">
+            <a:avLst/>
+          </a:prstGeom>
+          <a:noFill/>
+        </p:spPr>
+        <p:txBody>
+          <a:bodyPr wrap="square">
+            <a:spAutoFit/>
+          </a:bodyPr>
+          <a:lstStyle/>
+          <a:p>
+            <a:pPr algn="l"/>
+            <a:r>
+              <a:rPr sz="1200" b="0" i="0">
+                <a:solidFill>
+                  <a:srgbClr val="333344"/>
+                </a:solidFill>
+                <a:latin typeface="Calibri"/>
+              </a:rPr>
+              <a:t>1,910</a:t>
+            </a:r>
+          </a:p>
+        </p:txBody>
+      </p:sp>
+      <p:sp>
+        <p:nvSpPr>
+          <p:cNvPr id="63" name="TextBox 62"/>
+          <p:cNvSpPr txBox="1"/>
+          <p:nvPr/>
+        </p:nvSpPr>
+        <p:spPr>
+          <a:xfrm>
+            <a:off x="8503920" y="5065776"/>
+            <a:ext cx="1097280" cy="347472"/>
+          </a:xfrm>
+          <a:prstGeom prst="rect">
+            <a:avLst/>
+          </a:prstGeom>
+          <a:noFill/>
+        </p:spPr>
+        <p:txBody>
+          <a:bodyPr wrap="square">
+            <a:spAutoFit/>
+          </a:bodyPr>
+          <a:lstStyle/>
+          <a:p>
+            <a:pPr algn="l"/>
+            <a:r>
+              <a:rPr sz="1200" b="0" i="0">
+                <a:solidFill>
+                  <a:srgbClr val="333344"/>
+                </a:solidFill>
+                <a:latin typeface="Calibri"/>
+              </a:rPr>
+              <a:t>170,8</a:t>
+            </a:r>
+          </a:p>
+        </p:txBody>
+      </p:sp>
+      <p:sp>
+        <p:nvSpPr>
+          <p:cNvPr id="64" name="Rectangle 63"/>
+          <p:cNvSpPr/>
+          <p:nvPr/>
+        </p:nvSpPr>
+        <p:spPr>
+          <a:xfrm>
+            <a:off x="9464040" y="5020056"/>
+            <a:ext cx="2331720" cy="438912"/>
+          </a:xfrm>
+          <a:prstGeom prst="rect">
+            <a:avLst/>
+          </a:prstGeom>
+          <a:solidFill>
+            <a:srgbClr val="FF7F11"/>
+          </a:solidFill>
+          <a:ln>
+            <a:noFill/>
+          </a:ln>
+        </p:spPr>
+        <p:style>
+          <a:lnRef idx="1">
+            <a:schemeClr val="accent1"/>
+          </a:lnRef>
+          <a:fillRef idx="3">
+            <a:schemeClr val="accent1"/>
+          </a:fillRef>
+          <a:effectRef idx="2">
+            <a:schemeClr val="accent1"/>
+          </a:effectRef>
+          <a:fontRef idx="minor">
+            <a:schemeClr val="lt1"/>
+          </a:fontRef>
+        </p:style>
+        <p:txBody>
+          <a:bodyPr rtlCol="0" anchor="ctr"/>
+          <a:lstStyle/>
+          <a:p>
+            <a:pPr algn="ctr"/>
+          </a:p>
+        </p:txBody>
+      </p:sp>
+      <p:sp>
+        <p:nvSpPr>
+          <p:cNvPr id="65" name="TextBox 64"/>
+          <p:cNvSpPr txBox="1"/>
+          <p:nvPr/>
+        </p:nvSpPr>
+        <p:spPr>
+          <a:xfrm>
+            <a:off x="9464040" y="5020056"/>
+            <a:ext cx="2331720" cy="438912"/>
+          </a:xfrm>
+          <a:prstGeom prst="rect">
+            <a:avLst/>
+          </a:prstGeom>
+          <a:noFill/>
+        </p:spPr>
+        <p:txBody>
+          <a:bodyPr wrap="square">
+            <a:spAutoFit/>
+          </a:bodyPr>
+          <a:lstStyle/>
+          <a:p>
+            <a:pPr algn="ctr"/>
+            <a:r>
+              <a:rPr sz="1300" b="1" i="0">
+                <a:solidFill>
+                  <a:srgbClr val="FFFFFF"/>
+                </a:solidFill>
+                <a:latin typeface="Calibri"/>
+              </a:rPr>
+              <a:t>Instavel</a:t>
+            </a:r>
+          </a:p>
+        </p:txBody>
+      </p:sp>
+      <p:sp>
+        <p:nvSpPr>
+          <p:cNvPr id="66" name="Rectangle 65"/>
+          <p:cNvSpPr/>
+          <p:nvPr/>
+        </p:nvSpPr>
+        <p:spPr>
+          <a:xfrm>
+            <a:off x="274320" y="5733288"/>
+            <a:ext cx="11612880" cy="960120"/>
+          </a:xfrm>
+          <a:prstGeom prst="rect">
+            <a:avLst/>
+          </a:prstGeom>
+          <a:solidFill>
+            <a:srgbClr val="0D2B55"/>
+          </a:solidFill>
+          <a:ln>
+            <a:noFill/>
+          </a:ln>
+        </p:spPr>
+        <p:style>
+          <a:lnRef idx="1">
+            <a:schemeClr val="accent1"/>
+          </a:lnRef>
+          <a:fillRef idx="3">
+            <a:schemeClr val="accent1"/>
+          </a:fillRef>
+          <a:effectRef idx="2">
+            <a:schemeClr val="accent1"/>
+          </a:effectRef>
+          <a:fontRef idx="minor">
+            <a:schemeClr val="lt1"/>
+          </a:fontRef>
+        </p:style>
+        <p:txBody>
+          <a:bodyPr rtlCol="0" anchor="ctr"/>
+          <a:lstStyle/>
+          <a:p>
+            <a:pPr algn="ctr"/>
+          </a:p>
+        </p:txBody>
+      </p:sp>
+      <p:sp>
+        <p:nvSpPr>
+          <p:cNvPr id="67" name="TextBox 66"/>
+          <p:cNvSpPr txBox="1"/>
+          <p:nvPr/>
+        </p:nvSpPr>
+        <p:spPr>
+          <a:xfrm>
+            <a:off x="457200" y="5779008"/>
+            <a:ext cx="11247120" cy="347472"/>
+          </a:xfrm>
+          <a:prstGeom prst="rect">
+            <a:avLst/>
+          </a:prstGeom>
+          <a:noFill/>
+        </p:spPr>
+        <p:txBody>
+          <a:bodyPr wrap="square">
+            <a:spAutoFit/>
+          </a:bodyPr>
+          <a:lstStyle/>
+          <a:p>
+            <a:pPr algn="l"/>
+            <a:r>
+              <a:rPr sz="1300" b="1" i="0">
                 <a:solidFill>
                   <a:srgbClr val="00B4D8"/>
                 </a:solidFill>
                 <a:latin typeface="Calibri"/>
               </a:rPr>
-              <a:t>Metricas de Estabilidade (10 ns)</a:t>
-            </a:r>
-          </a:p>
-        </p:txBody>
-      </p:sp>
-      <p:sp>
-        <p:nvSpPr>
-          <p:cNvPr id="10" name="TextBox 9"/>
-          <p:cNvSpPr txBox="1"/>
-          <p:nvPr/>
-        </p:nvSpPr>
-        <p:spPr>
-          <a:xfrm>
-            <a:off x="548640" y="1664208"/>
-            <a:ext cx="4937760" cy="274320"/>
+              <a:t>RECLASSIFICACAO FINAL (Vina + I_sc Rosetta + RMSD MD)</a:t>
+            </a:r>
+          </a:p>
+        </p:txBody>
+      </p:sp>
+      <p:sp>
+        <p:nvSpPr>
+          <p:cNvPr id="68" name="TextBox 67"/>
+          <p:cNvSpPr txBox="1"/>
+          <p:nvPr/>
+        </p:nvSpPr>
+        <p:spPr>
+          <a:xfrm>
+            <a:off x="457200" y="6144768"/>
+            <a:ext cx="11247120" cy="502920"/>
           </a:xfrm>
           <a:prstGeom prst="rect">
             <a:avLst/>
@@ -18944,1766 +21102,20 @@
           <a:p>
             <a:pPr algn="l"/>
             <a:r>
-              <a:rPr sz="1200" b="0" i="0">
+              <a:rPr sz="1100" b="0" i="0">
                 <a:solidFill>
                   <a:srgbClr val="F0F4F8"/>
                 </a:solidFill>
                 <a:latin typeface="Calibri"/>
               </a:rPr>
-              <a:t>Melhor replica (Run 4, mais equilibrado):</a:t>
-            </a:r>
-          </a:p>
-        </p:txBody>
-      </p:sp>
-      <p:sp>
-        <p:nvSpPr>
-          <p:cNvPr id="11" name="Rectangle 10"/>
-          <p:cNvSpPr/>
-          <p:nvPr/>
-        </p:nvSpPr>
-        <p:spPr>
-          <a:xfrm>
-            <a:off x="457200" y="1993392"/>
-            <a:ext cx="5120640" cy="777240"/>
-          </a:xfrm>
-          <a:prstGeom prst="rect">
-            <a:avLst/>
-          </a:prstGeom>
-          <a:solidFill>
-            <a:srgbClr val="143D6B"/>
-          </a:solidFill>
-          <a:ln>
-            <a:noFill/>
-          </a:ln>
-        </p:spPr>
-        <p:style>
-          <a:lnRef idx="1">
-            <a:schemeClr val="accent1"/>
-          </a:lnRef>
-          <a:fillRef idx="3">
-            <a:schemeClr val="accent1"/>
-          </a:fillRef>
-          <a:effectRef idx="2">
-            <a:schemeClr val="accent1"/>
-          </a:effectRef>
-          <a:fontRef idx="minor">
-            <a:schemeClr val="lt1"/>
-          </a:fontRef>
-        </p:style>
-        <p:txBody>
-          <a:bodyPr rtlCol="0" anchor="ctr"/>
-          <a:lstStyle/>
-          <a:p>
-            <a:pPr algn="ctr"/>
-          </a:p>
-        </p:txBody>
-      </p:sp>
-      <p:sp>
-        <p:nvSpPr>
-          <p:cNvPr id="12" name="Rectangle 11"/>
-          <p:cNvSpPr/>
-          <p:nvPr/>
-        </p:nvSpPr>
-        <p:spPr>
-          <a:xfrm>
-            <a:off x="457200" y="1993392"/>
-            <a:ext cx="109728" cy="777240"/>
-          </a:xfrm>
-          <a:prstGeom prst="rect">
-            <a:avLst/>
-          </a:prstGeom>
-          <a:solidFill>
-            <a:srgbClr val="06D6A0"/>
-          </a:solidFill>
-          <a:ln>
-            <a:noFill/>
-          </a:ln>
-        </p:spPr>
-        <p:style>
-          <a:lnRef idx="1">
-            <a:schemeClr val="accent1"/>
-          </a:lnRef>
-          <a:fillRef idx="3">
-            <a:schemeClr val="accent1"/>
-          </a:fillRef>
-          <a:effectRef idx="2">
-            <a:schemeClr val="accent1"/>
-          </a:effectRef>
-          <a:fontRef idx="minor">
-            <a:schemeClr val="lt1"/>
-          </a:fontRef>
-        </p:style>
-        <p:txBody>
-          <a:bodyPr rtlCol="0" anchor="ctr"/>
-          <a:lstStyle/>
-          <a:p>
-            <a:pPr algn="ctr"/>
-          </a:p>
-        </p:txBody>
-      </p:sp>
-      <p:sp>
-        <p:nvSpPr>
-          <p:cNvPr id="13" name="TextBox 12"/>
-          <p:cNvSpPr txBox="1"/>
-          <p:nvPr/>
-        </p:nvSpPr>
-        <p:spPr>
-          <a:xfrm>
-            <a:off x="658368" y="2039112"/>
-            <a:ext cx="2103120" cy="320040"/>
-          </a:xfrm>
-          <a:prstGeom prst="rect">
-            <a:avLst/>
-          </a:prstGeom>
-          <a:noFill/>
-        </p:spPr>
-        <p:txBody>
-          <a:bodyPr wrap="square">
-            <a:spAutoFit/>
-          </a:bodyPr>
-          <a:lstStyle/>
-          <a:p>
-            <a:pPr algn="l"/>
-            <a:r>
-              <a:rPr sz="1300" b="1" i="0">
-                <a:solidFill>
-                  <a:srgbClr val="F0F4F8"/>
-                </a:solidFill>
-                <a:latin typeface="Calibri"/>
-              </a:rPr>
-              <a:t>RMSD backbone</a:t>
-            </a:r>
-          </a:p>
-        </p:txBody>
-      </p:sp>
-      <p:sp>
-        <p:nvSpPr>
-          <p:cNvPr id="14" name="TextBox 13"/>
-          <p:cNvSpPr txBox="1"/>
-          <p:nvPr/>
-        </p:nvSpPr>
-        <p:spPr>
-          <a:xfrm>
-            <a:off x="2834640" y="2020824"/>
-            <a:ext cx="2651760" cy="347472"/>
-          </a:xfrm>
-          <a:prstGeom prst="rect">
-            <a:avLst/>
-          </a:prstGeom>
-          <a:noFill/>
-        </p:spPr>
-        <p:txBody>
-          <a:bodyPr wrap="square">
-            <a:spAutoFit/>
-          </a:bodyPr>
-          <a:lstStyle/>
-          <a:p>
-            <a:pPr algn="r"/>
-            <a:r>
-              <a:rPr sz="1500" b="1" i="0">
-                <a:solidFill>
-                  <a:srgbClr val="06D6A0"/>
-                </a:solidFill>
-                <a:latin typeface="Calibri"/>
-              </a:rPr>
-              <a:t>0,365 nm (avg)</a:t>
-            </a:r>
-          </a:p>
-        </p:txBody>
-      </p:sp>
-      <p:sp>
-        <p:nvSpPr>
-          <p:cNvPr id="15" name="TextBox 14"/>
-          <p:cNvSpPr txBox="1"/>
-          <p:nvPr/>
-        </p:nvSpPr>
-        <p:spPr>
-          <a:xfrm>
-            <a:off x="658368" y="2432304"/>
-            <a:ext cx="4389120" cy="274320"/>
-          </a:xfrm>
-          <a:prstGeom prst="rect">
-            <a:avLst/>
-          </a:prstGeom>
-          <a:noFill/>
-        </p:spPr>
-        <p:txBody>
-          <a:bodyPr wrap="square">
-            <a:spAutoFit/>
-          </a:bodyPr>
-          <a:lstStyle/>
-          <a:p>
-            <a:pPr algn="l"/>
-            <a:r>
-              <a:rPr sz="1000" b="0" i="1">
-                <a:solidFill>
-                  <a:srgbClr val="AABBCC"/>
-                </a:solidFill>
-                <a:latin typeface="Calibri"/>
-              </a:rPr>
-              <a:t>0,375 nm (final)</a:t>
-            </a:r>
-          </a:p>
-        </p:txBody>
-      </p:sp>
-      <p:sp>
-        <p:nvSpPr>
-          <p:cNvPr id="16" name="Rectangle 15"/>
-          <p:cNvSpPr/>
-          <p:nvPr/>
-        </p:nvSpPr>
-        <p:spPr>
-          <a:xfrm>
-            <a:off x="457200" y="2862072"/>
-            <a:ext cx="5120640" cy="777240"/>
-          </a:xfrm>
-          <a:prstGeom prst="rect">
-            <a:avLst/>
-          </a:prstGeom>
-          <a:solidFill>
-            <a:srgbClr val="143D6B"/>
-          </a:solidFill>
-          <a:ln>
-            <a:noFill/>
-          </a:ln>
-        </p:spPr>
-        <p:style>
-          <a:lnRef idx="1">
-            <a:schemeClr val="accent1"/>
-          </a:lnRef>
-          <a:fillRef idx="3">
-            <a:schemeClr val="accent1"/>
-          </a:fillRef>
-          <a:effectRef idx="2">
-            <a:schemeClr val="accent1"/>
-          </a:effectRef>
-          <a:fontRef idx="minor">
-            <a:schemeClr val="lt1"/>
-          </a:fontRef>
-        </p:style>
-        <p:txBody>
-          <a:bodyPr rtlCol="0" anchor="ctr"/>
-          <a:lstStyle/>
-          <a:p>
-            <a:pPr algn="ctr"/>
-          </a:p>
-        </p:txBody>
-      </p:sp>
-      <p:sp>
-        <p:nvSpPr>
-          <p:cNvPr id="17" name="Rectangle 16"/>
-          <p:cNvSpPr/>
-          <p:nvPr/>
-        </p:nvSpPr>
-        <p:spPr>
-          <a:xfrm>
-            <a:off x="457200" y="2862072"/>
-            <a:ext cx="109728" cy="777240"/>
-          </a:xfrm>
-          <a:prstGeom prst="rect">
-            <a:avLst/>
-          </a:prstGeom>
-          <a:solidFill>
-            <a:srgbClr val="FFD166"/>
-          </a:solidFill>
-          <a:ln>
-            <a:noFill/>
-          </a:ln>
-        </p:spPr>
-        <p:style>
-          <a:lnRef idx="1">
-            <a:schemeClr val="accent1"/>
-          </a:lnRef>
-          <a:fillRef idx="3">
-            <a:schemeClr val="accent1"/>
-          </a:fillRef>
-          <a:effectRef idx="2">
-            <a:schemeClr val="accent1"/>
-          </a:effectRef>
-          <a:fontRef idx="minor">
-            <a:schemeClr val="lt1"/>
-          </a:fontRef>
-        </p:style>
-        <p:txBody>
-          <a:bodyPr rtlCol="0" anchor="ctr"/>
-          <a:lstStyle/>
-          <a:p>
-            <a:pPr algn="ctr"/>
-          </a:p>
-        </p:txBody>
-      </p:sp>
-      <p:sp>
-        <p:nvSpPr>
-          <p:cNvPr id="18" name="TextBox 17"/>
-          <p:cNvSpPr txBox="1"/>
-          <p:nvPr/>
-        </p:nvSpPr>
-        <p:spPr>
-          <a:xfrm>
-            <a:off x="658368" y="2907791"/>
-            <a:ext cx="2103120" cy="320040"/>
-          </a:xfrm>
-          <a:prstGeom prst="rect">
-            <a:avLst/>
-          </a:prstGeom>
-          <a:noFill/>
-        </p:spPr>
-        <p:txBody>
-          <a:bodyPr wrap="square">
-            <a:spAutoFit/>
-          </a:bodyPr>
-          <a:lstStyle/>
-          <a:p>
-            <a:pPr algn="l"/>
-            <a:r>
-              <a:rPr sz="1300" b="1" i="0">
-                <a:solidFill>
-                  <a:srgbClr val="F0F4F8"/>
-                </a:solidFill>
-                <a:latin typeface="Calibri"/>
-              </a:rPr>
-              <a:t>RMSD maximo</a:t>
-            </a:r>
-          </a:p>
-        </p:txBody>
-      </p:sp>
-      <p:sp>
-        <p:nvSpPr>
-          <p:cNvPr id="19" name="TextBox 18"/>
-          <p:cNvSpPr txBox="1"/>
-          <p:nvPr/>
-        </p:nvSpPr>
-        <p:spPr>
-          <a:xfrm>
-            <a:off x="2834640" y="2889503"/>
-            <a:ext cx="2651760" cy="347472"/>
-          </a:xfrm>
-          <a:prstGeom prst="rect">
-            <a:avLst/>
-          </a:prstGeom>
-          <a:noFill/>
-        </p:spPr>
-        <p:txBody>
-          <a:bodyPr wrap="square">
-            <a:spAutoFit/>
-          </a:bodyPr>
-          <a:lstStyle/>
-          <a:p>
-            <a:pPr algn="r"/>
-            <a:r>
-              <a:rPr sz="1500" b="1" i="0">
-                <a:solidFill>
-                  <a:srgbClr val="FFD166"/>
-                </a:solidFill>
-                <a:latin typeface="Calibri"/>
-              </a:rPr>
-              <a:t>2,507 nm</a:t>
-            </a:r>
-          </a:p>
-        </p:txBody>
-      </p:sp>
-      <p:sp>
-        <p:nvSpPr>
-          <p:cNvPr id="20" name="TextBox 19"/>
-          <p:cNvSpPr txBox="1"/>
-          <p:nvPr/>
-        </p:nvSpPr>
-        <p:spPr>
-          <a:xfrm>
-            <a:off x="658368" y="3300984"/>
-            <a:ext cx="4389120" cy="274320"/>
-          </a:xfrm>
-          <a:prstGeom prst="rect">
-            <a:avLst/>
-          </a:prstGeom>
-          <a:noFill/>
-        </p:spPr>
-        <p:txBody>
-          <a:bodyPr wrap="square">
-            <a:spAutoFit/>
-          </a:bodyPr>
-          <a:lstStyle/>
-          <a:p>
-            <a:pPr algn="l"/>
-            <a:r>
-              <a:rPr sz="1000" b="0" i="1">
-                <a:solidFill>
-                  <a:srgbClr val="AABBCC"/>
-                </a:solidFill>
-                <a:latin typeface="Calibri"/>
-              </a:rPr>
-              <a:t>fase inicial (&lt;2 ns)</a:t>
-            </a:r>
-          </a:p>
-        </p:txBody>
-      </p:sp>
-      <p:sp>
-        <p:nvSpPr>
-          <p:cNvPr id="21" name="Rectangle 20"/>
-          <p:cNvSpPr/>
-          <p:nvPr/>
-        </p:nvSpPr>
-        <p:spPr>
-          <a:xfrm>
-            <a:off x="457200" y="3730752"/>
-            <a:ext cx="5120640" cy="777240"/>
-          </a:xfrm>
-          <a:prstGeom prst="rect">
-            <a:avLst/>
-          </a:prstGeom>
-          <a:solidFill>
-            <a:srgbClr val="143D6B"/>
-          </a:solidFill>
-          <a:ln>
-            <a:noFill/>
-          </a:ln>
-        </p:spPr>
-        <p:style>
-          <a:lnRef idx="1">
-            <a:schemeClr val="accent1"/>
-          </a:lnRef>
-          <a:fillRef idx="3">
-            <a:schemeClr val="accent1"/>
-          </a:fillRef>
-          <a:effectRef idx="2">
-            <a:schemeClr val="accent1"/>
-          </a:effectRef>
-          <a:fontRef idx="minor">
-            <a:schemeClr val="lt1"/>
-          </a:fontRef>
-        </p:style>
-        <p:txBody>
-          <a:bodyPr rtlCol="0" anchor="ctr"/>
-          <a:lstStyle/>
-          <a:p>
-            <a:pPr algn="ctr"/>
-          </a:p>
-        </p:txBody>
-      </p:sp>
-      <p:sp>
-        <p:nvSpPr>
-          <p:cNvPr id="22" name="Rectangle 21"/>
-          <p:cNvSpPr/>
-          <p:nvPr/>
-        </p:nvSpPr>
-        <p:spPr>
-          <a:xfrm>
-            <a:off x="457200" y="3730752"/>
-            <a:ext cx="109728" cy="777240"/>
-          </a:xfrm>
-          <a:prstGeom prst="rect">
-            <a:avLst/>
-          </a:prstGeom>
-          <a:solidFill>
-            <a:srgbClr val="06D6A0"/>
-          </a:solidFill>
-          <a:ln>
-            <a:noFill/>
-          </a:ln>
-        </p:spPr>
-        <p:style>
-          <a:lnRef idx="1">
-            <a:schemeClr val="accent1"/>
-          </a:lnRef>
-          <a:fillRef idx="3">
-            <a:schemeClr val="accent1"/>
-          </a:fillRef>
-          <a:effectRef idx="2">
-            <a:schemeClr val="accent1"/>
-          </a:effectRef>
-          <a:fontRef idx="minor">
-            <a:schemeClr val="lt1"/>
-          </a:fontRef>
-        </p:style>
-        <p:txBody>
-          <a:bodyPr rtlCol="0" anchor="ctr"/>
-          <a:lstStyle/>
-          <a:p>
-            <a:pPr algn="ctr"/>
-          </a:p>
-        </p:txBody>
-      </p:sp>
-      <p:sp>
-        <p:nvSpPr>
-          <p:cNvPr id="23" name="TextBox 22"/>
-          <p:cNvSpPr txBox="1"/>
-          <p:nvPr/>
-        </p:nvSpPr>
-        <p:spPr>
-          <a:xfrm>
-            <a:off x="658368" y="3776472"/>
-            <a:ext cx="2103120" cy="320040"/>
-          </a:xfrm>
-          <a:prstGeom prst="rect">
-            <a:avLst/>
-          </a:prstGeom>
-          <a:noFill/>
-        </p:spPr>
-        <p:txBody>
-          <a:bodyPr wrap="square">
-            <a:spAutoFit/>
-          </a:bodyPr>
-          <a:lstStyle/>
-          <a:p>
-            <a:pPr algn="l"/>
-            <a:r>
-              <a:rPr sz="1300" b="1" i="0">
-                <a:solidFill>
-                  <a:srgbClr val="F0F4F8"/>
-                </a:solidFill>
-                <a:latin typeface="Calibri"/>
-              </a:rPr>
-              <a:t>Rg complexo</a:t>
-            </a:r>
-          </a:p>
-        </p:txBody>
-      </p:sp>
-      <p:sp>
-        <p:nvSpPr>
-          <p:cNvPr id="24" name="TextBox 23"/>
-          <p:cNvSpPr txBox="1"/>
-          <p:nvPr/>
-        </p:nvSpPr>
-        <p:spPr>
-          <a:xfrm>
-            <a:off x="2834640" y="3758184"/>
-            <a:ext cx="2651760" cy="347472"/>
-          </a:xfrm>
-          <a:prstGeom prst="rect">
-            <a:avLst/>
-          </a:prstGeom>
-          <a:noFill/>
-        </p:spPr>
-        <p:txBody>
-          <a:bodyPr wrap="square">
-            <a:spAutoFit/>
-          </a:bodyPr>
-          <a:lstStyle/>
-          <a:p>
-            <a:pPr algn="r"/>
-            <a:r>
-              <a:rPr sz="1500" b="1" i="0">
-                <a:solidFill>
-                  <a:srgbClr val="06D6A0"/>
-                </a:solidFill>
-                <a:latin typeface="Calibri"/>
-              </a:rPr>
-              <a:t>1,792 nm (avg)</a:t>
-            </a:r>
-          </a:p>
-        </p:txBody>
-      </p:sp>
-      <p:sp>
-        <p:nvSpPr>
-          <p:cNvPr id="25" name="TextBox 24"/>
-          <p:cNvSpPr txBox="1"/>
-          <p:nvPr/>
-        </p:nvSpPr>
-        <p:spPr>
-          <a:xfrm>
-            <a:off x="658368" y="4169664"/>
-            <a:ext cx="4389120" cy="274320"/>
-          </a:xfrm>
-          <a:prstGeom prst="rect">
-            <a:avLst/>
-          </a:prstGeom>
-          <a:noFill/>
-        </p:spPr>
-        <p:txBody>
-          <a:bodyPr wrap="square">
-            <a:spAutoFit/>
-          </a:bodyPr>
-          <a:lstStyle/>
-          <a:p>
-            <a:pPr algn="l"/>
-            <a:r>
-              <a:rPr sz="1000" b="0" i="1">
-                <a:solidFill>
-                  <a:srgbClr val="AABBCC"/>
-                </a:solidFill>
-                <a:latin typeface="Calibri"/>
-              </a:rPr>
-              <a:t>std = 0,023 nm</a:t>
-            </a:r>
-          </a:p>
-        </p:txBody>
-      </p:sp>
-      <p:sp>
-        <p:nvSpPr>
-          <p:cNvPr id="26" name="Rectangle 25"/>
-          <p:cNvSpPr/>
-          <p:nvPr/>
-        </p:nvSpPr>
-        <p:spPr>
-          <a:xfrm>
-            <a:off x="457200" y="4599431"/>
-            <a:ext cx="5120640" cy="777240"/>
-          </a:xfrm>
-          <a:prstGeom prst="rect">
-            <a:avLst/>
-          </a:prstGeom>
-          <a:solidFill>
-            <a:srgbClr val="143D6B"/>
-          </a:solidFill>
-          <a:ln>
-            <a:noFill/>
-          </a:ln>
-        </p:spPr>
-        <p:style>
-          <a:lnRef idx="1">
-            <a:schemeClr val="accent1"/>
-          </a:lnRef>
-          <a:fillRef idx="3">
-            <a:schemeClr val="accent1"/>
-          </a:fillRef>
-          <a:effectRef idx="2">
-            <a:schemeClr val="accent1"/>
-          </a:effectRef>
-          <a:fontRef idx="minor">
-            <a:schemeClr val="lt1"/>
-          </a:fontRef>
-        </p:style>
-        <p:txBody>
-          <a:bodyPr rtlCol="0" anchor="ctr"/>
-          <a:lstStyle/>
-          <a:p>
-            <a:pPr algn="ctr"/>
-          </a:p>
-        </p:txBody>
-      </p:sp>
-      <p:sp>
-        <p:nvSpPr>
-          <p:cNvPr id="27" name="Rectangle 26"/>
-          <p:cNvSpPr/>
-          <p:nvPr/>
-        </p:nvSpPr>
-        <p:spPr>
-          <a:xfrm>
-            <a:off x="457200" y="4599431"/>
-            <a:ext cx="109728" cy="777240"/>
-          </a:xfrm>
-          <a:prstGeom prst="rect">
-            <a:avLst/>
-          </a:prstGeom>
-          <a:solidFill>
-            <a:srgbClr val="00B4D8"/>
-          </a:solidFill>
-          <a:ln>
-            <a:noFill/>
-          </a:ln>
-        </p:spPr>
-        <p:style>
-          <a:lnRef idx="1">
-            <a:schemeClr val="accent1"/>
-          </a:lnRef>
-          <a:fillRef idx="3">
-            <a:schemeClr val="accent1"/>
-          </a:fillRef>
-          <a:effectRef idx="2">
-            <a:schemeClr val="accent1"/>
-          </a:effectRef>
-          <a:fontRef idx="minor">
-            <a:schemeClr val="lt1"/>
-          </a:fontRef>
-        </p:style>
-        <p:txBody>
-          <a:bodyPr rtlCol="0" anchor="ctr"/>
-          <a:lstStyle/>
-          <a:p>
-            <a:pPr algn="ctr"/>
-          </a:p>
-        </p:txBody>
-      </p:sp>
-      <p:sp>
-        <p:nvSpPr>
-          <p:cNvPr id="28" name="TextBox 27"/>
-          <p:cNvSpPr txBox="1"/>
-          <p:nvPr/>
-        </p:nvSpPr>
-        <p:spPr>
-          <a:xfrm>
-            <a:off x="658368" y="4645151"/>
-            <a:ext cx="2103120" cy="320040"/>
-          </a:xfrm>
-          <a:prstGeom prst="rect">
-            <a:avLst/>
-          </a:prstGeom>
-          <a:noFill/>
-        </p:spPr>
-        <p:txBody>
-          <a:bodyPr wrap="square">
-            <a:spAutoFit/>
-          </a:bodyPr>
-          <a:lstStyle/>
-          <a:p>
-            <a:pPr algn="l"/>
-            <a:r>
-              <a:rPr sz="1300" b="1" i="0">
-                <a:solidFill>
-                  <a:srgbClr val="F0F4F8"/>
-                </a:solidFill>
-                <a:latin typeface="Calibri"/>
-              </a:rPr>
-              <a:t>H-bonds sist.</a:t>
-            </a:r>
-          </a:p>
-        </p:txBody>
-      </p:sp>
-      <p:sp>
-        <p:nvSpPr>
-          <p:cNvPr id="29" name="TextBox 28"/>
-          <p:cNvSpPr txBox="1"/>
-          <p:nvPr/>
-        </p:nvSpPr>
-        <p:spPr>
-          <a:xfrm>
-            <a:off x="2834640" y="4626864"/>
-            <a:ext cx="2651760" cy="347472"/>
-          </a:xfrm>
-          <a:prstGeom prst="rect">
-            <a:avLst/>
-          </a:prstGeom>
-          <a:noFill/>
-        </p:spPr>
-        <p:txBody>
-          <a:bodyPr wrap="square">
-            <a:spAutoFit/>
-          </a:bodyPr>
-          <a:lstStyle/>
-          <a:p>
-            <a:pPr algn="r"/>
-            <a:r>
-              <a:rPr sz="1500" b="1" i="0">
-                <a:solidFill>
-                  <a:srgbClr val="00B4D8"/>
-                </a:solidFill>
-                <a:latin typeface="Calibri"/>
-              </a:rPr>
-              <a:t>160,1 (avg)</a:t>
-            </a:r>
-          </a:p>
-        </p:txBody>
-      </p:sp>
-      <p:sp>
-        <p:nvSpPr>
-          <p:cNvPr id="30" name="TextBox 29"/>
-          <p:cNvSpPr txBox="1"/>
-          <p:nvPr/>
-        </p:nvSpPr>
-        <p:spPr>
-          <a:xfrm>
-            <a:off x="658368" y="5038344"/>
-            <a:ext cx="4389120" cy="274320"/>
-          </a:xfrm>
-          <a:prstGeom prst="rect">
-            <a:avLst/>
-          </a:prstGeom>
-          <a:noFill/>
-        </p:spPr>
-        <p:txBody>
-          <a:bodyPr wrap="square">
-            <a:spAutoFit/>
-          </a:bodyPr>
-          <a:lstStyle/>
-          <a:p>
-            <a:pPr algn="l"/>
-            <a:r>
-              <a:rPr sz="1000" b="0" i="1">
-                <a:solidFill>
-                  <a:srgbClr val="AABBCC"/>
-                </a:solidFill>
-                <a:latin typeface="Calibri"/>
-              </a:rPr>
-              <a:t>max 182</a:t>
-            </a:r>
-          </a:p>
-        </p:txBody>
-      </p:sp>
-      <p:sp>
-        <p:nvSpPr>
-          <p:cNvPr id="31" name="TextBox 30"/>
-          <p:cNvSpPr txBox="1"/>
-          <p:nvPr/>
-        </p:nvSpPr>
-        <p:spPr>
-          <a:xfrm>
-            <a:off x="548640" y="5532120"/>
-            <a:ext cx="4937760" cy="256032"/>
-          </a:xfrm>
-          <a:prstGeom prst="rect">
-            <a:avLst/>
-          </a:prstGeom>
-          <a:noFill/>
-        </p:spPr>
-        <p:txBody>
-          <a:bodyPr wrap="square">
-            <a:spAutoFit/>
-          </a:bodyPr>
-          <a:lstStyle/>
-          <a:p>
-            <a:pPr algn="l"/>
-            <a:r>
-              <a:rPr sz="1100" b="0" i="0">
-                <a:solidFill>
-                  <a:srgbClr val="F0F4F8"/>
-                </a:solidFill>
-                <a:latin typeface="Calibri"/>
-              </a:rPr>
-              <a:t>Replica Run 3 (ref. adicional):</a:t>
-            </a:r>
-          </a:p>
-        </p:txBody>
-      </p:sp>
-      <p:sp>
-        <p:nvSpPr>
-          <p:cNvPr id="32" name="TextBox 31"/>
-          <p:cNvSpPr txBox="1"/>
-          <p:nvPr/>
-        </p:nvSpPr>
-        <p:spPr>
-          <a:xfrm>
-            <a:off x="548640" y="5788152"/>
-            <a:ext cx="4937760" cy="256032"/>
-          </a:xfrm>
-          <a:prstGeom prst="rect">
-            <a:avLst/>
-          </a:prstGeom>
-          <a:noFill/>
-        </p:spPr>
-        <p:txBody>
-          <a:bodyPr wrap="square">
-            <a:spAutoFit/>
-          </a:bodyPr>
-          <a:lstStyle/>
-          <a:p>
-            <a:pPr algn="l"/>
-            <a:r>
-              <a:rPr sz="1000" b="0" i="1">
-                <a:solidFill>
-                  <a:srgbClr val="8899AA"/>
-                </a:solidFill>
-                <a:latin typeface="Calibri"/>
-              </a:rPr>
-              <a:t>RMSD avg 0,522 nm | final 0,462 nm | Rg 1,840 ± 0,077 nm | Hbond avg 169,0</a:t>
-            </a:r>
-          </a:p>
-        </p:txBody>
-      </p:sp>
-      <p:sp>
-        <p:nvSpPr>
-          <p:cNvPr id="33" name="TextBox 32"/>
-          <p:cNvSpPr txBox="1"/>
-          <p:nvPr/>
-        </p:nvSpPr>
-        <p:spPr>
-          <a:xfrm>
-            <a:off x="548640" y="6035040"/>
-            <a:ext cx="4937760" cy="256032"/>
-          </a:xfrm>
-          <a:prstGeom prst="rect">
-            <a:avLst/>
-          </a:prstGeom>
-          <a:noFill/>
-        </p:spPr>
-        <p:txBody>
-          <a:bodyPr wrap="square">
-            <a:spAutoFit/>
-          </a:bodyPr>
-          <a:lstStyle/>
-          <a:p>
-            <a:pPr algn="l"/>
-            <a:r>
-              <a:rPr sz="900" b="0" i="1">
-                <a:solidFill>
-                  <a:srgbClr val="667788"/>
-                </a:solidFill>
-                <a:latin typeface="Calibri"/>
-              </a:rPr>
-              <a:t>Consistente com Run 4 — convergencia progressiva entre replicas (1,20-&gt;0,52-&gt;0,37 nm avg RMSD)</a:t>
-            </a:r>
-          </a:p>
-        </p:txBody>
-      </p:sp>
-      <p:sp>
-        <p:nvSpPr>
-          <p:cNvPr id="34" name="Rectangle 33"/>
-          <p:cNvSpPr/>
-          <p:nvPr/>
-        </p:nvSpPr>
-        <p:spPr>
-          <a:xfrm>
-            <a:off x="5943600" y="1143000"/>
-            <a:ext cx="5852160" cy="5212080"/>
-          </a:xfrm>
-          <a:prstGeom prst="rect">
-            <a:avLst/>
-          </a:prstGeom>
-          <a:solidFill>
-            <a:srgbClr val="FFFFFF"/>
-          </a:solidFill>
-          <a:ln>
-            <a:noFill/>
-          </a:ln>
-        </p:spPr>
-        <p:style>
-          <a:lnRef idx="1">
-            <a:schemeClr val="accent1"/>
-          </a:lnRef>
-          <a:fillRef idx="3">
-            <a:schemeClr val="accent1"/>
-          </a:fillRef>
-          <a:effectRef idx="2">
-            <a:schemeClr val="accent1"/>
-          </a:effectRef>
-          <a:fontRef idx="minor">
-            <a:schemeClr val="lt1"/>
-          </a:fontRef>
-        </p:style>
-        <p:txBody>
-          <a:bodyPr rtlCol="0" anchor="ctr"/>
-          <a:lstStyle/>
-          <a:p>
-            <a:pPr algn="ctr"/>
-          </a:p>
-        </p:txBody>
-      </p:sp>
-      <p:sp>
-        <p:nvSpPr>
-          <p:cNvPr id="35" name="Rectangle 34"/>
-          <p:cNvSpPr/>
-          <p:nvPr/>
-        </p:nvSpPr>
-        <p:spPr>
-          <a:xfrm>
-            <a:off x="5943600" y="1143000"/>
-            <a:ext cx="5852160" cy="45720"/>
-          </a:xfrm>
-          <a:prstGeom prst="rect">
-            <a:avLst/>
-          </a:prstGeom>
-          <a:solidFill>
-            <a:srgbClr val="06D6A0"/>
-          </a:solidFill>
-          <a:ln>
-            <a:noFill/>
-          </a:ln>
-        </p:spPr>
-        <p:style>
-          <a:lnRef idx="1">
-            <a:schemeClr val="accent1"/>
-          </a:lnRef>
-          <a:fillRef idx="3">
-            <a:schemeClr val="accent1"/>
-          </a:fillRef>
-          <a:effectRef idx="2">
-            <a:schemeClr val="accent1"/>
-          </a:effectRef>
-          <a:fontRef idx="minor">
-            <a:schemeClr val="lt1"/>
-          </a:fontRef>
-        </p:style>
-        <p:txBody>
-          <a:bodyPr rtlCol="0" anchor="ctr"/>
-          <a:lstStyle/>
-          <a:p>
-            <a:pPr algn="ctr"/>
-          </a:p>
-        </p:txBody>
-      </p:sp>
-      <p:sp>
-        <p:nvSpPr>
-          <p:cNvPr id="36" name="TextBox 35"/>
-          <p:cNvSpPr txBox="1"/>
-          <p:nvPr/>
-        </p:nvSpPr>
-        <p:spPr>
-          <a:xfrm>
-            <a:off x="6126480" y="1207008"/>
-            <a:ext cx="5486400" cy="384048"/>
-          </a:xfrm>
-          <a:prstGeom prst="rect">
-            <a:avLst/>
-          </a:prstGeom>
-          <a:noFill/>
-        </p:spPr>
-        <p:txBody>
-          <a:bodyPr wrap="square">
-            <a:spAutoFit/>
-          </a:bodyPr>
-          <a:lstStyle/>
-          <a:p>
-            <a:pPr algn="l"/>
-            <a:r>
-              <a:rPr sz="1500" b="1" i="0">
-                <a:solidFill>
-                  <a:srgbClr val="0D2B55"/>
-                </a:solidFill>
-                <a:latin typeface="Calibri"/>
-              </a:rPr>
-              <a:t>Interpretacao</a:t>
-            </a:r>
-          </a:p>
-        </p:txBody>
-      </p:sp>
-      <p:sp>
-        <p:nvSpPr>
-          <p:cNvPr id="37" name="Rectangle 36"/>
-          <p:cNvSpPr/>
-          <p:nvPr/>
-        </p:nvSpPr>
-        <p:spPr>
-          <a:xfrm>
-            <a:off x="6035040" y="1627632"/>
-            <a:ext cx="109728" cy="640080"/>
-          </a:xfrm>
-          <a:prstGeom prst="rect">
-            <a:avLst/>
-          </a:prstGeom>
-          <a:solidFill>
-            <a:srgbClr val="06D6A0"/>
-          </a:solidFill>
-          <a:ln>
-            <a:noFill/>
-          </a:ln>
-        </p:spPr>
-        <p:style>
-          <a:lnRef idx="1">
-            <a:schemeClr val="accent1"/>
-          </a:lnRef>
-          <a:fillRef idx="3">
-            <a:schemeClr val="accent1"/>
-          </a:fillRef>
-          <a:effectRef idx="2">
-            <a:schemeClr val="accent1"/>
-          </a:effectRef>
-          <a:fontRef idx="minor">
-            <a:schemeClr val="lt1"/>
-          </a:fontRef>
-        </p:style>
-        <p:txBody>
-          <a:bodyPr rtlCol="0" anchor="ctr"/>
-          <a:lstStyle/>
-          <a:p>
-            <a:pPr algn="ctr"/>
-          </a:p>
-        </p:txBody>
-      </p:sp>
-      <p:sp>
-        <p:nvSpPr>
-          <p:cNvPr id="38" name="TextBox 37"/>
-          <p:cNvSpPr txBox="1"/>
-          <p:nvPr/>
-        </p:nvSpPr>
-        <p:spPr>
-          <a:xfrm>
-            <a:off x="6217920" y="1645920"/>
-            <a:ext cx="5394960" cy="274320"/>
-          </a:xfrm>
-          <a:prstGeom prst="rect">
-            <a:avLst/>
-          </a:prstGeom>
-          <a:noFill/>
-        </p:spPr>
-        <p:txBody>
-          <a:bodyPr wrap="square">
-            <a:spAutoFit/>
-          </a:bodyPr>
-          <a:lstStyle/>
-          <a:p>
-            <a:pPr algn="l"/>
-            <a:r>
-              <a:rPr sz="1200" b="1" i="0">
-                <a:solidFill>
-                  <a:srgbClr val="0D2B55"/>
-                </a:solidFill>
-                <a:latin typeface="Calibri"/>
-              </a:rPr>
-              <a:t>RMSD &lt; 0,5 nm ao final (0,375 nm)</a:t>
-            </a:r>
-          </a:p>
-        </p:txBody>
-      </p:sp>
-      <p:sp>
-        <p:nvSpPr>
-          <p:cNvPr id="39" name="TextBox 38"/>
-          <p:cNvSpPr txBox="1"/>
-          <p:nvPr/>
-        </p:nvSpPr>
-        <p:spPr>
-          <a:xfrm>
-            <a:off x="6217920" y="1938528"/>
-            <a:ext cx="5394960" cy="384048"/>
-          </a:xfrm>
-          <a:prstGeom prst="rect">
-            <a:avLst/>
-          </a:prstGeom>
-          <a:noFill/>
-        </p:spPr>
-        <p:txBody>
-          <a:bodyPr wrap="square">
-            <a:spAutoFit/>
-          </a:bodyPr>
-          <a:lstStyle/>
-          <a:p>
-            <a:pPr algn="l"/>
-            <a:r>
-              <a:rPr sz="1100" b="0" i="0">
-                <a:solidFill>
-                  <a:srgbClr val="333344"/>
-                </a:solidFill>
-                <a:latin typeface="Calibri"/>
-              </a:rPr>
-              <a:t>Peptideo MANTEM pose de ligacao em 10 ns. Sem dissociacao.</a:t>
-            </a:r>
-          </a:p>
-        </p:txBody>
-      </p:sp>
-      <p:sp>
-        <p:nvSpPr>
-          <p:cNvPr id="40" name="Rectangle 39"/>
-          <p:cNvSpPr/>
-          <p:nvPr/>
-        </p:nvSpPr>
-        <p:spPr>
-          <a:xfrm>
-            <a:off x="6035040" y="2377440"/>
-            <a:ext cx="109728" cy="640080"/>
-          </a:xfrm>
-          <a:prstGeom prst="rect">
-            <a:avLst/>
-          </a:prstGeom>
-          <a:solidFill>
-            <a:srgbClr val="06D6A0"/>
-          </a:solidFill>
-          <a:ln>
-            <a:noFill/>
-          </a:ln>
-        </p:spPr>
-        <p:style>
-          <a:lnRef idx="1">
-            <a:schemeClr val="accent1"/>
-          </a:lnRef>
-          <a:fillRef idx="3">
-            <a:schemeClr val="accent1"/>
-          </a:fillRef>
-          <a:effectRef idx="2">
-            <a:schemeClr val="accent1"/>
-          </a:effectRef>
-          <a:fontRef idx="minor">
-            <a:schemeClr val="lt1"/>
-          </a:fontRef>
-        </p:style>
-        <p:txBody>
-          <a:bodyPr rtlCol="0" anchor="ctr"/>
-          <a:lstStyle/>
-          <a:p>
-            <a:pPr algn="ctr"/>
-          </a:p>
-        </p:txBody>
-      </p:sp>
-      <p:sp>
-        <p:nvSpPr>
-          <p:cNvPr id="41" name="TextBox 40"/>
-          <p:cNvSpPr txBox="1"/>
-          <p:nvPr/>
-        </p:nvSpPr>
-        <p:spPr>
-          <a:xfrm>
-            <a:off x="6217920" y="2395728"/>
-            <a:ext cx="5394960" cy="274320"/>
-          </a:xfrm>
-          <a:prstGeom prst="rect">
-            <a:avLst/>
-          </a:prstGeom>
-          <a:noFill/>
-        </p:spPr>
-        <p:txBody>
-          <a:bodyPr wrap="square">
-            <a:spAutoFit/>
-          </a:bodyPr>
-          <a:lstStyle/>
-          <a:p>
-            <a:pPr algn="l"/>
-            <a:r>
-              <a:rPr sz="1200" b="1" i="0">
-                <a:solidFill>
-                  <a:srgbClr val="0D2B55"/>
-                </a:solidFill>
-                <a:latin typeface="Calibri"/>
-              </a:rPr>
-              <a:t>Rg 1,792 nm, std 0,023 nm</a:t>
-            </a:r>
-          </a:p>
-        </p:txBody>
-      </p:sp>
-      <p:sp>
-        <p:nvSpPr>
-          <p:cNvPr id="42" name="TextBox 41"/>
-          <p:cNvSpPr txBox="1"/>
-          <p:nvPr/>
-        </p:nvSpPr>
-        <p:spPr>
-          <a:xfrm>
-            <a:off x="6217920" y="2688336"/>
-            <a:ext cx="5394960" cy="384048"/>
-          </a:xfrm>
-          <a:prstGeom prst="rect">
-            <a:avLst/>
-          </a:prstGeom>
-          <a:noFill/>
-        </p:spPr>
-        <p:txBody>
-          <a:bodyPr wrap="square">
-            <a:spAutoFit/>
-          </a:bodyPr>
-          <a:lstStyle/>
-          <a:p>
-            <a:pPr algn="l"/>
-            <a:r>
-              <a:rPr sz="1100" b="0" i="0">
-                <a:solidFill>
-                  <a:srgbClr val="333344"/>
-                </a:solidFill>
-                <a:latin typeface="Calibri"/>
-              </a:rPr>
-              <a:t>ACR157 mantem compacidade estrutural. Sem desnaturacao.</a:t>
-            </a:r>
-          </a:p>
-        </p:txBody>
-      </p:sp>
-      <p:sp>
-        <p:nvSpPr>
-          <p:cNvPr id="43" name="Rectangle 42"/>
-          <p:cNvSpPr/>
-          <p:nvPr/>
-        </p:nvSpPr>
-        <p:spPr>
-          <a:xfrm>
-            <a:off x="6035040" y="3127248"/>
-            <a:ext cx="109728" cy="640080"/>
-          </a:xfrm>
-          <a:prstGeom prst="rect">
-            <a:avLst/>
-          </a:prstGeom>
-          <a:solidFill>
-            <a:srgbClr val="FFD166"/>
-          </a:solidFill>
-          <a:ln>
-            <a:noFill/>
-          </a:ln>
-        </p:spPr>
-        <p:style>
-          <a:lnRef idx="1">
-            <a:schemeClr val="accent1"/>
-          </a:lnRef>
-          <a:fillRef idx="3">
-            <a:schemeClr val="accent1"/>
-          </a:fillRef>
-          <a:effectRef idx="2">
-            <a:schemeClr val="accent1"/>
-          </a:effectRef>
-          <a:fontRef idx="minor">
-            <a:schemeClr val="lt1"/>
-          </a:fontRef>
-        </p:style>
-        <p:txBody>
-          <a:bodyPr rtlCol="0" anchor="ctr"/>
-          <a:lstStyle/>
-          <a:p>
-            <a:pPr algn="ctr"/>
-          </a:p>
-        </p:txBody>
-      </p:sp>
-      <p:sp>
-        <p:nvSpPr>
-          <p:cNvPr id="44" name="TextBox 43"/>
-          <p:cNvSpPr txBox="1"/>
-          <p:nvPr/>
-        </p:nvSpPr>
-        <p:spPr>
-          <a:xfrm>
-            <a:off x="6217920" y="3145536"/>
-            <a:ext cx="5394960" cy="274320"/>
-          </a:xfrm>
-          <a:prstGeom prst="rect">
-            <a:avLst/>
-          </a:prstGeom>
-          <a:noFill/>
-        </p:spPr>
-        <p:txBody>
-          <a:bodyPr wrap="square">
-            <a:spAutoFit/>
-          </a:bodyPr>
-          <a:lstStyle/>
-          <a:p>
-            <a:pPr algn="l"/>
-            <a:r>
-              <a:rPr sz="1200" b="1" i="0">
-                <a:solidFill>
-                  <a:srgbClr val="0D2B55"/>
-                </a:solidFill>
-                <a:latin typeface="Calibri"/>
-              </a:rPr>
-              <a:t>Pico RMSD ~2,5 nm em t&lt;2 ns</a:t>
-            </a:r>
-          </a:p>
-        </p:txBody>
-      </p:sp>
-      <p:sp>
-        <p:nvSpPr>
-          <p:cNvPr id="45" name="TextBox 44"/>
-          <p:cNvSpPr txBox="1"/>
-          <p:nvPr/>
-        </p:nvSpPr>
-        <p:spPr>
-          <a:xfrm>
-            <a:off x="6217920" y="3438144"/>
-            <a:ext cx="5394960" cy="384048"/>
-          </a:xfrm>
-          <a:prstGeom prst="rect">
-            <a:avLst/>
-          </a:prstGeom>
-          <a:noFill/>
-        </p:spPr>
-        <p:txBody>
-          <a:bodyPr wrap="square">
-            <a:spAutoFit/>
-          </a:bodyPr>
-          <a:lstStyle/>
-          <a:p>
-            <a:pPr algn="l"/>
-            <a:r>
-              <a:rPr sz="1100" b="0" i="0">
-                <a:solidFill>
-                  <a:srgbClr val="333344"/>
-                </a:solidFill>
-                <a:latin typeface="Calibri"/>
-              </a:rPr>
-              <a:t>Relaxamento inicial do complexo — comportamento normal. Pose estavel apos equilibracao.</a:t>
-            </a:r>
-          </a:p>
-        </p:txBody>
-      </p:sp>
-      <p:sp>
-        <p:nvSpPr>
-          <p:cNvPr id="46" name="Rectangle 45"/>
-          <p:cNvSpPr/>
-          <p:nvPr/>
-        </p:nvSpPr>
-        <p:spPr>
-          <a:xfrm>
-            <a:off x="6035040" y="3877056"/>
-            <a:ext cx="109728" cy="640080"/>
-          </a:xfrm>
-          <a:prstGeom prst="rect">
-            <a:avLst/>
-          </a:prstGeom>
-          <a:solidFill>
-            <a:srgbClr val="00B4D8"/>
-          </a:solidFill>
-          <a:ln>
-            <a:noFill/>
-          </a:ln>
-        </p:spPr>
-        <p:style>
-          <a:lnRef idx="1">
-            <a:schemeClr val="accent1"/>
-          </a:lnRef>
-          <a:fillRef idx="3">
-            <a:schemeClr val="accent1"/>
-          </a:fillRef>
-          <a:effectRef idx="2">
-            <a:schemeClr val="accent1"/>
-          </a:effectRef>
-          <a:fontRef idx="minor">
-            <a:schemeClr val="lt1"/>
-          </a:fontRef>
-        </p:style>
-        <p:txBody>
-          <a:bodyPr rtlCol="0" anchor="ctr"/>
-          <a:lstStyle/>
-          <a:p>
-            <a:pPr algn="ctr"/>
-          </a:p>
-        </p:txBody>
-      </p:sp>
-      <p:sp>
-        <p:nvSpPr>
-          <p:cNvPr id="47" name="TextBox 46"/>
-          <p:cNvSpPr txBox="1"/>
-          <p:nvPr/>
-        </p:nvSpPr>
-        <p:spPr>
-          <a:xfrm>
-            <a:off x="6217920" y="3895344"/>
-            <a:ext cx="5394960" cy="274320"/>
-          </a:xfrm>
-          <a:prstGeom prst="rect">
-            <a:avLst/>
-          </a:prstGeom>
-          <a:noFill/>
-        </p:spPr>
-        <p:txBody>
-          <a:bodyPr wrap="square">
-            <a:spAutoFit/>
-          </a:bodyPr>
-          <a:lstStyle/>
-          <a:p>
-            <a:pPr algn="l"/>
-            <a:r>
-              <a:rPr sz="1200" b="1" i="0">
-                <a:solidFill>
-                  <a:srgbClr val="0D2B55"/>
-                </a:solidFill>
-                <a:latin typeface="Calibri"/>
-              </a:rPr>
-              <a:t>H-bonds sistema avg 160</a:t>
-            </a:r>
-          </a:p>
-        </p:txBody>
-      </p:sp>
-      <p:sp>
-        <p:nvSpPr>
-          <p:cNvPr id="48" name="TextBox 47"/>
-          <p:cNvSpPr txBox="1"/>
-          <p:nvPr/>
-        </p:nvSpPr>
-        <p:spPr>
-          <a:xfrm>
-            <a:off x="6217920" y="4187952"/>
-            <a:ext cx="5394960" cy="384048"/>
-          </a:xfrm>
-          <a:prstGeom prst="rect">
-            <a:avLst/>
-          </a:prstGeom>
-          <a:noFill/>
-        </p:spPr>
-        <p:txBody>
-          <a:bodyPr wrap="square">
-            <a:spAutoFit/>
-          </a:bodyPr>
-          <a:lstStyle/>
-          <a:p>
-            <a:pPr algn="l"/>
-            <a:r>
-              <a:rPr sz="1100" b="0" i="0">
-                <a:solidFill>
-                  <a:srgbClr val="333344"/>
-                </a:solidFill>
-                <a:latin typeface="Calibri"/>
-              </a:rPr>
-              <a:t>Total proteina+peptideo (inter+intramolecular). Interface especifica sera quantificada em analise posterior.</a:t>
-            </a:r>
-          </a:p>
-        </p:txBody>
-      </p:sp>
-      <p:sp>
-        <p:nvSpPr>
-          <p:cNvPr id="49" name="Rectangle 48"/>
-          <p:cNvSpPr/>
-          <p:nvPr/>
-        </p:nvSpPr>
-        <p:spPr>
-          <a:xfrm>
-            <a:off x="6035040" y="4626864"/>
-            <a:ext cx="109728" cy="640080"/>
-          </a:xfrm>
-          <a:prstGeom prst="rect">
-            <a:avLst/>
-          </a:prstGeom>
-          <a:solidFill>
-            <a:srgbClr val="00B4D8"/>
-          </a:solidFill>
-          <a:ln>
-            <a:noFill/>
-          </a:ln>
-        </p:spPr>
-        <p:style>
-          <a:lnRef idx="1">
-            <a:schemeClr val="accent1"/>
-          </a:lnRef>
-          <a:fillRef idx="3">
-            <a:schemeClr val="accent1"/>
-          </a:fillRef>
-          <a:effectRef idx="2">
-            <a:schemeClr val="accent1"/>
-          </a:effectRef>
-          <a:fontRef idx="minor">
-            <a:schemeClr val="lt1"/>
-          </a:fontRef>
-        </p:style>
-        <p:txBody>
-          <a:bodyPr rtlCol="0" anchor="ctr"/>
-          <a:lstStyle/>
-          <a:p>
-            <a:pPr algn="ctr"/>
-          </a:p>
-        </p:txBody>
-      </p:sp>
-      <p:sp>
-        <p:nvSpPr>
-          <p:cNvPr id="50" name="TextBox 49"/>
-          <p:cNvSpPr txBox="1"/>
-          <p:nvPr/>
-        </p:nvSpPr>
-        <p:spPr>
-          <a:xfrm>
-            <a:off x="6217920" y="4645151"/>
-            <a:ext cx="5394960" cy="274320"/>
-          </a:xfrm>
-          <a:prstGeom prst="rect">
-            <a:avLst/>
-          </a:prstGeom>
-          <a:noFill/>
-        </p:spPr>
-        <p:txBody>
-          <a:bodyPr wrap="square">
-            <a:spAutoFit/>
-          </a:bodyPr>
-          <a:lstStyle/>
-          <a:p>
-            <a:pPr algn="l"/>
-            <a:r>
-              <a:rPr sz="1200" b="1" i="0">
-                <a:solidFill>
-                  <a:srgbClr val="0D2B55"/>
-                </a:solidFill>
-                <a:latin typeface="Calibri"/>
-              </a:rPr>
-              <a:t>Mecanismo proposto</a:t>
-            </a:r>
-          </a:p>
-        </p:txBody>
-      </p:sp>
-      <p:sp>
-        <p:nvSpPr>
-          <p:cNvPr id="51" name="TextBox 50"/>
-          <p:cNvSpPr txBox="1"/>
-          <p:nvPr/>
-        </p:nvSpPr>
-        <p:spPr>
-          <a:xfrm>
-            <a:off x="6217920" y="4937759"/>
-            <a:ext cx="5394960" cy="384048"/>
-          </a:xfrm>
-          <a:prstGeom prst="rect">
-            <a:avLst/>
-          </a:prstGeom>
-          <a:noFill/>
-        </p:spPr>
-        <p:txBody>
-          <a:bodyPr wrap="square">
-            <a:spAutoFit/>
-          </a:bodyPr>
-          <a:lstStyle/>
-          <a:p>
-            <a:pPr algn="l"/>
-            <a:r>
-              <a:rPr sz="1100" b="0" i="0">
-                <a:solidFill>
-                  <a:srgbClr val="333344"/>
-                </a:solidFill>
-                <a:latin typeface="Calibri"/>
-              </a:rPr>
-              <a:t>Seg. GSRASA-R ancora Asp205 (S1) via guanidinio^2+. C-term RARRAAL contribui contatos secundarios.</a:t>
-            </a:r>
-          </a:p>
-        </p:txBody>
-      </p:sp>
-      <p:sp>
-        <p:nvSpPr>
-          <p:cNvPr id="52" name="Rectangle 51"/>
-          <p:cNvSpPr/>
-          <p:nvPr/>
-        </p:nvSpPr>
-        <p:spPr>
-          <a:xfrm>
-            <a:off x="6035040" y="5376672"/>
-            <a:ext cx="109728" cy="640080"/>
-          </a:xfrm>
-          <a:prstGeom prst="rect">
-            <a:avLst/>
-          </a:prstGeom>
-          <a:solidFill>
-            <a:srgbClr val="06D6A0"/>
-          </a:solidFill>
-          <a:ln>
-            <a:noFill/>
-          </a:ln>
-        </p:spPr>
-        <p:style>
-          <a:lnRef idx="1">
-            <a:schemeClr val="accent1"/>
-          </a:lnRef>
-          <a:fillRef idx="3">
-            <a:schemeClr val="accent1"/>
-          </a:fillRef>
-          <a:effectRef idx="2">
-            <a:schemeClr val="accent1"/>
-          </a:effectRef>
-          <a:fontRef idx="minor">
-            <a:schemeClr val="lt1"/>
-          </a:fontRef>
-        </p:style>
-        <p:txBody>
-          <a:bodyPr rtlCol="0" anchor="ctr"/>
-          <a:lstStyle/>
-          <a:p>
-            <a:pPr algn="ctr"/>
-          </a:p>
-        </p:txBody>
-      </p:sp>
-      <p:sp>
-        <p:nvSpPr>
-          <p:cNvPr id="53" name="TextBox 52"/>
-          <p:cNvSpPr txBox="1"/>
-          <p:nvPr/>
-        </p:nvSpPr>
-        <p:spPr>
-          <a:xfrm>
-            <a:off x="6217920" y="5394959"/>
-            <a:ext cx="5394960" cy="274320"/>
-          </a:xfrm>
-          <a:prstGeom prst="rect">
-            <a:avLst/>
-          </a:prstGeom>
-          <a:noFill/>
-        </p:spPr>
-        <p:txBody>
-          <a:bodyPr wrap="square">
-            <a:spAutoFit/>
-          </a:bodyPr>
-          <a:lstStyle/>
-          <a:p>
-            <a:pPr algn="l"/>
-            <a:r>
-              <a:rPr sz="1200" b="1" i="0">
-                <a:solidFill>
-                  <a:srgbClr val="0D2B55"/>
-                </a:solidFill>
-                <a:latin typeface="Calibri"/>
-              </a:rPr>
-              <a:t>Validacao computacional confirmada</a:t>
-            </a:r>
-          </a:p>
-        </p:txBody>
-      </p:sp>
-      <p:sp>
-        <p:nvSpPr>
-          <p:cNvPr id="54" name="TextBox 53"/>
-          <p:cNvSpPr txBox="1"/>
-          <p:nvPr/>
-        </p:nvSpPr>
-        <p:spPr>
-          <a:xfrm>
-            <a:off x="6217920" y="5687568"/>
-            <a:ext cx="5394960" cy="384048"/>
-          </a:xfrm>
-          <a:prstGeom prst="rect">
-            <a:avLst/>
-          </a:prstGeom>
-          <a:noFill/>
-        </p:spPr>
-        <p:txBody>
-          <a:bodyPr wrap="square">
-            <a:spAutoFit/>
-          </a:bodyPr>
-          <a:lstStyle/>
-          <a:p>
-            <a:pPr algn="l"/>
-            <a:r>
-              <a:rPr sz="1100" b="0" i="0">
-                <a:solidFill>
-                  <a:srgbClr val="333344"/>
-                </a:solidFill>
-                <a:latin typeface="Calibri"/>
-              </a:rPr>
-              <a:t>Vina (-13,62) + Rosetta I_sc (-78,44) + MD (RMSD 0,37 nm) — tres metodos independentes concordam.</a:t>
-            </a:r>
-          </a:p>
-        </p:txBody>
-      </p:sp>
-      <p:sp>
-        <p:nvSpPr>
-          <p:cNvPr id="55" name="Rectangle 54"/>
-          <p:cNvSpPr/>
-          <p:nvPr/>
-        </p:nvSpPr>
-        <p:spPr>
-          <a:xfrm>
-            <a:off x="365760" y="6473952"/>
-            <a:ext cx="11430000" cy="274320"/>
-          </a:xfrm>
-          <a:prstGeom prst="rect">
-            <a:avLst/>
-          </a:prstGeom>
-          <a:solidFill>
-            <a:srgbClr val="1A4F8A"/>
-          </a:solidFill>
-          <a:ln>
-            <a:noFill/>
-          </a:ln>
-        </p:spPr>
-        <p:style>
-          <a:lnRef idx="1">
-            <a:schemeClr val="accent1"/>
-          </a:lnRef>
-          <a:fillRef idx="3">
-            <a:schemeClr val="accent1"/>
-          </a:fillRef>
-          <a:effectRef idx="2">
-            <a:schemeClr val="accent1"/>
-          </a:effectRef>
-          <a:fontRef idx="minor">
-            <a:schemeClr val="lt1"/>
-          </a:fontRef>
-        </p:style>
-        <p:txBody>
-          <a:bodyPr rtlCol="0" anchor="ctr"/>
-          <a:lstStyle/>
-          <a:p>
-            <a:pPr algn="ctr"/>
-          </a:p>
-        </p:txBody>
-      </p:sp>
-      <p:sp>
-        <p:nvSpPr>
-          <p:cNvPr id="56" name="TextBox 55"/>
-          <p:cNvSpPr txBox="1"/>
-          <p:nvPr/>
-        </p:nvSpPr>
-        <p:spPr>
-          <a:xfrm>
-            <a:off x="502920" y="6510528"/>
-            <a:ext cx="11155680" cy="219456"/>
-          </a:xfrm>
-          <a:prstGeom prst="rect">
-            <a:avLst/>
-          </a:prstGeom>
-          <a:noFill/>
-        </p:spPr>
-        <p:txBody>
-          <a:bodyPr wrap="square">
-            <a:spAutoFit/>
-          </a:bodyPr>
-          <a:lstStyle/>
-          <a:p>
-            <a:pPr algn="ctr"/>
-            <a:r>
-              <a:rPr sz="1200" b="1" i="0">
-                <a:solidFill>
-                  <a:srgbClr val="FFFFFF"/>
-                </a:solidFill>
-                <a:latin typeface="Calibri"/>
-              </a:rPr>
-              <a:t>Bug 40 CORRIGIDO (commit 36a83f6) — proxima rodada: GARKSIREYQKRVLERLKKK + AARASQREYQKKFLERLKKK + MKKQRENAKKVAEITLKKAK</a:t>
-            </a:r>
-          </a:p>
-        </p:txBody>
-      </p:sp>
-      <p:sp>
-        <p:nvSpPr>
-          <p:cNvPr id="57" name="TextBox 56"/>
+              <a:t>#1 MKKQRENAKKVAEITLKKAK (RMSD 0,447 nm — mais estavel)    #2 GSRASARAYAARVRARRAAL (Vina -13,62 + RMSD 0,494 nm)    GARKSIREYQKRVLERLKKK descartado (melhor I_sc mas RMSD 1,45 nm = instavel em solvente)</a:t>
+            </a:r>
+          </a:p>
+        </p:txBody>
+      </p:sp>
+      <p:sp>
+        <p:nvSpPr>
+          <p:cNvPr id="69" name="TextBox 68"/>
           <p:cNvSpPr txBox="1"/>
           <p:nvPr/>
         </p:nvSpPr>
@@ -26008,7 +26420,7 @@
                 </a:solidFill>
                 <a:latin typeface="Calibri"/>
               </a:rPr>
-              <a:t>MD GSRASARA concluido (RMSD 0,37 nm) | outros 4 candidatos em execucao | 2026-06-18</a:t>
+              <a:t>MD 5/5 concluido | 2 estaveis: MKKQRENA (0,447 nm) + GSRASARA (0,494 nm) | 2026-06-25</a:t>
             </a:r>
           </a:p>
         </p:txBody>
@@ -26242,7 +26654,7 @@
                 </a:solidFill>
                 <a:latin typeface="Calibri"/>
               </a:rPr>
-              <a:t>MD GSRASARAYAARVRARRAAL — COMPLEXO ESTAVEL</a:t>
+              <a:t>MD 5 candidatos — RECLASSIFICACAO COMPLETA</a:t>
             </a:r>
           </a:p>
         </p:txBody>
@@ -26277,8 +26689,8 @@
                 </a:solidFill>
                 <a:latin typeface="Calibri"/>
               </a:rPr>
-              <a:t>RMSD 0,37 nm (10 ns) | Rg 1,79 nm | 3 replicas completas
-Bug 40 corrigido (commit 36a83f6) — rodar outros 4 candidatos</a:t>
+              <a:t>MKKQRENAKKVAEITLKKAK (0,447 nm) e GSRASARAYAARVRARRAAL (0,494 nm) ESTAVEIS
+GARKSIREYQKRVLERLKKK descartado (RMSD 1,45 nm apesar de melhor I_sc -86,28)</a:t>
             </a:r>
           </a:p>
         </p:txBody>

</xml_diff>

<commit_message>
docs: consolidar estado 2026-06-25 — slides + artigo + memória
- artigo_resultados.md: status expandido (docking 194->1000 rodando,
  Rosetta 10->50, ML script pronto, 4 fases mapeadas)
- criar_slides.py slide 17: próximos passos com status real (Fase 2
  RODANDO, Fases 1/3/4 sequenciadas); slide 18: conclusões com MD 5/5
  e candidatos de síntese corretos
- PPTX regenerado

Co-Authored-By: Claude Sonnet 4.6 <noreply@anthropic.com>
</commit_message>
<xml_diff>
--- a/apresentacao_design_inibidores.pptx
+++ b/apresentacao_design_inibidores.pptx
@@ -26420,7 +26420,7 @@
                 </a:solidFill>
                 <a:latin typeface="Calibri"/>
               </a:rPr>
-              <a:t>MD 5/5 concluido | 2 estaveis: MKKQRENA (0,447 nm) + GSRASARA (0,494 nm) | 2026-06-25</a:t>
+              <a:t>4 fases planejadas | Fase 2 rodando no servidor (2026-06-25)</a:t>
             </a:r>
           </a:p>
         </p:txBody>
@@ -26541,7 +26541,7 @@
                 </a:solidFill>
                 <a:latin typeface="Calibri"/>
               </a:rPr>
-              <a:t>1</a:t>
+              <a:t>2</a:t>
             </a:r>
           </a:p>
         </p:txBody>
@@ -26619,7 +26619,7 @@
                 </a:solidFill>
                 <a:latin typeface="Calibri"/>
               </a:rPr>
-              <a:t>CONCLUIDO</a:t>
+              <a:t>RODANDO</a:t>
             </a:r>
           </a:p>
         </p:txBody>
@@ -26654,7 +26654,7 @@
                 </a:solidFill>
                 <a:latin typeface="Calibri"/>
               </a:rPr>
-              <a:t>MD 5 candidatos — RECLASSIFICACAO COMPLETA</a:t>
+              <a:t>Docking 1000 seqs + Rosetta top-50 + Ranking</a:t>
             </a:r>
           </a:p>
         </p:txBody>
@@ -26689,8 +26689,8 @@
                 </a:solidFill>
                 <a:latin typeface="Calibri"/>
               </a:rPr>
-              <a:t>MKKQRENAKKVAEITLKKAK (0,447 nm) e GSRASARAYAARVRARRAAL (0,494 nm) ESTAVEIS
-GARKSIREYQKRVLERLKKK descartado (RMSD 1,45 nm apesar de melhor I_sc -86,28)</a:t>
+              <a:t>top_for_docking: 200-&gt;1000 | optimization.top_k: 10-&gt;50
+28x mais labels Vina | 5x mais I_sc -&gt; dataset ML robusto (~8h GPU)</a:t>
             </a:r>
           </a:p>
         </p:txBody>
@@ -26725,7 +26725,7 @@
                 </a:solidFill>
                 <a:latin typeface="Calibri"/>
               </a:rPr>
-              <a:t>done</a:t>
+              <a:t>~8h GPU</a:t>
             </a:r>
           </a:p>
         </p:txBody>
@@ -26788,7 +26788,7 @@
             <a:avLst/>
           </a:prstGeom>
           <a:solidFill>
-            <a:srgbClr val="FFD166"/>
+            <a:srgbClr val="00B4D8"/>
           </a:solidFill>
           <a:ln>
             <a:noFill/>
@@ -26846,7 +26846,7 @@
                 </a:solidFill>
                 <a:latin typeface="Calibri"/>
               </a:rPr>
-              <a:t>2</a:t>
+              <a:t>3</a:t>
             </a:r>
           </a:p>
         </p:txBody>
@@ -26866,7 +26866,7 @@
             <a:avLst/>
           </a:prstGeom>
           <a:solidFill>
-            <a:srgbClr val="FFD166"/>
+            <a:srgbClr val="00B4D8"/>
           </a:solidFill>
           <a:ln>
             <a:noFill/>
@@ -26924,7 +26924,7 @@
                 </a:solidFill>
                 <a:latin typeface="Calibri"/>
               </a:rPr>
-              <a:t>CURTO</a:t>
+              <a:t>PROXIMO</a:t>
             </a:r>
           </a:p>
         </p:txBody>
@@ -26959,7 +26959,7 @@
                 </a:solidFill>
                 <a:latin typeface="Calibri"/>
               </a:rPr>
-              <a:t>Re-rodar RFdiffusion com comprimentos variados (5-15 aa)</a:t>
+              <a:t>ML Training: Random Forest + XGBoost</a:t>
             </a:r>
           </a:p>
         </p:txBody>
@@ -26994,8 +26994,8 @@
                 </a:solidFill>
                 <a:latin typeface="Calibri"/>
               </a:rPr>
-              <a:t>Chamar RFdiffusion com comprimentos independentes por rodada
--&gt; peptideos curtos (5-15 aa) mais praticos para sintese por Fmoc-SPPS</a:t>
+              <a:t>scripts/train_ml.py: 1000 labels -&gt; prediz afinidade para 24.513 seqs
+Output: ml_top100_predicted.csv | feature importance | RMSE &lt; 0,8 kcal/mol</a:t>
             </a:r>
           </a:p>
         </p:txBody>
@@ -27026,11 +27026,11 @@
             <a:r>
               <a:rPr sz="1100" b="1" i="0">
                 <a:solidFill>
-                  <a:srgbClr val="FFD166"/>
-                </a:solidFill>
-                <a:latin typeface="Calibri"/>
-              </a:rPr>
-              <a:t>~2h GPU</a:t>
+                  <a:srgbClr val="00B4D8"/>
+                </a:solidFill>
+                <a:latin typeface="Calibri"/>
+              </a:rPr>
+              <a:t>~5 min</a:t>
             </a:r>
           </a:p>
         </p:txBody>
@@ -27151,7 +27151,7 @@
                 </a:solidFill>
                 <a:latin typeface="Calibri"/>
               </a:rPr>
-              <a:t>3</a:t>
+              <a:t>1</a:t>
             </a:r>
           </a:p>
         </p:txBody>
@@ -27229,7 +27229,7 @@
                 </a:solidFill>
                 <a:latin typeface="Calibri"/>
               </a:rPr>
-              <a:t>CURTO</a:t>
+              <a:t>PROXIMO</a:t>
             </a:r>
           </a:p>
         </p:txBody>
@@ -27264,7 +27264,7 @@
                 </a:solidFill>
                 <a:latin typeface="Calibri"/>
               </a:rPr>
-              <a:t>Docking completo dos 24.513 candidatos</a:t>
+              <a:t>OptimizationAgent: variantes dos candidatos estaveis</a:t>
             </a:r>
           </a:p>
         </p:txBody>
@@ -27299,8 +27299,8 @@
                 </a:solidFill>
                 <a:latin typeface="Calibri"/>
               </a:rPr>
-              <a:t>Afinidade Vina para todo o dataset -&gt; labels ML supervisionados completos
-Atual: 194 labels / 24.513 totais (0.8%)</a:t>
+              <a:t>MKKQRENAKKVAEITLKKAK + GSRASARAYAARVRARRAAL -&gt; point mutations + conservative swaps
+-&gt; re-dock automatico -&gt; novos candidatos aprimorados (top_k: 50-&gt;5)</a:t>
             </a:r>
           </a:p>
         </p:txBody>
@@ -27335,7 +27335,7 @@
                 </a:solidFill>
                 <a:latin typeface="Calibri"/>
               </a:rPr>
-              <a:t>~GPU</a:t>
+              <a:t>~2h GPU</a:t>
             </a:r>
           </a:p>
         </p:txBody>
@@ -27398,7 +27398,7 @@
             <a:avLst/>
           </a:prstGeom>
           <a:solidFill>
-            <a:srgbClr val="1A4F8A"/>
+            <a:srgbClr val="FFD166"/>
           </a:solidFill>
           <a:ln>
             <a:noFill/>
@@ -27476,7 +27476,7 @@
             <a:avLst/>
           </a:prstGeom>
           <a:solidFill>
-            <a:srgbClr val="1A4F8A"/>
+            <a:srgbClr val="FFD166"/>
           </a:solidFill>
           <a:ln>
             <a:noFill/>
@@ -27534,7 +27534,7 @@
                 </a:solidFill>
                 <a:latin typeface="Calibri"/>
               </a:rPr>
-              <a:t>MEDIO</a:t>
+              <a:t>PARALELA</a:t>
             </a:r>
           </a:p>
         </p:txBody>
@@ -27569,7 +27569,7 @@
                 </a:solidFill>
                 <a:latin typeface="Calibri"/>
               </a:rPr>
-              <a:t>Treinamento ML/DL sobre dataset supervisionado</a:t>
+              <a:t>RFdiffusion comprimentos variaveis (5-15 aa)</a:t>
             </a:r>
           </a:p>
         </p:txBody>
@@ -27604,8 +27604,8 @@
                 </a:solidFill>
                 <a:latin typeface="Calibri"/>
               </a:rPr>
-              <a:t>194+ labels Vina + 10 labels Rosetta -&gt; Random Forest -&gt; GNN
-Preditor de afinidade: input=seq, output=Vina/I_sc</a:t>
+              <a:t>250 novos backbones reais: 50 x [5, 7, 10, 12, 15 aa]
+Peptideos curtos: melhor sintese Fmoc-SPPS + bioatividade oral</a:t>
             </a:r>
           </a:p>
         </p:txBody>
@@ -27636,11 +27636,11 @@
             <a:r>
               <a:rPr sz="1100" b="1" i="0">
                 <a:solidFill>
-                  <a:srgbClr val="1A4F8A"/>
-                </a:solidFill>
-                <a:latin typeface="Calibri"/>
-              </a:rPr>
-              <a:t>horas</a:t>
+                  <a:srgbClr val="FFD166"/>
+                </a:solidFill>
+                <a:latin typeface="Calibri"/>
+              </a:rPr>
+              <a:t>~3h GPU</a:t>
             </a:r>
           </a:p>
         </p:txBody>
@@ -27839,7 +27839,7 @@
                 </a:solidFill>
                 <a:latin typeface="Calibri"/>
               </a:rPr>
-              <a:t>MEDIO</a:t>
+              <a:t>FUTURO</a:t>
             </a:r>
           </a:p>
         </p:txBody>
@@ -27909,8 +27909,8 @@
                 </a:solidFill>
                 <a:latin typeface="Calibri"/>
               </a:rPr>
-              <a:t>Pipeline primario usou ACR157. Rodar docking e Rosetta para outros 3 receptores
--&gt; candidatos com seletividade (especifico para XP273 hidrofobico)</a:t>
+              <a:t>Pipeline atual: ACR157 apenas. Rodar docking+Rosetta nos outros 3 receptores
+-&gt; seletividade por tripsina (XP273 hidrofobico = target diferenciado)</a:t>
             </a:r>
           </a:p>
         </p:txBody>
@@ -28214,8 +28214,8 @@
                 </a:solidFill>
                 <a:latin typeface="Calibri"/>
               </a:rPr>
-              <a:t>Top-3 candidatos -&gt; sintese Fmoc-SPPS -&gt; ensaios IC50 in vitro
-Tripsinas recombinantes de S. frugiperda e A. gemmatalis</a:t>
+              <a:t>Top-2: MKKQRENAKKVAEITLKKAK + GSRASARAYAARVRARRAAL -&gt; Fmoc-SPPS -&gt; IC50 in vitro
+Tripsinas recombinantes S. frugiperda + A. gemmatalis (GenOne / Peptide 2.0)</a:t>
             </a:r>
           </a:p>
         </p:txBody>
@@ -28502,7 +28502,7 @@
                 </a:solidFill>
                 <a:latin typeface="Calibri"/>
               </a:rPr>
-              <a:t>Pipeline completo executado em modo REAL — 2026-06-18</a:t>
+              <a:t>MD 5/5 concluido | Docking 1000 rodando | 2 candidatos estaveis — 2026-06-25</a:t>
             </a:r>
           </a:p>
         </p:txBody>
@@ -28615,7 +28615,7 @@
                 </a:solidFill>
                 <a:latin typeface="Calibri"/>
               </a:rPr>
-              <a:t>330 backbones reais (RFdiffusion, Complex_base_ckpt.pt) | 24.513 binders únicos 20 aa (ProteinMPNN real, bug FASTA corrigido) — dataset 41 features × labels Vina + I_sc</a:t>
+              <a:t>330 backbones reais (RFdiffusion) | 24.513 binders 20 aa (ProteinMPNN) | 42 bugs corrigidos | dataset 44 features × 24.513 sequencias</a:t>
             </a:r>
           </a:p>
         </p:txBody>
@@ -28728,7 +28728,7 @@
                 </a:solidFill>
                 <a:latin typeface="Calibri"/>
               </a:rPr>
-              <a:t>194/194 poses Vina reais com binders RFdiffusion genuínos (5 bugs críticos corrigidos, incl. inversão da identidade dos candidatos — redesigns de tripsinas identificados e eliminados)</a:t>
+              <a:t>194 poses Vina reais (expandindo para 1000) | 10 I_sc PyRosetta (expandindo para 50) | Ranking composto: Vina 50% + Rosetta 20% + H-bond 15% + RMSD 10%</a:t>
             </a:r>
           </a:p>
         </p:txBody>
@@ -28841,7 +28841,7 @@
                 </a:solidFill>
                 <a:latin typeface="Calibri"/>
               </a:rPr>
-              <a:t>PyRosetta 2026.25 instalado e integrado | 10/10 complexos refinados (FastRelax + InterfaceAnalyzerMover) | integração docking-&gt;rosetta corrigida (best_affinity_kcal, commits a7ac84f+e16a28f)</a:t>
+              <a:t>MD 10 ns — 5/5 candidatos concluidos | MKKQRENAKKVAEITLKKAK (0,447 nm) ESTAVEL #1 | GSRASARAYAARVRARRAAL (0,494 nm) ESTAVEL #2 | GARKSIREYQKRVLERLKKK descartado (1,453 nm)</a:t>
             </a:r>
           </a:p>
         </p:txBody>
@@ -28954,7 +28954,7 @@
                 </a:solidFill>
                 <a:latin typeface="Calibri"/>
               </a:rPr>
-              <a:t>Top-3 por dupla validação Vina+Rosetta: GARKSIREYQKRVLERLKKK (I_sc=-86.28, Vina=-12.76) | GSRASARAYAARVRARRAAL (Vina=-13.62, I_sc=-78.44) | AARASQREYQKKFLERLKKK (I_sc=-85.92)</a:t>
+              <a:t>Reclassificacao pos-MD: melhor I_sc (GARKSIREYQKRVLERLKKK, -86,28) instavel em solvente. MD obrigatorio para filtrar falsos-positivos Rosetta — resultado consistente com literatura</a:t>
             </a:r>
           </a:p>
         </p:txBody>
@@ -29067,7 +29067,7 @@
                 </a:solidFill>
                 <a:latin typeface="Calibri"/>
               </a:rPr>
-              <a:t>Padrão composicional: Arg/Lys + Ala/Ser (sem aromáticos) — mecanismo competitivo clássico (Arg-Asp205 S1). SLARKRAEENAKRFLERVKK descartado (Vina #3, Rosetta #10 — divergência indica interface fraca)</a:t>
+              <a:t>Padrao composicional: Arg/Lys + Ala/Ser (sem aromaticos) — mecanismo competitivo Arg-Asp205 (S1). Mecanismo proposto validado por 3 metodos independentes (Vina + Rosetta + MD)</a:t>
             </a:r>
           </a:p>
         </p:txBody>
@@ -29087,7 +29087,7 @@
             <a:avLst/>
           </a:prstGeom>
           <a:solidFill>
-            <a:srgbClr val="06D6A0"/>
+            <a:srgbClr val="FFD166"/>
           </a:solidFill>
           <a:ln>
             <a:noFill/>
@@ -29145,7 +29145,7 @@
                 </a:solidFill>
                 <a:latin typeface="Calibri"/>
               </a:rPr>
-              <a:t>✓</a:t>
+              <a:t>⏳</a:t>
             </a:r>
           </a:p>
         </p:txBody>
@@ -29180,7 +29180,7 @@
                 </a:solidFill>
                 <a:latin typeface="Calibri"/>
               </a:rPr>
-              <a:t>MD 10 ns concluido para GSRASARAYAARVRARRAAL: RMSD 0,37 nm (avg Run4) | Rg 1,79 nm | Complexo ESTAVEL em 10 ns — valida predicao computacional. Bug 40/41 corrigidos (36a83f6).</a:t>
+              <a:t>Fase 2 RODANDO: docking 1000 seqs + Rosetta 50 + ranking | Proximo: scripts/train_ml.py (RF/XGBoost) + OptimizationAgent + RFdiffusion 5-15 aa</a:t>
             </a:r>
           </a:p>
         </p:txBody>
@@ -29200,7 +29200,7 @@
             <a:avLst/>
           </a:prstGeom>
           <a:solidFill>
-            <a:srgbClr val="FFD166"/>
+            <a:srgbClr val="FF7F11"/>
           </a:solidFill>
           <a:ln>
             <a:noFill/>
@@ -29258,7 +29258,7 @@
                 </a:solidFill>
                 <a:latin typeface="Calibri"/>
               </a:rPr>
-              <a:t>◑</a:t>
+              <a:t>→</a:t>
             </a:r>
           </a:p>
         </p:txBody>
@@ -29293,7 +29293,7 @@
                 </a:solidFill>
                 <a:latin typeface="Calibri"/>
               </a:rPr>
-              <a:t>Proximos: MD outros 4 candidatos (Bug 40 corrigido) | RFdiffusion 5-15 aa | docking 24.513 | ML/DL 194+ labels | expansao QCL936/XP273/XP352 | sintese Fmoc-SPPS top-3</a:t>
+              <a:t>Alvo final: MKKQRENAKKVAEITLKKAK + GSRASARAYAARVRARRAAL -&gt; sintese Fmoc-SPPS -&gt; ensaios IC50 in vitro (S. frugiperda + A. gemmatalis). Publicacao: JCIM / CSBJ</a:t>
             </a:r>
           </a:p>
         </p:txBody>

</xml_diff>

<commit_message>
docs: artigo + slides atualizados — Fase 1-3 concluída (2026-06-27)
- Docking 880 poses: novo top-1 SARESIKKAYKTFLERYKKL (-14,58 kcal/mol)
- Ranking: SARESIKKAYKTFLERYKKL score=0,748
- ML: RF RMSE=0,514, 24.513 predicoes
- Cleavage: 0/20 resistentes (top-20 ranking)
- Specificity: 20/20 aprovados vs 1TRN + A0A7M7MMI1 (Apis)
- Seção 3.9 ML adicionada; 3.11 Especificidade expandida
- Slides 10,17,18 atualizados com dados reais
</commit_message>
<xml_diff>
--- a/apresentacao_design_inibidores.pptx
+++ b/apresentacao_design_inibidores.pptx
@@ -4132,7 +4132,7 @@
                 </a:solidFill>
                 <a:latin typeface="Calibri"/>
               </a:rPr>
-              <a:t>Resultados Docking — Binders RFdiffusion+ProteinMPNN (2026-06-17)</a:t>
+              <a:t>Resultados Docking + Ranking — Rodada Expandida (2026-06-27)</a:t>
             </a:r>
           </a:p>
         </p:txBody>
@@ -4167,7 +4167,7 @@
                 </a:solidFill>
                 <a:latin typeface="Calibri"/>
               </a:rPr>
-              <a:t>194/194 poses validas | perfil basico/alifatico | mecanismo competitivo classico</a:t>
+              <a:t>880/1000 poses validas | novo top-1: SARESIKKAYKTFLERYKKL -14,58 kcal/mol | 24.513 rankeados</a:t>
             </a:r>
           </a:p>
         </p:txBody>
@@ -4245,7 +4245,7 @@
                 </a:solidFill>
                 <a:latin typeface="Calibri"/>
               </a:rPr>
-              <a:t>194 / 194</a:t>
+              <a:t>880 / 1000</a:t>
             </a:r>
           </a:p>
         </p:txBody>
@@ -4280,7 +4280,7 @@
                 </a:solidFill>
                 <a:latin typeface="Calibri"/>
               </a:rPr>
-              <a:t>poses Vina reais (kcal/mol)</a:t>
+              <a:t>poses Vina validas (rodada expandida)</a:t>
             </a:r>
           </a:p>
         </p:txBody>
@@ -4350,7 +4350,7 @@
                 </a:solidFill>
                 <a:latin typeface="Calibri"/>
               </a:rPr>
-              <a:t>-13.62 kcal/mol</a:t>
+              <a:t>-14.58 kcal/mol</a:t>
             </a:r>
           </a:p>
         </p:txBody>
@@ -4420,7 +4420,7 @@
                 </a:solidFill>
                 <a:latin typeface="Calibri"/>
               </a:rPr>
-              <a:t>~-12.2 kcal/mol</a:t>
+              <a:t>~-12.4 kcal/mol</a:t>
             </a:r>
           </a:p>
         </p:txBody>
@@ -4455,7 +4455,7 @@
                 </a:solidFill>
                 <a:latin typeface="Calibri"/>
               </a:rPr>
-              <a:t>Pior:</a:t>
+              <a:t>ML RMSE:</a:t>
             </a:r>
           </a:p>
         </p:txBody>
@@ -4490,7 +4490,7 @@
                 </a:solidFill>
                 <a:latin typeface="Calibri"/>
               </a:rPr>
-              <a:t>~-10.8 kcal/mol</a:t>
+              <a:t>0.514 kcal/mol</a:t>
             </a:r>
           </a:p>
         </p:txBody>
@@ -4525,7 +4525,7 @@
                 </a:solidFill>
                 <a:latin typeface="Calibri"/>
               </a:rPr>
-              <a:t>Top-10 por Vina puro:</a:t>
+              <a:t>Top-5 por score composto (ranking expandido):</a:t>
             </a:r>
           </a:p>
         </p:txBody>
@@ -4617,7 +4617,7 @@
         <p:spPr>
           <a:xfrm>
             <a:off x="713232" y="2560320"/>
-            <a:ext cx="3840480" cy="320040"/>
+            <a:ext cx="3657600" cy="320040"/>
           </a:xfrm>
           <a:prstGeom prst="rect">
             <a:avLst/>
@@ -4660,7 +4660,7 @@
         <p:spPr>
           <a:xfrm>
             <a:off x="749808" y="2578608"/>
-            <a:ext cx="3767328" cy="283464"/>
+            <a:ext cx="3584448" cy="283464"/>
           </a:xfrm>
           <a:prstGeom prst="rect">
             <a:avLst/>
@@ -4694,7 +4694,7 @@
         </p:nvSpPr>
         <p:spPr>
           <a:xfrm>
-            <a:off x="4553712" y="2560320"/>
+            <a:off x="4370832" y="2560320"/>
             <a:ext cx="384048" cy="320040"/>
           </a:xfrm>
           <a:prstGeom prst="rect">
@@ -4737,7 +4737,7 @@
         </p:nvSpPr>
         <p:spPr>
           <a:xfrm>
-            <a:off x="4590288" y="2578608"/>
+            <a:off x="4407408" y="2578608"/>
             <a:ext cx="310896" cy="283464"/>
           </a:xfrm>
           <a:prstGeom prst="rect">
@@ -4772,7 +4772,7 @@
         </p:nvSpPr>
         <p:spPr>
           <a:xfrm>
-            <a:off x="4937760" y="2560320"/>
+            <a:off x="4754880" y="2560320"/>
             <a:ext cx="1097280" cy="320040"/>
           </a:xfrm>
           <a:prstGeom prst="rect">
@@ -4815,7 +4815,7 @@
         </p:nvSpPr>
         <p:spPr>
           <a:xfrm>
-            <a:off x="4974336" y="2578608"/>
+            <a:off x="4791456" y="2578608"/>
             <a:ext cx="1024127" cy="283464"/>
           </a:xfrm>
           <a:prstGeom prst="rect">
@@ -4850,8 +4850,8 @@
         </p:nvSpPr>
         <p:spPr>
           <a:xfrm>
-            <a:off x="6035040" y="2560320"/>
-            <a:ext cx="5577840" cy="320040"/>
+            <a:off x="5852160" y="2560320"/>
+            <a:ext cx="777240" cy="320040"/>
           </a:xfrm>
           <a:prstGeom prst="rect">
             <a:avLst/>
@@ -4893,8 +4893,8 @@
         </p:nvSpPr>
         <p:spPr>
           <a:xfrm>
-            <a:off x="6071616" y="2578608"/>
-            <a:ext cx="5504688" cy="283464"/>
+            <a:off x="5888736" y="2578608"/>
+            <a:ext cx="704088" cy="283464"/>
           </a:xfrm>
           <a:prstGeom prst="rect">
             <a:avLst/>
@@ -4915,7 +4915,7 @@
                 </a:solidFill>
                 <a:latin typeface="Calibri"/>
               </a:rPr>
-              <a:t>Perfil composicional</a:t>
+              <a:t>Score</a:t>
             </a:r>
           </a:p>
         </p:txBody>
@@ -4928,14 +4928,14 @@
         </p:nvSpPr>
         <p:spPr>
           <a:xfrm>
-            <a:off x="365760" y="2880360"/>
-            <a:ext cx="64008" cy="283464"/>
-          </a:xfrm>
-          <a:prstGeom prst="rect">
-            <a:avLst/>
-          </a:prstGeom>
-          <a:solidFill>
-            <a:srgbClr val="06D6A0"/>
+            <a:off x="6629400" y="2560320"/>
+            <a:ext cx="5001768" cy="320040"/>
+          </a:xfrm>
+          <a:prstGeom prst="rect">
+            <a:avLst/>
+          </a:prstGeom>
+          <a:solidFill>
+            <a:srgbClr val="0D2B55"/>
           </a:solidFill>
           <a:ln>
             <a:noFill/>
@@ -4965,20 +4965,55 @@
       </p:sp>
       <p:sp>
         <p:nvSpPr>
-          <p:cNvPr id="29" name="Rectangle 28"/>
+          <p:cNvPr id="29" name="TextBox 28"/>
+          <p:cNvSpPr txBox="1"/>
+          <p:nvPr/>
+        </p:nvSpPr>
+        <p:spPr>
+          <a:xfrm>
+            <a:off x="6665976" y="2578608"/>
+            <a:ext cx="4928616" cy="283464"/>
+          </a:xfrm>
+          <a:prstGeom prst="rect">
+            <a:avLst/>
+          </a:prstGeom>
+          <a:noFill/>
+        </p:spPr>
+        <p:txBody>
+          <a:bodyPr wrap="square">
+            <a:spAutoFit/>
+          </a:bodyPr>
+          <a:lstStyle/>
+          <a:p>
+            <a:pPr algn="ctr"/>
+            <a:r>
+              <a:rPr sz="1000" b="1" i="0">
+                <a:solidFill>
+                  <a:srgbClr val="FFFFFF"/>
+                </a:solidFill>
+                <a:latin typeface="Calibri"/>
+              </a:rPr>
+              <a:t>Observacao</a:t>
+            </a:r>
+          </a:p>
+        </p:txBody>
+      </p:sp>
+      <p:sp>
+        <p:nvSpPr>
+          <p:cNvPr id="30" name="Rectangle 29"/>
           <p:cNvSpPr/>
           <p:nvPr/>
         </p:nvSpPr>
         <p:spPr>
           <a:xfrm>
             <a:off x="365760" y="2880360"/>
-            <a:ext cx="347472" cy="283464"/>
-          </a:xfrm>
-          <a:prstGeom prst="rect">
-            <a:avLst/>
-          </a:prstGeom>
-          <a:solidFill>
-            <a:srgbClr val="F0F4F8"/>
+            <a:ext cx="64008" cy="347472"/>
+          </a:xfrm>
+          <a:prstGeom prst="rect">
+            <a:avLst/>
+          </a:prstGeom>
+          <a:solidFill>
+            <a:srgbClr val="06D6A0"/>
           </a:solidFill>
           <a:ln>
             <a:noFill/>
@@ -5008,49 +5043,14 @@
       </p:sp>
       <p:sp>
         <p:nvSpPr>
-          <p:cNvPr id="30" name="TextBox 29"/>
-          <p:cNvSpPr txBox="1"/>
-          <p:nvPr/>
-        </p:nvSpPr>
-        <p:spPr>
-          <a:xfrm>
-            <a:off x="402336" y="2898648"/>
-            <a:ext cx="274320" cy="246888"/>
-          </a:xfrm>
-          <a:prstGeom prst="rect">
-            <a:avLst/>
-          </a:prstGeom>
-          <a:noFill/>
-        </p:spPr>
-        <p:txBody>
-          <a:bodyPr wrap="square">
-            <a:spAutoFit/>
-          </a:bodyPr>
-          <a:lstStyle/>
-          <a:p>
-            <a:pPr algn="ctr"/>
-            <a:r>
-              <a:rPr sz="1000" b="0" i="0">
-                <a:solidFill>
-                  <a:srgbClr val="333344"/>
-                </a:solidFill>
-                <a:latin typeface="Calibri"/>
-              </a:rPr>
-              <a:t>1</a:t>
-            </a:r>
-          </a:p>
-        </p:txBody>
-      </p:sp>
-      <p:sp>
-        <p:nvSpPr>
           <p:cNvPr id="31" name="Rectangle 30"/>
           <p:cNvSpPr/>
           <p:nvPr/>
         </p:nvSpPr>
         <p:spPr>
           <a:xfrm>
-            <a:off x="713232" y="2880360"/>
-            <a:ext cx="3840480" cy="283464"/>
+            <a:off x="365760" y="2880360"/>
+            <a:ext cx="347472" cy="347472"/>
           </a:xfrm>
           <a:prstGeom prst="rect">
             <a:avLst/>
@@ -5092,29 +5092,29 @@
         </p:nvSpPr>
         <p:spPr>
           <a:xfrm>
-            <a:off x="749808" y="2898648"/>
-            <a:ext cx="3767328" cy="246888"/>
-          </a:xfrm>
-          <a:prstGeom prst="rect">
-            <a:avLst/>
-          </a:prstGeom>
-          <a:noFill/>
-        </p:spPr>
-        <p:txBody>
-          <a:bodyPr wrap="square">
-            <a:spAutoFit/>
-          </a:bodyPr>
-          <a:lstStyle/>
-          <a:p>
-            <a:pPr algn="l"/>
-            <a:r>
-              <a:rPr sz="900" b="1" i="0">
-                <a:solidFill>
-                  <a:srgbClr val="0D2B55"/>
-                </a:solidFill>
-                <a:latin typeface="Calibri"/>
-              </a:rPr>
-              <a:t>GSRASARAYAARVRARRAAL</a:t>
+            <a:off x="402336" y="2898648"/>
+            <a:ext cx="274320" cy="310896"/>
+          </a:xfrm>
+          <a:prstGeom prst="rect">
+            <a:avLst/>
+          </a:prstGeom>
+          <a:noFill/>
+        </p:spPr>
+        <p:txBody>
+          <a:bodyPr wrap="square">
+            <a:spAutoFit/>
+          </a:bodyPr>
+          <a:lstStyle/>
+          <a:p>
+            <a:pPr algn="ctr"/>
+            <a:r>
+              <a:rPr sz="1000" b="0" i="0">
+                <a:solidFill>
+                  <a:srgbClr val="333344"/>
+                </a:solidFill>
+                <a:latin typeface="Calibri"/>
+              </a:rPr>
+              <a:t>1</a:t>
             </a:r>
           </a:p>
         </p:txBody>
@@ -5127,8 +5127,8 @@
         </p:nvSpPr>
         <p:spPr>
           <a:xfrm>
-            <a:off x="4553712" y="2880360"/>
-            <a:ext cx="384048" cy="283464"/>
+            <a:off x="713232" y="2880360"/>
+            <a:ext cx="3657600" cy="347472"/>
           </a:xfrm>
           <a:prstGeom prst="rect">
             <a:avLst/>
@@ -5170,29 +5170,29 @@
         </p:nvSpPr>
         <p:spPr>
           <a:xfrm>
-            <a:off x="4590288" y="2898648"/>
-            <a:ext cx="310896" cy="246888"/>
-          </a:xfrm>
-          <a:prstGeom prst="rect">
-            <a:avLst/>
-          </a:prstGeom>
-          <a:noFill/>
-        </p:spPr>
-        <p:txBody>
-          <a:bodyPr wrap="square">
-            <a:spAutoFit/>
-          </a:bodyPr>
-          <a:lstStyle/>
-          <a:p>
-            <a:pPr algn="ctr"/>
-            <a:r>
-              <a:rPr sz="1000" b="0" i="0">
-                <a:solidFill>
-                  <a:srgbClr val="333344"/>
-                </a:solidFill>
-                <a:latin typeface="Calibri"/>
-              </a:rPr>
-              <a:t>20</a:t>
+            <a:off x="749808" y="2898648"/>
+            <a:ext cx="3584448" cy="310896"/>
+          </a:xfrm>
+          <a:prstGeom prst="rect">
+            <a:avLst/>
+          </a:prstGeom>
+          <a:noFill/>
+        </p:spPr>
+        <p:txBody>
+          <a:bodyPr wrap="square">
+            <a:spAutoFit/>
+          </a:bodyPr>
+          <a:lstStyle/>
+          <a:p>
+            <a:pPr algn="l"/>
+            <a:r>
+              <a:rPr sz="900" b="1" i="0">
+                <a:solidFill>
+                  <a:srgbClr val="0D2B55"/>
+                </a:solidFill>
+                <a:latin typeface="Calibri"/>
+              </a:rPr>
+              <a:t>SARESIKKAYKTFLERYKKL</a:t>
             </a:r>
           </a:p>
         </p:txBody>
@@ -5205,8 +5205,8 @@
         </p:nvSpPr>
         <p:spPr>
           <a:xfrm>
-            <a:off x="4937760" y="2880360"/>
-            <a:ext cx="1097280" cy="283464"/>
+            <a:off x="4370832" y="2880360"/>
+            <a:ext cx="384048" cy="347472"/>
           </a:xfrm>
           <a:prstGeom prst="rect">
             <a:avLst/>
@@ -5248,8 +5248,8 @@
         </p:nvSpPr>
         <p:spPr>
           <a:xfrm>
-            <a:off x="4974336" y="2898648"/>
-            <a:ext cx="1024127" cy="246888"/>
+            <a:off x="4407408" y="2898648"/>
+            <a:ext cx="310896" cy="310896"/>
           </a:xfrm>
           <a:prstGeom prst="rect">
             <a:avLst/>
@@ -5266,11 +5266,11 @@
             <a:r>
               <a:rPr sz="1000" b="0" i="0">
                 <a:solidFill>
-                  <a:srgbClr val="06D6A0"/>
-                </a:solidFill>
-                <a:latin typeface="Calibri"/>
-              </a:rPr>
-              <a:t>-13.62</a:t>
+                  <a:srgbClr val="333344"/>
+                </a:solidFill>
+                <a:latin typeface="Calibri"/>
+              </a:rPr>
+              <a:t>20</a:t>
             </a:r>
           </a:p>
         </p:txBody>
@@ -5283,8 +5283,8 @@
         </p:nvSpPr>
         <p:spPr>
           <a:xfrm>
-            <a:off x="6035040" y="2880360"/>
-            <a:ext cx="5577840" cy="283464"/>
+            <a:off x="4754880" y="2880360"/>
+            <a:ext cx="1097280" cy="347472"/>
           </a:xfrm>
           <a:prstGeom prst="rect">
             <a:avLst/>
@@ -5326,29 +5326,29 @@
         </p:nvSpPr>
         <p:spPr>
           <a:xfrm>
-            <a:off x="6071616" y="2898648"/>
-            <a:ext cx="5504688" cy="246888"/>
-          </a:xfrm>
-          <a:prstGeom prst="rect">
-            <a:avLst/>
-          </a:prstGeom>
-          <a:noFill/>
-        </p:spPr>
-        <p:txBody>
-          <a:bodyPr wrap="square">
-            <a:spAutoFit/>
-          </a:bodyPr>
-          <a:lstStyle/>
-          <a:p>
-            <a:pPr algn="l"/>
-            <a:r>
-              <a:rPr sz="900" b="0" i="0">
-                <a:solidFill>
-                  <a:srgbClr val="333344"/>
-                </a:solidFill>
-                <a:latin typeface="Calibri"/>
-              </a:rPr>
-              <a:t>Gly/Ser N-term + Arg/Ala central — melhor absoluto</a:t>
+            <a:off x="4791456" y="2898648"/>
+            <a:ext cx="1024127" cy="310896"/>
+          </a:xfrm>
+          <a:prstGeom prst="rect">
+            <a:avLst/>
+          </a:prstGeom>
+          <a:noFill/>
+        </p:spPr>
+        <p:txBody>
+          <a:bodyPr wrap="square">
+            <a:spAutoFit/>
+          </a:bodyPr>
+          <a:lstStyle/>
+          <a:p>
+            <a:pPr algn="ctr"/>
+            <a:r>
+              <a:rPr sz="1000" b="0" i="0">
+                <a:solidFill>
+                  <a:srgbClr val="06D6A0"/>
+                </a:solidFill>
+                <a:latin typeface="Calibri"/>
+              </a:rPr>
+              <a:t>-14.58</a:t>
             </a:r>
           </a:p>
         </p:txBody>
@@ -5361,14 +5361,14 @@
         </p:nvSpPr>
         <p:spPr>
           <a:xfrm>
-            <a:off x="365760" y="3163824"/>
-            <a:ext cx="64008" cy="283464"/>
-          </a:xfrm>
-          <a:prstGeom prst="rect">
-            <a:avLst/>
-          </a:prstGeom>
-          <a:solidFill>
-            <a:srgbClr val="06D6A0"/>
+            <a:off x="5852160" y="2880360"/>
+            <a:ext cx="777240" cy="347472"/>
+          </a:xfrm>
+          <a:prstGeom prst="rect">
+            <a:avLst/>
+          </a:prstGeom>
+          <a:solidFill>
+            <a:srgbClr val="F0F4F8"/>
           </a:solidFill>
           <a:ln>
             <a:noFill/>
@@ -5398,20 +5398,55 @@
       </p:sp>
       <p:sp>
         <p:nvSpPr>
-          <p:cNvPr id="40" name="Rectangle 39"/>
+          <p:cNvPr id="40" name="TextBox 39"/>
+          <p:cNvSpPr txBox="1"/>
+          <p:nvPr/>
+        </p:nvSpPr>
+        <p:spPr>
+          <a:xfrm>
+            <a:off x="5888736" y="2898648"/>
+            <a:ext cx="704088" cy="310896"/>
+          </a:xfrm>
+          <a:prstGeom prst="rect">
+            <a:avLst/>
+          </a:prstGeom>
+          <a:noFill/>
+        </p:spPr>
+        <p:txBody>
+          <a:bodyPr wrap="square">
+            <a:spAutoFit/>
+          </a:bodyPr>
+          <a:lstStyle/>
+          <a:p>
+            <a:pPr algn="ctr"/>
+            <a:r>
+              <a:rPr sz="1000" b="0" i="0">
+                <a:solidFill>
+                  <a:srgbClr val="333344"/>
+                </a:solidFill>
+                <a:latin typeface="Calibri"/>
+              </a:rPr>
+              <a:t>0.748</a:t>
+            </a:r>
+          </a:p>
+        </p:txBody>
+      </p:sp>
+      <p:sp>
+        <p:nvSpPr>
+          <p:cNvPr id="41" name="Rectangle 40"/>
           <p:cNvSpPr/>
           <p:nvPr/>
         </p:nvSpPr>
         <p:spPr>
           <a:xfrm>
-            <a:off x="365760" y="3163824"/>
-            <a:ext cx="347472" cy="283464"/>
-          </a:xfrm>
-          <a:prstGeom prst="rect">
-            <a:avLst/>
-          </a:prstGeom>
-          <a:solidFill>
-            <a:srgbClr val="FFFFFF"/>
+            <a:off x="6629400" y="2880360"/>
+            <a:ext cx="5001768" cy="347472"/>
+          </a:xfrm>
+          <a:prstGeom prst="rect">
+            <a:avLst/>
+          </a:prstGeom>
+          <a:solidFill>
+            <a:srgbClr val="F0F4F8"/>
           </a:solidFill>
           <a:ln>
             <a:noFill/>
@@ -5441,55 +5476,55 @@
       </p:sp>
       <p:sp>
         <p:nvSpPr>
-          <p:cNvPr id="41" name="TextBox 40"/>
-          <p:cNvSpPr txBox="1"/>
-          <p:nvPr/>
-        </p:nvSpPr>
-        <p:spPr>
-          <a:xfrm>
-            <a:off x="402336" y="3182112"/>
-            <a:ext cx="274320" cy="246888"/>
-          </a:xfrm>
-          <a:prstGeom prst="rect">
-            <a:avLst/>
-          </a:prstGeom>
-          <a:noFill/>
-        </p:spPr>
-        <p:txBody>
-          <a:bodyPr wrap="square">
-            <a:spAutoFit/>
-          </a:bodyPr>
-          <a:lstStyle/>
-          <a:p>
-            <a:pPr algn="ctr"/>
-            <a:r>
-              <a:rPr sz="1000" b="0" i="0">
+          <p:cNvPr id="42" name="TextBox 41"/>
+          <p:cNvSpPr txBox="1"/>
+          <p:nvPr/>
+        </p:nvSpPr>
+        <p:spPr>
+          <a:xfrm>
+            <a:off x="6665976" y="2898648"/>
+            <a:ext cx="4928616" cy="310896"/>
+          </a:xfrm>
+          <a:prstGeom prst="rect">
+            <a:avLst/>
+          </a:prstGeom>
+          <a:noFill/>
+        </p:spPr>
+        <p:txBody>
+          <a:bodyPr wrap="square">
+            <a:spAutoFit/>
+          </a:bodyPr>
+          <a:lstStyle/>
+          <a:p>
+            <a:pPr algn="l"/>
+            <a:r>
+              <a:rPr sz="900" b="0" i="0">
                 <a:solidFill>
                   <a:srgbClr val="333344"/>
                 </a:solidFill>
                 <a:latin typeface="Calibri"/>
               </a:rPr>
-              <a:t>2</a:t>
-            </a:r>
-          </a:p>
-        </p:txBody>
-      </p:sp>
-      <p:sp>
-        <p:nvSpPr>
-          <p:cNvPr id="42" name="Rectangle 41"/>
+              <a:t>NOVO top-1 — Vina mais negativo do pipeline</a:t>
+            </a:r>
+          </a:p>
+        </p:txBody>
+      </p:sp>
+      <p:sp>
+        <p:nvSpPr>
+          <p:cNvPr id="43" name="Rectangle 42"/>
           <p:cNvSpPr/>
           <p:nvPr/>
         </p:nvSpPr>
         <p:spPr>
           <a:xfrm>
-            <a:off x="713232" y="3163824"/>
-            <a:ext cx="3840480" cy="283464"/>
-          </a:xfrm>
-          <a:prstGeom prst="rect">
-            <a:avLst/>
-          </a:prstGeom>
-          <a:solidFill>
-            <a:srgbClr val="FFFFFF"/>
+            <a:off x="365760" y="3227832"/>
+            <a:ext cx="64008" cy="347472"/>
+          </a:xfrm>
+          <a:prstGeom prst="rect">
+            <a:avLst/>
+          </a:prstGeom>
+          <a:solidFill>
+            <a:srgbClr val="06D6A0"/>
           </a:solidFill>
           <a:ln>
             <a:noFill/>
@@ -5519,49 +5554,14 @@
       </p:sp>
       <p:sp>
         <p:nvSpPr>
-          <p:cNvPr id="43" name="TextBox 42"/>
-          <p:cNvSpPr txBox="1"/>
-          <p:nvPr/>
-        </p:nvSpPr>
-        <p:spPr>
-          <a:xfrm>
-            <a:off x="749808" y="3182112"/>
-            <a:ext cx="3767328" cy="246888"/>
-          </a:xfrm>
-          <a:prstGeom prst="rect">
-            <a:avLst/>
-          </a:prstGeom>
-          <a:noFill/>
-        </p:spPr>
-        <p:txBody>
-          <a:bodyPr wrap="square">
-            <a:spAutoFit/>
-          </a:bodyPr>
-          <a:lstStyle/>
-          <a:p>
-            <a:pPr algn="l"/>
-            <a:r>
-              <a:rPr sz="900" b="1" i="0">
-                <a:solidFill>
-                  <a:srgbClr val="0D2B55"/>
-                </a:solidFill>
-                <a:latin typeface="Calibri"/>
-              </a:rPr>
-              <a:t>GARKSIREYQKRVLERLKKK</a:t>
-            </a:r>
-          </a:p>
-        </p:txBody>
-      </p:sp>
-      <p:sp>
-        <p:nvSpPr>
           <p:cNvPr id="44" name="Rectangle 43"/>
           <p:cNvSpPr/>
           <p:nvPr/>
         </p:nvSpPr>
         <p:spPr>
           <a:xfrm>
-            <a:off x="4553712" y="3163824"/>
-            <a:ext cx="384048" cy="283464"/>
+            <a:off x="365760" y="3227832"/>
+            <a:ext cx="347472" cy="347472"/>
           </a:xfrm>
           <a:prstGeom prst="rect">
             <a:avLst/>
@@ -5603,8 +5603,8 @@
         </p:nvSpPr>
         <p:spPr>
           <a:xfrm>
-            <a:off x="4590288" y="3182112"/>
-            <a:ext cx="310896" cy="246888"/>
+            <a:off x="402336" y="3246120"/>
+            <a:ext cx="274320" cy="310896"/>
           </a:xfrm>
           <a:prstGeom prst="rect">
             <a:avLst/>
@@ -5625,7 +5625,7 @@
                 </a:solidFill>
                 <a:latin typeface="Calibri"/>
               </a:rPr>
-              <a:t>20</a:t>
+              <a:t>2</a:t>
             </a:r>
           </a:p>
         </p:txBody>
@@ -5638,8 +5638,8 @@
         </p:nvSpPr>
         <p:spPr>
           <a:xfrm>
-            <a:off x="4937760" y="3163824"/>
-            <a:ext cx="1097280" cy="283464"/>
+            <a:off x="713232" y="3227832"/>
+            <a:ext cx="3657600" cy="347472"/>
           </a:xfrm>
           <a:prstGeom prst="rect">
             <a:avLst/>
@@ -5681,29 +5681,29 @@
         </p:nvSpPr>
         <p:spPr>
           <a:xfrm>
-            <a:off x="4974336" y="3182112"/>
-            <a:ext cx="1024127" cy="246888"/>
-          </a:xfrm>
-          <a:prstGeom prst="rect">
-            <a:avLst/>
-          </a:prstGeom>
-          <a:noFill/>
-        </p:spPr>
-        <p:txBody>
-          <a:bodyPr wrap="square">
-            <a:spAutoFit/>
-          </a:bodyPr>
-          <a:lstStyle/>
-          <a:p>
-            <a:pPr algn="ctr"/>
-            <a:r>
-              <a:rPr sz="1000" b="0" i="0">
-                <a:solidFill>
-                  <a:srgbClr val="06D6A0"/>
-                </a:solidFill>
-                <a:latin typeface="Calibri"/>
-              </a:rPr>
-              <a:t>-12.76</a:t>
+            <a:off x="749808" y="3246120"/>
+            <a:ext cx="3584448" cy="310896"/>
+          </a:xfrm>
+          <a:prstGeom prst="rect">
+            <a:avLst/>
+          </a:prstGeom>
+          <a:noFill/>
+        </p:spPr>
+        <p:txBody>
+          <a:bodyPr wrap="square">
+            <a:spAutoFit/>
+          </a:bodyPr>
+          <a:lstStyle/>
+          <a:p>
+            <a:pPr algn="l"/>
+            <a:r>
+              <a:rPr sz="900" b="1" i="0">
+                <a:solidFill>
+                  <a:srgbClr val="0D2B55"/>
+                </a:solidFill>
+                <a:latin typeface="Calibri"/>
+              </a:rPr>
+              <a:t>GSRASARAYAARVRARRAAL</a:t>
             </a:r>
           </a:p>
         </p:txBody>
@@ -5716,8 +5716,8 @@
         </p:nvSpPr>
         <p:spPr>
           <a:xfrm>
-            <a:off x="6035040" y="3163824"/>
-            <a:ext cx="5577840" cy="283464"/>
+            <a:off x="4370832" y="3227832"/>
+            <a:ext cx="384048" cy="347472"/>
           </a:xfrm>
           <a:prstGeom prst="rect">
             <a:avLst/>
@@ -5759,29 +5759,29 @@
         </p:nvSpPr>
         <p:spPr>
           <a:xfrm>
-            <a:off x="6071616" y="3182112"/>
-            <a:ext cx="5504688" cy="246888"/>
-          </a:xfrm>
-          <a:prstGeom prst="rect">
-            <a:avLst/>
-          </a:prstGeom>
-          <a:noFill/>
-        </p:spPr>
-        <p:txBody>
-          <a:bodyPr wrap="square">
-            <a:spAutoFit/>
-          </a:bodyPr>
-          <a:lstStyle/>
-          <a:p>
-            <a:pPr algn="l"/>
-            <a:r>
-              <a:rPr sz="900" b="0" i="0">
+            <a:off x="4407408" y="3246120"/>
+            <a:ext cx="310896" cy="310896"/>
+          </a:xfrm>
+          <a:prstGeom prst="rect">
+            <a:avLst/>
+          </a:prstGeom>
+          <a:noFill/>
+        </p:spPr>
+        <p:txBody>
+          <a:bodyPr wrap="square">
+            <a:spAutoFit/>
+          </a:bodyPr>
+          <a:lstStyle/>
+          <a:p>
+            <a:pPr algn="ctr"/>
+            <a:r>
+              <a:rPr sz="1000" b="0" i="0">
                 <a:solidFill>
                   <a:srgbClr val="333344"/>
                 </a:solidFill>
                 <a:latin typeface="Calibri"/>
               </a:rPr>
-              <a:t>Alta densidade R/K (n=9) + Glu/Tyr — melhor I_sc Rosetta</a:t>
+              <a:t>20</a:t>
             </a:r>
           </a:p>
         </p:txBody>
@@ -5794,14 +5794,14 @@
         </p:nvSpPr>
         <p:spPr>
           <a:xfrm>
-            <a:off x="365760" y="3447288"/>
-            <a:ext cx="64008" cy="283464"/>
-          </a:xfrm>
-          <a:prstGeom prst="rect">
-            <a:avLst/>
-          </a:prstGeom>
-          <a:solidFill>
-            <a:srgbClr val="06D6A0"/>
+            <a:off x="4754880" y="3227832"/>
+            <a:ext cx="1097280" cy="347472"/>
+          </a:xfrm>
+          <a:prstGeom prst="rect">
+            <a:avLst/>
+          </a:prstGeom>
+          <a:solidFill>
+            <a:srgbClr val="FFFFFF"/>
           </a:solidFill>
           <a:ln>
             <a:noFill/>
@@ -5831,20 +5831,55 @@
       </p:sp>
       <p:sp>
         <p:nvSpPr>
-          <p:cNvPr id="51" name="Rectangle 50"/>
+          <p:cNvPr id="51" name="TextBox 50"/>
+          <p:cNvSpPr txBox="1"/>
+          <p:nvPr/>
+        </p:nvSpPr>
+        <p:spPr>
+          <a:xfrm>
+            <a:off x="4791456" y="3246120"/>
+            <a:ext cx="1024127" cy="310896"/>
+          </a:xfrm>
+          <a:prstGeom prst="rect">
+            <a:avLst/>
+          </a:prstGeom>
+          <a:noFill/>
+        </p:spPr>
+        <p:txBody>
+          <a:bodyPr wrap="square">
+            <a:spAutoFit/>
+          </a:bodyPr>
+          <a:lstStyle/>
+          <a:p>
+            <a:pPr algn="ctr"/>
+            <a:r>
+              <a:rPr sz="1000" b="0" i="0">
+                <a:solidFill>
+                  <a:srgbClr val="333344"/>
+                </a:solidFill>
+                <a:latin typeface="Calibri"/>
+              </a:rPr>
+              <a:t>-13.62</a:t>
+            </a:r>
+          </a:p>
+        </p:txBody>
+      </p:sp>
+      <p:sp>
+        <p:nvSpPr>
+          <p:cNvPr id="52" name="Rectangle 51"/>
           <p:cNvSpPr/>
           <p:nvPr/>
         </p:nvSpPr>
         <p:spPr>
           <a:xfrm>
-            <a:off x="365760" y="3447288"/>
-            <a:ext cx="347472" cy="283464"/>
-          </a:xfrm>
-          <a:prstGeom prst="rect">
-            <a:avLst/>
-          </a:prstGeom>
-          <a:solidFill>
-            <a:srgbClr val="F0F4F8"/>
+            <a:off x="5852160" y="3227832"/>
+            <a:ext cx="777240" cy="347472"/>
+          </a:xfrm>
+          <a:prstGeom prst="rect">
+            <a:avLst/>
+          </a:prstGeom>
+          <a:solidFill>
+            <a:srgbClr val="FFFFFF"/>
           </a:solidFill>
           <a:ln>
             <a:noFill/>
@@ -5874,14 +5909,14 @@
       </p:sp>
       <p:sp>
         <p:nvSpPr>
-          <p:cNvPr id="52" name="TextBox 51"/>
-          <p:cNvSpPr txBox="1"/>
-          <p:nvPr/>
-        </p:nvSpPr>
-        <p:spPr>
-          <a:xfrm>
-            <a:off x="402336" y="3465576"/>
-            <a:ext cx="274320" cy="246888"/>
+          <p:cNvPr id="53" name="TextBox 52"/>
+          <p:cNvSpPr txBox="1"/>
+          <p:nvPr/>
+        </p:nvSpPr>
+        <p:spPr>
+          <a:xfrm>
+            <a:off x="5888736" y="3246120"/>
+            <a:ext cx="704088" cy="310896"/>
           </a:xfrm>
           <a:prstGeom prst="rect">
             <a:avLst/>
@@ -5902,27 +5937,27 @@
                 </a:solidFill>
                 <a:latin typeface="Calibri"/>
               </a:rPr>
-              <a:t>3</a:t>
-            </a:r>
-          </a:p>
-        </p:txBody>
-      </p:sp>
-      <p:sp>
-        <p:nvSpPr>
-          <p:cNvPr id="53" name="Rectangle 52"/>
+              <a:t>0.701</a:t>
+            </a:r>
+          </a:p>
+        </p:txBody>
+      </p:sp>
+      <p:sp>
+        <p:nvSpPr>
+          <p:cNvPr id="54" name="Rectangle 53"/>
           <p:cNvSpPr/>
           <p:nvPr/>
         </p:nvSpPr>
         <p:spPr>
           <a:xfrm>
-            <a:off x="713232" y="3447288"/>
-            <a:ext cx="3840480" cy="283464"/>
-          </a:xfrm>
-          <a:prstGeom prst="rect">
-            <a:avLst/>
-          </a:prstGeom>
-          <a:solidFill>
-            <a:srgbClr val="F0F4F8"/>
+            <a:off x="6629400" y="3227832"/>
+            <a:ext cx="5001768" cy="347472"/>
+          </a:xfrm>
+          <a:prstGeom prst="rect">
+            <a:avLst/>
+          </a:prstGeom>
+          <a:solidFill>
+            <a:srgbClr val="FFFFFF"/>
           </a:solidFill>
           <a:ln>
             <a:noFill/>
@@ -5952,14 +5987,14 @@
       </p:sp>
       <p:sp>
         <p:nvSpPr>
-          <p:cNvPr id="54" name="TextBox 53"/>
-          <p:cNvSpPr txBox="1"/>
-          <p:nvPr/>
-        </p:nvSpPr>
-        <p:spPr>
-          <a:xfrm>
-            <a:off x="749808" y="3465576"/>
-            <a:ext cx="3767328" cy="246888"/>
+          <p:cNvPr id="55" name="TextBox 54"/>
+          <p:cNvSpPr txBox="1"/>
+          <p:nvPr/>
+        </p:nvSpPr>
+        <p:spPr>
+          <a:xfrm>
+            <a:off x="6665976" y="3246120"/>
+            <a:ext cx="4928616" cy="310896"/>
           </a:xfrm>
           <a:prstGeom prst="rect">
             <a:avLst/>
@@ -5974,33 +6009,33 @@
           <a:p>
             <a:pPr algn="l"/>
             <a:r>
-              <a:rPr sz="900" b="1" i="0">
-                <a:solidFill>
-                  <a:srgbClr val="0D2B55"/>
-                </a:solidFill>
-                <a:latin typeface="Calibri"/>
-              </a:rPr>
-              <a:t>SLARKRAEENAKRFLERVKK</a:t>
-            </a:r>
-          </a:p>
-        </p:txBody>
-      </p:sp>
-      <p:sp>
-        <p:nvSpPr>
-          <p:cNvPr id="55" name="Rectangle 54"/>
+              <a:rPr sz="900" b="0" i="0">
+                <a:solidFill>
+                  <a:srgbClr val="333344"/>
+                </a:solidFill>
+                <a:latin typeface="Calibri"/>
+              </a:rPr>
+              <a:t>Validado por MD (RMSD 0,494 nm, ESTAVEL)</a:t>
+            </a:r>
+          </a:p>
+        </p:txBody>
+      </p:sp>
+      <p:sp>
+        <p:nvSpPr>
+          <p:cNvPr id="56" name="Rectangle 55"/>
           <p:cNvSpPr/>
           <p:nvPr/>
         </p:nvSpPr>
         <p:spPr>
           <a:xfrm>
-            <a:off x="4553712" y="3447288"/>
-            <a:ext cx="384048" cy="283464"/>
-          </a:xfrm>
-          <a:prstGeom prst="rect">
-            <a:avLst/>
-          </a:prstGeom>
-          <a:solidFill>
-            <a:srgbClr val="F0F4F8"/>
+            <a:off x="365760" y="3575304"/>
+            <a:ext cx="64008" cy="347472"/>
+          </a:xfrm>
+          <a:prstGeom prst="rect">
+            <a:avLst/>
+          </a:prstGeom>
+          <a:solidFill>
+            <a:srgbClr val="1A4F8A"/>
           </a:solidFill>
           <a:ln>
             <a:noFill/>
@@ -6030,49 +6065,14 @@
       </p:sp>
       <p:sp>
         <p:nvSpPr>
-          <p:cNvPr id="56" name="TextBox 55"/>
-          <p:cNvSpPr txBox="1"/>
-          <p:nvPr/>
-        </p:nvSpPr>
-        <p:spPr>
-          <a:xfrm>
-            <a:off x="4590288" y="3465576"/>
-            <a:ext cx="310896" cy="246888"/>
-          </a:xfrm>
-          <a:prstGeom prst="rect">
-            <a:avLst/>
-          </a:prstGeom>
-          <a:noFill/>
-        </p:spPr>
-        <p:txBody>
-          <a:bodyPr wrap="square">
-            <a:spAutoFit/>
-          </a:bodyPr>
-          <a:lstStyle/>
-          <a:p>
-            <a:pPr algn="ctr"/>
-            <a:r>
-              <a:rPr sz="1000" b="0" i="0">
-                <a:solidFill>
-                  <a:srgbClr val="333344"/>
-                </a:solidFill>
-                <a:latin typeface="Calibri"/>
-              </a:rPr>
-              <a:t>20</a:t>
-            </a:r>
-          </a:p>
-        </p:txBody>
-      </p:sp>
-      <p:sp>
-        <p:nvSpPr>
           <p:cNvPr id="57" name="Rectangle 56"/>
           <p:cNvSpPr/>
           <p:nvPr/>
         </p:nvSpPr>
         <p:spPr>
           <a:xfrm>
-            <a:off x="4937760" y="3447288"/>
-            <a:ext cx="1097280" cy="283464"/>
+            <a:off x="365760" y="3575304"/>
+            <a:ext cx="347472" cy="347472"/>
           </a:xfrm>
           <a:prstGeom prst="rect">
             <a:avLst/>
@@ -6114,8 +6114,8 @@
         </p:nvSpPr>
         <p:spPr>
           <a:xfrm>
-            <a:off x="4974336" y="3465576"/>
-            <a:ext cx="1024127" cy="246888"/>
+            <a:off x="402336" y="3593591"/>
+            <a:ext cx="274320" cy="310896"/>
           </a:xfrm>
           <a:prstGeom prst="rect">
             <a:avLst/>
@@ -6132,11 +6132,11 @@
             <a:r>
               <a:rPr sz="1000" b="0" i="0">
                 <a:solidFill>
-                  <a:srgbClr val="06D6A0"/>
-                </a:solidFill>
-                <a:latin typeface="Calibri"/>
-              </a:rPr>
-              <a:t>-12.71</a:t>
+                  <a:srgbClr val="333344"/>
+                </a:solidFill>
+                <a:latin typeface="Calibri"/>
+              </a:rPr>
+              <a:t>3</a:t>
             </a:r>
           </a:p>
         </p:txBody>
@@ -6149,8 +6149,8 @@
         </p:nvSpPr>
         <p:spPr>
           <a:xfrm>
-            <a:off x="6035040" y="3447288"/>
-            <a:ext cx="5577840" cy="283464"/>
+            <a:off x="713232" y="3575304"/>
+            <a:ext cx="3657600" cy="347472"/>
           </a:xfrm>
           <a:prstGeom prst="rect">
             <a:avLst/>
@@ -6192,8 +6192,8 @@
         </p:nvSpPr>
         <p:spPr>
           <a:xfrm>
-            <a:off x="6071616" y="3465576"/>
-            <a:ext cx="5504688" cy="246888"/>
+            <a:off x="749808" y="3593591"/>
+            <a:ext cx="3584448" cy="310896"/>
           </a:xfrm>
           <a:prstGeom prst="rect">
             <a:avLst/>
@@ -6210,11 +6210,11 @@
             <a:r>
               <a:rPr sz="900" b="0" i="0">
                 <a:solidFill>
-                  <a:srgbClr val="333344"/>
-                </a:solidFill>
-                <a:latin typeface="Calibri"/>
-              </a:rPr>
-              <a:t>Leu/Ala scaffold + R/K alternados</a:t>
+                  <a:srgbClr val="0D2B55"/>
+                </a:solidFill>
+                <a:latin typeface="Calibri"/>
+              </a:rPr>
+              <a:t>GARESIREHQKRFLERYKKK</a:t>
             </a:r>
           </a:p>
         </p:txBody>
@@ -6227,14 +6227,14 @@
         </p:nvSpPr>
         <p:spPr>
           <a:xfrm>
-            <a:off x="365760" y="3730752"/>
-            <a:ext cx="64008" cy="283464"/>
-          </a:xfrm>
-          <a:prstGeom prst="rect">
-            <a:avLst/>
-          </a:prstGeom>
-          <a:solidFill>
-            <a:srgbClr val="1A4F8A"/>
+            <a:off x="4370832" y="3575304"/>
+            <a:ext cx="384048" cy="347472"/>
+          </a:xfrm>
+          <a:prstGeom prst="rect">
+            <a:avLst/>
+          </a:prstGeom>
+          <a:solidFill>
+            <a:srgbClr val="F0F4F8"/>
           </a:solidFill>
           <a:ln>
             <a:noFill/>
@@ -6264,20 +6264,55 @@
       </p:sp>
       <p:sp>
         <p:nvSpPr>
-          <p:cNvPr id="62" name="Rectangle 61"/>
+          <p:cNvPr id="62" name="TextBox 61"/>
+          <p:cNvSpPr txBox="1"/>
+          <p:nvPr/>
+        </p:nvSpPr>
+        <p:spPr>
+          <a:xfrm>
+            <a:off x="4407408" y="3593591"/>
+            <a:ext cx="310896" cy="310896"/>
+          </a:xfrm>
+          <a:prstGeom prst="rect">
+            <a:avLst/>
+          </a:prstGeom>
+          <a:noFill/>
+        </p:spPr>
+        <p:txBody>
+          <a:bodyPr wrap="square">
+            <a:spAutoFit/>
+          </a:bodyPr>
+          <a:lstStyle/>
+          <a:p>
+            <a:pPr algn="ctr"/>
+            <a:r>
+              <a:rPr sz="1000" b="0" i="0">
+                <a:solidFill>
+                  <a:srgbClr val="333344"/>
+                </a:solidFill>
+                <a:latin typeface="Calibri"/>
+              </a:rPr>
+              <a:t>20</a:t>
+            </a:r>
+          </a:p>
+        </p:txBody>
+      </p:sp>
+      <p:sp>
+        <p:nvSpPr>
+          <p:cNvPr id="63" name="Rectangle 62"/>
           <p:cNvSpPr/>
           <p:nvPr/>
         </p:nvSpPr>
         <p:spPr>
           <a:xfrm>
-            <a:off x="365760" y="3730752"/>
-            <a:ext cx="347472" cy="283464"/>
-          </a:xfrm>
-          <a:prstGeom prst="rect">
-            <a:avLst/>
-          </a:prstGeom>
-          <a:solidFill>
-            <a:srgbClr val="FFFFFF"/>
+            <a:off x="4754880" y="3575304"/>
+            <a:ext cx="1097280" cy="347472"/>
+          </a:xfrm>
+          <a:prstGeom prst="rect">
+            <a:avLst/>
+          </a:prstGeom>
+          <a:solidFill>
+            <a:srgbClr val="F0F4F8"/>
           </a:solidFill>
           <a:ln>
             <a:noFill/>
@@ -6307,14 +6342,14 @@
       </p:sp>
       <p:sp>
         <p:nvSpPr>
-          <p:cNvPr id="63" name="TextBox 62"/>
-          <p:cNvSpPr txBox="1"/>
-          <p:nvPr/>
-        </p:nvSpPr>
-        <p:spPr>
-          <a:xfrm>
-            <a:off x="402336" y="3749039"/>
-            <a:ext cx="274320" cy="246888"/>
+          <p:cNvPr id="64" name="TextBox 63"/>
+          <p:cNvSpPr txBox="1"/>
+          <p:nvPr/>
+        </p:nvSpPr>
+        <p:spPr>
+          <a:xfrm>
+            <a:off x="4791456" y="3593591"/>
+            <a:ext cx="1024127" cy="310896"/>
           </a:xfrm>
           <a:prstGeom prst="rect">
             <a:avLst/>
@@ -6335,27 +6370,27 @@
                 </a:solidFill>
                 <a:latin typeface="Calibri"/>
               </a:rPr>
-              <a:t>4</a:t>
-            </a:r>
-          </a:p>
-        </p:txBody>
-      </p:sp>
-      <p:sp>
-        <p:nvSpPr>
-          <p:cNvPr id="64" name="Rectangle 63"/>
+              <a:t>-13.56</a:t>
+            </a:r>
+          </a:p>
+        </p:txBody>
+      </p:sp>
+      <p:sp>
+        <p:nvSpPr>
+          <p:cNvPr id="65" name="Rectangle 64"/>
           <p:cNvSpPr/>
           <p:nvPr/>
         </p:nvSpPr>
         <p:spPr>
           <a:xfrm>
-            <a:off x="713232" y="3730752"/>
-            <a:ext cx="3840480" cy="283464"/>
-          </a:xfrm>
-          <a:prstGeom prst="rect">
-            <a:avLst/>
-          </a:prstGeom>
-          <a:solidFill>
-            <a:srgbClr val="FFFFFF"/>
+            <a:off x="5852160" y="3575304"/>
+            <a:ext cx="777240" cy="347472"/>
+          </a:xfrm>
+          <a:prstGeom prst="rect">
+            <a:avLst/>
+          </a:prstGeom>
+          <a:solidFill>
+            <a:srgbClr val="F0F4F8"/>
           </a:solidFill>
           <a:ln>
             <a:noFill/>
@@ -6385,55 +6420,55 @@
       </p:sp>
       <p:sp>
         <p:nvSpPr>
-          <p:cNvPr id="65" name="TextBox 64"/>
-          <p:cNvSpPr txBox="1"/>
-          <p:nvPr/>
-        </p:nvSpPr>
-        <p:spPr>
-          <a:xfrm>
-            <a:off x="749808" y="3749039"/>
-            <a:ext cx="3767328" cy="246888"/>
-          </a:xfrm>
-          <a:prstGeom prst="rect">
-            <a:avLst/>
-          </a:prstGeom>
-          <a:noFill/>
-        </p:spPr>
-        <p:txBody>
-          <a:bodyPr wrap="square">
-            <a:spAutoFit/>
-          </a:bodyPr>
-          <a:lstStyle/>
-          <a:p>
-            <a:pPr algn="l"/>
-            <a:r>
-              <a:rPr sz="900" b="0" i="0">
-                <a:solidFill>
-                  <a:srgbClr val="0D2B55"/>
-                </a:solidFill>
-                <a:latin typeface="Calibri"/>
-              </a:rPr>
-              <a:t>MKKQRENAKKVAEITLKKAK</a:t>
-            </a:r>
-          </a:p>
-        </p:txBody>
-      </p:sp>
-      <p:sp>
-        <p:nvSpPr>
-          <p:cNvPr id="66" name="Rectangle 65"/>
+          <p:cNvPr id="66" name="TextBox 65"/>
+          <p:cNvSpPr txBox="1"/>
+          <p:nvPr/>
+        </p:nvSpPr>
+        <p:spPr>
+          <a:xfrm>
+            <a:off x="5888736" y="3593591"/>
+            <a:ext cx="704088" cy="310896"/>
+          </a:xfrm>
+          <a:prstGeom prst="rect">
+            <a:avLst/>
+          </a:prstGeom>
+          <a:noFill/>
+        </p:spPr>
+        <p:txBody>
+          <a:bodyPr wrap="square">
+            <a:spAutoFit/>
+          </a:bodyPr>
+          <a:lstStyle/>
+          <a:p>
+            <a:pPr algn="ctr"/>
+            <a:r>
+              <a:rPr sz="1000" b="0" i="0">
+                <a:solidFill>
+                  <a:srgbClr val="333344"/>
+                </a:solidFill>
+                <a:latin typeface="Calibri"/>
+              </a:rPr>
+              <a:t>0.661</a:t>
+            </a:r>
+          </a:p>
+        </p:txBody>
+      </p:sp>
+      <p:sp>
+        <p:nvSpPr>
+          <p:cNvPr id="67" name="Rectangle 66"/>
           <p:cNvSpPr/>
           <p:nvPr/>
         </p:nvSpPr>
         <p:spPr>
           <a:xfrm>
-            <a:off x="4553712" y="3730752"/>
-            <a:ext cx="384048" cy="283464"/>
-          </a:xfrm>
-          <a:prstGeom prst="rect">
-            <a:avLst/>
-          </a:prstGeom>
-          <a:solidFill>
-            <a:srgbClr val="FFFFFF"/>
+            <a:off x="6629400" y="3575304"/>
+            <a:ext cx="5001768" cy="347472"/>
+          </a:xfrm>
+          <a:prstGeom prst="rect">
+            <a:avLst/>
+          </a:prstGeom>
+          <a:solidFill>
+            <a:srgbClr val="F0F4F8"/>
           </a:solidFill>
           <a:ln>
             <a:noFill/>
@@ -6463,55 +6498,55 @@
       </p:sp>
       <p:sp>
         <p:nvSpPr>
-          <p:cNvPr id="67" name="TextBox 66"/>
-          <p:cNvSpPr txBox="1"/>
-          <p:nvPr/>
-        </p:nvSpPr>
-        <p:spPr>
-          <a:xfrm>
-            <a:off x="4590288" y="3749039"/>
-            <a:ext cx="310896" cy="246888"/>
-          </a:xfrm>
-          <a:prstGeom prst="rect">
-            <a:avLst/>
-          </a:prstGeom>
-          <a:noFill/>
-        </p:spPr>
-        <p:txBody>
-          <a:bodyPr wrap="square">
-            <a:spAutoFit/>
-          </a:bodyPr>
-          <a:lstStyle/>
-          <a:p>
-            <a:pPr algn="ctr"/>
-            <a:r>
-              <a:rPr sz="1000" b="0" i="0">
+          <p:cNvPr id="68" name="TextBox 67"/>
+          <p:cNvSpPr txBox="1"/>
+          <p:nvPr/>
+        </p:nvSpPr>
+        <p:spPr>
+          <a:xfrm>
+            <a:off x="6665976" y="3593591"/>
+            <a:ext cx="4928616" cy="310896"/>
+          </a:xfrm>
+          <a:prstGeom prst="rect">
+            <a:avLst/>
+          </a:prstGeom>
+          <a:noFill/>
+        </p:spPr>
+        <p:txBody>
+          <a:bodyPr wrap="square">
+            <a:spAutoFit/>
+          </a:bodyPr>
+          <a:lstStyle/>
+          <a:p>
+            <a:pPr algn="l"/>
+            <a:r>
+              <a:rPr sz="900" b="0" i="0">
                 <a:solidFill>
                   <a:srgbClr val="333344"/>
                 </a:solidFill>
                 <a:latin typeface="Calibri"/>
               </a:rPr>
-              <a:t>20</a:t>
-            </a:r>
-          </a:p>
-        </p:txBody>
-      </p:sp>
-      <p:sp>
-        <p:nvSpPr>
-          <p:cNvPr id="68" name="Rectangle 67"/>
+              <a:t>Gly/Ala + Glu/His + R/K C-term</a:t>
+            </a:r>
+          </a:p>
+        </p:txBody>
+      </p:sp>
+      <p:sp>
+        <p:nvSpPr>
+          <p:cNvPr id="69" name="Rectangle 68"/>
           <p:cNvSpPr/>
           <p:nvPr/>
         </p:nvSpPr>
         <p:spPr>
           <a:xfrm>
-            <a:off x="4937760" y="3730752"/>
-            <a:ext cx="1097280" cy="283464"/>
-          </a:xfrm>
-          <a:prstGeom prst="rect">
-            <a:avLst/>
-          </a:prstGeom>
-          <a:solidFill>
-            <a:srgbClr val="FFFFFF"/>
+            <a:off x="365760" y="3922776"/>
+            <a:ext cx="64008" cy="347472"/>
+          </a:xfrm>
+          <a:prstGeom prst="rect">
+            <a:avLst/>
+          </a:prstGeom>
+          <a:solidFill>
+            <a:srgbClr val="1A4F8A"/>
           </a:solidFill>
           <a:ln>
             <a:noFill/>
@@ -6541,49 +6576,14 @@
       </p:sp>
       <p:sp>
         <p:nvSpPr>
-          <p:cNvPr id="69" name="TextBox 68"/>
-          <p:cNvSpPr txBox="1"/>
-          <p:nvPr/>
-        </p:nvSpPr>
-        <p:spPr>
-          <a:xfrm>
-            <a:off x="4974336" y="3749039"/>
-            <a:ext cx="1024127" cy="246888"/>
-          </a:xfrm>
-          <a:prstGeom prst="rect">
-            <a:avLst/>
-          </a:prstGeom>
-          <a:noFill/>
-        </p:spPr>
-        <p:txBody>
-          <a:bodyPr wrap="square">
-            <a:spAutoFit/>
-          </a:bodyPr>
-          <a:lstStyle/>
-          <a:p>
-            <a:pPr algn="ctr"/>
-            <a:r>
-              <a:rPr sz="1000" b="0" i="0">
-                <a:solidFill>
-                  <a:srgbClr val="333344"/>
-                </a:solidFill>
-                <a:latin typeface="Calibri"/>
-              </a:rPr>
-              <a:t>-12.68</a:t>
-            </a:r>
-          </a:p>
-        </p:txBody>
-      </p:sp>
-      <p:sp>
-        <p:nvSpPr>
           <p:cNvPr id="70" name="Rectangle 69"/>
           <p:cNvSpPr/>
           <p:nvPr/>
         </p:nvSpPr>
         <p:spPr>
           <a:xfrm>
-            <a:off x="6035040" y="3730752"/>
-            <a:ext cx="5577840" cy="283464"/>
+            <a:off x="365760" y="3922776"/>
+            <a:ext cx="347472" cy="347472"/>
           </a:xfrm>
           <a:prstGeom prst="rect">
             <a:avLst/>
@@ -6625,29 +6625,29 @@
         </p:nvSpPr>
         <p:spPr>
           <a:xfrm>
-            <a:off x="6071616" y="3749039"/>
-            <a:ext cx="5504688" cy="246888"/>
-          </a:xfrm>
-          <a:prstGeom prst="rect">
-            <a:avLst/>
-          </a:prstGeom>
-          <a:noFill/>
-        </p:spPr>
-        <p:txBody>
-          <a:bodyPr wrap="square">
-            <a:spAutoFit/>
-          </a:bodyPr>
-          <a:lstStyle/>
-          <a:p>
-            <a:pPr algn="l"/>
-            <a:r>
-              <a:rPr sz="900" b="0" i="0">
+            <a:off x="402336" y="3941064"/>
+            <a:ext cx="274320" cy="310896"/>
+          </a:xfrm>
+          <a:prstGeom prst="rect">
+            <a:avLst/>
+          </a:prstGeom>
+          <a:noFill/>
+        </p:spPr>
+        <p:txBody>
+          <a:bodyPr wrap="square">
+            <a:spAutoFit/>
+          </a:bodyPr>
+          <a:lstStyle/>
+          <a:p>
+            <a:pPr algn="ctr"/>
+            <a:r>
+              <a:rPr sz="1000" b="0" i="0">
                 <a:solidFill>
                   <a:srgbClr val="333344"/>
                 </a:solidFill>
                 <a:latin typeface="Calibri"/>
               </a:rPr>
-              <a:t>Lys-rico (n=8), alifatico, solúvel</a:t>
+              <a:t>4</a:t>
             </a:r>
           </a:p>
         </p:txBody>
@@ -6660,14 +6660,14 @@
         </p:nvSpPr>
         <p:spPr>
           <a:xfrm>
-            <a:off x="365760" y="4014215"/>
-            <a:ext cx="64008" cy="283464"/>
-          </a:xfrm>
-          <a:prstGeom prst="rect">
-            <a:avLst/>
-          </a:prstGeom>
-          <a:solidFill>
-            <a:srgbClr val="1A4F8A"/>
+            <a:off x="713232" y="3922776"/>
+            <a:ext cx="3657600" cy="347472"/>
+          </a:xfrm>
+          <a:prstGeom prst="rect">
+            <a:avLst/>
+          </a:prstGeom>
+          <a:solidFill>
+            <a:srgbClr val="FFFFFF"/>
           </a:solidFill>
           <a:ln>
             <a:noFill/>
@@ -6697,20 +6697,55 @@
       </p:sp>
       <p:sp>
         <p:nvSpPr>
-          <p:cNvPr id="73" name="Rectangle 72"/>
+          <p:cNvPr id="73" name="TextBox 72"/>
+          <p:cNvSpPr txBox="1"/>
+          <p:nvPr/>
+        </p:nvSpPr>
+        <p:spPr>
+          <a:xfrm>
+            <a:off x="749808" y="3941064"/>
+            <a:ext cx="3584448" cy="310896"/>
+          </a:xfrm>
+          <a:prstGeom prst="rect">
+            <a:avLst/>
+          </a:prstGeom>
+          <a:noFill/>
+        </p:spPr>
+        <p:txBody>
+          <a:bodyPr wrap="square">
+            <a:spAutoFit/>
+          </a:bodyPr>
+          <a:lstStyle/>
+          <a:p>
+            <a:pPr algn="l"/>
+            <a:r>
+              <a:rPr sz="900" b="0" i="0">
+                <a:solidFill>
+                  <a:srgbClr val="0D2B55"/>
+                </a:solidFill>
+                <a:latin typeface="Calibri"/>
+              </a:rPr>
+              <a:t>GGPTGKRIAELYKKSLEKKK</a:t>
+            </a:r>
+          </a:p>
+        </p:txBody>
+      </p:sp>
+      <p:sp>
+        <p:nvSpPr>
+          <p:cNvPr id="74" name="Rectangle 73"/>
           <p:cNvSpPr/>
           <p:nvPr/>
         </p:nvSpPr>
         <p:spPr>
           <a:xfrm>
-            <a:off x="365760" y="4014215"/>
-            <a:ext cx="347472" cy="283464"/>
-          </a:xfrm>
-          <a:prstGeom prst="rect">
-            <a:avLst/>
-          </a:prstGeom>
-          <a:solidFill>
-            <a:srgbClr val="F0F4F8"/>
+            <a:off x="4370832" y="3922776"/>
+            <a:ext cx="384048" cy="347472"/>
+          </a:xfrm>
+          <a:prstGeom prst="rect">
+            <a:avLst/>
+          </a:prstGeom>
+          <a:solidFill>
+            <a:srgbClr val="FFFFFF"/>
           </a:solidFill>
           <a:ln>
             <a:noFill/>
@@ -6740,14 +6775,14 @@
       </p:sp>
       <p:sp>
         <p:nvSpPr>
-          <p:cNvPr id="74" name="TextBox 73"/>
-          <p:cNvSpPr txBox="1"/>
-          <p:nvPr/>
-        </p:nvSpPr>
-        <p:spPr>
-          <a:xfrm>
-            <a:off x="402336" y="4032504"/>
-            <a:ext cx="274320" cy="246888"/>
+          <p:cNvPr id="75" name="TextBox 74"/>
+          <p:cNvSpPr txBox="1"/>
+          <p:nvPr/>
+        </p:nvSpPr>
+        <p:spPr>
+          <a:xfrm>
+            <a:off x="4407408" y="3941064"/>
+            <a:ext cx="310896" cy="310896"/>
           </a:xfrm>
           <a:prstGeom prst="rect">
             <a:avLst/>
@@ -6768,27 +6803,27 @@
                 </a:solidFill>
                 <a:latin typeface="Calibri"/>
               </a:rPr>
-              <a:t>5</a:t>
-            </a:r>
-          </a:p>
-        </p:txBody>
-      </p:sp>
-      <p:sp>
-        <p:nvSpPr>
-          <p:cNvPr id="75" name="Rectangle 74"/>
+              <a:t>20</a:t>
+            </a:r>
+          </a:p>
+        </p:txBody>
+      </p:sp>
+      <p:sp>
+        <p:nvSpPr>
+          <p:cNvPr id="76" name="Rectangle 75"/>
           <p:cNvSpPr/>
           <p:nvPr/>
         </p:nvSpPr>
         <p:spPr>
           <a:xfrm>
-            <a:off x="713232" y="4014215"/>
-            <a:ext cx="3840480" cy="283464"/>
-          </a:xfrm>
-          <a:prstGeom prst="rect">
-            <a:avLst/>
-          </a:prstGeom>
-          <a:solidFill>
-            <a:srgbClr val="F0F4F8"/>
+            <a:off x="4754880" y="3922776"/>
+            <a:ext cx="1097280" cy="347472"/>
+          </a:xfrm>
+          <a:prstGeom prst="rect">
+            <a:avLst/>
+          </a:prstGeom>
+          <a:solidFill>
+            <a:srgbClr val="FFFFFF"/>
           </a:solidFill>
           <a:ln>
             <a:noFill/>
@@ -6818,55 +6853,55 @@
       </p:sp>
       <p:sp>
         <p:nvSpPr>
-          <p:cNvPr id="76" name="TextBox 75"/>
-          <p:cNvSpPr txBox="1"/>
-          <p:nvPr/>
-        </p:nvSpPr>
-        <p:spPr>
-          <a:xfrm>
-            <a:off x="749808" y="4032504"/>
-            <a:ext cx="3767328" cy="246888"/>
-          </a:xfrm>
-          <a:prstGeom prst="rect">
-            <a:avLst/>
-          </a:prstGeom>
-          <a:noFill/>
-        </p:spPr>
-        <p:txBody>
-          <a:bodyPr wrap="square">
-            <a:spAutoFit/>
-          </a:bodyPr>
-          <a:lstStyle/>
-          <a:p>
-            <a:pPr algn="l"/>
-            <a:r>
-              <a:rPr sz="900" b="0" i="0">
-                <a:solidFill>
-                  <a:srgbClr val="0D2B55"/>
-                </a:solidFill>
-                <a:latin typeface="Calibri"/>
-              </a:rPr>
-              <a:t>AARASIRAAAARFRARRAAL</a:t>
-            </a:r>
-          </a:p>
-        </p:txBody>
-      </p:sp>
-      <p:sp>
-        <p:nvSpPr>
-          <p:cNvPr id="77" name="Rectangle 76"/>
+          <p:cNvPr id="77" name="TextBox 76"/>
+          <p:cNvSpPr txBox="1"/>
+          <p:nvPr/>
+        </p:nvSpPr>
+        <p:spPr>
+          <a:xfrm>
+            <a:off x="4791456" y="3941064"/>
+            <a:ext cx="1024127" cy="310896"/>
+          </a:xfrm>
+          <a:prstGeom prst="rect">
+            <a:avLst/>
+          </a:prstGeom>
+          <a:noFill/>
+        </p:spPr>
+        <p:txBody>
+          <a:bodyPr wrap="square">
+            <a:spAutoFit/>
+          </a:bodyPr>
+          <a:lstStyle/>
+          <a:p>
+            <a:pPr algn="ctr"/>
+            <a:r>
+              <a:rPr sz="1000" b="0" i="0">
+                <a:solidFill>
+                  <a:srgbClr val="333344"/>
+                </a:solidFill>
+                <a:latin typeface="Calibri"/>
+              </a:rPr>
+              <a:t>-13.47</a:t>
+            </a:r>
+          </a:p>
+        </p:txBody>
+      </p:sp>
+      <p:sp>
+        <p:nvSpPr>
+          <p:cNvPr id="78" name="Rectangle 77"/>
           <p:cNvSpPr/>
           <p:nvPr/>
         </p:nvSpPr>
         <p:spPr>
           <a:xfrm>
-            <a:off x="4553712" y="4014215"/>
-            <a:ext cx="384048" cy="283464"/>
-          </a:xfrm>
-          <a:prstGeom prst="rect">
-            <a:avLst/>
-          </a:prstGeom>
-          <a:solidFill>
-            <a:srgbClr val="F0F4F8"/>
+            <a:off x="5852160" y="3922776"/>
+            <a:ext cx="777240" cy="347472"/>
+          </a:xfrm>
+          <a:prstGeom prst="rect">
+            <a:avLst/>
+          </a:prstGeom>
+          <a:solidFill>
+            <a:srgbClr val="FFFFFF"/>
           </a:solidFill>
           <a:ln>
             <a:noFill/>
@@ -6896,14 +6931,14 @@
       </p:sp>
       <p:sp>
         <p:nvSpPr>
-          <p:cNvPr id="78" name="TextBox 77"/>
-          <p:cNvSpPr txBox="1"/>
-          <p:nvPr/>
-        </p:nvSpPr>
-        <p:spPr>
-          <a:xfrm>
-            <a:off x="4590288" y="4032504"/>
-            <a:ext cx="310896" cy="246888"/>
+          <p:cNvPr id="79" name="TextBox 78"/>
+          <p:cNvSpPr txBox="1"/>
+          <p:nvPr/>
+        </p:nvSpPr>
+        <p:spPr>
+          <a:xfrm>
+            <a:off x="5888736" y="3941064"/>
+            <a:ext cx="704088" cy="310896"/>
           </a:xfrm>
           <a:prstGeom prst="rect">
             <a:avLst/>
@@ -6924,27 +6959,27 @@
                 </a:solidFill>
                 <a:latin typeface="Calibri"/>
               </a:rPr>
-              <a:t>20</a:t>
-            </a:r>
-          </a:p>
-        </p:txBody>
-      </p:sp>
-      <p:sp>
-        <p:nvSpPr>
-          <p:cNvPr id="79" name="Rectangle 78"/>
+              <a:t>0.653</a:t>
+            </a:r>
+          </a:p>
+        </p:txBody>
+      </p:sp>
+      <p:sp>
+        <p:nvSpPr>
+          <p:cNvPr id="80" name="Rectangle 79"/>
           <p:cNvSpPr/>
           <p:nvPr/>
         </p:nvSpPr>
         <p:spPr>
           <a:xfrm>
-            <a:off x="4937760" y="4014215"/>
-            <a:ext cx="1097280" cy="283464"/>
-          </a:xfrm>
-          <a:prstGeom prst="rect">
-            <a:avLst/>
-          </a:prstGeom>
-          <a:solidFill>
-            <a:srgbClr val="F0F4F8"/>
+            <a:off x="6629400" y="3922776"/>
+            <a:ext cx="5001768" cy="347472"/>
+          </a:xfrm>
+          <a:prstGeom prst="rect">
+            <a:avLst/>
+          </a:prstGeom>
+          <a:solidFill>
+            <a:srgbClr val="FFFFFF"/>
           </a:solidFill>
           <a:ln>
             <a:noFill/>
@@ -6974,55 +7009,55 @@
       </p:sp>
       <p:sp>
         <p:nvSpPr>
-          <p:cNvPr id="80" name="TextBox 79"/>
-          <p:cNvSpPr txBox="1"/>
-          <p:nvPr/>
-        </p:nvSpPr>
-        <p:spPr>
-          <a:xfrm>
-            <a:off x="4974336" y="4032504"/>
-            <a:ext cx="1024127" cy="246888"/>
-          </a:xfrm>
-          <a:prstGeom prst="rect">
-            <a:avLst/>
-          </a:prstGeom>
-          <a:noFill/>
-        </p:spPr>
-        <p:txBody>
-          <a:bodyPr wrap="square">
-            <a:spAutoFit/>
-          </a:bodyPr>
-          <a:lstStyle/>
-          <a:p>
-            <a:pPr algn="ctr"/>
-            <a:r>
-              <a:rPr sz="1000" b="0" i="0">
+          <p:cNvPr id="81" name="TextBox 80"/>
+          <p:cNvSpPr txBox="1"/>
+          <p:nvPr/>
+        </p:nvSpPr>
+        <p:spPr>
+          <a:xfrm>
+            <a:off x="6665976" y="3941064"/>
+            <a:ext cx="4928616" cy="310896"/>
+          </a:xfrm>
+          <a:prstGeom prst="rect">
+            <a:avLst/>
+          </a:prstGeom>
+          <a:noFill/>
+        </p:spPr>
+        <p:txBody>
+          <a:bodyPr wrap="square">
+            <a:spAutoFit/>
+          </a:bodyPr>
+          <a:lstStyle/>
+          <a:p>
+            <a:pPr algn="l"/>
+            <a:r>
+              <a:rPr sz="900" b="0" i="0">
                 <a:solidFill>
                   <a:srgbClr val="333344"/>
                 </a:solidFill>
                 <a:latin typeface="Calibri"/>
               </a:rPr>
-              <a:t>-12.62</a:t>
-            </a:r>
-          </a:p>
-        </p:txBody>
-      </p:sp>
-      <p:sp>
-        <p:nvSpPr>
-          <p:cNvPr id="81" name="Rectangle 80"/>
+              <a:t>Gly/Pro scaffold + Lys-rico</a:t>
+            </a:r>
+          </a:p>
+        </p:txBody>
+      </p:sp>
+      <p:sp>
+        <p:nvSpPr>
+          <p:cNvPr id="82" name="Rectangle 81"/>
           <p:cNvSpPr/>
           <p:nvPr/>
         </p:nvSpPr>
         <p:spPr>
           <a:xfrm>
-            <a:off x="6035040" y="4014215"/>
-            <a:ext cx="5577840" cy="283464"/>
-          </a:xfrm>
-          <a:prstGeom prst="rect">
-            <a:avLst/>
-          </a:prstGeom>
-          <a:solidFill>
-            <a:srgbClr val="F0F4F8"/>
+            <a:off x="365760" y="4270248"/>
+            <a:ext cx="64008" cy="347472"/>
+          </a:xfrm>
+          <a:prstGeom prst="rect">
+            <a:avLst/>
+          </a:prstGeom>
+          <a:solidFill>
+            <a:srgbClr val="1A4F8A"/>
           </a:solidFill>
           <a:ln>
             <a:noFill/>
@@ -7052,55 +7087,20 @@
       </p:sp>
       <p:sp>
         <p:nvSpPr>
-          <p:cNvPr id="82" name="TextBox 81"/>
-          <p:cNvSpPr txBox="1"/>
-          <p:nvPr/>
-        </p:nvSpPr>
-        <p:spPr>
-          <a:xfrm>
-            <a:off x="6071616" y="4032504"/>
-            <a:ext cx="5504688" cy="246888"/>
-          </a:xfrm>
-          <a:prstGeom prst="rect">
-            <a:avLst/>
-          </a:prstGeom>
-          <a:noFill/>
-        </p:spPr>
-        <p:txBody>
-          <a:bodyPr wrap="square">
-            <a:spAutoFit/>
-          </a:bodyPr>
-          <a:lstStyle/>
-          <a:p>
-            <a:pPr algn="l"/>
-            <a:r>
-              <a:rPr sz="900" b="0" i="0">
-                <a:solidFill>
-                  <a:srgbClr val="333344"/>
-                </a:solidFill>
-                <a:latin typeface="Calibri"/>
-              </a:rPr>
-              <a:t>Ala-rico com Arg interno e Phe aromático</a:t>
-            </a:r>
-          </a:p>
-        </p:txBody>
-      </p:sp>
-      <p:sp>
-        <p:nvSpPr>
           <p:cNvPr id="83" name="Rectangle 82"/>
           <p:cNvSpPr/>
           <p:nvPr/>
         </p:nvSpPr>
         <p:spPr>
           <a:xfrm>
-            <a:off x="365760" y="4297680"/>
-            <a:ext cx="64008" cy="283464"/>
-          </a:xfrm>
-          <a:prstGeom prst="rect">
-            <a:avLst/>
-          </a:prstGeom>
-          <a:solidFill>
-            <a:srgbClr val="1A4F8A"/>
+            <a:off x="365760" y="4270248"/>
+            <a:ext cx="347472" cy="347472"/>
+          </a:xfrm>
+          <a:prstGeom prst="rect">
+            <a:avLst/>
+          </a:prstGeom>
+          <a:solidFill>
+            <a:srgbClr val="F0F4F8"/>
           </a:solidFill>
           <a:ln>
             <a:noFill/>
@@ -7130,20 +7130,55 @@
       </p:sp>
       <p:sp>
         <p:nvSpPr>
-          <p:cNvPr id="84" name="Rectangle 83"/>
+          <p:cNvPr id="84" name="TextBox 83"/>
+          <p:cNvSpPr txBox="1"/>
+          <p:nvPr/>
+        </p:nvSpPr>
+        <p:spPr>
+          <a:xfrm>
+            <a:off x="402336" y="4288536"/>
+            <a:ext cx="274320" cy="310896"/>
+          </a:xfrm>
+          <a:prstGeom prst="rect">
+            <a:avLst/>
+          </a:prstGeom>
+          <a:noFill/>
+        </p:spPr>
+        <p:txBody>
+          <a:bodyPr wrap="square">
+            <a:spAutoFit/>
+          </a:bodyPr>
+          <a:lstStyle/>
+          <a:p>
+            <a:pPr algn="ctr"/>
+            <a:r>
+              <a:rPr sz="1000" b="0" i="0">
+                <a:solidFill>
+                  <a:srgbClr val="333344"/>
+                </a:solidFill>
+                <a:latin typeface="Calibri"/>
+              </a:rPr>
+              <a:t>5</a:t>
+            </a:r>
+          </a:p>
+        </p:txBody>
+      </p:sp>
+      <p:sp>
+        <p:nvSpPr>
+          <p:cNvPr id="85" name="Rectangle 84"/>
           <p:cNvSpPr/>
           <p:nvPr/>
         </p:nvSpPr>
         <p:spPr>
           <a:xfrm>
-            <a:off x="365760" y="4297680"/>
-            <a:ext cx="347472" cy="283464"/>
-          </a:xfrm>
-          <a:prstGeom prst="rect">
-            <a:avLst/>
-          </a:prstGeom>
-          <a:solidFill>
-            <a:srgbClr val="FFFFFF"/>
+            <a:off x="713232" y="4270248"/>
+            <a:ext cx="3657600" cy="347472"/>
+          </a:xfrm>
+          <a:prstGeom prst="rect">
+            <a:avLst/>
+          </a:prstGeom>
+          <a:solidFill>
+            <a:srgbClr val="F0F4F8"/>
           </a:solidFill>
           <a:ln>
             <a:noFill/>
@@ -7173,55 +7208,55 @@
       </p:sp>
       <p:sp>
         <p:nvSpPr>
-          <p:cNvPr id="85" name="TextBox 84"/>
-          <p:cNvSpPr txBox="1"/>
-          <p:nvPr/>
-        </p:nvSpPr>
-        <p:spPr>
-          <a:xfrm>
-            <a:off x="402336" y="4315968"/>
-            <a:ext cx="274320" cy="246888"/>
-          </a:xfrm>
-          <a:prstGeom prst="rect">
-            <a:avLst/>
-          </a:prstGeom>
-          <a:noFill/>
-        </p:spPr>
-        <p:txBody>
-          <a:bodyPr wrap="square">
-            <a:spAutoFit/>
-          </a:bodyPr>
-          <a:lstStyle/>
-          <a:p>
-            <a:pPr algn="ctr"/>
-            <a:r>
-              <a:rPr sz="1000" b="0" i="0">
-                <a:solidFill>
-                  <a:srgbClr val="333344"/>
-                </a:solidFill>
-                <a:latin typeface="Calibri"/>
-              </a:rPr>
-              <a:t>6</a:t>
-            </a:r>
-          </a:p>
-        </p:txBody>
-      </p:sp>
-      <p:sp>
-        <p:nvSpPr>
-          <p:cNvPr id="86" name="Rectangle 85"/>
+          <p:cNvPr id="86" name="TextBox 85"/>
+          <p:cNvSpPr txBox="1"/>
+          <p:nvPr/>
+        </p:nvSpPr>
+        <p:spPr>
+          <a:xfrm>
+            <a:off x="749808" y="4288536"/>
+            <a:ext cx="3584448" cy="310896"/>
+          </a:xfrm>
+          <a:prstGeom prst="rect">
+            <a:avLst/>
+          </a:prstGeom>
+          <a:noFill/>
+        </p:spPr>
+        <p:txBody>
+          <a:bodyPr wrap="square">
+            <a:spAutoFit/>
+          </a:bodyPr>
+          <a:lstStyle/>
+          <a:p>
+            <a:pPr algn="l"/>
+            <a:r>
+              <a:rPr sz="900" b="0" i="0">
+                <a:solidFill>
+                  <a:srgbClr val="0D2B55"/>
+                </a:solidFill>
+                <a:latin typeface="Calibri"/>
+              </a:rPr>
+              <a:t>AARENIRAYAARFRARLAAK</a:t>
+            </a:r>
+          </a:p>
+        </p:txBody>
+      </p:sp>
+      <p:sp>
+        <p:nvSpPr>
+          <p:cNvPr id="87" name="Rectangle 86"/>
           <p:cNvSpPr/>
           <p:nvPr/>
         </p:nvSpPr>
         <p:spPr>
           <a:xfrm>
-            <a:off x="713232" y="4297680"/>
-            <a:ext cx="3840480" cy="283464"/>
-          </a:xfrm>
-          <a:prstGeom prst="rect">
-            <a:avLst/>
-          </a:prstGeom>
-          <a:solidFill>
-            <a:srgbClr val="FFFFFF"/>
+            <a:off x="4370832" y="4270248"/>
+            <a:ext cx="384048" cy="347472"/>
+          </a:xfrm>
+          <a:prstGeom prst="rect">
+            <a:avLst/>
+          </a:prstGeom>
+          <a:solidFill>
+            <a:srgbClr val="F0F4F8"/>
           </a:solidFill>
           <a:ln>
             <a:noFill/>
@@ -7251,55 +7286,55 @@
       </p:sp>
       <p:sp>
         <p:nvSpPr>
-          <p:cNvPr id="87" name="TextBox 86"/>
-          <p:cNvSpPr txBox="1"/>
-          <p:nvPr/>
-        </p:nvSpPr>
-        <p:spPr>
-          <a:xfrm>
-            <a:off x="749808" y="4315968"/>
-            <a:ext cx="3767328" cy="246888"/>
-          </a:xfrm>
-          <a:prstGeom prst="rect">
-            <a:avLst/>
-          </a:prstGeom>
-          <a:noFill/>
-        </p:spPr>
-        <p:txBody>
-          <a:bodyPr wrap="square">
-            <a:spAutoFit/>
-          </a:bodyPr>
-          <a:lstStyle/>
-          <a:p>
-            <a:pPr algn="l"/>
-            <a:r>
-              <a:rPr sz="900" b="0" i="0">
-                <a:solidFill>
-                  <a:srgbClr val="0D2B55"/>
-                </a:solidFill>
-                <a:latin typeface="Calibri"/>
-              </a:rPr>
-              <a:t>AARASQREYQKKFLERLKKK</a:t>
-            </a:r>
-          </a:p>
-        </p:txBody>
-      </p:sp>
-      <p:sp>
-        <p:nvSpPr>
-          <p:cNvPr id="88" name="Rectangle 87"/>
+          <p:cNvPr id="88" name="TextBox 87"/>
+          <p:cNvSpPr txBox="1"/>
+          <p:nvPr/>
+        </p:nvSpPr>
+        <p:spPr>
+          <a:xfrm>
+            <a:off x="4407408" y="4288536"/>
+            <a:ext cx="310896" cy="310896"/>
+          </a:xfrm>
+          <a:prstGeom prst="rect">
+            <a:avLst/>
+          </a:prstGeom>
+          <a:noFill/>
+        </p:spPr>
+        <p:txBody>
+          <a:bodyPr wrap="square">
+            <a:spAutoFit/>
+          </a:bodyPr>
+          <a:lstStyle/>
+          <a:p>
+            <a:pPr algn="ctr"/>
+            <a:r>
+              <a:rPr sz="1000" b="0" i="0">
+                <a:solidFill>
+                  <a:srgbClr val="333344"/>
+                </a:solidFill>
+                <a:latin typeface="Calibri"/>
+              </a:rPr>
+              <a:t>20</a:t>
+            </a:r>
+          </a:p>
+        </p:txBody>
+      </p:sp>
+      <p:sp>
+        <p:nvSpPr>
+          <p:cNvPr id="89" name="Rectangle 88"/>
           <p:cNvSpPr/>
           <p:nvPr/>
         </p:nvSpPr>
         <p:spPr>
           <a:xfrm>
-            <a:off x="4553712" y="4297680"/>
-            <a:ext cx="384048" cy="283464"/>
-          </a:xfrm>
-          <a:prstGeom prst="rect">
-            <a:avLst/>
-          </a:prstGeom>
-          <a:solidFill>
-            <a:srgbClr val="FFFFFF"/>
+            <a:off x="4754880" y="4270248"/>
+            <a:ext cx="1097280" cy="347472"/>
+          </a:xfrm>
+          <a:prstGeom prst="rect">
+            <a:avLst/>
+          </a:prstGeom>
+          <a:solidFill>
+            <a:srgbClr val="F0F4F8"/>
           </a:solidFill>
           <a:ln>
             <a:noFill/>
@@ -7329,14 +7364,14 @@
       </p:sp>
       <p:sp>
         <p:nvSpPr>
-          <p:cNvPr id="89" name="TextBox 88"/>
-          <p:cNvSpPr txBox="1"/>
-          <p:nvPr/>
-        </p:nvSpPr>
-        <p:spPr>
-          <a:xfrm>
-            <a:off x="4590288" y="4315968"/>
-            <a:ext cx="310896" cy="246888"/>
+          <p:cNvPr id="90" name="TextBox 89"/>
+          <p:cNvSpPr txBox="1"/>
+          <p:nvPr/>
+        </p:nvSpPr>
+        <p:spPr>
+          <a:xfrm>
+            <a:off x="4791456" y="4288536"/>
+            <a:ext cx="1024127" cy="310896"/>
           </a:xfrm>
           <a:prstGeom prst="rect">
             <a:avLst/>
@@ -7357,27 +7392,27 @@
                 </a:solidFill>
                 <a:latin typeface="Calibri"/>
               </a:rPr>
-              <a:t>20</a:t>
-            </a:r>
-          </a:p>
-        </p:txBody>
-      </p:sp>
-      <p:sp>
-        <p:nvSpPr>
-          <p:cNvPr id="90" name="Rectangle 89"/>
+              <a:t>-13.79</a:t>
+            </a:r>
+          </a:p>
+        </p:txBody>
+      </p:sp>
+      <p:sp>
+        <p:nvSpPr>
+          <p:cNvPr id="91" name="Rectangle 90"/>
           <p:cNvSpPr/>
           <p:nvPr/>
         </p:nvSpPr>
         <p:spPr>
           <a:xfrm>
-            <a:off x="4937760" y="4297680"/>
-            <a:ext cx="1097280" cy="283464"/>
-          </a:xfrm>
-          <a:prstGeom prst="rect">
-            <a:avLst/>
-          </a:prstGeom>
-          <a:solidFill>
-            <a:srgbClr val="FFFFFF"/>
+            <a:off x="5852160" y="4270248"/>
+            <a:ext cx="777240" cy="347472"/>
+          </a:xfrm>
+          <a:prstGeom prst="rect">
+            <a:avLst/>
+          </a:prstGeom>
+          <a:solidFill>
+            <a:srgbClr val="F0F4F8"/>
           </a:solidFill>
           <a:ln>
             <a:noFill/>
@@ -7407,14 +7442,14 @@
       </p:sp>
       <p:sp>
         <p:nvSpPr>
-          <p:cNvPr id="91" name="TextBox 90"/>
-          <p:cNvSpPr txBox="1"/>
-          <p:nvPr/>
-        </p:nvSpPr>
-        <p:spPr>
-          <a:xfrm>
-            <a:off x="4974336" y="4315968"/>
-            <a:ext cx="1024127" cy="246888"/>
+          <p:cNvPr id="92" name="TextBox 91"/>
+          <p:cNvSpPr txBox="1"/>
+          <p:nvPr/>
+        </p:nvSpPr>
+        <p:spPr>
+          <a:xfrm>
+            <a:off x="5888736" y="4288536"/>
+            <a:ext cx="704088" cy="310896"/>
           </a:xfrm>
           <a:prstGeom prst="rect">
             <a:avLst/>
@@ -7435,27 +7470,27 @@
                 </a:solidFill>
                 <a:latin typeface="Calibri"/>
               </a:rPr>
-              <a:t>-12.52</a:t>
-            </a:r>
-          </a:p>
-        </p:txBody>
-      </p:sp>
-      <p:sp>
-        <p:nvSpPr>
-          <p:cNvPr id="92" name="Rectangle 91"/>
+              <a:t>0.635</a:t>
+            </a:r>
+          </a:p>
+        </p:txBody>
+      </p:sp>
+      <p:sp>
+        <p:nvSpPr>
+          <p:cNvPr id="93" name="Rectangle 92"/>
           <p:cNvSpPr/>
           <p:nvPr/>
         </p:nvSpPr>
         <p:spPr>
           <a:xfrm>
-            <a:off x="6035040" y="4297680"/>
-            <a:ext cx="5577840" cy="283464"/>
-          </a:xfrm>
-          <a:prstGeom prst="rect">
-            <a:avLst/>
-          </a:prstGeom>
-          <a:solidFill>
-            <a:srgbClr val="FFFFFF"/>
+            <a:off x="6629400" y="4270248"/>
+            <a:ext cx="5001768" cy="347472"/>
+          </a:xfrm>
+          <a:prstGeom prst="rect">
+            <a:avLst/>
+          </a:prstGeom>
+          <a:solidFill>
+            <a:srgbClr val="F0F4F8"/>
           </a:solidFill>
           <a:ln>
             <a:noFill/>
@@ -7485,14 +7520,14 @@
       </p:sp>
       <p:sp>
         <p:nvSpPr>
-          <p:cNvPr id="93" name="TextBox 92"/>
-          <p:cNvSpPr txBox="1"/>
-          <p:nvPr/>
-        </p:nvSpPr>
-        <p:spPr>
-          <a:xfrm>
-            <a:off x="6071616" y="4315968"/>
-            <a:ext cx="5504688" cy="246888"/>
+          <p:cNvPr id="94" name="TextBox 93"/>
+          <p:cNvSpPr txBox="1"/>
+          <p:nvPr/>
+        </p:nvSpPr>
+        <p:spPr>
+          <a:xfrm>
+            <a:off x="6665976" y="4288536"/>
+            <a:ext cx="4928616" cy="310896"/>
           </a:xfrm>
           <a:prstGeom prst="rect">
             <a:avLst/>
@@ -7513,27 +7548,27 @@
                 </a:solidFill>
                 <a:latin typeface="Calibri"/>
               </a:rPr>
-              <a:t>Ala N-term + R/K/F C-term — 2o melhor I_sc Rosetta</a:t>
-            </a:r>
-          </a:p>
-        </p:txBody>
-      </p:sp>
-      <p:sp>
-        <p:nvSpPr>
-          <p:cNvPr id="94" name="Rectangle 93"/>
+              <a:t>Ala-rico + Arg/Tyr — Vina entre melhores</a:t>
+            </a:r>
+          </a:p>
+        </p:txBody>
+      </p:sp>
+      <p:sp>
+        <p:nvSpPr>
+          <p:cNvPr id="95" name="Rectangle 94"/>
           <p:cNvSpPr/>
           <p:nvPr/>
         </p:nvSpPr>
         <p:spPr>
           <a:xfrm>
-            <a:off x="365760" y="4581144"/>
-            <a:ext cx="347472" cy="283464"/>
-          </a:xfrm>
-          <a:prstGeom prst="rect">
-            <a:avLst/>
-          </a:prstGeom>
-          <a:solidFill>
-            <a:srgbClr val="F0F4F8"/>
+            <a:off x="365760" y="6492240"/>
+            <a:ext cx="11430000" cy="256032"/>
+          </a:xfrm>
+          <a:prstGeom prst="rect">
+            <a:avLst/>
+          </a:prstGeom>
+          <a:solidFill>
+            <a:srgbClr val="1A4F8A"/>
           </a:solidFill>
           <a:ln>
             <a:noFill/>
@@ -7563,1567 +7598,7 @@
       </p:sp>
       <p:sp>
         <p:nvSpPr>
-          <p:cNvPr id="95" name="TextBox 94"/>
-          <p:cNvSpPr txBox="1"/>
-          <p:nvPr/>
-        </p:nvSpPr>
-        <p:spPr>
-          <a:xfrm>
-            <a:off x="402336" y="4599431"/>
-            <a:ext cx="274320" cy="246888"/>
-          </a:xfrm>
-          <a:prstGeom prst="rect">
-            <a:avLst/>
-          </a:prstGeom>
-          <a:noFill/>
-        </p:spPr>
-        <p:txBody>
-          <a:bodyPr wrap="square">
-            <a:spAutoFit/>
-          </a:bodyPr>
-          <a:lstStyle/>
-          <a:p>
-            <a:pPr algn="ctr"/>
-            <a:r>
-              <a:rPr sz="1000" b="0" i="0">
-                <a:solidFill>
-                  <a:srgbClr val="333344"/>
-                </a:solidFill>
-                <a:latin typeface="Calibri"/>
-              </a:rPr>
-              <a:t>7</a:t>
-            </a:r>
-          </a:p>
-        </p:txBody>
-      </p:sp>
-      <p:sp>
-        <p:nvSpPr>
-          <p:cNvPr id="96" name="Rectangle 95"/>
-          <p:cNvSpPr/>
-          <p:nvPr/>
-        </p:nvSpPr>
-        <p:spPr>
-          <a:xfrm>
-            <a:off x="713232" y="4581144"/>
-            <a:ext cx="3840480" cy="283464"/>
-          </a:xfrm>
-          <a:prstGeom prst="rect">
-            <a:avLst/>
-          </a:prstGeom>
-          <a:solidFill>
-            <a:srgbClr val="F0F4F8"/>
-          </a:solidFill>
-          <a:ln>
-            <a:noFill/>
-          </a:ln>
-        </p:spPr>
-        <p:style>
-          <a:lnRef idx="1">
-            <a:schemeClr val="accent1"/>
-          </a:lnRef>
-          <a:fillRef idx="3">
-            <a:schemeClr val="accent1"/>
-          </a:fillRef>
-          <a:effectRef idx="2">
-            <a:schemeClr val="accent1"/>
-          </a:effectRef>
-          <a:fontRef idx="minor">
-            <a:schemeClr val="lt1"/>
-          </a:fontRef>
-        </p:style>
-        <p:txBody>
-          <a:bodyPr rtlCol="0" anchor="ctr"/>
-          <a:lstStyle/>
-          <a:p>
-            <a:pPr algn="ctr"/>
-          </a:p>
-        </p:txBody>
-      </p:sp>
-      <p:sp>
-        <p:nvSpPr>
-          <p:cNvPr id="97" name="TextBox 96"/>
-          <p:cNvSpPr txBox="1"/>
-          <p:nvPr/>
-        </p:nvSpPr>
-        <p:spPr>
-          <a:xfrm>
-            <a:off x="749808" y="4599431"/>
-            <a:ext cx="3767328" cy="246888"/>
-          </a:xfrm>
-          <a:prstGeom prst="rect">
-            <a:avLst/>
-          </a:prstGeom>
-          <a:noFill/>
-        </p:spPr>
-        <p:txBody>
-          <a:bodyPr wrap="square">
-            <a:spAutoFit/>
-          </a:bodyPr>
-          <a:lstStyle/>
-          <a:p>
-            <a:pPr algn="l"/>
-            <a:r>
-              <a:rPr sz="900" b="0" i="0">
-                <a:solidFill>
-                  <a:srgbClr val="0D2B55"/>
-                </a:solidFill>
-                <a:latin typeface="Calibri"/>
-              </a:rPr>
-              <a:t>AARASQREYAARFAERLAAK</a:t>
-            </a:r>
-          </a:p>
-        </p:txBody>
-      </p:sp>
-      <p:sp>
-        <p:nvSpPr>
-          <p:cNvPr id="98" name="Rectangle 97"/>
-          <p:cNvSpPr/>
-          <p:nvPr/>
-        </p:nvSpPr>
-        <p:spPr>
-          <a:xfrm>
-            <a:off x="4553712" y="4581144"/>
-            <a:ext cx="384048" cy="283464"/>
-          </a:xfrm>
-          <a:prstGeom prst="rect">
-            <a:avLst/>
-          </a:prstGeom>
-          <a:solidFill>
-            <a:srgbClr val="F0F4F8"/>
-          </a:solidFill>
-          <a:ln>
-            <a:noFill/>
-          </a:ln>
-        </p:spPr>
-        <p:style>
-          <a:lnRef idx="1">
-            <a:schemeClr val="accent1"/>
-          </a:lnRef>
-          <a:fillRef idx="3">
-            <a:schemeClr val="accent1"/>
-          </a:fillRef>
-          <a:effectRef idx="2">
-            <a:schemeClr val="accent1"/>
-          </a:effectRef>
-          <a:fontRef idx="minor">
-            <a:schemeClr val="lt1"/>
-          </a:fontRef>
-        </p:style>
-        <p:txBody>
-          <a:bodyPr rtlCol="0" anchor="ctr"/>
-          <a:lstStyle/>
-          <a:p>
-            <a:pPr algn="ctr"/>
-          </a:p>
-        </p:txBody>
-      </p:sp>
-      <p:sp>
-        <p:nvSpPr>
-          <p:cNvPr id="99" name="TextBox 98"/>
-          <p:cNvSpPr txBox="1"/>
-          <p:nvPr/>
-        </p:nvSpPr>
-        <p:spPr>
-          <a:xfrm>
-            <a:off x="4590288" y="4599431"/>
-            <a:ext cx="310896" cy="246888"/>
-          </a:xfrm>
-          <a:prstGeom prst="rect">
-            <a:avLst/>
-          </a:prstGeom>
-          <a:noFill/>
-        </p:spPr>
-        <p:txBody>
-          <a:bodyPr wrap="square">
-            <a:spAutoFit/>
-          </a:bodyPr>
-          <a:lstStyle/>
-          <a:p>
-            <a:pPr algn="ctr"/>
-            <a:r>
-              <a:rPr sz="1000" b="0" i="0">
-                <a:solidFill>
-                  <a:srgbClr val="333344"/>
-                </a:solidFill>
-                <a:latin typeface="Calibri"/>
-              </a:rPr>
-              <a:t>20</a:t>
-            </a:r>
-          </a:p>
-        </p:txBody>
-      </p:sp>
-      <p:sp>
-        <p:nvSpPr>
-          <p:cNvPr id="100" name="Rectangle 99"/>
-          <p:cNvSpPr/>
-          <p:nvPr/>
-        </p:nvSpPr>
-        <p:spPr>
-          <a:xfrm>
-            <a:off x="4937760" y="4581144"/>
-            <a:ext cx="1097280" cy="283464"/>
-          </a:xfrm>
-          <a:prstGeom prst="rect">
-            <a:avLst/>
-          </a:prstGeom>
-          <a:solidFill>
-            <a:srgbClr val="F0F4F8"/>
-          </a:solidFill>
-          <a:ln>
-            <a:noFill/>
-          </a:ln>
-        </p:spPr>
-        <p:style>
-          <a:lnRef idx="1">
-            <a:schemeClr val="accent1"/>
-          </a:lnRef>
-          <a:fillRef idx="3">
-            <a:schemeClr val="accent1"/>
-          </a:fillRef>
-          <a:effectRef idx="2">
-            <a:schemeClr val="accent1"/>
-          </a:effectRef>
-          <a:fontRef idx="minor">
-            <a:schemeClr val="lt1"/>
-          </a:fontRef>
-        </p:style>
-        <p:txBody>
-          <a:bodyPr rtlCol="0" anchor="ctr"/>
-          <a:lstStyle/>
-          <a:p>
-            <a:pPr algn="ctr"/>
-          </a:p>
-        </p:txBody>
-      </p:sp>
-      <p:sp>
-        <p:nvSpPr>
-          <p:cNvPr id="101" name="TextBox 100"/>
-          <p:cNvSpPr txBox="1"/>
-          <p:nvPr/>
-        </p:nvSpPr>
-        <p:spPr>
-          <a:xfrm>
-            <a:off x="4974336" y="4599431"/>
-            <a:ext cx="1024127" cy="246888"/>
-          </a:xfrm>
-          <a:prstGeom prst="rect">
-            <a:avLst/>
-          </a:prstGeom>
-          <a:noFill/>
-        </p:spPr>
-        <p:txBody>
-          <a:bodyPr wrap="square">
-            <a:spAutoFit/>
-          </a:bodyPr>
-          <a:lstStyle/>
-          <a:p>
-            <a:pPr algn="ctr"/>
-            <a:r>
-              <a:rPr sz="1000" b="0" i="0">
-                <a:solidFill>
-                  <a:srgbClr val="333344"/>
-                </a:solidFill>
-                <a:latin typeface="Calibri"/>
-              </a:rPr>
-              <a:t>-12.52</a:t>
-            </a:r>
-          </a:p>
-        </p:txBody>
-      </p:sp>
-      <p:sp>
-        <p:nvSpPr>
-          <p:cNvPr id="102" name="Rectangle 101"/>
-          <p:cNvSpPr/>
-          <p:nvPr/>
-        </p:nvSpPr>
-        <p:spPr>
-          <a:xfrm>
-            <a:off x="6035040" y="4581144"/>
-            <a:ext cx="5577840" cy="283464"/>
-          </a:xfrm>
-          <a:prstGeom prst="rect">
-            <a:avLst/>
-          </a:prstGeom>
-          <a:solidFill>
-            <a:srgbClr val="F0F4F8"/>
-          </a:solidFill>
-          <a:ln>
-            <a:noFill/>
-          </a:ln>
-        </p:spPr>
-        <p:style>
-          <a:lnRef idx="1">
-            <a:schemeClr val="accent1"/>
-          </a:lnRef>
-          <a:fillRef idx="3">
-            <a:schemeClr val="accent1"/>
-          </a:fillRef>
-          <a:effectRef idx="2">
-            <a:schemeClr val="accent1"/>
-          </a:effectRef>
-          <a:fontRef idx="minor">
-            <a:schemeClr val="lt1"/>
-          </a:fontRef>
-        </p:style>
-        <p:txBody>
-          <a:bodyPr rtlCol="0" anchor="ctr"/>
-          <a:lstStyle/>
-          <a:p>
-            <a:pPr algn="ctr"/>
-          </a:p>
-        </p:txBody>
-      </p:sp>
-      <p:sp>
-        <p:nvSpPr>
-          <p:cNvPr id="103" name="TextBox 102"/>
-          <p:cNvSpPr txBox="1"/>
-          <p:nvPr/>
-        </p:nvSpPr>
-        <p:spPr>
-          <a:xfrm>
-            <a:off x="6071616" y="4599431"/>
-            <a:ext cx="5504688" cy="246888"/>
-          </a:xfrm>
-          <a:prstGeom prst="rect">
-            <a:avLst/>
-          </a:prstGeom>
-          <a:noFill/>
-        </p:spPr>
-        <p:txBody>
-          <a:bodyPr wrap="square">
-            <a:spAutoFit/>
-          </a:bodyPr>
-          <a:lstStyle/>
-          <a:p>
-            <a:pPr algn="l"/>
-            <a:r>
-              <a:rPr sz="900" b="0" i="0">
-                <a:solidFill>
-                  <a:srgbClr val="333344"/>
-                </a:solidFill>
-                <a:latin typeface="Calibri"/>
-              </a:rPr>
-              <a:t>Tyr/Phe + Glu C-term</a:t>
-            </a:r>
-          </a:p>
-        </p:txBody>
-      </p:sp>
-      <p:sp>
-        <p:nvSpPr>
-          <p:cNvPr id="104" name="Rectangle 103"/>
-          <p:cNvSpPr/>
-          <p:nvPr/>
-        </p:nvSpPr>
-        <p:spPr>
-          <a:xfrm>
-            <a:off x="365760" y="4864608"/>
-            <a:ext cx="347472" cy="283464"/>
-          </a:xfrm>
-          <a:prstGeom prst="rect">
-            <a:avLst/>
-          </a:prstGeom>
-          <a:solidFill>
-            <a:srgbClr val="FFFFFF"/>
-          </a:solidFill>
-          <a:ln>
-            <a:noFill/>
-          </a:ln>
-        </p:spPr>
-        <p:style>
-          <a:lnRef idx="1">
-            <a:schemeClr val="accent1"/>
-          </a:lnRef>
-          <a:fillRef idx="3">
-            <a:schemeClr val="accent1"/>
-          </a:fillRef>
-          <a:effectRef idx="2">
-            <a:schemeClr val="accent1"/>
-          </a:effectRef>
-          <a:fontRef idx="minor">
-            <a:schemeClr val="lt1"/>
-          </a:fontRef>
-        </p:style>
-        <p:txBody>
-          <a:bodyPr rtlCol="0" anchor="ctr"/>
-          <a:lstStyle/>
-          <a:p>
-            <a:pPr algn="ctr"/>
-          </a:p>
-        </p:txBody>
-      </p:sp>
-      <p:sp>
-        <p:nvSpPr>
-          <p:cNvPr id="105" name="TextBox 104"/>
-          <p:cNvSpPr txBox="1"/>
-          <p:nvPr/>
-        </p:nvSpPr>
-        <p:spPr>
-          <a:xfrm>
-            <a:off x="402336" y="4882896"/>
-            <a:ext cx="274320" cy="246888"/>
-          </a:xfrm>
-          <a:prstGeom prst="rect">
-            <a:avLst/>
-          </a:prstGeom>
-          <a:noFill/>
-        </p:spPr>
-        <p:txBody>
-          <a:bodyPr wrap="square">
-            <a:spAutoFit/>
-          </a:bodyPr>
-          <a:lstStyle/>
-          <a:p>
-            <a:pPr algn="ctr"/>
-            <a:r>
-              <a:rPr sz="1000" b="0" i="0">
-                <a:solidFill>
-                  <a:srgbClr val="333344"/>
-                </a:solidFill>
-                <a:latin typeface="Calibri"/>
-              </a:rPr>
-              <a:t>8</a:t>
-            </a:r>
-          </a:p>
-        </p:txBody>
-      </p:sp>
-      <p:sp>
-        <p:nvSpPr>
-          <p:cNvPr id="106" name="Rectangle 105"/>
-          <p:cNvSpPr/>
-          <p:nvPr/>
-        </p:nvSpPr>
-        <p:spPr>
-          <a:xfrm>
-            <a:off x="713232" y="4864608"/>
-            <a:ext cx="3840480" cy="283464"/>
-          </a:xfrm>
-          <a:prstGeom prst="rect">
-            <a:avLst/>
-          </a:prstGeom>
-          <a:solidFill>
-            <a:srgbClr val="FFFFFF"/>
-          </a:solidFill>
-          <a:ln>
-            <a:noFill/>
-          </a:ln>
-        </p:spPr>
-        <p:style>
-          <a:lnRef idx="1">
-            <a:schemeClr val="accent1"/>
-          </a:lnRef>
-          <a:fillRef idx="3">
-            <a:schemeClr val="accent1"/>
-          </a:fillRef>
-          <a:effectRef idx="2">
-            <a:schemeClr val="accent1"/>
-          </a:effectRef>
-          <a:fontRef idx="minor">
-            <a:schemeClr val="lt1"/>
-          </a:fontRef>
-        </p:style>
-        <p:txBody>
-          <a:bodyPr rtlCol="0" anchor="ctr"/>
-          <a:lstStyle/>
-          <a:p>
-            <a:pPr algn="ctr"/>
-          </a:p>
-        </p:txBody>
-      </p:sp>
-      <p:sp>
-        <p:nvSpPr>
-          <p:cNvPr id="107" name="TextBox 106"/>
-          <p:cNvSpPr txBox="1"/>
-          <p:nvPr/>
-        </p:nvSpPr>
-        <p:spPr>
-          <a:xfrm>
-            <a:off x="749808" y="4882896"/>
-            <a:ext cx="3767328" cy="246888"/>
-          </a:xfrm>
-          <a:prstGeom prst="rect">
-            <a:avLst/>
-          </a:prstGeom>
-          <a:noFill/>
-        </p:spPr>
-        <p:txBody>
-          <a:bodyPr wrap="square">
-            <a:spAutoFit/>
-          </a:bodyPr>
-          <a:lstStyle/>
-          <a:p>
-            <a:pPr algn="l"/>
-            <a:r>
-              <a:rPr sz="900" b="0" i="0">
-                <a:solidFill>
-                  <a:srgbClr val="0D2B55"/>
-                </a:solidFill>
-                <a:latin typeface="Calibri"/>
-              </a:rPr>
-              <a:t>SAAARARQRAVIARARARVA</a:t>
-            </a:r>
-          </a:p>
-        </p:txBody>
-      </p:sp>
-      <p:sp>
-        <p:nvSpPr>
-          <p:cNvPr id="108" name="Rectangle 107"/>
-          <p:cNvSpPr/>
-          <p:nvPr/>
-        </p:nvSpPr>
-        <p:spPr>
-          <a:xfrm>
-            <a:off x="4553712" y="4864608"/>
-            <a:ext cx="384048" cy="283464"/>
-          </a:xfrm>
-          <a:prstGeom prst="rect">
-            <a:avLst/>
-          </a:prstGeom>
-          <a:solidFill>
-            <a:srgbClr val="FFFFFF"/>
-          </a:solidFill>
-          <a:ln>
-            <a:noFill/>
-          </a:ln>
-        </p:spPr>
-        <p:style>
-          <a:lnRef idx="1">
-            <a:schemeClr val="accent1"/>
-          </a:lnRef>
-          <a:fillRef idx="3">
-            <a:schemeClr val="accent1"/>
-          </a:fillRef>
-          <a:effectRef idx="2">
-            <a:schemeClr val="accent1"/>
-          </a:effectRef>
-          <a:fontRef idx="minor">
-            <a:schemeClr val="lt1"/>
-          </a:fontRef>
-        </p:style>
-        <p:txBody>
-          <a:bodyPr rtlCol="0" anchor="ctr"/>
-          <a:lstStyle/>
-          <a:p>
-            <a:pPr algn="ctr"/>
-          </a:p>
-        </p:txBody>
-      </p:sp>
-      <p:sp>
-        <p:nvSpPr>
-          <p:cNvPr id="109" name="TextBox 108"/>
-          <p:cNvSpPr txBox="1"/>
-          <p:nvPr/>
-        </p:nvSpPr>
-        <p:spPr>
-          <a:xfrm>
-            <a:off x="4590288" y="4882896"/>
-            <a:ext cx="310896" cy="246888"/>
-          </a:xfrm>
-          <a:prstGeom prst="rect">
-            <a:avLst/>
-          </a:prstGeom>
-          <a:noFill/>
-        </p:spPr>
-        <p:txBody>
-          <a:bodyPr wrap="square">
-            <a:spAutoFit/>
-          </a:bodyPr>
-          <a:lstStyle/>
-          <a:p>
-            <a:pPr algn="ctr"/>
-            <a:r>
-              <a:rPr sz="1000" b="0" i="0">
-                <a:solidFill>
-                  <a:srgbClr val="333344"/>
-                </a:solidFill>
-                <a:latin typeface="Calibri"/>
-              </a:rPr>
-              <a:t>20</a:t>
-            </a:r>
-          </a:p>
-        </p:txBody>
-      </p:sp>
-      <p:sp>
-        <p:nvSpPr>
-          <p:cNvPr id="110" name="Rectangle 109"/>
-          <p:cNvSpPr/>
-          <p:nvPr/>
-        </p:nvSpPr>
-        <p:spPr>
-          <a:xfrm>
-            <a:off x="4937760" y="4864608"/>
-            <a:ext cx="1097280" cy="283464"/>
-          </a:xfrm>
-          <a:prstGeom prst="rect">
-            <a:avLst/>
-          </a:prstGeom>
-          <a:solidFill>
-            <a:srgbClr val="FFFFFF"/>
-          </a:solidFill>
-          <a:ln>
-            <a:noFill/>
-          </a:ln>
-        </p:spPr>
-        <p:style>
-          <a:lnRef idx="1">
-            <a:schemeClr val="accent1"/>
-          </a:lnRef>
-          <a:fillRef idx="3">
-            <a:schemeClr val="accent1"/>
-          </a:fillRef>
-          <a:effectRef idx="2">
-            <a:schemeClr val="accent1"/>
-          </a:effectRef>
-          <a:fontRef idx="minor">
-            <a:schemeClr val="lt1"/>
-          </a:fontRef>
-        </p:style>
-        <p:txBody>
-          <a:bodyPr rtlCol="0" anchor="ctr"/>
-          <a:lstStyle/>
-          <a:p>
-            <a:pPr algn="ctr"/>
-          </a:p>
-        </p:txBody>
-      </p:sp>
-      <p:sp>
-        <p:nvSpPr>
-          <p:cNvPr id="111" name="TextBox 110"/>
-          <p:cNvSpPr txBox="1"/>
-          <p:nvPr/>
-        </p:nvSpPr>
-        <p:spPr>
-          <a:xfrm>
-            <a:off x="4974336" y="4882896"/>
-            <a:ext cx="1024127" cy="246888"/>
-          </a:xfrm>
-          <a:prstGeom prst="rect">
-            <a:avLst/>
-          </a:prstGeom>
-          <a:noFill/>
-        </p:spPr>
-        <p:txBody>
-          <a:bodyPr wrap="square">
-            <a:spAutoFit/>
-          </a:bodyPr>
-          <a:lstStyle/>
-          <a:p>
-            <a:pPr algn="ctr"/>
-            <a:r>
-              <a:rPr sz="1000" b="0" i="0">
-                <a:solidFill>
-                  <a:srgbClr val="333344"/>
-                </a:solidFill>
-                <a:latin typeface="Calibri"/>
-              </a:rPr>
-              <a:t>-12.44</a:t>
-            </a:r>
-          </a:p>
-        </p:txBody>
-      </p:sp>
-      <p:sp>
-        <p:nvSpPr>
-          <p:cNvPr id="112" name="Rectangle 111"/>
-          <p:cNvSpPr/>
-          <p:nvPr/>
-        </p:nvSpPr>
-        <p:spPr>
-          <a:xfrm>
-            <a:off x="6035040" y="4864608"/>
-            <a:ext cx="5577840" cy="283464"/>
-          </a:xfrm>
-          <a:prstGeom prst="rect">
-            <a:avLst/>
-          </a:prstGeom>
-          <a:solidFill>
-            <a:srgbClr val="FFFFFF"/>
-          </a:solidFill>
-          <a:ln>
-            <a:noFill/>
-          </a:ln>
-        </p:spPr>
-        <p:style>
-          <a:lnRef idx="1">
-            <a:schemeClr val="accent1"/>
-          </a:lnRef>
-          <a:fillRef idx="3">
-            <a:schemeClr val="accent1"/>
-          </a:fillRef>
-          <a:effectRef idx="2">
-            <a:schemeClr val="accent1"/>
-          </a:effectRef>
-          <a:fontRef idx="minor">
-            <a:schemeClr val="lt1"/>
-          </a:fontRef>
-        </p:style>
-        <p:txBody>
-          <a:bodyPr rtlCol="0" anchor="ctr"/>
-          <a:lstStyle/>
-          <a:p>
-            <a:pPr algn="ctr"/>
-          </a:p>
-        </p:txBody>
-      </p:sp>
-      <p:sp>
-        <p:nvSpPr>
-          <p:cNvPr id="113" name="TextBox 112"/>
-          <p:cNvSpPr txBox="1"/>
-          <p:nvPr/>
-        </p:nvSpPr>
-        <p:spPr>
-          <a:xfrm>
-            <a:off x="6071616" y="4882896"/>
-            <a:ext cx="5504688" cy="246888"/>
-          </a:xfrm>
-          <a:prstGeom prst="rect">
-            <a:avLst/>
-          </a:prstGeom>
-          <a:noFill/>
-        </p:spPr>
-        <p:txBody>
-          <a:bodyPr wrap="square">
-            <a:spAutoFit/>
-          </a:bodyPr>
-          <a:lstStyle/>
-          <a:p>
-            <a:pPr algn="l"/>
-            <a:r>
-              <a:rPr sz="900" b="0" i="0">
-                <a:solidFill>
-                  <a:srgbClr val="333344"/>
-                </a:solidFill>
-                <a:latin typeface="Calibri"/>
-              </a:rPr>
-              <a:t>Ala/Arg alternados (anfipático regular)</a:t>
-            </a:r>
-          </a:p>
-        </p:txBody>
-      </p:sp>
-      <p:sp>
-        <p:nvSpPr>
-          <p:cNvPr id="114" name="Rectangle 113"/>
-          <p:cNvSpPr/>
-          <p:nvPr/>
-        </p:nvSpPr>
-        <p:spPr>
-          <a:xfrm>
-            <a:off x="365760" y="5148072"/>
-            <a:ext cx="347472" cy="283464"/>
-          </a:xfrm>
-          <a:prstGeom prst="rect">
-            <a:avLst/>
-          </a:prstGeom>
-          <a:solidFill>
-            <a:srgbClr val="F0F4F8"/>
-          </a:solidFill>
-          <a:ln>
-            <a:noFill/>
-          </a:ln>
-        </p:spPr>
-        <p:style>
-          <a:lnRef idx="1">
-            <a:schemeClr val="accent1"/>
-          </a:lnRef>
-          <a:fillRef idx="3">
-            <a:schemeClr val="accent1"/>
-          </a:fillRef>
-          <a:effectRef idx="2">
-            <a:schemeClr val="accent1"/>
-          </a:effectRef>
-          <a:fontRef idx="minor">
-            <a:schemeClr val="lt1"/>
-          </a:fontRef>
-        </p:style>
-        <p:txBody>
-          <a:bodyPr rtlCol="0" anchor="ctr"/>
-          <a:lstStyle/>
-          <a:p>
-            <a:pPr algn="ctr"/>
-          </a:p>
-        </p:txBody>
-      </p:sp>
-      <p:sp>
-        <p:nvSpPr>
-          <p:cNvPr id="115" name="TextBox 114"/>
-          <p:cNvSpPr txBox="1"/>
-          <p:nvPr/>
-        </p:nvSpPr>
-        <p:spPr>
-          <a:xfrm>
-            <a:off x="402336" y="5166360"/>
-            <a:ext cx="274320" cy="246888"/>
-          </a:xfrm>
-          <a:prstGeom prst="rect">
-            <a:avLst/>
-          </a:prstGeom>
-          <a:noFill/>
-        </p:spPr>
-        <p:txBody>
-          <a:bodyPr wrap="square">
-            <a:spAutoFit/>
-          </a:bodyPr>
-          <a:lstStyle/>
-          <a:p>
-            <a:pPr algn="ctr"/>
-            <a:r>
-              <a:rPr sz="1000" b="0" i="0">
-                <a:solidFill>
-                  <a:srgbClr val="333344"/>
-                </a:solidFill>
-                <a:latin typeface="Calibri"/>
-              </a:rPr>
-              <a:t>9</a:t>
-            </a:r>
-          </a:p>
-        </p:txBody>
-      </p:sp>
-      <p:sp>
-        <p:nvSpPr>
-          <p:cNvPr id="116" name="Rectangle 115"/>
-          <p:cNvSpPr/>
-          <p:nvPr/>
-        </p:nvSpPr>
-        <p:spPr>
-          <a:xfrm>
-            <a:off x="713232" y="5148072"/>
-            <a:ext cx="3840480" cy="283464"/>
-          </a:xfrm>
-          <a:prstGeom prst="rect">
-            <a:avLst/>
-          </a:prstGeom>
-          <a:solidFill>
-            <a:srgbClr val="F0F4F8"/>
-          </a:solidFill>
-          <a:ln>
-            <a:noFill/>
-          </a:ln>
-        </p:spPr>
-        <p:style>
-          <a:lnRef idx="1">
-            <a:schemeClr val="accent1"/>
-          </a:lnRef>
-          <a:fillRef idx="3">
-            <a:schemeClr val="accent1"/>
-          </a:fillRef>
-          <a:effectRef idx="2">
-            <a:schemeClr val="accent1"/>
-          </a:effectRef>
-          <a:fontRef idx="minor">
-            <a:schemeClr val="lt1"/>
-          </a:fontRef>
-        </p:style>
-        <p:txBody>
-          <a:bodyPr rtlCol="0" anchor="ctr"/>
-          <a:lstStyle/>
-          <a:p>
-            <a:pPr algn="ctr"/>
-          </a:p>
-        </p:txBody>
-      </p:sp>
-      <p:sp>
-        <p:nvSpPr>
-          <p:cNvPr id="117" name="TextBox 116"/>
-          <p:cNvSpPr txBox="1"/>
-          <p:nvPr/>
-        </p:nvSpPr>
-        <p:spPr>
-          <a:xfrm>
-            <a:off x="749808" y="5166360"/>
-            <a:ext cx="3767328" cy="246888"/>
-          </a:xfrm>
-          <a:prstGeom prst="rect">
-            <a:avLst/>
-          </a:prstGeom>
-          <a:noFill/>
-        </p:spPr>
-        <p:txBody>
-          <a:bodyPr wrap="square">
-            <a:spAutoFit/>
-          </a:bodyPr>
-          <a:lstStyle/>
-          <a:p>
-            <a:pPr algn="l"/>
-            <a:r>
-              <a:rPr sz="900" b="0" i="0">
-                <a:solidFill>
-                  <a:srgbClr val="0D2B55"/>
-                </a:solidFill>
-                <a:latin typeface="Calibri"/>
-              </a:rPr>
-              <a:t>SAAARARQRAVGARMRARVA</a:t>
-            </a:r>
-          </a:p>
-        </p:txBody>
-      </p:sp>
-      <p:sp>
-        <p:nvSpPr>
-          <p:cNvPr id="118" name="Rectangle 117"/>
-          <p:cNvSpPr/>
-          <p:nvPr/>
-        </p:nvSpPr>
-        <p:spPr>
-          <a:xfrm>
-            <a:off x="4553712" y="5148072"/>
-            <a:ext cx="384048" cy="283464"/>
-          </a:xfrm>
-          <a:prstGeom prst="rect">
-            <a:avLst/>
-          </a:prstGeom>
-          <a:solidFill>
-            <a:srgbClr val="F0F4F8"/>
-          </a:solidFill>
-          <a:ln>
-            <a:noFill/>
-          </a:ln>
-        </p:spPr>
-        <p:style>
-          <a:lnRef idx="1">
-            <a:schemeClr val="accent1"/>
-          </a:lnRef>
-          <a:fillRef idx="3">
-            <a:schemeClr val="accent1"/>
-          </a:fillRef>
-          <a:effectRef idx="2">
-            <a:schemeClr val="accent1"/>
-          </a:effectRef>
-          <a:fontRef idx="minor">
-            <a:schemeClr val="lt1"/>
-          </a:fontRef>
-        </p:style>
-        <p:txBody>
-          <a:bodyPr rtlCol="0" anchor="ctr"/>
-          <a:lstStyle/>
-          <a:p>
-            <a:pPr algn="ctr"/>
-          </a:p>
-        </p:txBody>
-      </p:sp>
-      <p:sp>
-        <p:nvSpPr>
-          <p:cNvPr id="119" name="TextBox 118"/>
-          <p:cNvSpPr txBox="1"/>
-          <p:nvPr/>
-        </p:nvSpPr>
-        <p:spPr>
-          <a:xfrm>
-            <a:off x="4590288" y="5166360"/>
-            <a:ext cx="310896" cy="246888"/>
-          </a:xfrm>
-          <a:prstGeom prst="rect">
-            <a:avLst/>
-          </a:prstGeom>
-          <a:noFill/>
-        </p:spPr>
-        <p:txBody>
-          <a:bodyPr wrap="square">
-            <a:spAutoFit/>
-          </a:bodyPr>
-          <a:lstStyle/>
-          <a:p>
-            <a:pPr algn="ctr"/>
-            <a:r>
-              <a:rPr sz="1000" b="0" i="0">
-                <a:solidFill>
-                  <a:srgbClr val="333344"/>
-                </a:solidFill>
-                <a:latin typeface="Calibri"/>
-              </a:rPr>
-              <a:t>20</a:t>
-            </a:r>
-          </a:p>
-        </p:txBody>
-      </p:sp>
-      <p:sp>
-        <p:nvSpPr>
-          <p:cNvPr id="120" name="Rectangle 119"/>
-          <p:cNvSpPr/>
-          <p:nvPr/>
-        </p:nvSpPr>
-        <p:spPr>
-          <a:xfrm>
-            <a:off x="4937760" y="5148072"/>
-            <a:ext cx="1097280" cy="283464"/>
-          </a:xfrm>
-          <a:prstGeom prst="rect">
-            <a:avLst/>
-          </a:prstGeom>
-          <a:solidFill>
-            <a:srgbClr val="F0F4F8"/>
-          </a:solidFill>
-          <a:ln>
-            <a:noFill/>
-          </a:ln>
-        </p:spPr>
-        <p:style>
-          <a:lnRef idx="1">
-            <a:schemeClr val="accent1"/>
-          </a:lnRef>
-          <a:fillRef idx="3">
-            <a:schemeClr val="accent1"/>
-          </a:fillRef>
-          <a:effectRef idx="2">
-            <a:schemeClr val="accent1"/>
-          </a:effectRef>
-          <a:fontRef idx="minor">
-            <a:schemeClr val="lt1"/>
-          </a:fontRef>
-        </p:style>
-        <p:txBody>
-          <a:bodyPr rtlCol="0" anchor="ctr"/>
-          <a:lstStyle/>
-          <a:p>
-            <a:pPr algn="ctr"/>
-          </a:p>
-        </p:txBody>
-      </p:sp>
-      <p:sp>
-        <p:nvSpPr>
-          <p:cNvPr id="121" name="TextBox 120"/>
-          <p:cNvSpPr txBox="1"/>
-          <p:nvPr/>
-        </p:nvSpPr>
-        <p:spPr>
-          <a:xfrm>
-            <a:off x="4974336" y="5166360"/>
-            <a:ext cx="1024127" cy="246888"/>
-          </a:xfrm>
-          <a:prstGeom prst="rect">
-            <a:avLst/>
-          </a:prstGeom>
-          <a:noFill/>
-        </p:spPr>
-        <p:txBody>
-          <a:bodyPr wrap="square">
-            <a:spAutoFit/>
-          </a:bodyPr>
-          <a:lstStyle/>
-          <a:p>
-            <a:pPr algn="ctr"/>
-            <a:r>
-              <a:rPr sz="1000" b="0" i="0">
-                <a:solidFill>
-                  <a:srgbClr val="333344"/>
-                </a:solidFill>
-                <a:latin typeface="Calibri"/>
-              </a:rPr>
-              <a:t>-12.44</a:t>
-            </a:r>
-          </a:p>
-        </p:txBody>
-      </p:sp>
-      <p:sp>
-        <p:nvSpPr>
-          <p:cNvPr id="122" name="Rectangle 121"/>
-          <p:cNvSpPr/>
-          <p:nvPr/>
-        </p:nvSpPr>
-        <p:spPr>
-          <a:xfrm>
-            <a:off x="6035040" y="5148072"/>
-            <a:ext cx="5577840" cy="283464"/>
-          </a:xfrm>
-          <a:prstGeom prst="rect">
-            <a:avLst/>
-          </a:prstGeom>
-          <a:solidFill>
-            <a:srgbClr val="F0F4F8"/>
-          </a:solidFill>
-          <a:ln>
-            <a:noFill/>
-          </a:ln>
-        </p:spPr>
-        <p:style>
-          <a:lnRef idx="1">
-            <a:schemeClr val="accent1"/>
-          </a:lnRef>
-          <a:fillRef idx="3">
-            <a:schemeClr val="accent1"/>
-          </a:fillRef>
-          <a:effectRef idx="2">
-            <a:schemeClr val="accent1"/>
-          </a:effectRef>
-          <a:fontRef idx="minor">
-            <a:schemeClr val="lt1"/>
-          </a:fontRef>
-        </p:style>
-        <p:txBody>
-          <a:bodyPr rtlCol="0" anchor="ctr"/>
-          <a:lstStyle/>
-          <a:p>
-            <a:pPr algn="ctr"/>
-          </a:p>
-        </p:txBody>
-      </p:sp>
-      <p:sp>
-        <p:nvSpPr>
-          <p:cNvPr id="123" name="TextBox 122"/>
-          <p:cNvSpPr txBox="1"/>
-          <p:nvPr/>
-        </p:nvSpPr>
-        <p:spPr>
-          <a:xfrm>
-            <a:off x="6071616" y="5166360"/>
-            <a:ext cx="5504688" cy="246888"/>
-          </a:xfrm>
-          <a:prstGeom prst="rect">
-            <a:avLst/>
-          </a:prstGeom>
-          <a:noFill/>
-        </p:spPr>
-        <p:txBody>
-          <a:bodyPr wrap="square">
-            <a:spAutoFit/>
-          </a:bodyPr>
-          <a:lstStyle/>
-          <a:p>
-            <a:pPr algn="l"/>
-            <a:r>
-              <a:rPr sz="900" b="0" i="0">
-                <a:solidFill>
-                  <a:srgbClr val="333344"/>
-                </a:solidFill>
-                <a:latin typeface="Calibri"/>
-              </a:rPr>
-              <a:t>Ala/Arg/Met — variante de #8</a:t>
-            </a:r>
-          </a:p>
-        </p:txBody>
-      </p:sp>
-      <p:sp>
-        <p:nvSpPr>
-          <p:cNvPr id="124" name="Rectangle 123"/>
-          <p:cNvSpPr/>
-          <p:nvPr/>
-        </p:nvSpPr>
-        <p:spPr>
-          <a:xfrm>
-            <a:off x="365760" y="5431536"/>
-            <a:ext cx="347472" cy="283464"/>
-          </a:xfrm>
-          <a:prstGeom prst="rect">
-            <a:avLst/>
-          </a:prstGeom>
-          <a:solidFill>
-            <a:srgbClr val="FFFFFF"/>
-          </a:solidFill>
-          <a:ln>
-            <a:noFill/>
-          </a:ln>
-        </p:spPr>
-        <p:style>
-          <a:lnRef idx="1">
-            <a:schemeClr val="accent1"/>
-          </a:lnRef>
-          <a:fillRef idx="3">
-            <a:schemeClr val="accent1"/>
-          </a:fillRef>
-          <a:effectRef idx="2">
-            <a:schemeClr val="accent1"/>
-          </a:effectRef>
-          <a:fontRef idx="minor">
-            <a:schemeClr val="lt1"/>
-          </a:fontRef>
-        </p:style>
-        <p:txBody>
-          <a:bodyPr rtlCol="0" anchor="ctr"/>
-          <a:lstStyle/>
-          <a:p>
-            <a:pPr algn="ctr"/>
-          </a:p>
-        </p:txBody>
-      </p:sp>
-      <p:sp>
-        <p:nvSpPr>
-          <p:cNvPr id="125" name="TextBox 124"/>
-          <p:cNvSpPr txBox="1"/>
-          <p:nvPr/>
-        </p:nvSpPr>
-        <p:spPr>
-          <a:xfrm>
-            <a:off x="402336" y="5449824"/>
-            <a:ext cx="274320" cy="246888"/>
-          </a:xfrm>
-          <a:prstGeom prst="rect">
-            <a:avLst/>
-          </a:prstGeom>
-          <a:noFill/>
-        </p:spPr>
-        <p:txBody>
-          <a:bodyPr wrap="square">
-            <a:spAutoFit/>
-          </a:bodyPr>
-          <a:lstStyle/>
-          <a:p>
-            <a:pPr algn="ctr"/>
-            <a:r>
-              <a:rPr sz="1000" b="0" i="0">
-                <a:solidFill>
-                  <a:srgbClr val="333344"/>
-                </a:solidFill>
-                <a:latin typeface="Calibri"/>
-              </a:rPr>
-              <a:t>10</a:t>
-            </a:r>
-          </a:p>
-        </p:txBody>
-      </p:sp>
-      <p:sp>
-        <p:nvSpPr>
-          <p:cNvPr id="126" name="Rectangle 125"/>
-          <p:cNvSpPr/>
-          <p:nvPr/>
-        </p:nvSpPr>
-        <p:spPr>
-          <a:xfrm>
-            <a:off x="713232" y="5431536"/>
-            <a:ext cx="3840480" cy="283464"/>
-          </a:xfrm>
-          <a:prstGeom prst="rect">
-            <a:avLst/>
-          </a:prstGeom>
-          <a:solidFill>
-            <a:srgbClr val="FFFFFF"/>
-          </a:solidFill>
-          <a:ln>
-            <a:noFill/>
-          </a:ln>
-        </p:spPr>
-        <p:style>
-          <a:lnRef idx="1">
-            <a:schemeClr val="accent1"/>
-          </a:lnRef>
-          <a:fillRef idx="3">
-            <a:schemeClr val="accent1"/>
-          </a:fillRef>
-          <a:effectRef idx="2">
-            <a:schemeClr val="accent1"/>
-          </a:effectRef>
-          <a:fontRef idx="minor">
-            <a:schemeClr val="lt1"/>
-          </a:fontRef>
-        </p:style>
-        <p:txBody>
-          <a:bodyPr rtlCol="0" anchor="ctr"/>
-          <a:lstStyle/>
-          <a:p>
-            <a:pPr algn="ctr"/>
-          </a:p>
-        </p:txBody>
-      </p:sp>
-      <p:sp>
-        <p:nvSpPr>
-          <p:cNvPr id="127" name="TextBox 126"/>
-          <p:cNvSpPr txBox="1"/>
-          <p:nvPr/>
-        </p:nvSpPr>
-        <p:spPr>
-          <a:xfrm>
-            <a:off x="749808" y="5449824"/>
-            <a:ext cx="3767328" cy="246888"/>
-          </a:xfrm>
-          <a:prstGeom prst="rect">
-            <a:avLst/>
-          </a:prstGeom>
-          <a:noFill/>
-        </p:spPr>
-        <p:txBody>
-          <a:bodyPr wrap="square">
-            <a:spAutoFit/>
-          </a:bodyPr>
-          <a:lstStyle/>
-          <a:p>
-            <a:pPr algn="l"/>
-            <a:r>
-              <a:rPr sz="900" b="0" i="0">
-                <a:solidFill>
-                  <a:srgbClr val="0D2B55"/>
-                </a:solidFill>
-                <a:latin typeface="Calibri"/>
-              </a:rPr>
-              <a:t>AARENIRKAHKTFLERLKKK</a:t>
-            </a:r>
-          </a:p>
-        </p:txBody>
-      </p:sp>
-      <p:sp>
-        <p:nvSpPr>
-          <p:cNvPr id="128" name="Rectangle 127"/>
-          <p:cNvSpPr/>
-          <p:nvPr/>
-        </p:nvSpPr>
-        <p:spPr>
-          <a:xfrm>
-            <a:off x="4553712" y="5431536"/>
-            <a:ext cx="384048" cy="283464"/>
-          </a:xfrm>
-          <a:prstGeom prst="rect">
-            <a:avLst/>
-          </a:prstGeom>
-          <a:solidFill>
-            <a:srgbClr val="FFFFFF"/>
-          </a:solidFill>
-          <a:ln>
-            <a:noFill/>
-          </a:ln>
-        </p:spPr>
-        <p:style>
-          <a:lnRef idx="1">
-            <a:schemeClr val="accent1"/>
-          </a:lnRef>
-          <a:fillRef idx="3">
-            <a:schemeClr val="accent1"/>
-          </a:fillRef>
-          <a:effectRef idx="2">
-            <a:schemeClr val="accent1"/>
-          </a:effectRef>
-          <a:fontRef idx="minor">
-            <a:schemeClr val="lt1"/>
-          </a:fontRef>
-        </p:style>
-        <p:txBody>
-          <a:bodyPr rtlCol="0" anchor="ctr"/>
-          <a:lstStyle/>
-          <a:p>
-            <a:pPr algn="ctr"/>
-          </a:p>
-        </p:txBody>
-      </p:sp>
-      <p:sp>
-        <p:nvSpPr>
-          <p:cNvPr id="129" name="TextBox 128"/>
-          <p:cNvSpPr txBox="1"/>
-          <p:nvPr/>
-        </p:nvSpPr>
-        <p:spPr>
-          <a:xfrm>
-            <a:off x="4590288" y="5449824"/>
-            <a:ext cx="310896" cy="246888"/>
-          </a:xfrm>
-          <a:prstGeom prst="rect">
-            <a:avLst/>
-          </a:prstGeom>
-          <a:noFill/>
-        </p:spPr>
-        <p:txBody>
-          <a:bodyPr wrap="square">
-            <a:spAutoFit/>
-          </a:bodyPr>
-          <a:lstStyle/>
-          <a:p>
-            <a:pPr algn="ctr"/>
-            <a:r>
-              <a:rPr sz="1000" b="0" i="0">
-                <a:solidFill>
-                  <a:srgbClr val="333344"/>
-                </a:solidFill>
-                <a:latin typeface="Calibri"/>
-              </a:rPr>
-              <a:t>20</a:t>
-            </a:r>
-          </a:p>
-        </p:txBody>
-      </p:sp>
-      <p:sp>
-        <p:nvSpPr>
-          <p:cNvPr id="130" name="Rectangle 129"/>
-          <p:cNvSpPr/>
-          <p:nvPr/>
-        </p:nvSpPr>
-        <p:spPr>
-          <a:xfrm>
-            <a:off x="4937760" y="5431536"/>
-            <a:ext cx="1097280" cy="283464"/>
-          </a:xfrm>
-          <a:prstGeom prst="rect">
-            <a:avLst/>
-          </a:prstGeom>
-          <a:solidFill>
-            <a:srgbClr val="FFFFFF"/>
-          </a:solidFill>
-          <a:ln>
-            <a:noFill/>
-          </a:ln>
-        </p:spPr>
-        <p:style>
-          <a:lnRef idx="1">
-            <a:schemeClr val="accent1"/>
-          </a:lnRef>
-          <a:fillRef idx="3">
-            <a:schemeClr val="accent1"/>
-          </a:fillRef>
-          <a:effectRef idx="2">
-            <a:schemeClr val="accent1"/>
-          </a:effectRef>
-          <a:fontRef idx="minor">
-            <a:schemeClr val="lt1"/>
-          </a:fontRef>
-        </p:style>
-        <p:txBody>
-          <a:bodyPr rtlCol="0" anchor="ctr"/>
-          <a:lstStyle/>
-          <a:p>
-            <a:pPr algn="ctr"/>
-          </a:p>
-        </p:txBody>
-      </p:sp>
-      <p:sp>
-        <p:nvSpPr>
-          <p:cNvPr id="131" name="TextBox 130"/>
-          <p:cNvSpPr txBox="1"/>
-          <p:nvPr/>
-        </p:nvSpPr>
-        <p:spPr>
-          <a:xfrm>
-            <a:off x="4974336" y="5449824"/>
-            <a:ext cx="1024127" cy="246888"/>
-          </a:xfrm>
-          <a:prstGeom prst="rect">
-            <a:avLst/>
-          </a:prstGeom>
-          <a:noFill/>
-        </p:spPr>
-        <p:txBody>
-          <a:bodyPr wrap="square">
-            <a:spAutoFit/>
-          </a:bodyPr>
-          <a:lstStyle/>
-          <a:p>
-            <a:pPr algn="ctr"/>
-            <a:r>
-              <a:rPr sz="1000" b="0" i="0">
-                <a:solidFill>
-                  <a:srgbClr val="333344"/>
-                </a:solidFill>
-                <a:latin typeface="Calibri"/>
-              </a:rPr>
-              <a:t>-12.36</a:t>
-            </a:r>
-          </a:p>
-        </p:txBody>
-      </p:sp>
-      <p:sp>
-        <p:nvSpPr>
-          <p:cNvPr id="132" name="Rectangle 131"/>
-          <p:cNvSpPr/>
-          <p:nvPr/>
-        </p:nvSpPr>
-        <p:spPr>
-          <a:xfrm>
-            <a:off x="6035040" y="5431536"/>
-            <a:ext cx="5577840" cy="283464"/>
-          </a:xfrm>
-          <a:prstGeom prst="rect">
-            <a:avLst/>
-          </a:prstGeom>
-          <a:solidFill>
-            <a:srgbClr val="FFFFFF"/>
-          </a:solidFill>
-          <a:ln>
-            <a:noFill/>
-          </a:ln>
-        </p:spPr>
-        <p:style>
-          <a:lnRef idx="1">
-            <a:schemeClr val="accent1"/>
-          </a:lnRef>
-          <a:fillRef idx="3">
-            <a:schemeClr val="accent1"/>
-          </a:fillRef>
-          <a:effectRef idx="2">
-            <a:schemeClr val="accent1"/>
-          </a:effectRef>
-          <a:fontRef idx="minor">
-            <a:schemeClr val="lt1"/>
-          </a:fontRef>
-        </p:style>
-        <p:txBody>
-          <a:bodyPr rtlCol="0" anchor="ctr"/>
-          <a:lstStyle/>
-          <a:p>
-            <a:pPr algn="ctr"/>
-          </a:p>
-        </p:txBody>
-      </p:sp>
-      <p:sp>
-        <p:nvSpPr>
-          <p:cNvPr id="133" name="TextBox 132"/>
-          <p:cNvSpPr txBox="1"/>
-          <p:nvPr/>
-        </p:nvSpPr>
-        <p:spPr>
-          <a:xfrm>
-            <a:off x="6071616" y="5449824"/>
-            <a:ext cx="5504688" cy="246888"/>
-          </a:xfrm>
-          <a:prstGeom prst="rect">
-            <a:avLst/>
-          </a:prstGeom>
-          <a:noFill/>
-        </p:spPr>
-        <p:txBody>
-          <a:bodyPr wrap="square">
-            <a:spAutoFit/>
-          </a:bodyPr>
-          <a:lstStyle/>
-          <a:p>
-            <a:pPr algn="l"/>
-            <a:r>
-              <a:rPr sz="900" b="0" i="0">
-                <a:solidFill>
-                  <a:srgbClr val="333344"/>
-                </a:solidFill>
-                <a:latin typeface="Calibri"/>
-              </a:rPr>
-              <a:t>Ala/Leu + R/K/H distribuídos</a:t>
-            </a:r>
-          </a:p>
-        </p:txBody>
-      </p:sp>
-      <p:sp>
-        <p:nvSpPr>
-          <p:cNvPr id="134" name="Rectangle 133"/>
-          <p:cNvSpPr/>
-          <p:nvPr/>
-        </p:nvSpPr>
-        <p:spPr>
-          <a:xfrm>
-            <a:off x="365760" y="6492240"/>
-            <a:ext cx="11430000" cy="256032"/>
-          </a:xfrm>
-          <a:prstGeom prst="rect">
-            <a:avLst/>
-          </a:prstGeom>
-          <a:solidFill>
-            <a:srgbClr val="1A4F8A"/>
-          </a:solidFill>
-          <a:ln>
-            <a:noFill/>
-          </a:ln>
-        </p:spPr>
-        <p:style>
-          <a:lnRef idx="1">
-            <a:schemeClr val="accent1"/>
-          </a:lnRef>
-          <a:fillRef idx="3">
-            <a:schemeClr val="accent1"/>
-          </a:fillRef>
-          <a:effectRef idx="2">
-            <a:schemeClr val="accent1"/>
-          </a:effectRef>
-          <a:fontRef idx="minor">
-            <a:schemeClr val="lt1"/>
-          </a:fontRef>
-        </p:style>
-        <p:txBody>
-          <a:bodyPr rtlCol="0" anchor="ctr"/>
-          <a:lstStyle/>
-          <a:p>
-            <a:pPr algn="ctr"/>
-          </a:p>
-        </p:txBody>
-      </p:sp>
-      <p:sp>
-        <p:nvSpPr>
-          <p:cNvPr id="135" name="TextBox 134"/>
+          <p:cNvPr id="96" name="TextBox 95"/>
           <p:cNvSpPr txBox="1"/>
           <p:nvPr/>
         </p:nvSpPr>
@@ -9151,14 +7626,14 @@
                 </a:solidFill>
                 <a:latin typeface="Calibri"/>
               </a:rPr>
-              <a:t>Padrao: Arg/Lys + Ala/Ser (sem aromaticos) — mecanismo competitivo classico (Arg-Asp205 S1) | contraste com candidatos heuristicos anteriores (aromatico-ricos)</a:t>
-            </a:r>
-          </a:p>
-        </p:txBody>
-      </p:sp>
-      <p:sp>
-        <p:nvSpPr>
-          <p:cNvPr id="136" name="TextBox 135"/>
+              <a:t>Especificidade: 20/20 aprovados vs tripsina humana (1TRN) + Apis mellifera (A0A7M7MMI1) | Resistencia: 0/20 resistentes — todos susceptiveis (K/R internos) — sondas in vitro</a:t>
+            </a:r>
+          </a:p>
+        </p:txBody>
+      </p:sp>
+      <p:sp>
+        <p:nvSpPr>
+          <p:cNvPr id="97" name="TextBox 96"/>
           <p:cNvSpPr txBox="1"/>
           <p:nvPr/>
         </p:nvSpPr>
@@ -26420,7 +24895,7 @@
                 </a:solidFill>
                 <a:latin typeface="Calibri"/>
               </a:rPr>
-              <a:t>4 fases planejadas | Fase 2 rodando no servidor (2026-06-25)</a:t>
+              <a:t>Fase 4-5 | resultados Fase 1-3 concluidos (2026-06-27)</a:t>
             </a:r>
           </a:p>
         </p:txBody>
@@ -26541,7 +25016,7 @@
                 </a:solidFill>
                 <a:latin typeface="Calibri"/>
               </a:rPr>
-              <a:t>2</a:t>
+              <a:t>4a</a:t>
             </a:r>
           </a:p>
         </p:txBody>
@@ -26619,7 +25094,7 @@
                 </a:solidFill>
                 <a:latin typeface="Calibri"/>
               </a:rPr>
-              <a:t>RODANDO</a:t>
+              <a:t>PROXIMO</a:t>
             </a:r>
           </a:p>
         </p:txBody>
@@ -26654,7 +25129,7 @@
                 </a:solidFill>
                 <a:latin typeface="Calibri"/>
               </a:rPr>
-              <a:t>Docking 1000 seqs + Rosetta top-50 + Ranking</a:t>
+              <a:t>RFdiffusion 5-15 aa + filtro KR-interno=0</a:t>
             </a:r>
           </a:p>
         </p:txBody>
@@ -26689,8 +25164,8 @@
                 </a:solidFill>
                 <a:latin typeface="Calibri"/>
               </a:rPr>
-              <a:t>top_for_docking: 200-&gt;1000 | optimization.top_k: 10-&gt;50
-28x mais labels Vina | 5x mais I_sc -&gt; dataset ML robusto (~8h GPU)</a:t>
+              <a:t>250 backbones curtos: 50 x [5, 7, 10, 12, 15 aa] | contigs independentes por comprimento
+ProteinMPNN: P1 unico C-terminal (Arg/Lys) | posicoes internas = Ala/Ser/Gly/Pro</a:t>
             </a:r>
           </a:p>
         </p:txBody>
@@ -26725,7 +25200,7 @@
                 </a:solidFill>
                 <a:latin typeface="Calibri"/>
               </a:rPr>
-              <a:t>~8h GPU</a:t>
+              <a:t>~3h GPU</a:t>
             </a:r>
           </a:p>
         </p:txBody>
@@ -26846,7 +25321,7 @@
                 </a:solidFill>
                 <a:latin typeface="Calibri"/>
               </a:rPr>
-              <a:t>3</a:t>
+              <a:t>4b</a:t>
             </a:r>
           </a:p>
         </p:txBody>
@@ -26959,7 +25434,7 @@
                 </a:solidFill>
                 <a:latin typeface="Calibri"/>
               </a:rPr>
-              <a:t>ML Training: Random Forest + XGBoost</a:t>
+              <a:t>MD dos 219 candidatos OptimizationAgent</a:t>
             </a:r>
           </a:p>
         </p:txBody>
@@ -26994,8 +25469,8 @@
                 </a:solidFill>
                 <a:latin typeface="Calibri"/>
               </a:rPr>
-              <a:t>scripts/train_ml.py: 1000 labels -&gt; prediz afinidade para 24.513 seqs
-Output: ml_top100_predicted.csv | feature importance | RMSE &lt; 0,8 kcal/mol</a:t>
+              <a:t>219 variantes de MKKQRENAKKVAEITLKKAK + GSRASARAYAARVRARRAAL geradas
+Selecionar top-5 por Vina -&gt; MD 10 ns -&gt; filtrar estaveis (RMSD &lt; 0,5 nm)</a:t>
             </a:r>
           </a:p>
         </p:txBody>
@@ -27030,7 +25505,7 @@
                 </a:solidFill>
                 <a:latin typeface="Calibri"/>
               </a:rPr>
-              <a:t>~5 min</a:t>
+              <a:t>~5h GPU</a:t>
             </a:r>
           </a:p>
         </p:txBody>
@@ -27151,7 +25626,7 @@
                 </a:solidFill>
                 <a:latin typeface="Calibri"/>
               </a:rPr>
-              <a:t>1</a:t>
+              <a:t>4c</a:t>
             </a:r>
           </a:p>
         </p:txBody>
@@ -27264,7 +25739,7 @@
                 </a:solidFill>
                 <a:latin typeface="Calibri"/>
               </a:rPr>
-              <a:t>OptimizationAgent: variantes dos candidatos estaveis</a:t>
+              <a:t>MD de SARESIKKAYKTFLERYKKL (novo top-1 Vina)</a:t>
             </a:r>
           </a:p>
         </p:txBody>
@@ -27299,8 +25774,8 @@
                 </a:solidFill>
                 <a:latin typeface="Calibri"/>
               </a:rPr>
-              <a:t>MKKQRENAKKVAEITLKKAK + GSRASARAYAARVRARRAAL -&gt; point mutations + conservative swaps
--&gt; re-dock automatico -&gt; novos candidatos aprimorados (top_k: 50-&gt;5)</a:t>
+              <a:t>Melhor afinidade Vina do pipeline (-14,58 kcal/mol) ainda sem MD
+Confirmar estabilidade antes de priorizar para sintese</a:t>
             </a:r>
           </a:p>
         </p:txBody>
@@ -27335,7 +25810,7 @@
                 </a:solidFill>
                 <a:latin typeface="Calibri"/>
               </a:rPr>
-              <a:t>~2h GPU</a:t>
+              <a:t>~1h GPU</a:t>
             </a:r>
           </a:p>
         </p:txBody>
@@ -27398,7 +25873,7 @@
             <a:avLst/>
           </a:prstGeom>
           <a:solidFill>
-            <a:srgbClr val="FFD166"/>
+            <a:srgbClr val="1A4F8A"/>
           </a:solidFill>
           <a:ln>
             <a:noFill/>
@@ -27456,7 +25931,7 @@
                 </a:solidFill>
                 <a:latin typeface="Calibri"/>
               </a:rPr>
-              <a:t>4</a:t>
+              <a:t>5</a:t>
             </a:r>
           </a:p>
         </p:txBody>
@@ -27476,7 +25951,7 @@
             <a:avLst/>
           </a:prstGeom>
           <a:solidFill>
-            <a:srgbClr val="FFD166"/>
+            <a:srgbClr val="1A4F8A"/>
           </a:solidFill>
           <a:ln>
             <a:noFill/>
@@ -27534,7 +26009,7 @@
                 </a:solidFill>
                 <a:latin typeface="Calibri"/>
               </a:rPr>
-              <a:t>PARALELA</a:t>
+              <a:t>FUTURO</a:t>
             </a:r>
           </a:p>
         </p:txBody>
@@ -27569,7 +26044,7 @@
                 </a:solidFill>
                 <a:latin typeface="Calibri"/>
               </a:rPr>
-              <a:t>RFdiffusion comprimentos variaveis (5-15 aa)</a:t>
+              <a:t>Expansao taxonomica: H. armigera + A. gemmatalis + D. saccharalis</a:t>
             </a:r>
           </a:p>
         </p:txBody>
@@ -27604,8 +26079,8 @@
                 </a:solidFill>
                 <a:latin typeface="Calibri"/>
               </a:rPr>
-              <a:t>250 novos backbones reais: 50 x [5, 7, 10, 12, 15 aa]
-Peptideos curtos: melhor sintese Fmoc-SPPS + bioatividade oral</a:t>
+              <a:t>Pipeline atual: ACR157 (A. gemmatalis) apenas
+Rodar docking + Rosetta nos outros 3 receptores -&gt; seletividade por especie</a:t>
             </a:r>
           </a:p>
         </p:txBody>
@@ -27636,11 +26111,11 @@
             <a:r>
               <a:rPr sz="1100" b="1" i="0">
                 <a:solidFill>
-                  <a:srgbClr val="FFD166"/>
-                </a:solidFill>
-                <a:latin typeface="Calibri"/>
-              </a:rPr>
-              <a:t>~3h GPU</a:t>
+                  <a:srgbClr val="1A4F8A"/>
+                </a:solidFill>
+                <a:latin typeface="Calibri"/>
+              </a:rPr>
+              <a:t>~GPU</a:t>
             </a:r>
           </a:p>
         </p:txBody>
@@ -27703,7 +26178,7 @@
             <a:avLst/>
           </a:prstGeom>
           <a:solidFill>
-            <a:srgbClr val="1A4F8A"/>
+            <a:srgbClr val="FF7F11"/>
           </a:solidFill>
           <a:ln>
             <a:noFill/>
@@ -27761,7 +26236,7 @@
                 </a:solidFill>
                 <a:latin typeface="Calibri"/>
               </a:rPr>
-              <a:t>5</a:t>
+              <a:t>6a</a:t>
             </a:r>
           </a:p>
         </p:txBody>
@@ -27781,7 +26256,7 @@
             <a:avLst/>
           </a:prstGeom>
           <a:solidFill>
-            <a:srgbClr val="1A4F8A"/>
+            <a:srgbClr val="FF7F11"/>
           </a:solidFill>
           <a:ln>
             <a:noFill/>
@@ -27874,7 +26349,7 @@
                 </a:solidFill>
                 <a:latin typeface="Calibri"/>
               </a:rPr>
-              <a:t>Expandir para QCL936, XP273, XP352</a:t>
+              <a:t>Variantes resistentes: Nle/Orn/D-aa nos P1-internos</a:t>
             </a:r>
           </a:p>
         </p:txBody>
@@ -27909,8 +26384,8 @@
                 </a:solidFill>
                 <a:latin typeface="Calibri"/>
               </a:rPr>
-              <a:t>Pipeline atual: ACR157 apenas. Rodar docking+Rosetta nos outros 3 receptores
--&gt; seletividade por tripsina (XP273 hidrofobico = target diferenciado)</a:t>
+              <a:t>K interno -&gt; Nle (norleucina) | R interno -&gt; Orn (ornitina)
+D-Lys / D-Arg: invisiveis para L-tripsinas enantiosseletivas (Fmoc-SPPS)</a:t>
             </a:r>
           </a:p>
         </p:txBody>
@@ -27941,11 +26416,11 @@
             <a:r>
               <a:rPr sz="1100" b="1" i="0">
                 <a:solidFill>
-                  <a:srgbClr val="1A4F8A"/>
-                </a:solidFill>
-                <a:latin typeface="Calibri"/>
-              </a:rPr>
-              <a:t>~GPU</a:t>
+                  <a:srgbClr val="FF7F11"/>
+                </a:solidFill>
+                <a:latin typeface="Calibri"/>
+              </a:rPr>
+              <a:t>sintese</a:t>
             </a:r>
           </a:p>
         </p:txBody>
@@ -28066,7 +26541,7 @@
                 </a:solidFill>
                 <a:latin typeface="Calibri"/>
               </a:rPr>
-              <a:t>6</a:t>
+              <a:t>6b</a:t>
             </a:r>
           </a:p>
         </p:txBody>
@@ -28214,8 +26689,8 @@
                 </a:solidFill>
                 <a:latin typeface="Calibri"/>
               </a:rPr>
-              <a:t>Top-2: MKKQRENAKKVAEITLKKAK + GSRASARAYAARVRARRAAL -&gt; Fmoc-SPPS -&gt; IC50 in vitro
-Tripsinas recombinantes S. frugiperda + A. gemmatalis (GenOne / Peptide 2.0)</a:t>
+              <a:t>Top-2 estaveis -&gt; Fmoc-SPPS -&gt; IC50 in vitro (S. frugiperda + A. gemmatalis)
+Publicacao alvo: JCIM / CSBJ</a:t>
             </a:r>
           </a:p>
         </p:txBody>
@@ -28502,7 +26977,7 @@
                 </a:solidFill>
                 <a:latin typeface="Calibri"/>
               </a:rPr>
-              <a:t>MD 5/5 concluido | Docking 1000 rodando | 2 candidatos estaveis — 2026-06-25</a:t>
+              <a:t>Fase 1-3 CONCLUIDA | 880 poses | ML treinado | 20/20 seletivos | 0/20 resistentes — 2026-06-27</a:t>
             </a:r>
           </a:p>
         </p:txBody>
@@ -28615,7 +27090,7 @@
                 </a:solidFill>
                 <a:latin typeface="Calibri"/>
               </a:rPr>
-              <a:t>330 backbones reais (RFdiffusion) | 24.513 binders 20 aa (ProteinMPNN) | 42 bugs corrigidos | dataset 44 features × 24.513 sequencias</a:t>
+              <a:t>330 backbones RFdiffusion | 24.513 binders ProteinMPNN | 880 poses Vina | novo top-1: SARESIKKAYKTFLERYKKL (-14,58 kcal/mol, score=0,748)</a:t>
             </a:r>
           </a:p>
         </p:txBody>
@@ -28728,7 +27203,7 @@
                 </a:solidFill>
                 <a:latin typeface="Calibri"/>
               </a:rPr>
-              <a:t>194 poses Vina reais (expandindo para 1000) | 10 I_sc PyRosetta (expandindo para 50) | Ranking composto: Vina 50% + Rosetta 20% + H-bond 15% + RMSD 10%</a:t>
+              <a:t>MD 10 ns — 5/5 concluidos | MKKQRENAKKVAEITLKKAK (RMSD 0,447 nm) ESTAVEL #1 | GSRASARAYAARVRARRAAL (RMSD 0,494 nm) ESTAVEL #2 | 2 instáveis descartados</a:t>
             </a:r>
           </a:p>
         </p:txBody>
@@ -28841,7 +27316,7 @@
                 </a:solidFill>
                 <a:latin typeface="Calibri"/>
               </a:rPr>
-              <a:t>MD 10 ns — 5/5 candidatos concluidos | MKKQRENAKKVAEITLKKAK (0,447 nm) ESTAVEL #1 | GSRASARAYAARVRARRAAL (0,494 nm) ESTAVEL #2 | GARKSIREYQKRVLERLKKK descartado (1,453 nm)</a:t>
+              <a:t>ML: Random Forest RMSE=0,514 kcal/mol | 24.513 predicoes geradas | 219 novos candidatos por OptimizationAgent (redesign iterativo)</a:t>
             </a:r>
           </a:p>
         </p:txBody>
@@ -28861,7 +27336,7 @@
             <a:avLst/>
           </a:prstGeom>
           <a:solidFill>
-            <a:srgbClr val="00B4D8"/>
+            <a:srgbClr val="06D6A0"/>
           </a:solidFill>
           <a:ln>
             <a:noFill/>
@@ -28919,7 +27394,7 @@
                 </a:solidFill>
                 <a:latin typeface="Calibri"/>
               </a:rPr>
-              <a:t>→</a:t>
+              <a:t>✓</a:t>
             </a:r>
           </a:p>
         </p:txBody>
@@ -28954,7 +27429,7 @@
                 </a:solidFill>
                 <a:latin typeface="Calibri"/>
               </a:rPr>
-              <a:t>Reclassificacao pos-MD: melhor I_sc (GARKSIREYQKRVLERLKKK, -86,28) instavel em solvente. MD obrigatorio para filtrar falsos-positivos Rosetta — resultado consistente com literatura</a:t>
+              <a:t>Especificidade: 20/20 aprovados vs tripsina humana (1TRN) + Apis mellifera (SI &gt;= 2,0 kcal/mol) | Resistencia proteolitica: 0/20 resistentes — sondas in vitro; modificacao quimica necessaria</a:t>
             </a:r>
           </a:p>
         </p:txBody>
@@ -29067,7 +27542,7 @@
                 </a:solidFill>
                 <a:latin typeface="Calibri"/>
               </a:rPr>
-              <a:t>Padrao composicional: Arg/Lys + Ala/Ser (sem aromaticos) — mecanismo competitivo Arg-Asp205 (S1). Mecanismo proposto validado por 3 metodos independentes (Vina + Rosetta + MD)</a:t>
+              <a:t>Trade-off intrínseco: Arg/Lys maximizam afinidade S1 (Asp205) mas sao substratos da propria tripsina. Solucao: Fase 4 peptideos 5-15 aa + Nle/Orn/D-aa nos P1-internos</a:t>
             </a:r>
           </a:p>
         </p:txBody>
@@ -29087,7 +27562,7 @@
             <a:avLst/>
           </a:prstGeom>
           <a:solidFill>
-            <a:srgbClr val="FFD166"/>
+            <a:srgbClr val="00B4D8"/>
           </a:solidFill>
           <a:ln>
             <a:noFill/>
@@ -29145,7 +27620,7 @@
                 </a:solidFill>
                 <a:latin typeface="Calibri"/>
               </a:rPr>
-              <a:t>⏳</a:t>
+              <a:t>→</a:t>
             </a:r>
           </a:p>
         </p:txBody>
@@ -29180,7 +27655,7 @@
                 </a:solidFill>
                 <a:latin typeface="Calibri"/>
               </a:rPr>
-              <a:t>Fase 2 RODANDO: docking 1000 seqs + Rosetta 50 + ranking | Proximo: scripts/train_ml.py (RF/XGBoost) + OptimizationAgent + RFdiffusion 5-15 aa</a:t>
+              <a:t>MD obrigatorio: GARKSIREYQKRVLERLKKK melhor I_sc Rosetta (-86,28) mas instavel em solvente (RMSD 1,45 nm). 3 metodos concordantes validam mecanismo competitivo Arg-Asp205</a:t>
             </a:r>
           </a:p>
         </p:txBody>
@@ -29258,7 +27733,7 @@
                 </a:solidFill>
                 <a:latin typeface="Calibri"/>
               </a:rPr>
-              <a:t>→</a:t>
+              <a:t>⏳</a:t>
             </a:r>
           </a:p>
         </p:txBody>
@@ -29293,7 +27768,7 @@
                 </a:solidFill>
                 <a:latin typeface="Calibri"/>
               </a:rPr>
-              <a:t>Alvo final: MKKQRENAKKVAEITLKKAK + GSRASARAYAARVRARRAAL -&gt; sintese Fmoc-SPPS -&gt; ensaios IC50 in vitro (S. frugiperda + A. gemmatalis). Publicacao: JCIM / CSBJ</a:t>
+              <a:t>Fase 4: RFdiffusion 5-15 aa (KR-interno=0) + MD SARESIKKAYKTFLERYKKL + variantes Nle/Orn | Alvo sintese: MKKQRENAKKVAEITLKKAK + GSRASARAYAARVRARRAAL -&gt; Fmoc-SPPS -&gt; IC50 (JCIM/CSBJ)</a:t>
             </a:r>
           </a:p>
         </p:txBody>

</xml_diff>

<commit_message>
docs: Fase 4 MD — RLREELKKAEEWLEKRRKEE estável (0,294 nm); top-3 síntese definidos
</commit_message>
<xml_diff>
--- a/apresentacao_design_inibidores.pptx
+++ b/apresentacao_design_inibidores.pptx
@@ -17017,7 +17017,7 @@
                 </a:solidFill>
                 <a:latin typeface="Calibri"/>
               </a:rPr>
-              <a:t>MD 5/5 CONCLUIDO: MKKQRENAKKVAEITLKKAK (0,447 nm) e GSRASARAYAARVRARRAAL (0,494 nm) ESTAVEIS | ver slide 13</a:t>
+              <a:t>MD 11/11 CONCLUIDO (Fases 3+4): top-3 sintese — MKKQRENA(0,447nm) | RLREELKK(0,294nm★) | GSRASARA(0,494nm) | ver slide 13</a:t>
             </a:r>
           </a:p>
         </p:txBody>
@@ -17277,7 +17277,7 @@
                 </a:solidFill>
                 <a:latin typeface="Calibri"/>
               </a:rPr>
-              <a:t>Dinamica Molecular — Top-5 Candidatos × ACR157</a:t>
+              <a:t>Dinamica Molecular — 11 Candidatos × ACR157 (Fases 3+4)</a:t>
             </a:r>
           </a:p>
         </p:txBody>
@@ -17369,7 +17369,7 @@
         <p:spPr>
           <a:xfrm>
             <a:off x="320040" y="1188720"/>
-            <a:ext cx="3474720" cy="292608"/>
+            <a:ext cx="3246120" cy="292608"/>
           </a:xfrm>
           <a:prstGeom prst="rect">
             <a:avLst/>
@@ -17384,7 +17384,7 @@
           <a:p>
             <a:pPr algn="l"/>
             <a:r>
-              <a:rPr sz="1200" b="1" i="0">
+              <a:rPr sz="1100" b="1" i="0">
                 <a:solidFill>
                   <a:srgbClr val="FFFFFF"/>
                 </a:solidFill>
@@ -17403,8 +17403,8 @@
         </p:nvSpPr>
         <p:spPr>
           <a:xfrm>
-            <a:off x="3840480" y="1188720"/>
-            <a:ext cx="1097280" cy="292608"/>
+            <a:off x="3657600" y="1188720"/>
+            <a:ext cx="502920" cy="292608"/>
           </a:xfrm>
           <a:prstGeom prst="rect">
             <a:avLst/>
@@ -17419,12 +17419,47 @@
           <a:p>
             <a:pPr algn="l"/>
             <a:r>
-              <a:rPr sz="1200" b="1" i="0">
+              <a:rPr sz="1100" b="1" i="0">
                 <a:solidFill>
                   <a:srgbClr val="FFFFFF"/>
                 </a:solidFill>
                 <a:latin typeface="Calibri"/>
               </a:rPr>
+              <a:t>Fase</a:t>
+            </a:r>
+          </a:p>
+        </p:txBody>
+      </p:sp>
+      <p:sp>
+        <p:nvSpPr>
+          <p:cNvPr id="11" name="TextBox 10"/>
+          <p:cNvSpPr txBox="1"/>
+          <p:nvPr/>
+        </p:nvSpPr>
+        <p:spPr>
+          <a:xfrm>
+            <a:off x="4206240" y="1188720"/>
+            <a:ext cx="1005840" cy="292608"/>
+          </a:xfrm>
+          <a:prstGeom prst="rect">
+            <a:avLst/>
+          </a:prstGeom>
+          <a:noFill/>
+        </p:spPr>
+        <p:txBody>
+          <a:bodyPr wrap="square">
+            <a:spAutoFit/>
+          </a:bodyPr>
+          <a:lstStyle/>
+          <a:p>
+            <a:pPr algn="l"/>
+            <a:r>
+              <a:rPr sz="1100" b="1" i="0">
+                <a:solidFill>
+                  <a:srgbClr val="FFFFFF"/>
+                </a:solidFill>
+                <a:latin typeface="Calibri"/>
+              </a:rPr>
               <a:t>Vina</a:t>
             </a:r>
           </a:p>
@@ -17432,14 +17467,14 @@
       </p:sp>
       <p:sp>
         <p:nvSpPr>
-          <p:cNvPr id="11" name="TextBox 10"/>
-          <p:cNvSpPr txBox="1"/>
-          <p:nvPr/>
-        </p:nvSpPr>
-        <p:spPr>
-          <a:xfrm>
-            <a:off x="4983480" y="1188720"/>
-            <a:ext cx="1097280" cy="292608"/>
+          <p:cNvPr id="12" name="TextBox 11"/>
+          <p:cNvSpPr txBox="1"/>
+          <p:nvPr/>
+        </p:nvSpPr>
+        <p:spPr>
+          <a:xfrm>
+            <a:off x="5212080" y="1188720"/>
+            <a:ext cx="1005840" cy="292608"/>
           </a:xfrm>
           <a:prstGeom prst="rect">
             <a:avLst/>
@@ -17454,7 +17489,7 @@
           <a:p>
             <a:pPr algn="l"/>
             <a:r>
-              <a:rPr sz="1200" b="1" i="0">
+              <a:rPr sz="1100" b="1" i="0">
                 <a:solidFill>
                   <a:srgbClr val="FFFFFF"/>
                 </a:solidFill>
@@ -17467,14 +17502,14 @@
       </p:sp>
       <p:sp>
         <p:nvSpPr>
-          <p:cNvPr id="12" name="TextBox 11"/>
-          <p:cNvSpPr txBox="1"/>
-          <p:nvPr/>
-        </p:nvSpPr>
-        <p:spPr>
-          <a:xfrm>
-            <a:off x="6126480" y="1188720"/>
-            <a:ext cx="1188720" cy="292608"/>
+          <p:cNvPr id="13" name="TextBox 12"/>
+          <p:cNvSpPr txBox="1"/>
+          <p:nvPr/>
+        </p:nvSpPr>
+        <p:spPr>
+          <a:xfrm>
+            <a:off x="6263640" y="1188720"/>
+            <a:ext cx="2560320" cy="292608"/>
           </a:xfrm>
           <a:prstGeom prst="rect">
             <a:avLst/>
@@ -17489,27 +17524,27 @@
           <a:p>
             <a:pPr algn="l"/>
             <a:r>
-              <a:rPr sz="1200" b="1" i="0">
+              <a:rPr sz="1100" b="1" i="0">
                 <a:solidFill>
                   <a:srgbClr val="FFFFFF"/>
                 </a:solidFill>
                 <a:latin typeface="Calibri"/>
               </a:rPr>
-              <a:t>RMSD avg</a:t>
-            </a:r>
-          </a:p>
-        </p:txBody>
-      </p:sp>
-      <p:sp>
-        <p:nvSpPr>
-          <p:cNvPr id="13" name="TextBox 12"/>
-          <p:cNvSpPr txBox="1"/>
-          <p:nvPr/>
-        </p:nvSpPr>
-        <p:spPr>
-          <a:xfrm>
-            <a:off x="7360920" y="1188720"/>
-            <a:ext cx="1097280" cy="292608"/>
+              <a:t>RMSD avg±DP (nm)</a:t>
+            </a:r>
+          </a:p>
+        </p:txBody>
+      </p:sp>
+      <p:sp>
+        <p:nvSpPr>
+          <p:cNvPr id="14" name="TextBox 13"/>
+          <p:cNvSpPr txBox="1"/>
+          <p:nvPr/>
+        </p:nvSpPr>
+        <p:spPr>
+          <a:xfrm>
+            <a:off x="8869680" y="1188720"/>
+            <a:ext cx="731520" cy="292608"/>
           </a:xfrm>
           <a:prstGeom prst="rect">
             <a:avLst/>
@@ -17524,27 +17559,27 @@
           <a:p>
             <a:pPr algn="l"/>
             <a:r>
-              <a:rPr sz="1200" b="1" i="0">
+              <a:rPr sz="1100" b="1" i="0">
                 <a:solidFill>
                   <a:srgbClr val="FFFFFF"/>
                 </a:solidFill>
                 <a:latin typeface="Calibri"/>
               </a:rPr>
-              <a:t>Rg (nm)</a:t>
-            </a:r>
-          </a:p>
-        </p:txBody>
-      </p:sp>
-      <p:sp>
-        <p:nvSpPr>
-          <p:cNvPr id="14" name="TextBox 13"/>
-          <p:cNvSpPr txBox="1"/>
-          <p:nvPr/>
-        </p:nvSpPr>
-        <p:spPr>
-          <a:xfrm>
-            <a:off x="8503920" y="1188720"/>
-            <a:ext cx="914400" cy="292608"/>
+              <a:t>Rg</a:t>
+            </a:r>
+          </a:p>
+        </p:txBody>
+      </p:sp>
+      <p:sp>
+        <p:nvSpPr>
+          <p:cNvPr id="15" name="TextBox 14"/>
+          <p:cNvSpPr txBox="1"/>
+          <p:nvPr/>
+        </p:nvSpPr>
+        <p:spPr>
+          <a:xfrm>
+            <a:off x="8915400" y="1188720"/>
+            <a:ext cx="2926080" cy="292608"/>
           </a:xfrm>
           <a:prstGeom prst="rect">
             <a:avLst/>
@@ -17559,42 +17594,7 @@
           <a:p>
             <a:pPr algn="l"/>
             <a:r>
-              <a:rPr sz="1200" b="1" i="0">
-                <a:solidFill>
-                  <a:srgbClr val="FFFFFF"/>
-                </a:solidFill>
-                <a:latin typeface="Calibri"/>
-              </a:rPr>
-              <a:t>Hbond</a:t>
-            </a:r>
-          </a:p>
-        </p:txBody>
-      </p:sp>
-      <p:sp>
-        <p:nvSpPr>
-          <p:cNvPr id="15" name="TextBox 14"/>
-          <p:cNvSpPr txBox="1"/>
-          <p:nvPr/>
-        </p:nvSpPr>
-        <p:spPr>
-          <a:xfrm>
-            <a:off x="9464040" y="1188720"/>
-            <a:ext cx="2377440" cy="292608"/>
-          </a:xfrm>
-          <a:prstGeom prst="rect">
-            <a:avLst/>
-          </a:prstGeom>
-          <a:noFill/>
-        </p:spPr>
-        <p:txBody>
-          <a:bodyPr wrap="square">
-            <a:spAutoFit/>
-          </a:bodyPr>
-          <a:lstStyle/>
-          <a:p>
-            <a:pPr algn="l"/>
-            <a:r>
-              <a:rPr sz="1200" b="1" i="0">
+              <a:rPr sz="1100" b="1" i="0">
                 <a:solidFill>
                   <a:srgbClr val="FFFFFF"/>
                 </a:solidFill>
@@ -17614,7 +17614,7 @@
         <p:spPr>
           <a:xfrm>
             <a:off x="274320" y="1572768"/>
-            <a:ext cx="11612880" cy="777240"/>
+            <a:ext cx="11612880" cy="566928"/>
           </a:xfrm>
           <a:prstGeom prst="rect">
             <a:avLst/>
@@ -17657,7 +17657,7 @@
         <p:spPr>
           <a:xfrm>
             <a:off x="274320" y="1572768"/>
-            <a:ext cx="73152" cy="777240"/>
+            <a:ext cx="73152" cy="566928"/>
           </a:xfrm>
           <a:prstGeom prst="rect">
             <a:avLst/>
@@ -17699,8 +17699,8 @@
         </p:nvSpPr>
         <p:spPr>
           <a:xfrm>
-            <a:off x="411480" y="1773936"/>
-            <a:ext cx="3383280" cy="347472"/>
+            <a:off x="411480" y="1700784"/>
+            <a:ext cx="3246120" cy="292608"/>
           </a:xfrm>
           <a:prstGeom prst="rect">
             <a:avLst/>
@@ -17715,7 +17715,7 @@
           <a:p>
             <a:pPr algn="l"/>
             <a:r>
-              <a:rPr sz="1200" b="1" i="0">
+              <a:rPr sz="1000" b="1" i="0">
                 <a:solidFill>
                   <a:srgbClr val="0D2B55"/>
                 </a:solidFill>
@@ -17734,8 +17734,8 @@
         </p:nvSpPr>
         <p:spPr>
           <a:xfrm>
-            <a:off x="3840480" y="1773936"/>
-            <a:ext cx="1097280" cy="347472"/>
+            <a:off x="3657600" y="1700784"/>
+            <a:ext cx="502920" cy="292608"/>
           </a:xfrm>
           <a:prstGeom prst="rect">
             <a:avLst/>
@@ -17750,7 +17750,42 @@
           <a:p>
             <a:pPr algn="l"/>
             <a:r>
-              <a:rPr sz="1200" b="0" i="0">
+              <a:rPr sz="900" b="1" i="0">
+                <a:solidFill>
+                  <a:srgbClr val="1A4F8A"/>
+                </a:solidFill>
+                <a:latin typeface="Calibri"/>
+              </a:rPr>
+              <a:t>F3</a:t>
+            </a:r>
+          </a:p>
+        </p:txBody>
+      </p:sp>
+      <p:sp>
+        <p:nvSpPr>
+          <p:cNvPr id="20" name="TextBox 19"/>
+          <p:cNvSpPr txBox="1"/>
+          <p:nvPr/>
+        </p:nvSpPr>
+        <p:spPr>
+          <a:xfrm>
+            <a:off x="4206240" y="1700784"/>
+            <a:ext cx="1051560" cy="292608"/>
+          </a:xfrm>
+          <a:prstGeom prst="rect">
+            <a:avLst/>
+          </a:prstGeom>
+          <a:noFill/>
+        </p:spPr>
+        <p:txBody>
+          <a:bodyPr wrap="square">
+            <a:spAutoFit/>
+          </a:bodyPr>
+          <a:lstStyle/>
+          <a:p>
+            <a:pPr algn="l"/>
+            <a:r>
+              <a:rPr sz="1000" b="0" i="0">
                 <a:solidFill>
                   <a:srgbClr val="333344"/>
                 </a:solidFill>
@@ -17763,14 +17798,14 @@
       </p:sp>
       <p:sp>
         <p:nvSpPr>
-          <p:cNvPr id="20" name="TextBox 19"/>
-          <p:cNvSpPr txBox="1"/>
-          <p:nvPr/>
-        </p:nvSpPr>
-        <p:spPr>
-          <a:xfrm>
-            <a:off x="4983480" y="1773936"/>
-            <a:ext cx="1097280" cy="347472"/>
+          <p:cNvPr id="21" name="TextBox 20"/>
+          <p:cNvSpPr txBox="1"/>
+          <p:nvPr/>
+        </p:nvSpPr>
+        <p:spPr>
+          <a:xfrm>
+            <a:off x="5212080" y="1700784"/>
+            <a:ext cx="1051560" cy="292608"/>
           </a:xfrm>
           <a:prstGeom prst="rect">
             <a:avLst/>
@@ -17785,7 +17820,7 @@
           <a:p>
             <a:pPr algn="l"/>
             <a:r>
-              <a:rPr sz="1200" b="0" i="0">
+              <a:rPr sz="1000" b="0" i="0">
                 <a:solidFill>
                   <a:srgbClr val="333344"/>
                 </a:solidFill>
@@ -17798,14 +17833,14 @@
       </p:sp>
       <p:sp>
         <p:nvSpPr>
-          <p:cNvPr id="21" name="TextBox 20"/>
-          <p:cNvSpPr txBox="1"/>
-          <p:nvPr/>
-        </p:nvSpPr>
-        <p:spPr>
-          <a:xfrm>
-            <a:off x="6126480" y="1773936"/>
-            <a:ext cx="1097280" cy="347472"/>
+          <p:cNvPr id="22" name="TextBox 21"/>
+          <p:cNvSpPr txBox="1"/>
+          <p:nvPr/>
+        </p:nvSpPr>
+        <p:spPr>
+          <a:xfrm>
+            <a:off x="6263640" y="1700784"/>
+            <a:ext cx="1051560" cy="292608"/>
           </a:xfrm>
           <a:prstGeom prst="rect">
             <a:avLst/>
@@ -17820,7 +17855,7 @@
           <a:p>
             <a:pPr algn="l"/>
             <a:r>
-              <a:rPr sz="1200" b="0" i="0">
+              <a:rPr sz="1000" b="0" i="0">
                 <a:solidFill>
                   <a:srgbClr val="333344"/>
                 </a:solidFill>
@@ -17833,14 +17868,14 @@
       </p:sp>
       <p:sp>
         <p:nvSpPr>
-          <p:cNvPr id="22" name="TextBox 21"/>
-          <p:cNvSpPr txBox="1"/>
-          <p:nvPr/>
-        </p:nvSpPr>
-        <p:spPr>
-          <a:xfrm>
-            <a:off x="7360920" y="1773936"/>
-            <a:ext cx="1097280" cy="347472"/>
+          <p:cNvPr id="23" name="TextBox 22"/>
+          <p:cNvSpPr txBox="1"/>
+          <p:nvPr/>
+        </p:nvSpPr>
+        <p:spPr>
+          <a:xfrm>
+            <a:off x="7818120" y="1700784"/>
+            <a:ext cx="1051560" cy="292608"/>
           </a:xfrm>
           <a:prstGeom prst="rect">
             <a:avLst/>
@@ -17855,48 +17890,13 @@
           <a:p>
             <a:pPr algn="l"/>
             <a:r>
-              <a:rPr sz="1200" b="0" i="0">
+              <a:rPr sz="1000" b="0" i="0">
                 <a:solidFill>
                   <a:srgbClr val="333344"/>
                 </a:solidFill>
                 <a:latin typeface="Calibri"/>
               </a:rPr>
               <a:t>1,785</a:t>
-            </a:r>
-          </a:p>
-        </p:txBody>
-      </p:sp>
-      <p:sp>
-        <p:nvSpPr>
-          <p:cNvPr id="23" name="TextBox 22"/>
-          <p:cNvSpPr txBox="1"/>
-          <p:nvPr/>
-        </p:nvSpPr>
-        <p:spPr>
-          <a:xfrm>
-            <a:off x="8503920" y="1773936"/>
-            <a:ext cx="1097280" cy="347472"/>
-          </a:xfrm>
-          <a:prstGeom prst="rect">
-            <a:avLst/>
-          </a:prstGeom>
-          <a:noFill/>
-        </p:spPr>
-        <p:txBody>
-          <a:bodyPr wrap="square">
-            <a:spAutoFit/>
-          </a:bodyPr>
-          <a:lstStyle/>
-          <a:p>
-            <a:pPr algn="l"/>
-            <a:r>
-              <a:rPr sz="1200" b="0" i="0">
-                <a:solidFill>
-                  <a:srgbClr val="333344"/>
-                </a:solidFill>
-                <a:latin typeface="Calibri"/>
-              </a:rPr>
-              <a:t>161,0</a:t>
             </a:r>
           </a:p>
         </p:txBody>
@@ -17909,8 +17909,8 @@
         </p:nvSpPr>
         <p:spPr>
           <a:xfrm>
-            <a:off x="9464040" y="1728216"/>
-            <a:ext cx="2331720" cy="438912"/>
+            <a:off x="8915400" y="1664208"/>
+            <a:ext cx="2926080" cy="384048"/>
           </a:xfrm>
           <a:prstGeom prst="rect">
             <a:avLst/>
@@ -17952,23 +17952,23 @@
         </p:nvSpPr>
         <p:spPr>
           <a:xfrm>
-            <a:off x="9464040" y="1728216"/>
-            <a:ext cx="2331720" cy="438912"/>
-          </a:xfrm>
-          <a:prstGeom prst="rect">
-            <a:avLst/>
-          </a:prstGeom>
-          <a:noFill/>
-        </p:spPr>
-        <p:txBody>
-          <a:bodyPr wrap="square">
-            <a:spAutoFit/>
-          </a:bodyPr>
-          <a:lstStyle/>
-          <a:p>
-            <a:pPr algn="ctr"/>
-            <a:r>
-              <a:rPr sz="1300" b="1" i="0">
+            <a:off x="8915400" y="1664208"/>
+            <a:ext cx="2926080" cy="384048"/>
+          </a:xfrm>
+          <a:prstGeom prst="rect">
+            <a:avLst/>
+          </a:prstGeom>
+          <a:noFill/>
+        </p:spPr>
+        <p:txBody>
+          <a:bodyPr wrap="square">
+            <a:spAutoFit/>
+          </a:bodyPr>
+          <a:lstStyle/>
+          <a:p>
+            <a:pPr algn="ctr"/>
+            <a:r>
+              <a:rPr sz="1100" b="1" i="0">
                 <a:solidFill>
                   <a:srgbClr val="FFFFFF"/>
                 </a:solidFill>
@@ -17987,8 +17987,8 @@
         </p:nvSpPr>
         <p:spPr>
           <a:xfrm>
-            <a:off x="274320" y="2395728"/>
-            <a:ext cx="11612880" cy="777240"/>
+            <a:off x="274320" y="2185416"/>
+            <a:ext cx="11612880" cy="566928"/>
           </a:xfrm>
           <a:prstGeom prst="rect">
             <a:avLst/>
@@ -18030,8 +18030,8 @@
         </p:nvSpPr>
         <p:spPr>
           <a:xfrm>
-            <a:off x="274320" y="2395728"/>
-            <a:ext cx="73152" cy="777240"/>
+            <a:off x="274320" y="2185416"/>
+            <a:ext cx="73152" cy="566928"/>
           </a:xfrm>
           <a:prstGeom prst="rect">
             <a:avLst/>
@@ -18073,8 +18073,8 @@
         </p:nvSpPr>
         <p:spPr>
           <a:xfrm>
-            <a:off x="411480" y="2596896"/>
-            <a:ext cx="3383280" cy="347472"/>
+            <a:off x="411480" y="2313432"/>
+            <a:ext cx="3246120" cy="292608"/>
           </a:xfrm>
           <a:prstGeom prst="rect">
             <a:avLst/>
@@ -18089,7 +18089,7 @@
           <a:p>
             <a:pPr algn="l"/>
             <a:r>
-              <a:rPr sz="1200" b="1" i="0">
+              <a:rPr sz="1000" b="1" i="0">
                 <a:solidFill>
                   <a:srgbClr val="0D2B55"/>
                 </a:solidFill>
@@ -18108,8 +18108,8 @@
         </p:nvSpPr>
         <p:spPr>
           <a:xfrm>
-            <a:off x="3840480" y="2596896"/>
-            <a:ext cx="1097280" cy="347472"/>
+            <a:off x="3657600" y="2313432"/>
+            <a:ext cx="502920" cy="292608"/>
           </a:xfrm>
           <a:prstGeom prst="rect">
             <a:avLst/>
@@ -18124,7 +18124,42 @@
           <a:p>
             <a:pPr algn="l"/>
             <a:r>
-              <a:rPr sz="1200" b="0" i="0">
+              <a:rPr sz="900" b="1" i="0">
+                <a:solidFill>
+                  <a:srgbClr val="1A4F8A"/>
+                </a:solidFill>
+                <a:latin typeface="Calibri"/>
+              </a:rPr>
+              <a:t>F3</a:t>
+            </a:r>
+          </a:p>
+        </p:txBody>
+      </p:sp>
+      <p:sp>
+        <p:nvSpPr>
+          <p:cNvPr id="30" name="TextBox 29"/>
+          <p:cNvSpPr txBox="1"/>
+          <p:nvPr/>
+        </p:nvSpPr>
+        <p:spPr>
+          <a:xfrm>
+            <a:off x="4206240" y="2313432"/>
+            <a:ext cx="1051560" cy="292608"/>
+          </a:xfrm>
+          <a:prstGeom prst="rect">
+            <a:avLst/>
+          </a:prstGeom>
+          <a:noFill/>
+        </p:spPr>
+        <p:txBody>
+          <a:bodyPr wrap="square">
+            <a:spAutoFit/>
+          </a:bodyPr>
+          <a:lstStyle/>
+          <a:p>
+            <a:pPr algn="l"/>
+            <a:r>
+              <a:rPr sz="1000" b="0" i="0">
                 <a:solidFill>
                   <a:srgbClr val="333344"/>
                 </a:solidFill>
@@ -18137,14 +18172,14 @@
       </p:sp>
       <p:sp>
         <p:nvSpPr>
-          <p:cNvPr id="30" name="TextBox 29"/>
-          <p:cNvSpPr txBox="1"/>
-          <p:nvPr/>
-        </p:nvSpPr>
-        <p:spPr>
-          <a:xfrm>
-            <a:off x="4983480" y="2596896"/>
-            <a:ext cx="1097280" cy="347472"/>
+          <p:cNvPr id="31" name="TextBox 30"/>
+          <p:cNvSpPr txBox="1"/>
+          <p:nvPr/>
+        </p:nvSpPr>
+        <p:spPr>
+          <a:xfrm>
+            <a:off x="5212080" y="2313432"/>
+            <a:ext cx="1051560" cy="292608"/>
           </a:xfrm>
           <a:prstGeom prst="rect">
             <a:avLst/>
@@ -18159,7 +18194,7 @@
           <a:p>
             <a:pPr algn="l"/>
             <a:r>
-              <a:rPr sz="1200" b="0" i="0">
+              <a:rPr sz="1000" b="0" i="0">
                 <a:solidFill>
                   <a:srgbClr val="333344"/>
                 </a:solidFill>
@@ -18172,14 +18207,14 @@
       </p:sp>
       <p:sp>
         <p:nvSpPr>
-          <p:cNvPr id="31" name="TextBox 30"/>
-          <p:cNvSpPr txBox="1"/>
-          <p:nvPr/>
-        </p:nvSpPr>
-        <p:spPr>
-          <a:xfrm>
-            <a:off x="6126480" y="2596896"/>
-            <a:ext cx="1097280" cy="347472"/>
+          <p:cNvPr id="32" name="TextBox 31"/>
+          <p:cNvSpPr txBox="1"/>
+          <p:nvPr/>
+        </p:nvSpPr>
+        <p:spPr>
+          <a:xfrm>
+            <a:off x="6263640" y="2313432"/>
+            <a:ext cx="1051560" cy="292608"/>
           </a:xfrm>
           <a:prstGeom prst="rect">
             <a:avLst/>
@@ -18194,7 +18229,7 @@
           <a:p>
             <a:pPr algn="l"/>
             <a:r>
-              <a:rPr sz="1200" b="0" i="0">
+              <a:rPr sz="1000" b="0" i="0">
                 <a:solidFill>
                   <a:srgbClr val="333344"/>
                 </a:solidFill>
@@ -18207,14 +18242,14 @@
       </p:sp>
       <p:sp>
         <p:nvSpPr>
-          <p:cNvPr id="32" name="TextBox 31"/>
-          <p:cNvSpPr txBox="1"/>
-          <p:nvPr/>
-        </p:nvSpPr>
-        <p:spPr>
-          <a:xfrm>
-            <a:off x="7360920" y="2596896"/>
-            <a:ext cx="1097280" cy="347472"/>
+          <p:cNvPr id="33" name="TextBox 32"/>
+          <p:cNvSpPr txBox="1"/>
+          <p:nvPr/>
+        </p:nvSpPr>
+        <p:spPr>
+          <a:xfrm>
+            <a:off x="7818120" y="2313432"/>
+            <a:ext cx="1051560" cy="292608"/>
           </a:xfrm>
           <a:prstGeom prst="rect">
             <a:avLst/>
@@ -18229,48 +18264,13 @@
           <a:p>
             <a:pPr algn="l"/>
             <a:r>
-              <a:rPr sz="1200" b="0" i="0">
+              <a:rPr sz="1000" b="0" i="0">
                 <a:solidFill>
                   <a:srgbClr val="333344"/>
                 </a:solidFill>
                 <a:latin typeface="Calibri"/>
               </a:rPr>
               <a:t>1,799</a:t>
-            </a:r>
-          </a:p>
-        </p:txBody>
-      </p:sp>
-      <p:sp>
-        <p:nvSpPr>
-          <p:cNvPr id="33" name="TextBox 32"/>
-          <p:cNvSpPr txBox="1"/>
-          <p:nvPr/>
-        </p:nvSpPr>
-        <p:spPr>
-          <a:xfrm>
-            <a:off x="8503920" y="2596896"/>
-            <a:ext cx="1097280" cy="347472"/>
-          </a:xfrm>
-          <a:prstGeom prst="rect">
-            <a:avLst/>
-          </a:prstGeom>
-          <a:noFill/>
-        </p:spPr>
-        <p:txBody>
-          <a:bodyPr wrap="square">
-            <a:spAutoFit/>
-          </a:bodyPr>
-          <a:lstStyle/>
-          <a:p>
-            <a:pPr algn="l"/>
-            <a:r>
-              <a:rPr sz="1200" b="0" i="0">
-                <a:solidFill>
-                  <a:srgbClr val="333344"/>
-                </a:solidFill>
-                <a:latin typeface="Calibri"/>
-              </a:rPr>
-              <a:t>160,9</a:t>
             </a:r>
           </a:p>
         </p:txBody>
@@ -18283,8 +18283,8 @@
         </p:nvSpPr>
         <p:spPr>
           <a:xfrm>
-            <a:off x="9464040" y="2551176"/>
-            <a:ext cx="2331720" cy="438912"/>
+            <a:off x="8915400" y="2276856"/>
+            <a:ext cx="2926080" cy="384048"/>
           </a:xfrm>
           <a:prstGeom prst="rect">
             <a:avLst/>
@@ -18326,23 +18326,23 @@
         </p:nvSpPr>
         <p:spPr>
           <a:xfrm>
-            <a:off x="9464040" y="2551176"/>
-            <a:ext cx="2331720" cy="438912"/>
-          </a:xfrm>
-          <a:prstGeom prst="rect">
-            <a:avLst/>
-          </a:prstGeom>
-          <a:noFill/>
-        </p:spPr>
-        <p:txBody>
-          <a:bodyPr wrap="square">
-            <a:spAutoFit/>
-          </a:bodyPr>
-          <a:lstStyle/>
-          <a:p>
-            <a:pPr algn="ctr"/>
-            <a:r>
-              <a:rPr sz="1300" b="1" i="0">
+            <a:off x="8915400" y="2276856"/>
+            <a:ext cx="2926080" cy="384048"/>
+          </a:xfrm>
+          <a:prstGeom prst="rect">
+            <a:avLst/>
+          </a:prstGeom>
+          <a:noFill/>
+        </p:spPr>
+        <p:txBody>
+          <a:bodyPr wrap="square">
+            <a:spAutoFit/>
+          </a:bodyPr>
+          <a:lstStyle/>
+          <a:p>
+            <a:pPr algn="ctr"/>
+            <a:r>
+              <a:rPr sz="1100" b="1" i="0">
                 <a:solidFill>
                   <a:srgbClr val="FFFFFF"/>
                 </a:solidFill>
@@ -18361,8 +18361,8 @@
         </p:nvSpPr>
         <p:spPr>
           <a:xfrm>
-            <a:off x="274320" y="3218688"/>
-            <a:ext cx="11612880" cy="777240"/>
+            <a:off x="274320" y="2798064"/>
+            <a:ext cx="11612880" cy="566928"/>
           </a:xfrm>
           <a:prstGeom prst="rect">
             <a:avLst/>
@@ -18404,8 +18404,8 @@
         </p:nvSpPr>
         <p:spPr>
           <a:xfrm>
-            <a:off x="274320" y="3218688"/>
-            <a:ext cx="73152" cy="777240"/>
+            <a:off x="274320" y="2798064"/>
+            <a:ext cx="73152" cy="566928"/>
           </a:xfrm>
           <a:prstGeom prst="rect">
             <a:avLst/>
@@ -18447,8 +18447,8 @@
         </p:nvSpPr>
         <p:spPr>
           <a:xfrm>
-            <a:off x="411480" y="3419856"/>
-            <a:ext cx="3383280" cy="347472"/>
+            <a:off x="411480" y="2926080"/>
+            <a:ext cx="3246120" cy="292608"/>
           </a:xfrm>
           <a:prstGeom prst="rect">
             <a:avLst/>
@@ -18463,7 +18463,7 @@
           <a:p>
             <a:pPr algn="l"/>
             <a:r>
-              <a:rPr sz="1200" b="1" i="0">
+              <a:rPr sz="1000" b="1" i="0">
                 <a:solidFill>
                   <a:srgbClr val="0D2B55"/>
                 </a:solidFill>
@@ -18482,8 +18482,8 @@
         </p:nvSpPr>
         <p:spPr>
           <a:xfrm>
-            <a:off x="3840480" y="3419856"/>
-            <a:ext cx="1097280" cy="347472"/>
+            <a:off x="3657600" y="2926080"/>
+            <a:ext cx="502920" cy="292608"/>
           </a:xfrm>
           <a:prstGeom prst="rect">
             <a:avLst/>
@@ -18498,7 +18498,42 @@
           <a:p>
             <a:pPr algn="l"/>
             <a:r>
-              <a:rPr sz="1200" b="0" i="0">
+              <a:rPr sz="900" b="1" i="0">
+                <a:solidFill>
+                  <a:srgbClr val="1A4F8A"/>
+                </a:solidFill>
+                <a:latin typeface="Calibri"/>
+              </a:rPr>
+              <a:t>F3</a:t>
+            </a:r>
+          </a:p>
+        </p:txBody>
+      </p:sp>
+      <p:sp>
+        <p:nvSpPr>
+          <p:cNvPr id="40" name="TextBox 39"/>
+          <p:cNvSpPr txBox="1"/>
+          <p:nvPr/>
+        </p:nvSpPr>
+        <p:spPr>
+          <a:xfrm>
+            <a:off x="4206240" y="2926080"/>
+            <a:ext cx="1051560" cy="292608"/>
+          </a:xfrm>
+          <a:prstGeom prst="rect">
+            <a:avLst/>
+          </a:prstGeom>
+          <a:noFill/>
+        </p:spPr>
+        <p:txBody>
+          <a:bodyPr wrap="square">
+            <a:spAutoFit/>
+          </a:bodyPr>
+          <a:lstStyle/>
+          <a:p>
+            <a:pPr algn="l"/>
+            <a:r>
+              <a:rPr sz="1000" b="0" i="0">
                 <a:solidFill>
                   <a:srgbClr val="333344"/>
                 </a:solidFill>
@@ -18511,14 +18546,14 @@
       </p:sp>
       <p:sp>
         <p:nvSpPr>
-          <p:cNvPr id="40" name="TextBox 39"/>
-          <p:cNvSpPr txBox="1"/>
-          <p:nvPr/>
-        </p:nvSpPr>
-        <p:spPr>
-          <a:xfrm>
-            <a:off x="4983480" y="3419856"/>
-            <a:ext cx="1097280" cy="347472"/>
+          <p:cNvPr id="41" name="TextBox 40"/>
+          <p:cNvSpPr txBox="1"/>
+          <p:nvPr/>
+        </p:nvSpPr>
+        <p:spPr>
+          <a:xfrm>
+            <a:off x="5212080" y="2926080"/>
+            <a:ext cx="1051560" cy="292608"/>
           </a:xfrm>
           <a:prstGeom prst="rect">
             <a:avLst/>
@@ -18533,7 +18568,7 @@
           <a:p>
             <a:pPr algn="l"/>
             <a:r>
-              <a:rPr sz="1200" b="0" i="0">
+              <a:rPr sz="1000" b="0" i="0">
                 <a:solidFill>
                   <a:srgbClr val="333344"/>
                 </a:solidFill>
@@ -18546,14 +18581,14 @@
       </p:sp>
       <p:sp>
         <p:nvSpPr>
-          <p:cNvPr id="41" name="TextBox 40"/>
-          <p:cNvSpPr txBox="1"/>
-          <p:nvPr/>
-        </p:nvSpPr>
-        <p:spPr>
-          <a:xfrm>
-            <a:off x="6126480" y="3419856"/>
-            <a:ext cx="1097280" cy="347472"/>
+          <p:cNvPr id="42" name="TextBox 41"/>
+          <p:cNvSpPr txBox="1"/>
+          <p:nvPr/>
+        </p:nvSpPr>
+        <p:spPr>
+          <a:xfrm>
+            <a:off x="6263640" y="2926080"/>
+            <a:ext cx="1051560" cy="292608"/>
           </a:xfrm>
           <a:prstGeom prst="rect">
             <a:avLst/>
@@ -18568,7 +18603,7 @@
           <a:p>
             <a:pPr algn="l"/>
             <a:r>
-              <a:rPr sz="1200" b="0" i="0">
+              <a:rPr sz="1000" b="0" i="0">
                 <a:solidFill>
                   <a:srgbClr val="333344"/>
                 </a:solidFill>
@@ -18581,14 +18616,14 @@
       </p:sp>
       <p:sp>
         <p:nvSpPr>
-          <p:cNvPr id="42" name="TextBox 41"/>
-          <p:cNvSpPr txBox="1"/>
-          <p:nvPr/>
-        </p:nvSpPr>
-        <p:spPr>
-          <a:xfrm>
-            <a:off x="7360920" y="3419856"/>
-            <a:ext cx="1097280" cy="347472"/>
+          <p:cNvPr id="43" name="TextBox 42"/>
+          <p:cNvSpPr txBox="1"/>
+          <p:nvPr/>
+        </p:nvSpPr>
+        <p:spPr>
+          <a:xfrm>
+            <a:off x="7818120" y="2926080"/>
+            <a:ext cx="1051560" cy="292608"/>
           </a:xfrm>
           <a:prstGeom prst="rect">
             <a:avLst/>
@@ -18603,48 +18638,13 @@
           <a:p>
             <a:pPr algn="l"/>
             <a:r>
-              <a:rPr sz="1200" b="0" i="0">
+              <a:rPr sz="1000" b="0" i="0">
                 <a:solidFill>
                   <a:srgbClr val="333344"/>
                 </a:solidFill>
                 <a:latin typeface="Calibri"/>
               </a:rPr>
               <a:t>1,836</a:t>
-            </a:r>
-          </a:p>
-        </p:txBody>
-      </p:sp>
-      <p:sp>
-        <p:nvSpPr>
-          <p:cNvPr id="43" name="TextBox 42"/>
-          <p:cNvSpPr txBox="1"/>
-          <p:nvPr/>
-        </p:nvSpPr>
-        <p:spPr>
-          <a:xfrm>
-            <a:off x="8503920" y="3419856"/>
-            <a:ext cx="1097280" cy="347472"/>
-          </a:xfrm>
-          <a:prstGeom prst="rect">
-            <a:avLst/>
-          </a:prstGeom>
-          <a:noFill/>
-        </p:spPr>
-        <p:txBody>
-          <a:bodyPr wrap="square">
-            <a:spAutoFit/>
-          </a:bodyPr>
-          <a:lstStyle/>
-          <a:p>
-            <a:pPr algn="l"/>
-            <a:r>
-              <a:rPr sz="1200" b="0" i="0">
-                <a:solidFill>
-                  <a:srgbClr val="333344"/>
-                </a:solidFill>
-                <a:latin typeface="Calibri"/>
-              </a:rPr>
-              <a:t>163,6</a:t>
             </a:r>
           </a:p>
         </p:txBody>
@@ -18657,8 +18657,8 @@
         </p:nvSpPr>
         <p:spPr>
           <a:xfrm>
-            <a:off x="9464040" y="3374136"/>
-            <a:ext cx="2331720" cy="438912"/>
+            <a:off x="8915400" y="2889504"/>
+            <a:ext cx="2926080" cy="384048"/>
           </a:xfrm>
           <a:prstGeom prst="rect">
             <a:avLst/>
@@ -18700,23 +18700,23 @@
         </p:nvSpPr>
         <p:spPr>
           <a:xfrm>
-            <a:off x="9464040" y="3374136"/>
-            <a:ext cx="2331720" cy="438912"/>
-          </a:xfrm>
-          <a:prstGeom prst="rect">
-            <a:avLst/>
-          </a:prstGeom>
-          <a:noFill/>
-        </p:spPr>
-        <p:txBody>
-          <a:bodyPr wrap="square">
-            <a:spAutoFit/>
-          </a:bodyPr>
-          <a:lstStyle/>
-          <a:p>
-            <a:pPr algn="ctr"/>
-            <a:r>
-              <a:rPr sz="1300" b="1" i="0">
+            <a:off x="8915400" y="2889504"/>
+            <a:ext cx="2926080" cy="384048"/>
+          </a:xfrm>
+          <a:prstGeom prst="rect">
+            <a:avLst/>
+          </a:prstGeom>
+          <a:noFill/>
+        </p:spPr>
+        <p:txBody>
+          <a:bodyPr wrap="square">
+            <a:spAutoFit/>
+          </a:bodyPr>
+          <a:lstStyle/>
+          <a:p>
+            <a:pPr algn="ctr"/>
+            <a:r>
+              <a:rPr sz="1100" b="1" i="0">
                 <a:solidFill>
                   <a:srgbClr val="FFFFFF"/>
                 </a:solidFill>
@@ -18735,14 +18735,14 @@
         </p:nvSpPr>
         <p:spPr>
           <a:xfrm>
-            <a:off x="274320" y="4041648"/>
-            <a:ext cx="11612880" cy="777240"/>
-          </a:xfrm>
-          <a:prstGeom prst="rect">
-            <a:avLst/>
-          </a:prstGeom>
-          <a:solidFill>
-            <a:srgbClr val="F8D7DA"/>
+            <a:off x="274320" y="3410712"/>
+            <a:ext cx="11612880" cy="566928"/>
+          </a:xfrm>
+          <a:prstGeom prst="rect">
+            <a:avLst/>
+          </a:prstGeom>
+          <a:solidFill>
+            <a:srgbClr val="D4EDDA"/>
           </a:solidFill>
           <a:ln>
             <a:noFill/>
@@ -18778,14 +18778,14 @@
         </p:nvSpPr>
         <p:spPr>
           <a:xfrm>
-            <a:off x="274320" y="4041648"/>
-            <a:ext cx="73152" cy="777240"/>
-          </a:xfrm>
-          <a:prstGeom prst="rect">
-            <a:avLst/>
-          </a:prstGeom>
-          <a:solidFill>
-            <a:srgbClr val="FF7F11"/>
+            <a:off x="274320" y="3410712"/>
+            <a:ext cx="73152" cy="566928"/>
+          </a:xfrm>
+          <a:prstGeom prst="rect">
+            <a:avLst/>
+          </a:prstGeom>
+          <a:solidFill>
+            <a:srgbClr val="06D6A0"/>
           </a:solidFill>
           <a:ln>
             <a:noFill/>
@@ -18821,8 +18821,8 @@
         </p:nvSpPr>
         <p:spPr>
           <a:xfrm>
-            <a:off x="411480" y="4242816"/>
-            <a:ext cx="3383280" cy="347472"/>
+            <a:off x="411480" y="3538728"/>
+            <a:ext cx="3246120" cy="292608"/>
           </a:xfrm>
           <a:prstGeom prst="rect">
             <a:avLst/>
@@ -18837,13 +18837,13 @@
           <a:p>
             <a:pPr algn="l"/>
             <a:r>
-              <a:rPr sz="1200" b="1" i="0">
+              <a:rPr sz="1000" b="1" i="0">
                 <a:solidFill>
                   <a:srgbClr val="0D2B55"/>
                 </a:solidFill>
                 <a:latin typeface="Calibri"/>
               </a:rPr>
-              <a:t>GARKSIREYQKRVLERLKKK</a:t>
+              <a:t>RLREELKKAEEWLEKRRKEE</a:t>
             </a:r>
           </a:p>
         </p:txBody>
@@ -18856,8 +18856,8 @@
         </p:nvSpPr>
         <p:spPr>
           <a:xfrm>
-            <a:off x="3840480" y="4242816"/>
-            <a:ext cx="1097280" cy="347472"/>
+            <a:off x="3657600" y="3538728"/>
+            <a:ext cx="502920" cy="292608"/>
           </a:xfrm>
           <a:prstGeom prst="rect">
             <a:avLst/>
@@ -18872,27 +18872,62 @@
           <a:p>
             <a:pPr algn="l"/>
             <a:r>
-              <a:rPr sz="1200" b="0" i="0">
+              <a:rPr sz="900" b="1" i="0">
+                <a:solidFill>
+                  <a:srgbClr val="06D6A0"/>
+                </a:solidFill>
+                <a:latin typeface="Calibri"/>
+              </a:rPr>
+              <a:t>F4</a:t>
+            </a:r>
+          </a:p>
+        </p:txBody>
+      </p:sp>
+      <p:sp>
+        <p:nvSpPr>
+          <p:cNvPr id="50" name="TextBox 49"/>
+          <p:cNvSpPr txBox="1"/>
+          <p:nvPr/>
+        </p:nvSpPr>
+        <p:spPr>
+          <a:xfrm>
+            <a:off x="4206240" y="3538728"/>
+            <a:ext cx="1051560" cy="292608"/>
+          </a:xfrm>
+          <a:prstGeom prst="rect">
+            <a:avLst/>
+          </a:prstGeom>
+          <a:noFill/>
+        </p:spPr>
+        <p:txBody>
+          <a:bodyPr wrap="square">
+            <a:spAutoFit/>
+          </a:bodyPr>
+          <a:lstStyle/>
+          <a:p>
+            <a:pPr algn="l"/>
+            <a:r>
+              <a:rPr sz="1000" b="0" i="0">
                 <a:solidFill>
                   <a:srgbClr val="333344"/>
                 </a:solidFill>
                 <a:latin typeface="Calibri"/>
               </a:rPr>
-              <a:t>-12,76</a:t>
-            </a:r>
-          </a:p>
-        </p:txBody>
-      </p:sp>
-      <p:sp>
-        <p:nvSpPr>
-          <p:cNvPr id="50" name="TextBox 49"/>
-          <p:cNvSpPr txBox="1"/>
-          <p:nvPr/>
-        </p:nvSpPr>
-        <p:spPr>
-          <a:xfrm>
-            <a:off x="4983480" y="4242816"/>
-            <a:ext cx="1097280" cy="347472"/>
+              <a:t>—</a:t>
+            </a:r>
+          </a:p>
+        </p:txBody>
+      </p:sp>
+      <p:sp>
+        <p:nvSpPr>
+          <p:cNvPr id="51" name="TextBox 50"/>
+          <p:cNvSpPr txBox="1"/>
+          <p:nvPr/>
+        </p:nvSpPr>
+        <p:spPr>
+          <a:xfrm>
+            <a:off x="5212080" y="3538728"/>
+            <a:ext cx="1051560" cy="292608"/>
           </a:xfrm>
           <a:prstGeom prst="rect">
             <a:avLst/>
@@ -18907,27 +18942,27 @@
           <a:p>
             <a:pPr algn="l"/>
             <a:r>
-              <a:rPr sz="1200" b="0" i="0">
+              <a:rPr sz="1000" b="0" i="0">
                 <a:solidFill>
                   <a:srgbClr val="333344"/>
                 </a:solidFill>
                 <a:latin typeface="Calibri"/>
               </a:rPr>
-              <a:t>-86,28</a:t>
-            </a:r>
-          </a:p>
-        </p:txBody>
-      </p:sp>
-      <p:sp>
-        <p:nvSpPr>
-          <p:cNvPr id="51" name="TextBox 50"/>
-          <p:cNvSpPr txBox="1"/>
-          <p:nvPr/>
-        </p:nvSpPr>
-        <p:spPr>
-          <a:xfrm>
-            <a:off x="6126480" y="4242816"/>
-            <a:ext cx="1097280" cy="347472"/>
+              <a:t>—</a:t>
+            </a:r>
+          </a:p>
+        </p:txBody>
+      </p:sp>
+      <p:sp>
+        <p:nvSpPr>
+          <p:cNvPr id="52" name="TextBox 51"/>
+          <p:cNvSpPr txBox="1"/>
+          <p:nvPr/>
+        </p:nvSpPr>
+        <p:spPr>
+          <a:xfrm>
+            <a:off x="6263640" y="3538728"/>
+            <a:ext cx="1051560" cy="292608"/>
           </a:xfrm>
           <a:prstGeom prst="rect">
             <a:avLst/>
@@ -18942,27 +18977,27 @@
           <a:p>
             <a:pPr algn="l"/>
             <a:r>
-              <a:rPr sz="1200" b="0" i="0">
+              <a:rPr sz="1000" b="0" i="0">
                 <a:solidFill>
                   <a:srgbClr val="333344"/>
                 </a:solidFill>
                 <a:latin typeface="Calibri"/>
               </a:rPr>
-              <a:t>1,453 ± 1,003</a:t>
-            </a:r>
-          </a:p>
-        </p:txBody>
-      </p:sp>
-      <p:sp>
-        <p:nvSpPr>
-          <p:cNvPr id="52" name="TextBox 51"/>
-          <p:cNvSpPr txBox="1"/>
-          <p:nvPr/>
-        </p:nvSpPr>
-        <p:spPr>
-          <a:xfrm>
-            <a:off x="7360920" y="4242816"/>
-            <a:ext cx="1097280" cy="347472"/>
+              <a:t>0,294 ± 0,065</a:t>
+            </a:r>
+          </a:p>
+        </p:txBody>
+      </p:sp>
+      <p:sp>
+        <p:nvSpPr>
+          <p:cNvPr id="53" name="TextBox 52"/>
+          <p:cNvSpPr txBox="1"/>
+          <p:nvPr/>
+        </p:nvSpPr>
+        <p:spPr>
+          <a:xfrm>
+            <a:off x="7818120" y="3538728"/>
+            <a:ext cx="1051560" cy="292608"/>
           </a:xfrm>
           <a:prstGeom prst="rect">
             <a:avLst/>
@@ -18977,48 +19012,13 @@
           <a:p>
             <a:pPr algn="l"/>
             <a:r>
-              <a:rPr sz="1200" b="0" i="0">
+              <a:rPr sz="1000" b="0" i="0">
                 <a:solidFill>
                   <a:srgbClr val="333344"/>
                 </a:solidFill>
                 <a:latin typeface="Calibri"/>
               </a:rPr>
-              <a:t>1,952</a:t>
-            </a:r>
-          </a:p>
-        </p:txBody>
-      </p:sp>
-      <p:sp>
-        <p:nvSpPr>
-          <p:cNvPr id="53" name="TextBox 52"/>
-          <p:cNvSpPr txBox="1"/>
-          <p:nvPr/>
-        </p:nvSpPr>
-        <p:spPr>
-          <a:xfrm>
-            <a:off x="8503920" y="4242816"/>
-            <a:ext cx="1097280" cy="347472"/>
-          </a:xfrm>
-          <a:prstGeom prst="rect">
-            <a:avLst/>
-          </a:prstGeom>
-          <a:noFill/>
-        </p:spPr>
-        <p:txBody>
-          <a:bodyPr wrap="square">
-            <a:spAutoFit/>
-          </a:bodyPr>
-          <a:lstStyle/>
-          <a:p>
-            <a:pPr algn="l"/>
-            <a:r>
-              <a:rPr sz="1200" b="0" i="0">
-                <a:solidFill>
-                  <a:srgbClr val="333344"/>
-                </a:solidFill>
-                <a:latin typeface="Calibri"/>
-              </a:rPr>
-              <a:t>160,5</a:t>
+              <a:t>1,780</a:t>
             </a:r>
           </a:p>
         </p:txBody>
@@ -19031,14 +19031,14 @@
         </p:nvSpPr>
         <p:spPr>
           <a:xfrm>
-            <a:off x="9464040" y="4197096"/>
-            <a:ext cx="2331720" cy="438912"/>
-          </a:xfrm>
-          <a:prstGeom prst="rect">
-            <a:avLst/>
-          </a:prstGeom>
-          <a:solidFill>
-            <a:srgbClr val="FF7F11"/>
+            <a:off x="8915400" y="3502152"/>
+            <a:ext cx="2926080" cy="384048"/>
+          </a:xfrm>
+          <a:prstGeom prst="rect">
+            <a:avLst/>
+          </a:prstGeom>
+          <a:solidFill>
+            <a:srgbClr val="06D6A0"/>
           </a:solidFill>
           <a:ln>
             <a:noFill/>
@@ -19074,29 +19074,29 @@
         </p:nvSpPr>
         <p:spPr>
           <a:xfrm>
-            <a:off x="9464040" y="4197096"/>
-            <a:ext cx="2331720" cy="438912"/>
-          </a:xfrm>
-          <a:prstGeom prst="rect">
-            <a:avLst/>
-          </a:prstGeom>
-          <a:noFill/>
-        </p:spPr>
-        <p:txBody>
-          <a:bodyPr wrap="square">
-            <a:spAutoFit/>
-          </a:bodyPr>
-          <a:lstStyle/>
-          <a:p>
-            <a:pPr algn="ctr"/>
-            <a:r>
-              <a:rPr sz="1300" b="1" i="0">
+            <a:off x="8915400" y="3502152"/>
+            <a:ext cx="2926080" cy="384048"/>
+          </a:xfrm>
+          <a:prstGeom prst="rect">
+            <a:avLst/>
+          </a:prstGeom>
+          <a:noFill/>
+        </p:spPr>
+        <p:txBody>
+          <a:bodyPr wrap="square">
+            <a:spAutoFit/>
+          </a:bodyPr>
+          <a:lstStyle/>
+          <a:p>
+            <a:pPr algn="ctr"/>
+            <a:r>
+              <a:rPr sz="1100" b="1" i="0">
                 <a:solidFill>
                   <a:srgbClr val="FFFFFF"/>
                 </a:solidFill>
                 <a:latin typeface="Calibri"/>
               </a:rPr>
-              <a:t>Instavel</a:t>
+              <a:t>ESTAVEL*</a:t>
             </a:r>
           </a:p>
         </p:txBody>
@@ -19109,14 +19109,14 @@
         </p:nvSpPr>
         <p:spPr>
           <a:xfrm>
-            <a:off x="274320" y="4864608"/>
-            <a:ext cx="11612880" cy="777240"/>
-          </a:xfrm>
-          <a:prstGeom prst="rect">
-            <a:avLst/>
-          </a:prstGeom>
-          <a:solidFill>
-            <a:srgbClr val="F8D7DA"/>
+            <a:off x="274320" y="4023360"/>
+            <a:ext cx="11612880" cy="566928"/>
+          </a:xfrm>
+          <a:prstGeom prst="rect">
+            <a:avLst/>
+          </a:prstGeom>
+          <a:solidFill>
+            <a:srgbClr val="FFF3CD"/>
           </a:solidFill>
           <a:ln>
             <a:noFill/>
@@ -19152,14 +19152,14 @@
         </p:nvSpPr>
         <p:spPr>
           <a:xfrm>
-            <a:off x="274320" y="4864608"/>
-            <a:ext cx="73152" cy="777240"/>
-          </a:xfrm>
-          <a:prstGeom prst="rect">
-            <a:avLst/>
-          </a:prstGeom>
-          <a:solidFill>
-            <a:srgbClr val="FF7F11"/>
+            <a:off x="274320" y="4023360"/>
+            <a:ext cx="73152" cy="566928"/>
+          </a:xfrm>
+          <a:prstGeom prst="rect">
+            <a:avLst/>
+          </a:prstGeom>
+          <a:solidFill>
+            <a:srgbClr val="FFD166"/>
           </a:solidFill>
           <a:ln>
             <a:noFill/>
@@ -19195,8 +19195,8 @@
         </p:nvSpPr>
         <p:spPr>
           <a:xfrm>
-            <a:off x="411480" y="5065776"/>
-            <a:ext cx="3383280" cy="347472"/>
+            <a:off x="411480" y="4151376"/>
+            <a:ext cx="3246120" cy="292608"/>
           </a:xfrm>
           <a:prstGeom prst="rect">
             <a:avLst/>
@@ -19211,13 +19211,13 @@
           <a:p>
             <a:pPr algn="l"/>
             <a:r>
-              <a:rPr sz="1200" b="1" i="0">
+              <a:rPr sz="1000" b="1" i="0">
                 <a:solidFill>
                   <a:srgbClr val="0D2B55"/>
                 </a:solidFill>
                 <a:latin typeface="Calibri"/>
               </a:rPr>
-              <a:t>SLARKRAEENAKRFLERVKK</a:t>
+              <a:t>RLRAIWLEAEKLLEERRKKK</a:t>
             </a:r>
           </a:p>
         </p:txBody>
@@ -19230,8 +19230,8 @@
         </p:nvSpPr>
         <p:spPr>
           <a:xfrm>
-            <a:off x="3840480" y="5065776"/>
-            <a:ext cx="1097280" cy="347472"/>
+            <a:off x="3657600" y="4151376"/>
+            <a:ext cx="502920" cy="292608"/>
           </a:xfrm>
           <a:prstGeom prst="rect">
             <a:avLst/>
@@ -19246,27 +19246,62 @@
           <a:p>
             <a:pPr algn="l"/>
             <a:r>
-              <a:rPr sz="1200" b="0" i="0">
+              <a:rPr sz="900" b="1" i="0">
+                <a:solidFill>
+                  <a:srgbClr val="06D6A0"/>
+                </a:solidFill>
+                <a:latin typeface="Calibri"/>
+              </a:rPr>
+              <a:t>F4</a:t>
+            </a:r>
+          </a:p>
+        </p:txBody>
+      </p:sp>
+      <p:sp>
+        <p:nvSpPr>
+          <p:cNvPr id="60" name="TextBox 59"/>
+          <p:cNvSpPr txBox="1"/>
+          <p:nvPr/>
+        </p:nvSpPr>
+        <p:spPr>
+          <a:xfrm>
+            <a:off x="4206240" y="4151376"/>
+            <a:ext cx="1051560" cy="292608"/>
+          </a:xfrm>
+          <a:prstGeom prst="rect">
+            <a:avLst/>
+          </a:prstGeom>
+          <a:noFill/>
+        </p:spPr>
+        <p:txBody>
+          <a:bodyPr wrap="square">
+            <a:spAutoFit/>
+          </a:bodyPr>
+          <a:lstStyle/>
+          <a:p>
+            <a:pPr algn="l"/>
+            <a:r>
+              <a:rPr sz="1000" b="0" i="0">
                 <a:solidFill>
                   <a:srgbClr val="333344"/>
                 </a:solidFill>
                 <a:latin typeface="Calibri"/>
               </a:rPr>
-              <a:t>-12,71</a:t>
-            </a:r>
-          </a:p>
-        </p:txBody>
-      </p:sp>
-      <p:sp>
-        <p:nvSpPr>
-          <p:cNvPr id="60" name="TextBox 59"/>
-          <p:cNvSpPr txBox="1"/>
-          <p:nvPr/>
-        </p:nvSpPr>
-        <p:spPr>
-          <a:xfrm>
-            <a:off x="4983480" y="5065776"/>
-            <a:ext cx="1097280" cy="347472"/>
+              <a:t>—</a:t>
+            </a:r>
+          </a:p>
+        </p:txBody>
+      </p:sp>
+      <p:sp>
+        <p:nvSpPr>
+          <p:cNvPr id="61" name="TextBox 60"/>
+          <p:cNvSpPr txBox="1"/>
+          <p:nvPr/>
+        </p:nvSpPr>
+        <p:spPr>
+          <a:xfrm>
+            <a:off x="5212080" y="4151376"/>
+            <a:ext cx="1051560" cy="292608"/>
           </a:xfrm>
           <a:prstGeom prst="rect">
             <a:avLst/>
@@ -19281,27 +19316,27 @@
           <a:p>
             <a:pPr algn="l"/>
             <a:r>
-              <a:rPr sz="1200" b="0" i="0">
+              <a:rPr sz="1000" b="0" i="0">
                 <a:solidFill>
                   <a:srgbClr val="333344"/>
                 </a:solidFill>
                 <a:latin typeface="Calibri"/>
               </a:rPr>
-              <a:t>-61,41</a:t>
-            </a:r>
-          </a:p>
-        </p:txBody>
-      </p:sp>
-      <p:sp>
-        <p:nvSpPr>
-          <p:cNvPr id="61" name="TextBox 60"/>
-          <p:cNvSpPr txBox="1"/>
-          <p:nvPr/>
-        </p:nvSpPr>
-        <p:spPr>
-          <a:xfrm>
-            <a:off x="6126480" y="5065776"/>
-            <a:ext cx="1097280" cy="347472"/>
+              <a:t>—</a:t>
+            </a:r>
+          </a:p>
+        </p:txBody>
+      </p:sp>
+      <p:sp>
+        <p:nvSpPr>
+          <p:cNvPr id="62" name="TextBox 61"/>
+          <p:cNvSpPr txBox="1"/>
+          <p:nvPr/>
+        </p:nvSpPr>
+        <p:spPr>
+          <a:xfrm>
+            <a:off x="6263640" y="4151376"/>
+            <a:ext cx="1051560" cy="292608"/>
           </a:xfrm>
           <a:prstGeom prst="rect">
             <a:avLst/>
@@ -19316,27 +19351,27 @@
           <a:p>
             <a:pPr algn="l"/>
             <a:r>
-              <a:rPr sz="1200" b="0" i="0">
+              <a:rPr sz="1000" b="0" i="0">
                 <a:solidFill>
                   <a:srgbClr val="333344"/>
                 </a:solidFill>
                 <a:latin typeface="Calibri"/>
               </a:rPr>
-              <a:t>1,700 ± 1,033</a:t>
-            </a:r>
-          </a:p>
-        </p:txBody>
-      </p:sp>
-      <p:sp>
-        <p:nvSpPr>
-          <p:cNvPr id="62" name="TextBox 61"/>
-          <p:cNvSpPr txBox="1"/>
-          <p:nvPr/>
-        </p:nvSpPr>
-        <p:spPr>
-          <a:xfrm>
-            <a:off x="7360920" y="5065776"/>
-            <a:ext cx="1097280" cy="347472"/>
+              <a:t>0,725 ± 0,870</a:t>
+            </a:r>
+          </a:p>
+        </p:txBody>
+      </p:sp>
+      <p:sp>
+        <p:nvSpPr>
+          <p:cNvPr id="63" name="TextBox 62"/>
+          <p:cNvSpPr txBox="1"/>
+          <p:nvPr/>
+        </p:nvSpPr>
+        <p:spPr>
+          <a:xfrm>
+            <a:off x="7818120" y="4151376"/>
+            <a:ext cx="1051560" cy="292608"/>
           </a:xfrm>
           <a:prstGeom prst="rect">
             <a:avLst/>
@@ -19351,48 +19386,13 @@
           <a:p>
             <a:pPr algn="l"/>
             <a:r>
-              <a:rPr sz="1200" b="0" i="0">
+              <a:rPr sz="1000" b="0" i="0">
                 <a:solidFill>
                   <a:srgbClr val="333344"/>
                 </a:solidFill>
                 <a:latin typeface="Calibri"/>
               </a:rPr>
-              <a:t>1,910</a:t>
-            </a:r>
-          </a:p>
-        </p:txBody>
-      </p:sp>
-      <p:sp>
-        <p:nvSpPr>
-          <p:cNvPr id="63" name="TextBox 62"/>
-          <p:cNvSpPr txBox="1"/>
-          <p:nvPr/>
-        </p:nvSpPr>
-        <p:spPr>
-          <a:xfrm>
-            <a:off x="8503920" y="5065776"/>
-            <a:ext cx="1097280" cy="347472"/>
-          </a:xfrm>
-          <a:prstGeom prst="rect">
-            <a:avLst/>
-          </a:prstGeom>
-          <a:noFill/>
-        </p:spPr>
-        <p:txBody>
-          <a:bodyPr wrap="square">
-            <a:spAutoFit/>
-          </a:bodyPr>
-          <a:lstStyle/>
-          <a:p>
-            <a:pPr algn="l"/>
-            <a:r>
-              <a:rPr sz="1200" b="0" i="0">
-                <a:solidFill>
-                  <a:srgbClr val="333344"/>
-                </a:solidFill>
-                <a:latin typeface="Calibri"/>
-              </a:rPr>
-              <a:t>170,8</a:t>
+              <a:t>1,815</a:t>
             </a:r>
           </a:p>
         </p:txBody>
@@ -19405,14 +19405,14 @@
         </p:nvSpPr>
         <p:spPr>
           <a:xfrm>
-            <a:off x="9464040" y="5020056"/>
-            <a:ext cx="2331720" cy="438912"/>
-          </a:xfrm>
-          <a:prstGeom prst="rect">
-            <a:avLst/>
-          </a:prstGeom>
-          <a:solidFill>
-            <a:srgbClr val="FF7F11"/>
+            <a:off x="8915400" y="4114800"/>
+            <a:ext cx="2926080" cy="384048"/>
+          </a:xfrm>
+          <a:prstGeom prst="rect">
+            <a:avLst/>
+          </a:prstGeom>
+          <a:solidFill>
+            <a:srgbClr val="FFD166"/>
           </a:solidFill>
           <a:ln>
             <a:noFill/>
@@ -19448,29 +19448,29 @@
         </p:nvSpPr>
         <p:spPr>
           <a:xfrm>
-            <a:off x="9464040" y="5020056"/>
-            <a:ext cx="2331720" cy="438912"/>
-          </a:xfrm>
-          <a:prstGeom prst="rect">
-            <a:avLst/>
-          </a:prstGeom>
-          <a:noFill/>
-        </p:spPr>
-        <p:txBody>
-          <a:bodyPr wrap="square">
-            <a:spAutoFit/>
-          </a:bodyPr>
-          <a:lstStyle/>
-          <a:p>
-            <a:pPr algn="ctr"/>
-            <a:r>
-              <a:rPr sz="1300" b="1" i="0">
+            <a:off x="8915400" y="4114800"/>
+            <a:ext cx="2926080" cy="384048"/>
+          </a:xfrm>
+          <a:prstGeom prst="rect">
+            <a:avLst/>
+          </a:prstGeom>
+          <a:noFill/>
+        </p:spPr>
+        <p:txBody>
+          <a:bodyPr wrap="square">
+            <a:spAutoFit/>
+          </a:bodyPr>
+          <a:lstStyle/>
+          <a:p>
+            <a:pPr algn="ctr"/>
+            <a:r>
+              <a:rPr sz="1100" b="1" i="0">
                 <a:solidFill>
                   <a:srgbClr val="FFFFFF"/>
                 </a:solidFill>
                 <a:latin typeface="Calibri"/>
               </a:rPr>
-              <a:t>Instavel</a:t>
+              <a:t>Marginal</a:t>
             </a:r>
           </a:p>
         </p:txBody>
@@ -19483,14 +19483,14 @@
         </p:nvSpPr>
         <p:spPr>
           <a:xfrm>
-            <a:off x="274320" y="5733288"/>
-            <a:ext cx="11612880" cy="960120"/>
-          </a:xfrm>
-          <a:prstGeom prst="rect">
-            <a:avLst/>
-          </a:prstGeom>
-          <a:solidFill>
-            <a:srgbClr val="0D2B55"/>
+            <a:off x="274320" y="4636008"/>
+            <a:ext cx="11612880" cy="566928"/>
+          </a:xfrm>
+          <a:prstGeom prst="rect">
+            <a:avLst/>
+          </a:prstGeom>
+          <a:solidFill>
+            <a:srgbClr val="FFF3CD"/>
           </a:solidFill>
           <a:ln>
             <a:noFill/>
@@ -19520,14 +19520,57 @@
       </p:sp>
       <p:sp>
         <p:nvSpPr>
-          <p:cNvPr id="67" name="TextBox 66"/>
-          <p:cNvSpPr txBox="1"/>
-          <p:nvPr/>
-        </p:nvSpPr>
-        <p:spPr>
-          <a:xfrm>
-            <a:off x="457200" y="5779008"/>
-            <a:ext cx="11247120" cy="347472"/>
+          <p:cNvPr id="67" name="Rectangle 66"/>
+          <p:cNvSpPr/>
+          <p:nvPr/>
+        </p:nvSpPr>
+        <p:spPr>
+          <a:xfrm>
+            <a:off x="274320" y="4636008"/>
+            <a:ext cx="73152" cy="566928"/>
+          </a:xfrm>
+          <a:prstGeom prst="rect">
+            <a:avLst/>
+          </a:prstGeom>
+          <a:solidFill>
+            <a:srgbClr val="FFD166"/>
+          </a:solidFill>
+          <a:ln>
+            <a:noFill/>
+          </a:ln>
+        </p:spPr>
+        <p:style>
+          <a:lnRef idx="1">
+            <a:schemeClr val="accent1"/>
+          </a:lnRef>
+          <a:fillRef idx="3">
+            <a:schemeClr val="accent1"/>
+          </a:fillRef>
+          <a:effectRef idx="2">
+            <a:schemeClr val="accent1"/>
+          </a:effectRef>
+          <a:fontRef idx="minor">
+            <a:schemeClr val="lt1"/>
+          </a:fontRef>
+        </p:style>
+        <p:txBody>
+          <a:bodyPr rtlCol="0" anchor="ctr"/>
+          <a:lstStyle/>
+          <a:p>
+            <a:pPr algn="ctr"/>
+          </a:p>
+        </p:txBody>
+      </p:sp>
+      <p:sp>
+        <p:nvSpPr>
+          <p:cNvPr id="68" name="TextBox 67"/>
+          <p:cNvSpPr txBox="1"/>
+          <p:nvPr/>
+        </p:nvSpPr>
+        <p:spPr>
+          <a:xfrm>
+            <a:off x="411480" y="4764024"/>
+            <a:ext cx="3246120" cy="292608"/>
           </a:xfrm>
           <a:prstGeom prst="rect">
             <a:avLst/>
@@ -19542,27 +19585,732 @@
           <a:p>
             <a:pPr algn="l"/>
             <a:r>
-              <a:rPr sz="1300" b="1" i="0">
+              <a:rPr sz="1000" b="1" i="0">
+                <a:solidFill>
+                  <a:srgbClr val="0D2B55"/>
+                </a:solidFill>
+                <a:latin typeface="Calibri"/>
+              </a:rPr>
+              <a:t>SARESIKKAYKTFLERYKKL</a:t>
+            </a:r>
+          </a:p>
+        </p:txBody>
+      </p:sp>
+      <p:sp>
+        <p:nvSpPr>
+          <p:cNvPr id="69" name="TextBox 68"/>
+          <p:cNvSpPr txBox="1"/>
+          <p:nvPr/>
+        </p:nvSpPr>
+        <p:spPr>
+          <a:xfrm>
+            <a:off x="3657600" y="4764024"/>
+            <a:ext cx="502920" cy="292608"/>
+          </a:xfrm>
+          <a:prstGeom prst="rect">
+            <a:avLst/>
+          </a:prstGeom>
+          <a:noFill/>
+        </p:spPr>
+        <p:txBody>
+          <a:bodyPr wrap="square">
+            <a:spAutoFit/>
+          </a:bodyPr>
+          <a:lstStyle/>
+          <a:p>
+            <a:pPr algn="l"/>
+            <a:r>
+              <a:rPr sz="900" b="1" i="0">
+                <a:solidFill>
+                  <a:srgbClr val="06D6A0"/>
+                </a:solidFill>
+                <a:latin typeface="Calibri"/>
+              </a:rPr>
+              <a:t>F4</a:t>
+            </a:r>
+          </a:p>
+        </p:txBody>
+      </p:sp>
+      <p:sp>
+        <p:nvSpPr>
+          <p:cNvPr id="70" name="TextBox 69"/>
+          <p:cNvSpPr txBox="1"/>
+          <p:nvPr/>
+        </p:nvSpPr>
+        <p:spPr>
+          <a:xfrm>
+            <a:off x="4206240" y="4764024"/>
+            <a:ext cx="1051560" cy="292608"/>
+          </a:xfrm>
+          <a:prstGeom prst="rect">
+            <a:avLst/>
+          </a:prstGeom>
+          <a:noFill/>
+        </p:spPr>
+        <p:txBody>
+          <a:bodyPr wrap="square">
+            <a:spAutoFit/>
+          </a:bodyPr>
+          <a:lstStyle/>
+          <a:p>
+            <a:pPr algn="l"/>
+            <a:r>
+              <a:rPr sz="1000" b="0" i="0">
+                <a:solidFill>
+                  <a:srgbClr val="333344"/>
+                </a:solidFill>
+                <a:latin typeface="Calibri"/>
+              </a:rPr>
+              <a:t>-14,58</a:t>
+            </a:r>
+          </a:p>
+        </p:txBody>
+      </p:sp>
+      <p:sp>
+        <p:nvSpPr>
+          <p:cNvPr id="71" name="TextBox 70"/>
+          <p:cNvSpPr txBox="1"/>
+          <p:nvPr/>
+        </p:nvSpPr>
+        <p:spPr>
+          <a:xfrm>
+            <a:off x="5212080" y="4764024"/>
+            <a:ext cx="1051560" cy="292608"/>
+          </a:xfrm>
+          <a:prstGeom prst="rect">
+            <a:avLst/>
+          </a:prstGeom>
+          <a:noFill/>
+        </p:spPr>
+        <p:txBody>
+          <a:bodyPr wrap="square">
+            <a:spAutoFit/>
+          </a:bodyPr>
+          <a:lstStyle/>
+          <a:p>
+            <a:pPr algn="l"/>
+            <a:r>
+              <a:rPr sz="1000" b="0" i="0">
+                <a:solidFill>
+                  <a:srgbClr val="333344"/>
+                </a:solidFill>
+                <a:latin typeface="Calibri"/>
+              </a:rPr>
+              <a:t>—</a:t>
+            </a:r>
+          </a:p>
+        </p:txBody>
+      </p:sp>
+      <p:sp>
+        <p:nvSpPr>
+          <p:cNvPr id="72" name="TextBox 71"/>
+          <p:cNvSpPr txBox="1"/>
+          <p:nvPr/>
+        </p:nvSpPr>
+        <p:spPr>
+          <a:xfrm>
+            <a:off x="6263640" y="4764024"/>
+            <a:ext cx="1051560" cy="292608"/>
+          </a:xfrm>
+          <a:prstGeom prst="rect">
+            <a:avLst/>
+          </a:prstGeom>
+          <a:noFill/>
+        </p:spPr>
+        <p:txBody>
+          <a:bodyPr wrap="square">
+            <a:spAutoFit/>
+          </a:bodyPr>
+          <a:lstStyle/>
+          <a:p>
+            <a:pPr algn="l"/>
+            <a:r>
+              <a:rPr sz="1000" b="0" i="0">
+                <a:solidFill>
+                  <a:srgbClr val="333344"/>
+                </a:solidFill>
+                <a:latin typeface="Calibri"/>
+              </a:rPr>
+              <a:t>0,871 ± 0,844</a:t>
+            </a:r>
+          </a:p>
+        </p:txBody>
+      </p:sp>
+      <p:sp>
+        <p:nvSpPr>
+          <p:cNvPr id="73" name="TextBox 72"/>
+          <p:cNvSpPr txBox="1"/>
+          <p:nvPr/>
+        </p:nvSpPr>
+        <p:spPr>
+          <a:xfrm>
+            <a:off x="7818120" y="4764024"/>
+            <a:ext cx="1051560" cy="292608"/>
+          </a:xfrm>
+          <a:prstGeom prst="rect">
+            <a:avLst/>
+          </a:prstGeom>
+          <a:noFill/>
+        </p:spPr>
+        <p:txBody>
+          <a:bodyPr wrap="square">
+            <a:spAutoFit/>
+          </a:bodyPr>
+          <a:lstStyle/>
+          <a:p>
+            <a:pPr algn="l"/>
+            <a:r>
+              <a:rPr sz="1000" b="0" i="0">
+                <a:solidFill>
+                  <a:srgbClr val="333344"/>
+                </a:solidFill>
+                <a:latin typeface="Calibri"/>
+              </a:rPr>
+              <a:t>1,864</a:t>
+            </a:r>
+          </a:p>
+        </p:txBody>
+      </p:sp>
+      <p:sp>
+        <p:nvSpPr>
+          <p:cNvPr id="74" name="Rectangle 73"/>
+          <p:cNvSpPr/>
+          <p:nvPr/>
+        </p:nvSpPr>
+        <p:spPr>
+          <a:xfrm>
+            <a:off x="8915400" y="4727448"/>
+            <a:ext cx="2926080" cy="384048"/>
+          </a:xfrm>
+          <a:prstGeom prst="rect">
+            <a:avLst/>
+          </a:prstGeom>
+          <a:solidFill>
+            <a:srgbClr val="FFD166"/>
+          </a:solidFill>
+          <a:ln>
+            <a:noFill/>
+          </a:ln>
+        </p:spPr>
+        <p:style>
+          <a:lnRef idx="1">
+            <a:schemeClr val="accent1"/>
+          </a:lnRef>
+          <a:fillRef idx="3">
+            <a:schemeClr val="accent1"/>
+          </a:fillRef>
+          <a:effectRef idx="2">
+            <a:schemeClr val="accent1"/>
+          </a:effectRef>
+          <a:fontRef idx="minor">
+            <a:schemeClr val="lt1"/>
+          </a:fontRef>
+        </p:style>
+        <p:txBody>
+          <a:bodyPr rtlCol="0" anchor="ctr"/>
+          <a:lstStyle/>
+          <a:p>
+            <a:pPr algn="ctr"/>
+          </a:p>
+        </p:txBody>
+      </p:sp>
+      <p:sp>
+        <p:nvSpPr>
+          <p:cNvPr id="75" name="TextBox 74"/>
+          <p:cNvSpPr txBox="1"/>
+          <p:nvPr/>
+        </p:nvSpPr>
+        <p:spPr>
+          <a:xfrm>
+            <a:off x="8915400" y="4727448"/>
+            <a:ext cx="2926080" cy="384048"/>
+          </a:xfrm>
+          <a:prstGeom prst="rect">
+            <a:avLst/>
+          </a:prstGeom>
+          <a:noFill/>
+        </p:spPr>
+        <p:txBody>
+          <a:bodyPr wrap="square">
+            <a:spAutoFit/>
+          </a:bodyPr>
+          <a:lstStyle/>
+          <a:p>
+            <a:pPr algn="ctr"/>
+            <a:r>
+              <a:rPr sz="1100" b="1" i="0">
+                <a:solidFill>
+                  <a:srgbClr val="FFFFFF"/>
+                </a:solidFill>
+                <a:latin typeface="Calibri"/>
+              </a:rPr>
+              <a:t>Marginal</a:t>
+            </a:r>
+          </a:p>
+        </p:txBody>
+      </p:sp>
+      <p:sp>
+        <p:nvSpPr>
+          <p:cNvPr id="76" name="Rectangle 75"/>
+          <p:cNvSpPr/>
+          <p:nvPr/>
+        </p:nvSpPr>
+        <p:spPr>
+          <a:xfrm>
+            <a:off x="274320" y="5248656"/>
+            <a:ext cx="11612880" cy="566928"/>
+          </a:xfrm>
+          <a:prstGeom prst="rect">
+            <a:avLst/>
+          </a:prstGeom>
+          <a:solidFill>
+            <a:srgbClr val="F8D7DA"/>
+          </a:solidFill>
+          <a:ln>
+            <a:noFill/>
+          </a:ln>
+        </p:spPr>
+        <p:style>
+          <a:lnRef idx="1">
+            <a:schemeClr val="accent1"/>
+          </a:lnRef>
+          <a:fillRef idx="3">
+            <a:schemeClr val="accent1"/>
+          </a:fillRef>
+          <a:effectRef idx="2">
+            <a:schemeClr val="accent1"/>
+          </a:effectRef>
+          <a:fontRef idx="minor">
+            <a:schemeClr val="lt1"/>
+          </a:fontRef>
+        </p:style>
+        <p:txBody>
+          <a:bodyPr rtlCol="0" anchor="ctr"/>
+          <a:lstStyle/>
+          <a:p>
+            <a:pPr algn="ctr"/>
+          </a:p>
+        </p:txBody>
+      </p:sp>
+      <p:sp>
+        <p:nvSpPr>
+          <p:cNvPr id="77" name="Rectangle 76"/>
+          <p:cNvSpPr/>
+          <p:nvPr/>
+        </p:nvSpPr>
+        <p:spPr>
+          <a:xfrm>
+            <a:off x="274320" y="5248656"/>
+            <a:ext cx="73152" cy="566928"/>
+          </a:xfrm>
+          <a:prstGeom prst="rect">
+            <a:avLst/>
+          </a:prstGeom>
+          <a:solidFill>
+            <a:srgbClr val="FF7F11"/>
+          </a:solidFill>
+          <a:ln>
+            <a:noFill/>
+          </a:ln>
+        </p:spPr>
+        <p:style>
+          <a:lnRef idx="1">
+            <a:schemeClr val="accent1"/>
+          </a:lnRef>
+          <a:fillRef idx="3">
+            <a:schemeClr val="accent1"/>
+          </a:fillRef>
+          <a:effectRef idx="2">
+            <a:schemeClr val="accent1"/>
+          </a:effectRef>
+          <a:fontRef idx="minor">
+            <a:schemeClr val="lt1"/>
+          </a:fontRef>
+        </p:style>
+        <p:txBody>
+          <a:bodyPr rtlCol="0" anchor="ctr"/>
+          <a:lstStyle/>
+          <a:p>
+            <a:pPr algn="ctr"/>
+          </a:p>
+        </p:txBody>
+      </p:sp>
+      <p:sp>
+        <p:nvSpPr>
+          <p:cNvPr id="78" name="TextBox 77"/>
+          <p:cNvSpPr txBox="1"/>
+          <p:nvPr/>
+        </p:nvSpPr>
+        <p:spPr>
+          <a:xfrm>
+            <a:off x="411480" y="5376672"/>
+            <a:ext cx="3246120" cy="292608"/>
+          </a:xfrm>
+          <a:prstGeom prst="rect">
+            <a:avLst/>
+          </a:prstGeom>
+          <a:noFill/>
+        </p:spPr>
+        <p:txBody>
+          <a:bodyPr wrap="square">
+            <a:spAutoFit/>
+          </a:bodyPr>
+          <a:lstStyle/>
+          <a:p>
+            <a:pPr algn="l"/>
+            <a:r>
+              <a:rPr sz="1000" b="1" i="0">
+                <a:solidFill>
+                  <a:srgbClr val="0D2B55"/>
+                </a:solidFill>
+                <a:latin typeface="Calibri"/>
+              </a:rPr>
+              <a:t>KRLRENWLEAEKLLEERRKKK</a:t>
+            </a:r>
+          </a:p>
+        </p:txBody>
+      </p:sp>
+      <p:sp>
+        <p:nvSpPr>
+          <p:cNvPr id="79" name="TextBox 78"/>
+          <p:cNvSpPr txBox="1"/>
+          <p:nvPr/>
+        </p:nvSpPr>
+        <p:spPr>
+          <a:xfrm>
+            <a:off x="3657600" y="5376672"/>
+            <a:ext cx="502920" cy="292608"/>
+          </a:xfrm>
+          <a:prstGeom prst="rect">
+            <a:avLst/>
+          </a:prstGeom>
+          <a:noFill/>
+        </p:spPr>
+        <p:txBody>
+          <a:bodyPr wrap="square">
+            <a:spAutoFit/>
+          </a:bodyPr>
+          <a:lstStyle/>
+          <a:p>
+            <a:pPr algn="l"/>
+            <a:r>
+              <a:rPr sz="900" b="1" i="0">
+                <a:solidFill>
+                  <a:srgbClr val="06D6A0"/>
+                </a:solidFill>
+                <a:latin typeface="Calibri"/>
+              </a:rPr>
+              <a:t>F4</a:t>
+            </a:r>
+          </a:p>
+        </p:txBody>
+      </p:sp>
+      <p:sp>
+        <p:nvSpPr>
+          <p:cNvPr id="80" name="TextBox 79"/>
+          <p:cNvSpPr txBox="1"/>
+          <p:nvPr/>
+        </p:nvSpPr>
+        <p:spPr>
+          <a:xfrm>
+            <a:off x="4206240" y="5376672"/>
+            <a:ext cx="1051560" cy="292608"/>
+          </a:xfrm>
+          <a:prstGeom prst="rect">
+            <a:avLst/>
+          </a:prstGeom>
+          <a:noFill/>
+        </p:spPr>
+        <p:txBody>
+          <a:bodyPr wrap="square">
+            <a:spAutoFit/>
+          </a:bodyPr>
+          <a:lstStyle/>
+          <a:p>
+            <a:pPr algn="l"/>
+            <a:r>
+              <a:rPr sz="1000" b="0" i="0">
+                <a:solidFill>
+                  <a:srgbClr val="333344"/>
+                </a:solidFill>
+                <a:latin typeface="Calibri"/>
+              </a:rPr>
+              <a:t>—</a:t>
+            </a:r>
+          </a:p>
+        </p:txBody>
+      </p:sp>
+      <p:sp>
+        <p:nvSpPr>
+          <p:cNvPr id="81" name="TextBox 80"/>
+          <p:cNvSpPr txBox="1"/>
+          <p:nvPr/>
+        </p:nvSpPr>
+        <p:spPr>
+          <a:xfrm>
+            <a:off x="5212080" y="5376672"/>
+            <a:ext cx="1051560" cy="292608"/>
+          </a:xfrm>
+          <a:prstGeom prst="rect">
+            <a:avLst/>
+          </a:prstGeom>
+          <a:noFill/>
+        </p:spPr>
+        <p:txBody>
+          <a:bodyPr wrap="square">
+            <a:spAutoFit/>
+          </a:bodyPr>
+          <a:lstStyle/>
+          <a:p>
+            <a:pPr algn="l"/>
+            <a:r>
+              <a:rPr sz="1000" b="0" i="0">
+                <a:solidFill>
+                  <a:srgbClr val="333344"/>
+                </a:solidFill>
+                <a:latin typeface="Calibri"/>
+              </a:rPr>
+              <a:t>—</a:t>
+            </a:r>
+          </a:p>
+        </p:txBody>
+      </p:sp>
+      <p:sp>
+        <p:nvSpPr>
+          <p:cNvPr id="82" name="TextBox 81"/>
+          <p:cNvSpPr txBox="1"/>
+          <p:nvPr/>
+        </p:nvSpPr>
+        <p:spPr>
+          <a:xfrm>
+            <a:off x="6263640" y="5376672"/>
+            <a:ext cx="1051560" cy="292608"/>
+          </a:xfrm>
+          <a:prstGeom prst="rect">
+            <a:avLst/>
+          </a:prstGeom>
+          <a:noFill/>
+        </p:spPr>
+        <p:txBody>
+          <a:bodyPr wrap="square">
+            <a:spAutoFit/>
+          </a:bodyPr>
+          <a:lstStyle/>
+          <a:p>
+            <a:pPr algn="l"/>
+            <a:r>
+              <a:rPr sz="1000" b="0" i="0">
+                <a:solidFill>
+                  <a:srgbClr val="333344"/>
+                </a:solidFill>
+                <a:latin typeface="Calibri"/>
+              </a:rPr>
+              <a:t>1,074 ± 1,103</a:t>
+            </a:r>
+          </a:p>
+        </p:txBody>
+      </p:sp>
+      <p:sp>
+        <p:nvSpPr>
+          <p:cNvPr id="83" name="TextBox 82"/>
+          <p:cNvSpPr txBox="1"/>
+          <p:nvPr/>
+        </p:nvSpPr>
+        <p:spPr>
+          <a:xfrm>
+            <a:off x="7818120" y="5376672"/>
+            <a:ext cx="1051560" cy="292608"/>
+          </a:xfrm>
+          <a:prstGeom prst="rect">
+            <a:avLst/>
+          </a:prstGeom>
+          <a:noFill/>
+        </p:spPr>
+        <p:txBody>
+          <a:bodyPr wrap="square">
+            <a:spAutoFit/>
+          </a:bodyPr>
+          <a:lstStyle/>
+          <a:p>
+            <a:pPr algn="l"/>
+            <a:r>
+              <a:rPr sz="1000" b="0" i="0">
+                <a:solidFill>
+                  <a:srgbClr val="333344"/>
+                </a:solidFill>
+                <a:latin typeface="Calibri"/>
+              </a:rPr>
+              <a:t>1,869</a:t>
+            </a:r>
+          </a:p>
+        </p:txBody>
+      </p:sp>
+      <p:sp>
+        <p:nvSpPr>
+          <p:cNvPr id="84" name="Rectangle 83"/>
+          <p:cNvSpPr/>
+          <p:nvPr/>
+        </p:nvSpPr>
+        <p:spPr>
+          <a:xfrm>
+            <a:off x="8915400" y="5340096"/>
+            <a:ext cx="2926080" cy="384048"/>
+          </a:xfrm>
+          <a:prstGeom prst="rect">
+            <a:avLst/>
+          </a:prstGeom>
+          <a:solidFill>
+            <a:srgbClr val="FF7F11"/>
+          </a:solidFill>
+          <a:ln>
+            <a:noFill/>
+          </a:ln>
+        </p:spPr>
+        <p:style>
+          <a:lnRef idx="1">
+            <a:schemeClr val="accent1"/>
+          </a:lnRef>
+          <a:fillRef idx="3">
+            <a:schemeClr val="accent1"/>
+          </a:fillRef>
+          <a:effectRef idx="2">
+            <a:schemeClr val="accent1"/>
+          </a:effectRef>
+          <a:fontRef idx="minor">
+            <a:schemeClr val="lt1"/>
+          </a:fontRef>
+        </p:style>
+        <p:txBody>
+          <a:bodyPr rtlCol="0" anchor="ctr"/>
+          <a:lstStyle/>
+          <a:p>
+            <a:pPr algn="ctr"/>
+          </a:p>
+        </p:txBody>
+      </p:sp>
+      <p:sp>
+        <p:nvSpPr>
+          <p:cNvPr id="85" name="TextBox 84"/>
+          <p:cNvSpPr txBox="1"/>
+          <p:nvPr/>
+        </p:nvSpPr>
+        <p:spPr>
+          <a:xfrm>
+            <a:off x="8915400" y="5340096"/>
+            <a:ext cx="2926080" cy="384048"/>
+          </a:xfrm>
+          <a:prstGeom prst="rect">
+            <a:avLst/>
+          </a:prstGeom>
+          <a:noFill/>
+        </p:spPr>
+        <p:txBody>
+          <a:bodyPr wrap="square">
+            <a:spAutoFit/>
+          </a:bodyPr>
+          <a:lstStyle/>
+          <a:p>
+            <a:pPr algn="ctr"/>
+            <a:r>
+              <a:rPr sz="1100" b="1" i="0">
+                <a:solidFill>
+                  <a:srgbClr val="FFFFFF"/>
+                </a:solidFill>
+                <a:latin typeface="Calibri"/>
+              </a:rPr>
+              <a:t>Instavel</a:t>
+            </a:r>
+          </a:p>
+        </p:txBody>
+      </p:sp>
+      <p:sp>
+        <p:nvSpPr>
+          <p:cNvPr id="86" name="Rectangle 85"/>
+          <p:cNvSpPr/>
+          <p:nvPr/>
+        </p:nvSpPr>
+        <p:spPr>
+          <a:xfrm>
+            <a:off x="274320" y="5888736"/>
+            <a:ext cx="11612880" cy="804672"/>
+          </a:xfrm>
+          <a:prstGeom prst="rect">
+            <a:avLst/>
+          </a:prstGeom>
+          <a:solidFill>
+            <a:srgbClr val="0D2B55"/>
+          </a:solidFill>
+          <a:ln>
+            <a:noFill/>
+          </a:ln>
+        </p:spPr>
+        <p:style>
+          <a:lnRef idx="1">
+            <a:schemeClr val="accent1"/>
+          </a:lnRef>
+          <a:fillRef idx="3">
+            <a:schemeClr val="accent1"/>
+          </a:fillRef>
+          <a:effectRef idx="2">
+            <a:schemeClr val="accent1"/>
+          </a:effectRef>
+          <a:fontRef idx="minor">
+            <a:schemeClr val="lt1"/>
+          </a:fontRef>
+        </p:style>
+        <p:txBody>
+          <a:bodyPr rtlCol="0" anchor="ctr"/>
+          <a:lstStyle/>
+          <a:p>
+            <a:pPr algn="ctr"/>
+          </a:p>
+        </p:txBody>
+      </p:sp>
+      <p:sp>
+        <p:nvSpPr>
+          <p:cNvPr id="87" name="TextBox 86"/>
+          <p:cNvSpPr txBox="1"/>
+          <p:nvPr/>
+        </p:nvSpPr>
+        <p:spPr>
+          <a:xfrm>
+            <a:off x="457200" y="5925312"/>
+            <a:ext cx="11247120" cy="292608"/>
+          </a:xfrm>
+          <a:prstGeom prst="rect">
+            <a:avLst/>
+          </a:prstGeom>
+          <a:noFill/>
+        </p:spPr>
+        <p:txBody>
+          <a:bodyPr wrap="square">
+            <a:spAutoFit/>
+          </a:bodyPr>
+          <a:lstStyle/>
+          <a:p>
+            <a:pPr algn="l"/>
+            <a:r>
+              <a:rPr sz="1200" b="1" i="0">
                 <a:solidFill>
                   <a:srgbClr val="00B4D8"/>
                 </a:solidFill>
                 <a:latin typeface="Calibri"/>
               </a:rPr>
-              <a:t>RECLASSIFICACAO FINAL (Vina + I_sc Rosetta + RMSD MD)</a:t>
-            </a:r>
-          </a:p>
-        </p:txBody>
-      </p:sp>
-      <p:sp>
-        <p:nvSpPr>
-          <p:cNvPr id="68" name="TextBox 67"/>
-          <p:cNvSpPr txBox="1"/>
-          <p:nvPr/>
-        </p:nvSpPr>
-        <p:spPr>
-          <a:xfrm>
-            <a:off x="457200" y="6144768"/>
-            <a:ext cx="11247120" cy="502920"/>
+              <a:t>TOP-3 SINTESE (Fases 3+4) — todos RMSD &lt; 0,5 nm em 10 ns</a:t>
+            </a:r>
+          </a:p>
+        </p:txBody>
+      </p:sp>
+      <p:sp>
+        <p:nvSpPr>
+          <p:cNvPr id="88" name="TextBox 87"/>
+          <p:cNvSpPr txBox="1"/>
+          <p:nvPr/>
+        </p:nvSpPr>
+        <p:spPr>
+          <a:xfrm>
+            <a:off x="457200" y="6236208"/>
+            <a:ext cx="11247120" cy="420624"/>
           </a:xfrm>
           <a:prstGeom prst="rect">
             <a:avLst/>
@@ -19577,20 +20325,20 @@
           <a:p>
             <a:pPr algn="l"/>
             <a:r>
-              <a:rPr sz="1100" b="0" i="0">
+              <a:rPr sz="1000" b="0" i="0">
                 <a:solidFill>
                   <a:srgbClr val="F0F4F8"/>
                 </a:solidFill>
                 <a:latin typeface="Calibri"/>
               </a:rPr>
-              <a:t>#1 MKKQRENAKKVAEITLKKAK (RMSD 0,447 nm — mais estavel)    #2 GSRASARAYAARVRARRAAL (Vina -13,62 + RMSD 0,494 nm)    GARKSIREYQKRVLERLKKK descartado (melhor I_sc mas RMSD 1,45 nm = instavel em solvente)</a:t>
-            </a:r>
-          </a:p>
-        </p:txBody>
-      </p:sp>
-      <p:sp>
-        <p:nvSpPr>
-          <p:cNvPr id="69" name="TextBox 68"/>
+              <a:t>#1 MKKQRENAKKVAEITLKKAK (0,447 nm, F3)  |  #2 RLREELKKAEEWLEKRRKEE (0,294 nm, F4 — MAIS ESTAVEL DO PIPELINE)  |  #3 GSRASARAYAARVRARRAAL (0,494 nm, F3)  |  SARESIKKAYKTFLERYKKL: melhor Vina (-14,58) mas marginal em MD</a:t>
+            </a:r>
+          </a:p>
+        </p:txBody>
+      </p:sp>
+      <p:sp>
+        <p:nvSpPr>
+          <p:cNvPr id="89" name="TextBox 88"/>
           <p:cNvSpPr txBox="1"/>
           <p:nvPr/>
         </p:nvSpPr>
@@ -26977,7 +27725,7 @@
                 </a:solidFill>
                 <a:latin typeface="Calibri"/>
               </a:rPr>
-              <a:t>Fase 1-3 CONCLUIDA | 880 poses | ML treinado | 20/20 seletivos | 0/20 resistentes — 2026-06-27</a:t>
+              <a:t>Fases 1-4 CONCLUIDAS | 11 MD | 3 candidatos estaveis | RLREELKK mais estavel do pipeline — 2026-06-27</a:t>
             </a:r>
           </a:p>
         </p:txBody>
@@ -27090,7 +27838,7 @@
                 </a:solidFill>
                 <a:latin typeface="Calibri"/>
               </a:rPr>
-              <a:t>330 backbones RFdiffusion | 24.513 binders ProteinMPNN | 880 poses Vina | novo top-1: SARESIKKAYKTFLERYKKL (-14,58 kcal/mol, score=0,748)</a:t>
+              <a:t>330 backbones RFdiffusion | 24.513 binders ProteinMPNN | 880 poses Vina | top-1 Vina: SARESIKKAYKTFLERYKKL (-14,58 kcal/mol) | 219 variantes OptimizationAgent</a:t>
             </a:r>
           </a:p>
         </p:txBody>
@@ -27203,7 +27951,7 @@
                 </a:solidFill>
                 <a:latin typeface="Calibri"/>
               </a:rPr>
-              <a:t>MD 10 ns — 5/5 concluidos | MKKQRENAKKVAEITLKKAK (RMSD 0,447 nm) ESTAVEL #1 | GSRASARAYAARVRARRAAL (RMSD 0,494 nm) ESTAVEL #2 | 2 instáveis descartados</a:t>
+              <a:t>MD 11/11 concluidos (Fases 3+4) | TOP-3 SINTESE: #1 MKKQRENAKKVAEITLKKAK (0,447 nm) | #2 RLREELKKAEEWLEKRRKEE (0,294 nm ★MAIS ESTAVEL) | #3 GSRASARAYAARVRARRAAL (0,494 nm)</a:t>
             </a:r>
           </a:p>
         </p:txBody>
@@ -27316,7 +28064,7 @@
                 </a:solidFill>
                 <a:latin typeface="Calibri"/>
               </a:rPr>
-              <a:t>ML: Random Forest RMSE=0,514 kcal/mol | 24.513 predicoes geradas | 219 novos candidatos por OptimizationAgent (redesign iterativo)</a:t>
+              <a:t>Especificidade: 20/20 aprovados vs tripsina humana (1TRN) + Apis mellifera (SI &gt;= 2,0 kcal/mol) | ML RF RMSE=0,514 kcal/mol | 24.513 predicoes geradas</a:t>
             </a:r>
           </a:p>
         </p:txBody>
@@ -27429,7 +28177,7 @@
                 </a:solidFill>
                 <a:latin typeface="Calibri"/>
               </a:rPr>
-              <a:t>Especificidade: 20/20 aprovados vs tripsina humana (1TRN) + Apis mellifera (SI &gt;= 2,0 kcal/mol) | Resistencia proteolitica: 0/20 resistentes — sondas in vitro; modificacao quimica necessaria</a:t>
+              <a:t>Resistencia proteolitica: 0/20 resistentes (3-7 P1-internos K/R) — sondas in vitro. Especificidade preservada: seletividade nao e comprometida pelo perfil Arg/Lys</a:t>
             </a:r>
           </a:p>
         </p:txBody>
@@ -27542,7 +28290,7 @@
                 </a:solidFill>
                 <a:latin typeface="Calibri"/>
               </a:rPr>
-              <a:t>Trade-off intrínseco: Arg/Lys maximizam afinidade S1 (Asp205) mas sao substratos da propria tripsina. Solucao: Fase 4 peptideos 5-15 aa + Nle/Orn/D-aa nos P1-internos</a:t>
+              <a:t>MD obrigatorio como filtro: GARKSIREYQKRVLERLKKK (melhor I_sc -86,28) instavel em MD (1,45 nm). SARESIKKAYKTFLERYKKL (melhor Vina -14,58) marginal em MD (0,871 nm). Afinidade estatica != estabilidade dinamica</a:t>
             </a:r>
           </a:p>
         </p:txBody>
@@ -27655,7 +28403,7 @@
                 </a:solidFill>
                 <a:latin typeface="Calibri"/>
               </a:rPr>
-              <a:t>MD obrigatorio: GARKSIREYQKRVLERLKKK melhor I_sc Rosetta (-86,28) mas instavel em solvente (RMSD 1,45 nm). 3 metodos concordantes validam mecanismo competitivo Arg-Asp205</a:t>
+              <a:t>RLREELKKAEEWLEKRRKEE: surpresa positiva — 5o por heuristica OptimizationAgent mas mais estavel do pipeline (RMSD 0,294 nm, DP=0,065). Composicao Glu/Leu sugere mecanismo de ligacao distinto</a:t>
             </a:r>
           </a:p>
         </p:txBody>
@@ -27768,7 +28516,7 @@
                 </a:solidFill>
                 <a:latin typeface="Calibri"/>
               </a:rPr>
-              <a:t>Fase 4: RFdiffusion 5-15 aa (KR-interno=0) + MD SARESIKKAYKTFLERYKKL + variantes Nle/Orn | Alvo sintese: MKKQRENAKKVAEITLKKAK + GSRASARAYAARVRARRAAL -&gt; Fmoc-SPPS -&gt; IC50 (JCIM/CSBJ)</a:t>
+              <a:t>Proximo: RFdiffusion 5-15 aa (KR-interno=0) + estrategias Nle/Orn/D-aa para resistencia proteolitica | Sintese: MKKQRENA + RLREELKK + GSRASARA -&gt; Fmoc-SPPS -&gt; IC50 in vitro (JCIM/CSBJ)</a:t>
             </a:r>
           </a:p>
         </p:txBody>

</xml_diff>

<commit_message>
feat(pptx): insert 4 PNG figures in slides 12, 13, 14, 18
- Modified gerar_apresentacao_pptx.py to add insert_figures() function
- Removes placeholder rectangles from target slides
- Embeds 4 real PNG figures from outputs/figuras_artigo/:
  - Slide 12: fig4_fingerprint.png
  - Slide 13: fig1_replicas_md.png
  - Slide 14: fig2_ocupancia_s1.png
  - Slide 18: fig3_cross_species.png
- Images positioned at (6.8", 1.1") with width 2.7"
- All 4 images verified as embedded via python-pptx

Co-Authored-By: Claude Haiku 4.5 <noreply@anthropic.com>
</commit_message>
<xml_diff>
--- a/apresentacao_design_inibidores.pptx
+++ b/apresentacao_design_inibidores.pptx
@@ -3736,6 +3736,30 @@
           </a:p>
         </p:txBody>
       </p:sp>
+      <p:pic>
+        <p:nvPicPr>
+          <p:cNvPr id="5" name="Picture 4" descr="fig4_fingerprint.png"/>
+          <p:cNvPicPr>
+            <a:picLocks noChangeAspect="1"/>
+          </p:cNvPicPr>
+          <p:nvPr/>
+        </p:nvPicPr>
+        <p:blipFill>
+          <a:blip r:embed="rId2"/>
+          <a:stretch>
+            <a:fillRect/>
+          </a:stretch>
+        </p:blipFill>
+        <p:spPr>
+          <a:xfrm>
+            <a:off x="6217920" y="1005840"/>
+            <a:ext cx="2468880" cy="1357884"/>
+          </a:xfrm>
+          <a:prstGeom prst="rect">
+            <a:avLst/>
+          </a:prstGeom>
+        </p:spPr>
+      </p:pic>
     </p:spTree>
   </p:cSld>
   <p:clrMapOvr>
@@ -3937,6 +3961,30 @@
           </a:p>
         </p:txBody>
       </p:sp>
+      <p:pic>
+        <p:nvPicPr>
+          <p:cNvPr id="5" name="Picture 4" descr="fig1_replicas_md.png"/>
+          <p:cNvPicPr>
+            <a:picLocks noChangeAspect="1"/>
+          </p:cNvPicPr>
+          <p:nvPr/>
+        </p:nvPicPr>
+        <p:blipFill>
+          <a:blip r:embed="rId2"/>
+          <a:stretch>
+            <a:fillRect/>
+          </a:stretch>
+        </p:blipFill>
+        <p:spPr>
+          <a:xfrm>
+            <a:off x="6217920" y="1005840"/>
+            <a:ext cx="2468880" cy="1783080"/>
+          </a:xfrm>
+          <a:prstGeom prst="rect">
+            <a:avLst/>
+          </a:prstGeom>
+        </p:spPr>
+      </p:pic>
     </p:spTree>
   </p:cSld>
   <p:clrMapOvr>
@@ -4138,6 +4186,30 @@
           </a:p>
         </p:txBody>
       </p:sp>
+      <p:pic>
+        <p:nvPicPr>
+          <p:cNvPr id="5" name="Picture 4" descr="fig2_ocupancia_s1.png"/>
+          <p:cNvPicPr>
+            <a:picLocks noChangeAspect="1"/>
+          </p:cNvPicPr>
+          <p:nvPr/>
+        </p:nvPicPr>
+        <p:blipFill>
+          <a:blip r:embed="rId2"/>
+          <a:stretch>
+            <a:fillRect/>
+          </a:stretch>
+        </p:blipFill>
+        <p:spPr>
+          <a:xfrm>
+            <a:off x="6217920" y="1005840"/>
+            <a:ext cx="2468880" cy="1604772"/>
+          </a:xfrm>
+          <a:prstGeom prst="rect">
+            <a:avLst/>
+          </a:prstGeom>
+        </p:spPr>
+      </p:pic>
     </p:spTree>
   </p:cSld>
   <p:clrMapOvr>
@@ -4996,6 +5068,30 @@
           </a:p>
         </p:txBody>
       </p:sp>
+      <p:pic>
+        <p:nvPicPr>
+          <p:cNvPr id="5" name="Picture 4" descr="fig3_cross_species.png"/>
+          <p:cNvPicPr>
+            <a:picLocks noChangeAspect="1"/>
+          </p:cNvPicPr>
+          <p:nvPr/>
+        </p:nvPicPr>
+        <p:blipFill>
+          <a:blip r:embed="rId2"/>
+          <a:stretch>
+            <a:fillRect/>
+          </a:stretch>
+        </p:blipFill>
+        <p:spPr>
+          <a:xfrm>
+            <a:off x="6217920" y="1005840"/>
+            <a:ext cx="2468880" cy="1683327"/>
+          </a:xfrm>
+          <a:prstGeom prst="rect">
+            <a:avLst/>
+          </a:prstGeom>
+        </p:spPr>
+      </p:pic>
     </p:spTree>
   </p:cSld>
   <p:clrMapOvr>

</xml_diff>